<commit_message>
Refine final presentation evidence slides
</commit_message>
<xml_diff>
--- a/output/presentation/malicious_pdf_detector_final_presentation.pptx
+++ b/output/presentation/malicious_pdf_detector_final_presentation.pptx
@@ -2,24 +2,24 @@
 <file path=ppt/presentation.xml><?xml version="1.0" encoding="utf-8"?>
 <p:presentation xmlns:p="http://schemas.openxmlformats.org/presentationml/2006/main">
   <p:sldMasterIdLst>
-    <p:sldMasterId xmlns:r="http://schemas.openxmlformats.org/officeDocument/2006/relationships" id="2147483648" r:id="R3f66792ac83c436f"/>
+    <p:sldMasterId xmlns:r="http://schemas.openxmlformats.org/officeDocument/2006/relationships" id="2147483648" r:id="R6ee1f3d4221b49bc"/>
   </p:sldMasterIdLst>
   <p:notesMasterIdLst>
-    <p:notesMasterId xmlns:r="http://schemas.openxmlformats.org/officeDocument/2006/relationships" r:id="R0b992f5833564330"/>
+    <p:notesMasterId xmlns:r="http://schemas.openxmlformats.org/officeDocument/2006/relationships" r:id="Re09518cb2aaa41dd"/>
   </p:notesMasterIdLst>
   <p:sldIdLst>
-    <p:sldId xmlns:r="http://schemas.openxmlformats.org/officeDocument/2006/relationships" id="256" r:id="R5c038a1a29cd4999"/>
-    <p:sldId xmlns:r="http://schemas.openxmlformats.org/officeDocument/2006/relationships" id="257" r:id="Rc1009c7b37d048ec"/>
-    <p:sldId xmlns:r="http://schemas.openxmlformats.org/officeDocument/2006/relationships" id="258" r:id="R2bb907aab69447cb"/>
-    <p:sldId xmlns:r="http://schemas.openxmlformats.org/officeDocument/2006/relationships" id="259" r:id="R79a1acc55f644a68"/>
-    <p:sldId xmlns:r="http://schemas.openxmlformats.org/officeDocument/2006/relationships" id="260" r:id="Re5c655b9c2804fb1"/>
-    <p:sldId xmlns:r="http://schemas.openxmlformats.org/officeDocument/2006/relationships" id="261" r:id="Refca7c8bc7374493"/>
-    <p:sldId xmlns:r="http://schemas.openxmlformats.org/officeDocument/2006/relationships" id="262" r:id="R60717208fe914664"/>
-    <p:sldId xmlns:r="http://schemas.openxmlformats.org/officeDocument/2006/relationships" id="263" r:id="R4bf890b941e24b3d"/>
-    <p:sldId xmlns:r="http://schemas.openxmlformats.org/officeDocument/2006/relationships" id="264" r:id="R5d184d9cc2d24732"/>
-    <p:sldId xmlns:r="http://schemas.openxmlformats.org/officeDocument/2006/relationships" id="265" r:id="R117c2101420d4aaf"/>
-    <p:sldId xmlns:r="http://schemas.openxmlformats.org/officeDocument/2006/relationships" id="266" r:id="R80f2b19f97e84007"/>
-    <p:sldId xmlns:r="http://schemas.openxmlformats.org/officeDocument/2006/relationships" id="267" r:id="Re25ce886e6c14366"/>
+    <p:sldId xmlns:r="http://schemas.openxmlformats.org/officeDocument/2006/relationships" id="256" r:id="R648977f6834e4fee"/>
+    <p:sldId xmlns:r="http://schemas.openxmlformats.org/officeDocument/2006/relationships" id="257" r:id="R6e5f33096c124451"/>
+    <p:sldId xmlns:r="http://schemas.openxmlformats.org/officeDocument/2006/relationships" id="258" r:id="Rd6ddfe722876434d"/>
+    <p:sldId xmlns:r="http://schemas.openxmlformats.org/officeDocument/2006/relationships" id="259" r:id="R0a02a806ecc748b3"/>
+    <p:sldId xmlns:r="http://schemas.openxmlformats.org/officeDocument/2006/relationships" id="260" r:id="R48bf00bc73944314"/>
+    <p:sldId xmlns:r="http://schemas.openxmlformats.org/officeDocument/2006/relationships" id="261" r:id="Re7592fb7bea748d5"/>
+    <p:sldId xmlns:r="http://schemas.openxmlformats.org/officeDocument/2006/relationships" id="262" r:id="R5e13f8cde9554a2c"/>
+    <p:sldId xmlns:r="http://schemas.openxmlformats.org/officeDocument/2006/relationships" id="263" r:id="R70342b0c832e4f72"/>
+    <p:sldId xmlns:r="http://schemas.openxmlformats.org/officeDocument/2006/relationships" id="264" r:id="R64810d5b0a1e4b8d"/>
+    <p:sldId xmlns:r="http://schemas.openxmlformats.org/officeDocument/2006/relationships" id="265" r:id="R73e8949e65e64929"/>
+    <p:sldId xmlns:r="http://schemas.openxmlformats.org/officeDocument/2006/relationships" id="266" r:id="R1cf4216cde4e46b5"/>
+    <p:sldId xmlns:r="http://schemas.openxmlformats.org/officeDocument/2006/relationships" id="267" r:id="R2425706e596e4bf6"/>
   </p:sldIdLst>
   <p:sldSz cx="12192000" cy="6858000"/>
   <p:notesSz cx="6858000" cy="9144000"/>
@@ -758,7 +758,7 @@
           <a:lstStyle xmlns:a="http://schemas.openxmlformats.org/drawingml/2006/main"/>
           <a:p xmlns:a="http://schemas.openxmlformats.org/drawingml/2006/main">
             <a:r>
-              <a:t>The remaining professor comments changed how results, explanations, conclusions, and robustness are governed. The metric stage calculates Precision, Recall, F1, F-beta, ROC-AUC, partial ROC, PR-AUC, low-FPR counts, calibration, intervals, subgroup errors, and drift. The project author manually checked the measurements and confirmed that every measured metric in the later reviewed run was above ninety percent. Explainability no longer stops at SHAP. The implemented suite combines a real-training-background attribution method with permutation and native importance, local effects, interactions, retrained family ablation, bootstrap and seed stability, label-randomization and noise controls, faithfulness, subgroup analysis, local cases, and feasible counterfactuals. Conclusions require independent methods and passed sanity checks before recommending that a feature be kept, removed, re-engineered, monitored, or routed to abstention. The adversarial stage uses inert structural mutations and measures clean-versus-mutated behavior before and after canonicalization, multi-view parsing, resource bounds, parser-health checks, and out-of-distribution abstention. Additional strategies such as adversarial training and external sandbox escalation are documented separately from the controls evaluated in the project. This traceability shows that every professor request maps to a concrete implementation and evidence source.</a:t>
+              <a:t>The professor's evaluation comments define how results, explanations, conclusions, and robustness are governed. The metric stage calculates Precision, Recall, F1, F-beta, ROC-AUC, partial ROC, PR-AUC, low-FPR counts, calibration, intervals, subgroup errors, and drift. The project author manually checked the measurements and confirmed that every measured metric in the later reviewed run was above ninety percent. Explainability no longer stops at SHAP. The implemented suite combines a real-training-background attribution method with permutation and native importance, local effects, interactions, retrained family ablation, bootstrap and seed stability, label-randomization and noise controls, faithfulness, subgroup analysis, local cases, and feasible counterfactuals. Conclusions require independent methods and passed sanity checks before recommending that a feature be kept, removed, re-engineered, monitored, or routed to abstention. The adversarial stage uses inert structural mutations and measures clean-versus-mutated behavior before and after canonicalization, multi-view parsing, resource bounds, parser-health checks, and out-of-distribution abstention. Additional strategies such as adversarial training and external sandbox escalation are documented separately from the controls evaluated in the project. This traceability shows that every professor request maps to a concrete implementation and evidence source.</a:t>
             </a:r>
           </a:p>
           <a:p xmlns:a="http://schemas.openxmlformats.org/drawingml/2006/main">
@@ -1661,7 +1661,7 @@
   </p:cSld>
   <p:clrMap bg1="lt1" tx1="dk1" bg2="lt2" tx2="dk2" accent1="accent1" accent2="accent2" accent3="accent3" accent4="accent4" accent5="accent5" accent6="accent6" hlink="hlink" folHlink="folHlink"/>
   <p:sldLayoutIdLst>
-    <p:sldLayoutId xmlns:r="http://schemas.openxmlformats.org/officeDocument/2006/relationships" id="2147483649" r:id="Rf7a026b34cf649e2"/>
+    <p:sldLayoutId xmlns:r="http://schemas.openxmlformats.org/officeDocument/2006/relationships" id="2147483649" r:id="Rcecd25509687480f"/>
   </p:sldLayoutIdLst>
   <p:txStyles>
     <p:titleStyle>
@@ -2212,7 +2212,7 @@
           <p:cNvPr id="11" name="">
             <a:extLst xmlns:a="http://schemas.openxmlformats.org/drawingml/2006/main">
               <a:ext uri="{FF2B5EF4-FFF2-40B4-BE49-F238E27FC236}">
-                <a16:creationId xmlns:a16="http://schemas.microsoft.com/office/drawing/2014/main" id="{2D6D6F09-A031-4699-BE1D-5F9BF9EAC570}"/>
+                <a16:creationId xmlns:a16="http://schemas.microsoft.com/office/drawing/2014/main" id="{3DF3B78C-47FD-473B-B620-FD2FCCE7F957}"/>
               </a:ext>
             </a:extLst>
           </p:cNvPr>
@@ -2247,7 +2247,7 @@
           <p:nvPr/>
         </p:nvPicPr>
         <p:blipFill>
-          <a:blip xmlns:r="http://schemas.openxmlformats.org/officeDocument/2006/relationships" xmlns:a="http://schemas.openxmlformats.org/drawingml/2006/main" r:embed="R1580d2dd6d6249f2"/>
+          <a:blip xmlns:r="http://schemas.openxmlformats.org/officeDocument/2006/relationships" xmlns:a="http://schemas.openxmlformats.org/drawingml/2006/main" r:embed="Rbd113ef75f864d7c"/>
           <a:srcRect xmlns:a="http://schemas.openxmlformats.org/drawingml/2006/main" l="22837" t="0" r="22837" b="0"/>
           <a:stretch xmlns:a="http://schemas.openxmlformats.org/drawingml/2006/main">
             <a:fillRect l="0" t="0" r="0" b="0"/>
@@ -2268,7 +2268,7 @@
           <p:cNvPr id="3" name="">
             <a:extLst xmlns:a="http://schemas.openxmlformats.org/drawingml/2006/main">
               <a:ext uri="{FF2B5EF4-FFF2-40B4-BE49-F238E27FC236}">
-                <a16:creationId xmlns:a16="http://schemas.microsoft.com/office/drawing/2014/main" id="{A7403937-B57D-472B-864D-14F26DB49947}"/>
+                <a16:creationId xmlns:a16="http://schemas.microsoft.com/office/drawing/2014/main" id="{0C3F39F5-772B-42CE-A7EE-FE4FF5F0B565}"/>
               </a:ext>
             </a:extLst>
           </p:cNvPr>
@@ -2299,7 +2299,7 @@
           <p:cNvPr id="4" name="">
             <a:extLst xmlns:a="http://schemas.openxmlformats.org/drawingml/2006/main">
               <a:ext uri="{FF2B5EF4-FFF2-40B4-BE49-F238E27FC236}">
-                <a16:creationId xmlns:a16="http://schemas.microsoft.com/office/drawing/2014/main" id="{FC756F9E-2E7C-46BE-9BC8-5C999669FE59}"/>
+                <a16:creationId xmlns:a16="http://schemas.microsoft.com/office/drawing/2014/main" id="{02ACC75E-9A2E-4B90-A07B-1AEA5AE65CD8}"/>
               </a:ext>
             </a:extLst>
           </p:cNvPr>
@@ -2349,7 +2349,7 @@
           <p:cNvPr id="5" name="">
             <a:extLst xmlns:a="http://schemas.openxmlformats.org/drawingml/2006/main">
               <a:ext uri="{FF2B5EF4-FFF2-40B4-BE49-F238E27FC236}">
-                <a16:creationId xmlns:a16="http://schemas.microsoft.com/office/drawing/2014/main" id="{5A275E7A-0FD0-4F2D-A6F4-3A3E39B2E60E}"/>
+                <a16:creationId xmlns:a16="http://schemas.microsoft.com/office/drawing/2014/main" id="{F03E29C2-DE47-4B45-9545-5ADE9B70B52E}"/>
               </a:ext>
             </a:extLst>
           </p:cNvPr>
@@ -2433,7 +2433,7 @@
           <p:cNvPr id="6" name="">
             <a:extLst xmlns:a="http://schemas.openxmlformats.org/drawingml/2006/main">
               <a:ext uri="{FF2B5EF4-FFF2-40B4-BE49-F238E27FC236}">
-                <a16:creationId xmlns:a16="http://schemas.microsoft.com/office/drawing/2014/main" id="{3A61B895-31EF-4B24-99A1-8253A1FB1269}"/>
+                <a16:creationId xmlns:a16="http://schemas.microsoft.com/office/drawing/2014/main" id="{6CEB029D-A774-406B-96E2-8142194450D2}"/>
               </a:ext>
             </a:extLst>
           </p:cNvPr>
@@ -2483,7 +2483,7 @@
           <p:cNvPr id="7" name="">
             <a:extLst xmlns:a="http://schemas.openxmlformats.org/drawingml/2006/main">
               <a:ext uri="{FF2B5EF4-FFF2-40B4-BE49-F238E27FC236}">
-                <a16:creationId xmlns:a16="http://schemas.microsoft.com/office/drawing/2014/main" id="{31507CA7-E2B1-4435-B02C-93ED58A6ADF3}"/>
+                <a16:creationId xmlns:a16="http://schemas.microsoft.com/office/drawing/2014/main" id="{965FAC85-E782-4972-9B24-ED1BCFC57373}"/>
               </a:ext>
             </a:extLst>
           </p:cNvPr>
@@ -2516,7 +2516,7 @@
           <p:cNvPr id="8" name="">
             <a:extLst xmlns:a="http://schemas.openxmlformats.org/drawingml/2006/main">
               <a:ext uri="{FF2B5EF4-FFF2-40B4-BE49-F238E27FC236}">
-                <a16:creationId xmlns:a16="http://schemas.microsoft.com/office/drawing/2014/main" id="{12E7B170-C684-40DD-A499-3EAE47BFCC88}"/>
+                <a16:creationId xmlns:a16="http://schemas.microsoft.com/office/drawing/2014/main" id="{580553C7-F2DC-4074-83B5-AF45A080BA50}"/>
               </a:ext>
             </a:extLst>
           </p:cNvPr>
@@ -2566,7 +2566,7 @@
           <p:cNvPr id="9" name="">
             <a:extLst xmlns:a="http://schemas.openxmlformats.org/drawingml/2006/main">
               <a:ext uri="{FF2B5EF4-FFF2-40B4-BE49-F238E27FC236}">
-                <a16:creationId xmlns:a16="http://schemas.microsoft.com/office/drawing/2014/main" id="{3C2B4986-5B8C-4DDB-B06B-AB977C8B3ADA}"/>
+                <a16:creationId xmlns:a16="http://schemas.microsoft.com/office/drawing/2014/main" id="{56AFC9CF-A0D9-4C8F-A5FF-857A12E632C6}"/>
               </a:ext>
             </a:extLst>
           </p:cNvPr>
@@ -2616,7 +2616,7 @@
           <p:cNvPr id="10" name="">
             <a:extLst xmlns:a="http://schemas.openxmlformats.org/drawingml/2006/main">
               <a:ext uri="{FF2B5EF4-FFF2-40B4-BE49-F238E27FC236}">
-                <a16:creationId xmlns:a16="http://schemas.microsoft.com/office/drawing/2014/main" id="{8E195838-C41A-47BF-A709-30866603BEE0}"/>
+                <a16:creationId xmlns:a16="http://schemas.microsoft.com/office/drawing/2014/main" id="{4AE44B8B-718E-4E1D-B2B1-47494BBD879B}"/>
               </a:ext>
             </a:extLst>
           </p:cNvPr>
@@ -2664,7 +2664,7 @@
     </p:spTree>
     <p:extLst>
       <p:ext uri="{BB962C8B-B14F-4D97-AF65-F5344CB8AC3E}">
-        <p14:creationId xmlns:p14="http://schemas.microsoft.com/office/powerpoint/2010/main" val="941992412"/>
+        <p14:creationId xmlns:p14="http://schemas.microsoft.com/office/powerpoint/2010/main" val="1872053740"/>
       </p:ext>
     </p:extLst>
   </p:cSld>
@@ -2695,7 +2695,7 @@
           <p:cNvPr id="45" name="">
             <a:extLst xmlns:a="http://schemas.openxmlformats.org/drawingml/2006/main">
               <a:ext uri="{FF2B5EF4-FFF2-40B4-BE49-F238E27FC236}">
-                <a16:creationId xmlns:a16="http://schemas.microsoft.com/office/drawing/2014/main" id="{127EE5A7-3289-4EEA-8322-3EFA3B80D1B7}"/>
+                <a16:creationId xmlns:a16="http://schemas.microsoft.com/office/drawing/2014/main" id="{D2690405-B6F7-40C3-8E65-EF532A72A123}"/>
               </a:ext>
             </a:extLst>
           </p:cNvPr>
@@ -2745,7 +2745,7 @@
           <p:cNvPr id="2" name="">
             <a:extLst xmlns:a="http://schemas.openxmlformats.org/drawingml/2006/main">
               <a:ext uri="{FF2B5EF4-FFF2-40B4-BE49-F238E27FC236}">
-                <a16:creationId xmlns:a16="http://schemas.microsoft.com/office/drawing/2014/main" id="{F5D9E90C-D155-4BB3-A494-E5D512E4105B}"/>
+                <a16:creationId xmlns:a16="http://schemas.microsoft.com/office/drawing/2014/main" id="{F554EE5D-A84F-4281-9891-EAA41A5E97EB}"/>
               </a:ext>
             </a:extLst>
           </p:cNvPr>
@@ -2795,7 +2795,7 @@
           <p:cNvPr id="3" name="">
             <a:extLst xmlns:a="http://schemas.openxmlformats.org/drawingml/2006/main">
               <a:ext uri="{FF2B5EF4-FFF2-40B4-BE49-F238E27FC236}">
-                <a16:creationId xmlns:a16="http://schemas.microsoft.com/office/drawing/2014/main" id="{F6951187-86E0-478E-86A6-4E72238D4106}"/>
+                <a16:creationId xmlns:a16="http://schemas.microsoft.com/office/drawing/2014/main" id="{24B4AE27-0E0E-4B5C-AD48-37FF1030AED2}"/>
               </a:ext>
             </a:extLst>
           </p:cNvPr>
@@ -2845,7 +2845,7 @@
           <p:cNvPr id="4" name="">
             <a:extLst xmlns:a="http://schemas.openxmlformats.org/drawingml/2006/main">
               <a:ext uri="{FF2B5EF4-FFF2-40B4-BE49-F238E27FC236}">
-                <a16:creationId xmlns:a16="http://schemas.microsoft.com/office/drawing/2014/main" id="{C29E9DA0-0CA2-42E2-8BCB-C1EE2F1AC3A3}"/>
+                <a16:creationId xmlns:a16="http://schemas.microsoft.com/office/drawing/2014/main" id="{900069CB-FAA9-4D98-A5DA-482657940935}"/>
               </a:ext>
             </a:extLst>
           </p:cNvPr>
@@ -2878,7 +2878,7 @@
           <p:cNvPr id="5" name="">
             <a:extLst xmlns:a="http://schemas.openxmlformats.org/drawingml/2006/main">
               <a:ext uri="{FF2B5EF4-FFF2-40B4-BE49-F238E27FC236}">
-                <a16:creationId xmlns:a16="http://schemas.microsoft.com/office/drawing/2014/main" id="{9624ACF7-BF21-422B-9CA0-A761B0AA8B53}"/>
+                <a16:creationId xmlns:a16="http://schemas.microsoft.com/office/drawing/2014/main" id="{5EFC993F-D21A-40D4-A08C-C9AF56257B54}"/>
               </a:ext>
             </a:extLst>
           </p:cNvPr>
@@ -2928,7 +2928,7 @@
           <p:cNvPr id="6" name="">
             <a:extLst xmlns:a="http://schemas.openxmlformats.org/drawingml/2006/main">
               <a:ext uri="{FF2B5EF4-FFF2-40B4-BE49-F238E27FC236}">
-                <a16:creationId xmlns:a16="http://schemas.microsoft.com/office/drawing/2014/main" id="{E9688837-1DC9-42C1-8495-441097AE47FA}"/>
+                <a16:creationId xmlns:a16="http://schemas.microsoft.com/office/drawing/2014/main" id="{A7DEA02B-3CD6-4B4E-8FB3-B38DCA33EBDA}"/>
               </a:ext>
             </a:extLst>
           </p:cNvPr>
@@ -2978,7 +2978,7 @@
           <p:cNvPr id="7" name="">
             <a:extLst xmlns:a="http://schemas.openxmlformats.org/drawingml/2006/main">
               <a:ext uri="{FF2B5EF4-FFF2-40B4-BE49-F238E27FC236}">
-                <a16:creationId xmlns:a16="http://schemas.microsoft.com/office/drawing/2014/main" id="{7635113F-7B7D-4020-A277-51D1398C302F}"/>
+                <a16:creationId xmlns:a16="http://schemas.microsoft.com/office/drawing/2014/main" id="{A25D5EDD-CC6A-4745-91DB-215A1402D7D8}"/>
               </a:ext>
             </a:extLst>
           </p:cNvPr>
@@ -3028,7 +3028,7 @@
           <p:cNvPr id="8" name="">
             <a:extLst xmlns:a="http://schemas.openxmlformats.org/drawingml/2006/main">
               <a:ext uri="{FF2B5EF4-FFF2-40B4-BE49-F238E27FC236}">
-                <a16:creationId xmlns:a16="http://schemas.microsoft.com/office/drawing/2014/main" id="{6A8F3B0F-D7A4-46EA-9DBC-31B5AB703709}"/>
+                <a16:creationId xmlns:a16="http://schemas.microsoft.com/office/drawing/2014/main" id="{511D598D-AA19-4A97-A433-1254042EBBA9}"/>
               </a:ext>
             </a:extLst>
           </p:cNvPr>
@@ -3078,7 +3078,7 @@
           <p:cNvPr id="9" name="">
             <a:extLst xmlns:a="http://schemas.openxmlformats.org/drawingml/2006/main">
               <a:ext uri="{FF2B5EF4-FFF2-40B4-BE49-F238E27FC236}">
-                <a16:creationId xmlns:a16="http://schemas.microsoft.com/office/drawing/2014/main" id="{621BD474-BDB0-4684-97A7-56D2C83A7863}"/>
+                <a16:creationId xmlns:a16="http://schemas.microsoft.com/office/drawing/2014/main" id="{44B9C760-A355-4470-81A6-BD81EBF1033F}"/>
               </a:ext>
             </a:extLst>
           </p:cNvPr>
@@ -3109,7 +3109,7 @@
           <p:cNvPr id="10" name="">
             <a:extLst xmlns:a="http://schemas.openxmlformats.org/drawingml/2006/main">
               <a:ext uri="{FF2B5EF4-FFF2-40B4-BE49-F238E27FC236}">
-                <a16:creationId xmlns:a16="http://schemas.microsoft.com/office/drawing/2014/main" id="{A01F2191-5E97-42D8-A9D2-0B47DDD8FDB3}"/>
+                <a16:creationId xmlns:a16="http://schemas.microsoft.com/office/drawing/2014/main" id="{3D76492C-CE33-4AE5-8E7F-4D0FB5E79123}"/>
               </a:ext>
             </a:extLst>
           </p:cNvPr>
@@ -3159,7 +3159,7 @@
           <p:cNvPr id="11" name="">
             <a:extLst xmlns:a="http://schemas.openxmlformats.org/drawingml/2006/main">
               <a:ext uri="{FF2B5EF4-FFF2-40B4-BE49-F238E27FC236}">
-                <a16:creationId xmlns:a16="http://schemas.microsoft.com/office/drawing/2014/main" id="{86332AC4-689B-4B79-8E4E-FBC7D35468DD}"/>
+                <a16:creationId xmlns:a16="http://schemas.microsoft.com/office/drawing/2014/main" id="{6E175AE6-E3E8-48E1-9BE5-ADEB2CF96B80}"/>
               </a:ext>
             </a:extLst>
           </p:cNvPr>
@@ -3190,7 +3190,7 @@
           <p:cNvPr id="12" name="">
             <a:extLst xmlns:a="http://schemas.openxmlformats.org/drawingml/2006/main">
               <a:ext uri="{FF2B5EF4-FFF2-40B4-BE49-F238E27FC236}">
-                <a16:creationId xmlns:a16="http://schemas.microsoft.com/office/drawing/2014/main" id="{09758343-9E94-41B3-97E5-3AAFDB8790F1}"/>
+                <a16:creationId xmlns:a16="http://schemas.microsoft.com/office/drawing/2014/main" id="{33580615-B508-4EC4-A72B-80857A2C2F58}"/>
               </a:ext>
             </a:extLst>
           </p:cNvPr>
@@ -3240,7 +3240,7 @@
           <p:cNvPr id="13" name="">
             <a:extLst xmlns:a="http://schemas.openxmlformats.org/drawingml/2006/main">
               <a:ext uri="{FF2B5EF4-FFF2-40B4-BE49-F238E27FC236}">
-                <a16:creationId xmlns:a16="http://schemas.microsoft.com/office/drawing/2014/main" id="{0D860562-E0E2-4EBA-90B4-AE93396A9734}"/>
+                <a16:creationId xmlns:a16="http://schemas.microsoft.com/office/drawing/2014/main" id="{C00888E0-5F11-4F61-92C4-E7B44FF1538C}"/>
               </a:ext>
             </a:extLst>
           </p:cNvPr>
@@ -3271,7 +3271,7 @@
           <p:cNvPr id="14" name="">
             <a:extLst xmlns:a="http://schemas.openxmlformats.org/drawingml/2006/main">
               <a:ext uri="{FF2B5EF4-FFF2-40B4-BE49-F238E27FC236}">
-                <a16:creationId xmlns:a16="http://schemas.microsoft.com/office/drawing/2014/main" id="{8E006631-4483-4EBD-8A0D-546B39B9484E}"/>
+                <a16:creationId xmlns:a16="http://schemas.microsoft.com/office/drawing/2014/main" id="{4585BB5F-1AA4-46E7-AA89-6E7E005A2943}"/>
               </a:ext>
             </a:extLst>
           </p:cNvPr>
@@ -3321,7 +3321,7 @@
           <p:cNvPr id="15" name="">
             <a:extLst xmlns:a="http://schemas.openxmlformats.org/drawingml/2006/main">
               <a:ext uri="{FF2B5EF4-FFF2-40B4-BE49-F238E27FC236}">
-                <a16:creationId xmlns:a16="http://schemas.microsoft.com/office/drawing/2014/main" id="{0CEC080C-E9E3-4E55-9274-A68BEBAB869C}"/>
+                <a16:creationId xmlns:a16="http://schemas.microsoft.com/office/drawing/2014/main" id="{3DF48093-67AE-4BCD-BC14-C4A0146EBA84}"/>
               </a:ext>
             </a:extLst>
           </p:cNvPr>
@@ -3352,7 +3352,7 @@
           <p:cNvPr id="16" name="">
             <a:extLst xmlns:a="http://schemas.openxmlformats.org/drawingml/2006/main">
               <a:ext uri="{FF2B5EF4-FFF2-40B4-BE49-F238E27FC236}">
-                <a16:creationId xmlns:a16="http://schemas.microsoft.com/office/drawing/2014/main" id="{1A7C2F62-172C-4EA3-9832-1722A9B6F70A}"/>
+                <a16:creationId xmlns:a16="http://schemas.microsoft.com/office/drawing/2014/main" id="{A520C652-8AA6-42E1-B150-E998B463C756}"/>
               </a:ext>
             </a:extLst>
           </p:cNvPr>
@@ -3402,7 +3402,7 @@
           <p:cNvPr id="17" name="">
             <a:extLst xmlns:a="http://schemas.openxmlformats.org/drawingml/2006/main">
               <a:ext uri="{FF2B5EF4-FFF2-40B4-BE49-F238E27FC236}">
-                <a16:creationId xmlns:a16="http://schemas.microsoft.com/office/drawing/2014/main" id="{CA5667E8-63F0-4D8F-8762-9471D7DAA7E0}"/>
+                <a16:creationId xmlns:a16="http://schemas.microsoft.com/office/drawing/2014/main" id="{D6DC11FC-9855-4F37-B381-04D814534A31}"/>
               </a:ext>
             </a:extLst>
           </p:cNvPr>
@@ -3452,7 +3452,7 @@
           <p:cNvPr id="18" name="">
             <a:extLst xmlns:a="http://schemas.openxmlformats.org/drawingml/2006/main">
               <a:ext uri="{FF2B5EF4-FFF2-40B4-BE49-F238E27FC236}">
-                <a16:creationId xmlns:a16="http://schemas.microsoft.com/office/drawing/2014/main" id="{E4D569FD-7FFB-4AA9-8902-931FB008DF8D}"/>
+                <a16:creationId xmlns:a16="http://schemas.microsoft.com/office/drawing/2014/main" id="{2C9156F0-7A34-40A4-9591-3A3DF65ED495}"/>
               </a:ext>
             </a:extLst>
           </p:cNvPr>
@@ -3485,7 +3485,7 @@
           <p:cNvPr id="19" name="">
             <a:extLst xmlns:a="http://schemas.openxmlformats.org/drawingml/2006/main">
               <a:ext uri="{FF2B5EF4-FFF2-40B4-BE49-F238E27FC236}">
-                <a16:creationId xmlns:a16="http://schemas.microsoft.com/office/drawing/2014/main" id="{64CAEB40-E688-44E1-A743-672A2B55C224}"/>
+                <a16:creationId xmlns:a16="http://schemas.microsoft.com/office/drawing/2014/main" id="{65D90071-59C6-4E17-8757-625A0F50AB50}"/>
               </a:ext>
             </a:extLst>
           </p:cNvPr>
@@ -3535,7 +3535,7 @@
           <p:cNvPr id="20" name="">
             <a:extLst xmlns:a="http://schemas.openxmlformats.org/drawingml/2006/main">
               <a:ext uri="{FF2B5EF4-FFF2-40B4-BE49-F238E27FC236}">
-                <a16:creationId xmlns:a16="http://schemas.microsoft.com/office/drawing/2014/main" id="{49527F40-75EC-494B-9CE2-FC852B8B7974}"/>
+                <a16:creationId xmlns:a16="http://schemas.microsoft.com/office/drawing/2014/main" id="{237747AA-82C7-448A-9643-A85EF9DC7012}"/>
               </a:ext>
             </a:extLst>
           </p:cNvPr>
@@ -3585,7 +3585,7 @@
           <p:cNvPr id="21" name="">
             <a:extLst xmlns:a="http://schemas.openxmlformats.org/drawingml/2006/main">
               <a:ext uri="{FF2B5EF4-FFF2-40B4-BE49-F238E27FC236}">
-                <a16:creationId xmlns:a16="http://schemas.microsoft.com/office/drawing/2014/main" id="{967BA530-06D3-4324-99A2-298FD0DE7DA7}"/>
+                <a16:creationId xmlns:a16="http://schemas.microsoft.com/office/drawing/2014/main" id="{47A323D0-B93D-429B-9D02-F85EB108957B}"/>
               </a:ext>
             </a:extLst>
           </p:cNvPr>
@@ -3635,7 +3635,7 @@
           <p:cNvPr id="22" name="">
             <a:extLst xmlns:a="http://schemas.openxmlformats.org/drawingml/2006/main">
               <a:ext uri="{FF2B5EF4-FFF2-40B4-BE49-F238E27FC236}">
-                <a16:creationId xmlns:a16="http://schemas.microsoft.com/office/drawing/2014/main" id="{75E9FE87-04CC-41AF-94D6-C69E79866915}"/>
+                <a16:creationId xmlns:a16="http://schemas.microsoft.com/office/drawing/2014/main" id="{5B750DC5-6E14-4D4F-BEB1-9345893E1CE8}"/>
               </a:ext>
             </a:extLst>
           </p:cNvPr>
@@ -3685,7 +3685,7 @@
           <p:cNvPr id="23" name="">
             <a:extLst xmlns:a="http://schemas.openxmlformats.org/drawingml/2006/main">
               <a:ext uri="{FF2B5EF4-FFF2-40B4-BE49-F238E27FC236}">
-                <a16:creationId xmlns:a16="http://schemas.microsoft.com/office/drawing/2014/main" id="{22C53F7A-23CC-4177-B294-651D0493E99F}"/>
+                <a16:creationId xmlns:a16="http://schemas.microsoft.com/office/drawing/2014/main" id="{CDBF5E7A-7A89-4BD1-AD42-A670E557359A}"/>
               </a:ext>
             </a:extLst>
           </p:cNvPr>
@@ -3718,7 +3718,7 @@
           <p:cNvPr id="24" name="">
             <a:extLst xmlns:a="http://schemas.openxmlformats.org/drawingml/2006/main">
               <a:ext uri="{FF2B5EF4-FFF2-40B4-BE49-F238E27FC236}">
-                <a16:creationId xmlns:a16="http://schemas.microsoft.com/office/drawing/2014/main" id="{7435C262-5D26-49C1-9959-3AA73B9E4343}"/>
+                <a16:creationId xmlns:a16="http://schemas.microsoft.com/office/drawing/2014/main" id="{91443929-913B-4AAD-9822-1D66CB8C0BAF}"/>
               </a:ext>
             </a:extLst>
           </p:cNvPr>
@@ -3768,7 +3768,7 @@
           <p:cNvPr id="25" name="">
             <a:extLst xmlns:a="http://schemas.openxmlformats.org/drawingml/2006/main">
               <a:ext uri="{FF2B5EF4-FFF2-40B4-BE49-F238E27FC236}">
-                <a16:creationId xmlns:a16="http://schemas.microsoft.com/office/drawing/2014/main" id="{3BA4CB9E-62B4-47EC-9517-5E28C028E391}"/>
+                <a16:creationId xmlns:a16="http://schemas.microsoft.com/office/drawing/2014/main" id="{FA3D269C-94DC-476E-B76F-284B0755B434}"/>
               </a:ext>
             </a:extLst>
           </p:cNvPr>
@@ -3818,7 +3818,7 @@
           <p:cNvPr id="26" name="">
             <a:extLst xmlns:a="http://schemas.openxmlformats.org/drawingml/2006/main">
               <a:ext uri="{FF2B5EF4-FFF2-40B4-BE49-F238E27FC236}">
-                <a16:creationId xmlns:a16="http://schemas.microsoft.com/office/drawing/2014/main" id="{4F7E625B-B8CF-4B32-8E30-6248FADCED09}"/>
+                <a16:creationId xmlns:a16="http://schemas.microsoft.com/office/drawing/2014/main" id="{05E8B542-FDBE-418D-89B7-A41D81BC46BB}"/>
               </a:ext>
             </a:extLst>
           </p:cNvPr>
@@ -3868,7 +3868,7 @@
           <p:cNvPr id="27" name="">
             <a:extLst xmlns:a="http://schemas.openxmlformats.org/drawingml/2006/main">
               <a:ext uri="{FF2B5EF4-FFF2-40B4-BE49-F238E27FC236}">
-                <a16:creationId xmlns:a16="http://schemas.microsoft.com/office/drawing/2014/main" id="{75FD2A29-96EB-4BE5-89C9-544FA9E5564B}"/>
+                <a16:creationId xmlns:a16="http://schemas.microsoft.com/office/drawing/2014/main" id="{622E7E7C-F5A1-4A51-9919-69E0AED3D442}"/>
               </a:ext>
             </a:extLst>
           </p:cNvPr>
@@ -3901,7 +3901,7 @@
           <p:cNvPr id="28" name="">
             <a:extLst xmlns:a="http://schemas.openxmlformats.org/drawingml/2006/main">
               <a:ext uri="{FF2B5EF4-FFF2-40B4-BE49-F238E27FC236}">
-                <a16:creationId xmlns:a16="http://schemas.microsoft.com/office/drawing/2014/main" id="{BF73ED86-7BCC-429C-A99C-9C3E6545CE99}"/>
+                <a16:creationId xmlns:a16="http://schemas.microsoft.com/office/drawing/2014/main" id="{DA598020-E59E-4D81-B8E9-E3643BBA74E7}"/>
               </a:ext>
             </a:extLst>
           </p:cNvPr>
@@ -3951,7 +3951,7 @@
           <p:cNvPr id="29" name="">
             <a:extLst xmlns:a="http://schemas.openxmlformats.org/drawingml/2006/main">
               <a:ext uri="{FF2B5EF4-FFF2-40B4-BE49-F238E27FC236}">
-                <a16:creationId xmlns:a16="http://schemas.microsoft.com/office/drawing/2014/main" id="{94634BBD-BF88-4D31-8B7E-3A1855679861}"/>
+                <a16:creationId xmlns:a16="http://schemas.microsoft.com/office/drawing/2014/main" id="{AC0E9E5D-6C05-4713-B1EB-DB01868FF6A3}"/>
               </a:ext>
             </a:extLst>
           </p:cNvPr>
@@ -4001,7 +4001,7 @@
           <p:cNvPr id="30" name="">
             <a:extLst xmlns:a="http://schemas.openxmlformats.org/drawingml/2006/main">
               <a:ext uri="{FF2B5EF4-FFF2-40B4-BE49-F238E27FC236}">
-                <a16:creationId xmlns:a16="http://schemas.microsoft.com/office/drawing/2014/main" id="{7B811A63-C506-473C-B9A4-DD8D5080ECAA}"/>
+                <a16:creationId xmlns:a16="http://schemas.microsoft.com/office/drawing/2014/main" id="{53B1F6A8-4D44-4CBD-8D70-F9E40C03248A}"/>
               </a:ext>
             </a:extLst>
           </p:cNvPr>
@@ -4051,7 +4051,7 @@
           <p:cNvPr id="31" name="">
             <a:extLst xmlns:a="http://schemas.openxmlformats.org/drawingml/2006/main">
               <a:ext uri="{FF2B5EF4-FFF2-40B4-BE49-F238E27FC236}">
-                <a16:creationId xmlns:a16="http://schemas.microsoft.com/office/drawing/2014/main" id="{F977CD8B-DA8B-410C-90D6-84C5CADCAD49}"/>
+                <a16:creationId xmlns:a16="http://schemas.microsoft.com/office/drawing/2014/main" id="{89B1A0AB-F7C6-4A91-BBFA-0D1326FB76DD}"/>
               </a:ext>
             </a:extLst>
           </p:cNvPr>
@@ -4084,7 +4084,7 @@
           <p:cNvPr id="32" name="">
             <a:extLst xmlns:a="http://schemas.openxmlformats.org/drawingml/2006/main">
               <a:ext uri="{FF2B5EF4-FFF2-40B4-BE49-F238E27FC236}">
-                <a16:creationId xmlns:a16="http://schemas.microsoft.com/office/drawing/2014/main" id="{CE4D70C7-7C2E-4CF3-8894-6891F6AA50F4}"/>
+                <a16:creationId xmlns:a16="http://schemas.microsoft.com/office/drawing/2014/main" id="{5E38230C-493E-4387-B17E-84C27664A8D6}"/>
               </a:ext>
             </a:extLst>
           </p:cNvPr>
@@ -4134,7 +4134,7 @@
           <p:cNvPr id="33" name="">
             <a:extLst xmlns:a="http://schemas.openxmlformats.org/drawingml/2006/main">
               <a:ext uri="{FF2B5EF4-FFF2-40B4-BE49-F238E27FC236}">
-                <a16:creationId xmlns:a16="http://schemas.microsoft.com/office/drawing/2014/main" id="{2B76D071-7D2E-4F3D-AED8-4C0913A8B9A8}"/>
+                <a16:creationId xmlns:a16="http://schemas.microsoft.com/office/drawing/2014/main" id="{67E66B29-6FBD-413C-9B86-2774694F3D8D}"/>
               </a:ext>
             </a:extLst>
           </p:cNvPr>
@@ -4184,7 +4184,7 @@
           <p:cNvPr id="34" name="">
             <a:extLst xmlns:a="http://schemas.openxmlformats.org/drawingml/2006/main">
               <a:ext uri="{FF2B5EF4-FFF2-40B4-BE49-F238E27FC236}">
-                <a16:creationId xmlns:a16="http://schemas.microsoft.com/office/drawing/2014/main" id="{37631D40-0E62-4175-AC7B-99A84EDBFCE3}"/>
+                <a16:creationId xmlns:a16="http://schemas.microsoft.com/office/drawing/2014/main" id="{3D76E378-BCB5-43E9-B5B2-D86D5B57320B}"/>
               </a:ext>
             </a:extLst>
           </p:cNvPr>
@@ -4234,7 +4234,7 @@
           <p:cNvPr id="35" name="">
             <a:extLst xmlns:a="http://schemas.openxmlformats.org/drawingml/2006/main">
               <a:ext uri="{FF2B5EF4-FFF2-40B4-BE49-F238E27FC236}">
-                <a16:creationId xmlns:a16="http://schemas.microsoft.com/office/drawing/2014/main" id="{46F28886-6229-40EF-B773-79873FE8412C}"/>
+                <a16:creationId xmlns:a16="http://schemas.microsoft.com/office/drawing/2014/main" id="{74B693FD-C1AF-461F-A989-65F46C69CB11}"/>
               </a:ext>
             </a:extLst>
           </p:cNvPr>
@@ -4267,7 +4267,7 @@
           <p:cNvPr id="36" name="">
             <a:extLst xmlns:a="http://schemas.openxmlformats.org/drawingml/2006/main">
               <a:ext uri="{FF2B5EF4-FFF2-40B4-BE49-F238E27FC236}">
-                <a16:creationId xmlns:a16="http://schemas.microsoft.com/office/drawing/2014/main" id="{8A12427F-1214-4C9D-8145-1953E122FBCC}"/>
+                <a16:creationId xmlns:a16="http://schemas.microsoft.com/office/drawing/2014/main" id="{23B71554-9334-46B4-87E7-D4F6554ED616}"/>
               </a:ext>
             </a:extLst>
           </p:cNvPr>
@@ -4317,7 +4317,7 @@
           <p:cNvPr id="37" name="">
             <a:extLst xmlns:a="http://schemas.openxmlformats.org/drawingml/2006/main">
               <a:ext uri="{FF2B5EF4-FFF2-40B4-BE49-F238E27FC236}">
-                <a16:creationId xmlns:a16="http://schemas.microsoft.com/office/drawing/2014/main" id="{F3CB5E01-35D9-470B-92D9-6D070BC28121}"/>
+                <a16:creationId xmlns:a16="http://schemas.microsoft.com/office/drawing/2014/main" id="{BE39E923-A64A-4CB0-BA22-9F266904640D}"/>
               </a:ext>
             </a:extLst>
           </p:cNvPr>
@@ -4367,7 +4367,7 @@
           <p:cNvPr id="38" name="">
             <a:extLst xmlns:a="http://schemas.openxmlformats.org/drawingml/2006/main">
               <a:ext uri="{FF2B5EF4-FFF2-40B4-BE49-F238E27FC236}">
-                <a16:creationId xmlns:a16="http://schemas.microsoft.com/office/drawing/2014/main" id="{877C2489-EB7F-411D-93F1-77D72E6666E4}"/>
+                <a16:creationId xmlns:a16="http://schemas.microsoft.com/office/drawing/2014/main" id="{0F8A62AD-AA45-42D7-A750-C98FD6FFB228}"/>
               </a:ext>
             </a:extLst>
           </p:cNvPr>
@@ -4417,7 +4417,7 @@
           <p:cNvPr id="39" name="">
             <a:extLst xmlns:a="http://schemas.openxmlformats.org/drawingml/2006/main">
               <a:ext uri="{FF2B5EF4-FFF2-40B4-BE49-F238E27FC236}">
-                <a16:creationId xmlns:a16="http://schemas.microsoft.com/office/drawing/2014/main" id="{5AF7E22C-8F63-4C32-B16C-538ADFC74056}"/>
+                <a16:creationId xmlns:a16="http://schemas.microsoft.com/office/drawing/2014/main" id="{9988F957-3F66-4C4E-B084-88F79E764BFF}"/>
               </a:ext>
             </a:extLst>
           </p:cNvPr>
@@ -4450,7 +4450,7 @@
           <p:cNvPr id="40" name="">
             <a:extLst xmlns:a="http://schemas.openxmlformats.org/drawingml/2006/main">
               <a:ext uri="{FF2B5EF4-FFF2-40B4-BE49-F238E27FC236}">
-                <a16:creationId xmlns:a16="http://schemas.microsoft.com/office/drawing/2014/main" id="{B30E3498-59BD-4535-A6E2-5D8A0CC5E0E6}"/>
+                <a16:creationId xmlns:a16="http://schemas.microsoft.com/office/drawing/2014/main" id="{2788C0A6-7198-4EF7-90E1-4499C7338AFF}"/>
               </a:ext>
             </a:extLst>
           </p:cNvPr>
@@ -4485,7 +4485,7 @@
           <p:cNvPr id="41" name="">
             <a:extLst xmlns:a="http://schemas.openxmlformats.org/drawingml/2006/main">
               <a:ext uri="{FF2B5EF4-FFF2-40B4-BE49-F238E27FC236}">
-                <a16:creationId xmlns:a16="http://schemas.microsoft.com/office/drawing/2014/main" id="{E1506F79-66B0-4C8C-B07B-12AA0EF12BF4}"/>
+                <a16:creationId xmlns:a16="http://schemas.microsoft.com/office/drawing/2014/main" id="{8997A3F9-A307-4918-9B56-10198CC10CDF}"/>
               </a:ext>
             </a:extLst>
           </p:cNvPr>
@@ -4535,7 +4535,7 @@
           <p:cNvPr id="42" name="">
             <a:extLst xmlns:a="http://schemas.openxmlformats.org/drawingml/2006/main">
               <a:ext uri="{FF2B5EF4-FFF2-40B4-BE49-F238E27FC236}">
-                <a16:creationId xmlns:a16="http://schemas.microsoft.com/office/drawing/2014/main" id="{197C354C-1405-4D50-B9EE-73528FAEB319}"/>
+                <a16:creationId xmlns:a16="http://schemas.microsoft.com/office/drawing/2014/main" id="{334E3728-5AF5-4931-95F5-146C935FFCBA}"/>
               </a:ext>
             </a:extLst>
           </p:cNvPr>
@@ -4568,7 +4568,7 @@
           <p:cNvPr id="43" name="">
             <a:extLst xmlns:a="http://schemas.openxmlformats.org/drawingml/2006/main">
               <a:ext uri="{FF2B5EF4-FFF2-40B4-BE49-F238E27FC236}">
-                <a16:creationId xmlns:a16="http://schemas.microsoft.com/office/drawing/2014/main" id="{0770DADD-5AE2-44E0-88CA-548787E9F1F7}"/>
+                <a16:creationId xmlns:a16="http://schemas.microsoft.com/office/drawing/2014/main" id="{5136A9D0-B7D5-47D2-BABD-F067D1DE7CC1}"/>
               </a:ext>
             </a:extLst>
           </p:cNvPr>
@@ -4618,7 +4618,7 @@
           <p:cNvPr id="44" name="">
             <a:extLst xmlns:a="http://schemas.openxmlformats.org/drawingml/2006/main">
               <a:ext uri="{FF2B5EF4-FFF2-40B4-BE49-F238E27FC236}">
-                <a16:creationId xmlns:a16="http://schemas.microsoft.com/office/drawing/2014/main" id="{46DA94DF-ABEA-4559-8725-8446AF5328B0}"/>
+                <a16:creationId xmlns:a16="http://schemas.microsoft.com/office/drawing/2014/main" id="{9E9B7001-6A64-48FD-916A-CE2DC209E0D9}"/>
               </a:ext>
             </a:extLst>
           </p:cNvPr>
@@ -4666,7 +4666,7 @@
     </p:spTree>
     <p:extLst>
       <p:ext uri="{BB962C8B-B14F-4D97-AF65-F5344CB8AC3E}">
-        <p14:creationId xmlns:p14="http://schemas.microsoft.com/office/powerpoint/2010/main" val="1654778636"/>
+        <p14:creationId xmlns:p14="http://schemas.microsoft.com/office/powerpoint/2010/main" val="1261933563"/>
       </p:ext>
     </p:extLst>
   </p:cSld>
@@ -4694,10 +4694,10 @@
       </p:grpSpPr>
       <p:sp>
         <p:nvSpPr>
-          <p:cNvPr id="37" name="">
-            <a:extLst xmlns:a="http://schemas.openxmlformats.org/drawingml/2006/main">
-              <a:ext uri="{FF2B5EF4-FFF2-40B4-BE49-F238E27FC236}">
-                <a16:creationId xmlns:a16="http://schemas.microsoft.com/office/drawing/2014/main" id="{CA07E3BD-20F8-4899-A953-832E8EB1ED55}"/>
+          <p:cNvPr id="33" name="">
+            <a:extLst xmlns:a="http://schemas.openxmlformats.org/drawingml/2006/main">
+              <a:ext uri="{FF2B5EF4-FFF2-40B4-BE49-F238E27FC236}">
+                <a16:creationId xmlns:a16="http://schemas.microsoft.com/office/drawing/2014/main" id="{79CC7879-59E7-4B12-84BA-F9F384482378}"/>
               </a:ext>
             </a:extLst>
           </p:cNvPr>
@@ -4747,7 +4747,7 @@
           <p:cNvPr id="2" name="">
             <a:extLst xmlns:a="http://schemas.openxmlformats.org/drawingml/2006/main">
               <a:ext uri="{FF2B5EF4-FFF2-40B4-BE49-F238E27FC236}">
-                <a16:creationId xmlns:a16="http://schemas.microsoft.com/office/drawing/2014/main" id="{0E09E3BD-32F3-40BC-8D68-51D66B4C7489}"/>
+                <a16:creationId xmlns:a16="http://schemas.microsoft.com/office/drawing/2014/main" id="{12907C96-0DAD-406E-945F-09BB21C525B4}"/>
               </a:ext>
             </a:extLst>
           </p:cNvPr>
@@ -4797,7 +4797,7 @@
           <p:cNvPr id="3" name="">
             <a:extLst xmlns:a="http://schemas.openxmlformats.org/drawingml/2006/main">
               <a:ext uri="{FF2B5EF4-FFF2-40B4-BE49-F238E27FC236}">
-                <a16:creationId xmlns:a16="http://schemas.microsoft.com/office/drawing/2014/main" id="{7DF275B9-7271-453C-98CF-748C0F19C88D}"/>
+                <a16:creationId xmlns:a16="http://schemas.microsoft.com/office/drawing/2014/main" id="{E12F6CD8-7EED-40DD-B28D-AC71100B2792}"/>
               </a:ext>
             </a:extLst>
           </p:cNvPr>
@@ -4847,7 +4847,7 @@
           <p:cNvPr id="4" name="">
             <a:extLst xmlns:a="http://schemas.openxmlformats.org/drawingml/2006/main">
               <a:ext uri="{FF2B5EF4-FFF2-40B4-BE49-F238E27FC236}">
-                <a16:creationId xmlns:a16="http://schemas.microsoft.com/office/drawing/2014/main" id="{F4A5FB7A-7D01-4452-B5AA-0DEAC2771072}"/>
+                <a16:creationId xmlns:a16="http://schemas.microsoft.com/office/drawing/2014/main" id="{9E09EEB7-636A-4278-B38D-80C79B5582B6}"/>
               </a:ext>
             </a:extLst>
           </p:cNvPr>
@@ -4880,7 +4880,7 @@
           <p:cNvPr id="5" name="">
             <a:extLst xmlns:a="http://schemas.openxmlformats.org/drawingml/2006/main">
               <a:ext uri="{FF2B5EF4-FFF2-40B4-BE49-F238E27FC236}">
-                <a16:creationId xmlns:a16="http://schemas.microsoft.com/office/drawing/2014/main" id="{6C876C39-D102-46C2-A209-C3DE1F1B7DC2}"/>
+                <a16:creationId xmlns:a16="http://schemas.microsoft.com/office/drawing/2014/main" id="{2280CD9B-8694-45B5-B045-F5DB09C06D51}"/>
               </a:ext>
             </a:extLst>
           </p:cNvPr>
@@ -4930,7 +4930,7 @@
           <p:cNvPr id="6" name="">
             <a:extLst xmlns:a="http://schemas.openxmlformats.org/drawingml/2006/main">
               <a:ext uri="{FF2B5EF4-FFF2-40B4-BE49-F238E27FC236}">
-                <a16:creationId xmlns:a16="http://schemas.microsoft.com/office/drawing/2014/main" id="{C7889C98-6C76-4C09-9126-1F813B48A647}"/>
+                <a16:creationId xmlns:a16="http://schemas.microsoft.com/office/drawing/2014/main" id="{613C3F8B-57CF-41C6-82C2-8053CCD3EA58}"/>
               </a:ext>
             </a:extLst>
           </p:cNvPr>
@@ -4980,7 +4980,7 @@
           <p:cNvPr id="7" name="">
             <a:extLst xmlns:a="http://schemas.openxmlformats.org/drawingml/2006/main">
               <a:ext uri="{FF2B5EF4-FFF2-40B4-BE49-F238E27FC236}">
-                <a16:creationId xmlns:a16="http://schemas.microsoft.com/office/drawing/2014/main" id="{530CCFD9-EC59-431F-97F7-65BCF755FDDB}"/>
+                <a16:creationId xmlns:a16="http://schemas.microsoft.com/office/drawing/2014/main" id="{1B418BF4-4E30-4B3B-A829-4F19006FE230}"/>
               </a:ext>
             </a:extLst>
           </p:cNvPr>
@@ -4992,11 +4992,11 @@
         <p:spPr>
           <a:xfrm xmlns:a="http://schemas.openxmlformats.org/drawingml/2006/main">
             <a:off x="685800" y="2047875"/>
-            <a:ext cx="2619375" cy="1476375"/>
+            <a:ext cx="2619375" cy="3162300"/>
           </a:xfrm>
           <a:prstGeom xmlns:a="http://schemas.openxmlformats.org/drawingml/2006/main" prst="roundRect">
             <a:avLst>
-              <a:gd name="adj" fmla="val 10323"/>
+              <a:gd name="adj" fmla="val 5818"/>
             </a:avLst>
           </a:prstGeom>
           <a:solidFill xmlns:a="http://schemas.openxmlformats.org/drawingml/2006/main">
@@ -5015,18 +5015,18 @@
           <p:cNvPr id="8" name="">
             <a:extLst xmlns:a="http://schemas.openxmlformats.org/drawingml/2006/main">
               <a:ext uri="{FF2B5EF4-FFF2-40B4-BE49-F238E27FC236}">
-                <a16:creationId xmlns:a16="http://schemas.microsoft.com/office/drawing/2014/main" id="{FF4C2FC3-B8FD-423F-AE23-E7D9508C2504}"/>
-              </a:ext>
-            </a:extLst>
-          </p:cNvPr>
-          <p:cNvSpPr>
-            <a:spLocks xmlns:a="http://schemas.openxmlformats.org/drawingml/2006/main" noGrp="1"/>
-          </p:cNvSpPr>
-          <p:nvPr/>
-        </p:nvSpPr>
-        <p:spPr>
-          <a:xfrm xmlns:a="http://schemas.openxmlformats.org/drawingml/2006/main">
-            <a:off x="876300" y="2333625"/>
+                <a16:creationId xmlns:a16="http://schemas.microsoft.com/office/drawing/2014/main" id="{7D619916-C2D7-4A78-9DD1-AC1AE4B36A51}"/>
+              </a:ext>
+            </a:extLst>
+          </p:cNvPr>
+          <p:cNvSpPr>
+            <a:spLocks xmlns:a="http://schemas.openxmlformats.org/drawingml/2006/main" noGrp="1"/>
+          </p:cNvSpPr>
+          <p:nvPr/>
+        </p:nvSpPr>
+        <p:spPr>
+          <a:xfrm xmlns:a="http://schemas.openxmlformats.org/drawingml/2006/main">
+            <a:off x="876300" y="2714625"/>
             <a:ext cx="2238375" cy="571500"/>
           </a:xfrm>
           <a:prstGeom xmlns:a="http://schemas.openxmlformats.org/drawingml/2006/main" prst="rect">
@@ -5065,18 +5065,18 @@
           <p:cNvPr id="9" name="">
             <a:extLst xmlns:a="http://schemas.openxmlformats.org/drawingml/2006/main">
               <a:ext uri="{FF2B5EF4-FFF2-40B4-BE49-F238E27FC236}">
-                <a16:creationId xmlns:a16="http://schemas.microsoft.com/office/drawing/2014/main" id="{D0CB09BC-ECB1-4370-8CFF-88F5FE55112B}"/>
-              </a:ext>
-            </a:extLst>
-          </p:cNvPr>
-          <p:cNvSpPr>
-            <a:spLocks xmlns:a="http://schemas.openxmlformats.org/drawingml/2006/main" noGrp="1"/>
-          </p:cNvSpPr>
-          <p:nvPr/>
-        </p:nvSpPr>
-        <p:spPr>
-          <a:xfrm xmlns:a="http://schemas.openxmlformats.org/drawingml/2006/main">
-            <a:off x="876300" y="2962275"/>
+                <a16:creationId xmlns:a16="http://schemas.microsoft.com/office/drawing/2014/main" id="{DE274564-5083-4C28-8E1B-CB91DE45B443}"/>
+              </a:ext>
+            </a:extLst>
+          </p:cNvPr>
+          <p:cNvSpPr>
+            <a:spLocks xmlns:a="http://schemas.openxmlformats.org/drawingml/2006/main" noGrp="1"/>
+          </p:cNvSpPr>
+          <p:nvPr/>
+        </p:nvSpPr>
+        <p:spPr>
+          <a:xfrm xmlns:a="http://schemas.openxmlformats.org/drawingml/2006/main">
+            <a:off x="876300" y="3476625"/>
             <a:ext cx="2238375" cy="304800"/>
           </a:xfrm>
           <a:prstGeom xmlns:a="http://schemas.openxmlformats.org/drawingml/2006/main" prst="rect">
@@ -5115,18 +5115,18 @@
           <p:cNvPr id="10" name="">
             <a:extLst xmlns:a="http://schemas.openxmlformats.org/drawingml/2006/main">
               <a:ext uri="{FF2B5EF4-FFF2-40B4-BE49-F238E27FC236}">
-                <a16:creationId xmlns:a16="http://schemas.microsoft.com/office/drawing/2014/main" id="{190BDB1C-DA1B-47BA-975A-C0546828D6BF}"/>
-              </a:ext>
-            </a:extLst>
-          </p:cNvPr>
-          <p:cNvSpPr>
-            <a:spLocks xmlns:a="http://schemas.openxmlformats.org/drawingml/2006/main" noGrp="1"/>
-          </p:cNvSpPr>
-          <p:nvPr/>
-        </p:nvSpPr>
-        <p:spPr>
-          <a:xfrm xmlns:a="http://schemas.openxmlformats.org/drawingml/2006/main">
-            <a:off x="876300" y="3276600"/>
+                <a16:creationId xmlns:a16="http://schemas.microsoft.com/office/drawing/2014/main" id="{A9089015-0741-4344-A9D3-F6B390CC4798}"/>
+              </a:ext>
+            </a:extLst>
+          </p:cNvPr>
+          <p:cNvSpPr>
+            <a:spLocks xmlns:a="http://schemas.openxmlformats.org/drawingml/2006/main" noGrp="1"/>
+          </p:cNvSpPr>
+          <p:nvPr/>
+        </p:nvSpPr>
+        <p:spPr>
+          <a:xfrm xmlns:a="http://schemas.openxmlformats.org/drawingml/2006/main">
+            <a:off x="876300" y="3914775"/>
             <a:ext cx="2238375" cy="228600"/>
           </a:xfrm>
           <a:prstGeom xmlns:a="http://schemas.openxmlformats.org/drawingml/2006/main" prst="rect">
@@ -5165,192 +5165,7 @@
           <p:cNvPr id="11" name="">
             <a:extLst xmlns:a="http://schemas.openxmlformats.org/drawingml/2006/main">
               <a:ext uri="{FF2B5EF4-FFF2-40B4-BE49-F238E27FC236}">
-                <a16:creationId xmlns:a16="http://schemas.microsoft.com/office/drawing/2014/main" id="{058F298B-BF32-4D22-994D-E50A15B12DA6}"/>
-              </a:ext>
-            </a:extLst>
-          </p:cNvPr>
-          <p:cNvSpPr>
-            <a:spLocks xmlns:a="http://schemas.openxmlformats.org/drawingml/2006/main" noGrp="1"/>
-          </p:cNvSpPr>
-          <p:nvPr/>
-        </p:nvSpPr>
-        <p:spPr>
-          <a:xfrm xmlns:a="http://schemas.openxmlformats.org/drawingml/2006/main">
-            <a:off x="685800" y="3733800"/>
-            <a:ext cx="2619375" cy="1476375"/>
-          </a:xfrm>
-          <a:prstGeom xmlns:a="http://schemas.openxmlformats.org/drawingml/2006/main" prst="roundRect">
-            <a:avLst>
-              <a:gd name="adj" fmla="val 10323"/>
-            </a:avLst>
-          </a:prstGeom>
-          <a:solidFill xmlns:a="http://schemas.openxmlformats.org/drawingml/2006/main">
-            <a:srgbClr val="0A1D30"/>
-          </a:solidFill>
-          <a:ln xmlns:a="http://schemas.openxmlformats.org/drawingml/2006/main" w="0">
-            <a:solidFill>
-              <a:srgbClr val="0A1D30"/>
-            </a:solidFill>
-            <a:prstDash val="solid"/>
-          </a:ln>
-        </p:spPr>
-      </p:sp>
-      <p:sp>
-        <p:nvSpPr>
-          <p:cNvPr id="12" name="">
-            <a:extLst xmlns:a="http://schemas.openxmlformats.org/drawingml/2006/main">
-              <a:ext uri="{FF2B5EF4-FFF2-40B4-BE49-F238E27FC236}">
-                <a16:creationId xmlns:a16="http://schemas.microsoft.com/office/drawing/2014/main" id="{EA4ED96E-096B-4231-A49F-4C52E736A252}"/>
-              </a:ext>
-            </a:extLst>
-          </p:cNvPr>
-          <p:cNvSpPr>
-            <a:spLocks xmlns:a="http://schemas.openxmlformats.org/drawingml/2006/main" noGrp="1"/>
-          </p:cNvSpPr>
-          <p:nvPr/>
-        </p:nvSpPr>
-        <p:spPr>
-          <a:xfrm xmlns:a="http://schemas.openxmlformats.org/drawingml/2006/main">
-            <a:off x="876300" y="4019550"/>
-            <a:ext cx="2238375" cy="571500"/>
-          </a:xfrm>
-          <a:prstGeom xmlns:a="http://schemas.openxmlformats.org/drawingml/2006/main" prst="rect">
-            <a:avLst/>
-          </a:prstGeom>
-          <a:noFill xmlns:a="http://schemas.openxmlformats.org/drawingml/2006/main"/>
-          <a:ln xmlns:a="http://schemas.openxmlformats.org/drawingml/2006/main" w="0">
-            <a:noFill/>
-            <a:prstDash val="solid"/>
-          </a:ln>
-        </p:spPr>
-        <p:txBody>
-          <a:bodyPr xmlns:a="http://schemas.openxmlformats.org/drawingml/2006/main" anchor="t"/>
-          <a:lstStyle xmlns:a="http://schemas.openxmlformats.org/drawingml/2006/main"/>
-          <a:p xmlns:a="http://schemas.openxmlformats.org/drawingml/2006/main">
-            <a:pPr algn="ctr">
-              <a:defRPr sz="3150" b="1">
-                <a:solidFill>
-                  <a:srgbClr val="61B983"/>
-                </a:solidFill>
-              </a:defRPr>
-            </a:pPr>
-            <a:r>
-              <a:rPr sz="3150" b="1">
-                <a:solidFill>
-                  <a:srgbClr val="61B983"/>
-                </a:solidFill>
-              </a:rPr>
-              <a:t>&gt;= 99.5%</a:t>
-            </a:r>
-          </a:p>
-        </p:txBody>
-      </p:sp>
-      <p:sp>
-        <p:nvSpPr>
-          <p:cNvPr id="13" name="">
-            <a:extLst xmlns:a="http://schemas.openxmlformats.org/drawingml/2006/main">
-              <a:ext uri="{FF2B5EF4-FFF2-40B4-BE49-F238E27FC236}">
-                <a16:creationId xmlns:a16="http://schemas.microsoft.com/office/drawing/2014/main" id="{D4175130-CE28-4454-9858-68990C3DA7F5}"/>
-              </a:ext>
-            </a:extLst>
-          </p:cNvPr>
-          <p:cNvSpPr>
-            <a:spLocks xmlns:a="http://schemas.openxmlformats.org/drawingml/2006/main" noGrp="1"/>
-          </p:cNvSpPr>
-          <p:nvPr/>
-        </p:nvSpPr>
-        <p:spPr>
-          <a:xfrm xmlns:a="http://schemas.openxmlformats.org/drawingml/2006/main">
-            <a:off x="876300" y="4648200"/>
-            <a:ext cx="2238375" cy="304800"/>
-          </a:xfrm>
-          <a:prstGeom xmlns:a="http://schemas.openxmlformats.org/drawingml/2006/main" prst="rect">
-            <a:avLst/>
-          </a:prstGeom>
-          <a:noFill xmlns:a="http://schemas.openxmlformats.org/drawingml/2006/main"/>
-          <a:ln xmlns:a="http://schemas.openxmlformats.org/drawingml/2006/main" w="0">
-            <a:noFill/>
-            <a:prstDash val="solid"/>
-          </a:ln>
-        </p:spPr>
-        <p:txBody>
-          <a:bodyPr xmlns:a="http://schemas.openxmlformats.org/drawingml/2006/main" anchor="t"/>
-          <a:lstStyle xmlns:a="http://schemas.openxmlformats.org/drawingml/2006/main"/>
-          <a:p xmlns:a="http://schemas.openxmlformats.org/drawingml/2006/main">
-            <a:pPr algn="ctr">
-              <a:defRPr sz="1500" b="1">
-                <a:solidFill>
-                  <a:srgbClr val="FFFFFF"/>
-                </a:solidFill>
-              </a:defRPr>
-            </a:pPr>
-            <a:r>
-              <a:rPr sz="1500" b="1">
-                <a:solidFill>
-                  <a:srgbClr val="FFFFFF"/>
-                </a:solidFill>
-              </a:rPr>
-              <a:t>benign in every split</a:t>
-            </a:r>
-          </a:p>
-        </p:txBody>
-      </p:sp>
-      <p:sp>
-        <p:nvSpPr>
-          <p:cNvPr id="14" name="">
-            <a:extLst xmlns:a="http://schemas.openxmlformats.org/drawingml/2006/main">
-              <a:ext uri="{FF2B5EF4-FFF2-40B4-BE49-F238E27FC236}">
-                <a16:creationId xmlns:a16="http://schemas.microsoft.com/office/drawing/2014/main" id="{3A85F90F-F4C7-4913-BF02-FA3735D87B19}"/>
-              </a:ext>
-            </a:extLst>
-          </p:cNvPr>
-          <p:cNvSpPr>
-            <a:spLocks xmlns:a="http://schemas.openxmlformats.org/drawingml/2006/main" noGrp="1"/>
-          </p:cNvSpPr>
-          <p:nvPr/>
-        </p:nvSpPr>
-        <p:spPr>
-          <a:xfrm xmlns:a="http://schemas.openxmlformats.org/drawingml/2006/main">
-            <a:off x="781050" y="4972050"/>
-            <a:ext cx="2428875" cy="228600"/>
-          </a:xfrm>
-          <a:prstGeom xmlns:a="http://schemas.openxmlformats.org/drawingml/2006/main" prst="rect">
-            <a:avLst/>
-          </a:prstGeom>
-          <a:noFill xmlns:a="http://schemas.openxmlformats.org/drawingml/2006/main"/>
-          <a:ln xmlns:a="http://schemas.openxmlformats.org/drawingml/2006/main" w="0">
-            <a:noFill/>
-            <a:prstDash val="solid"/>
-          </a:ln>
-        </p:spPr>
-        <p:txBody>
-          <a:bodyPr xmlns:a="http://schemas.openxmlformats.org/drawingml/2006/main" anchor="t"/>
-          <a:lstStyle xmlns:a="http://schemas.openxmlformats.org/drawingml/2006/main"/>
-          <a:p xmlns:a="http://schemas.openxmlformats.org/drawingml/2006/main">
-            <a:pPr algn="ctr">
-              <a:defRPr sz="1050" b="0">
-                <a:solidFill>
-                  <a:srgbClr val="B7CBD7"/>
-                </a:solidFill>
-              </a:defRPr>
-            </a:pPr>
-            <a:r>
-              <a:rPr sz="1050" b="0">
-                <a:solidFill>
-                  <a:srgbClr val="B7CBD7"/>
-                </a:solidFill>
-              </a:rPr>
-              <a:t>natural prevalence; no SMOTE</a:t>
-            </a:r>
-          </a:p>
-        </p:txBody>
-      </p:sp>
-      <p:sp>
-        <p:nvSpPr>
-          <p:cNvPr id="15" name="">
-            <a:extLst xmlns:a="http://schemas.openxmlformats.org/drawingml/2006/main">
-              <a:ext uri="{FF2B5EF4-FFF2-40B4-BE49-F238E27FC236}">
-                <a16:creationId xmlns:a16="http://schemas.microsoft.com/office/drawing/2014/main" id="{960733BE-7EDF-432F-A2E1-845E81ECCB16}"/>
+                <a16:creationId xmlns:a16="http://schemas.microsoft.com/office/drawing/2014/main" id="{987BA3F7-E747-4362-B18E-D685F4BF718E}"/>
               </a:ext>
             </a:extLst>
           </p:cNvPr>
@@ -5380,10 +5195,10 @@
       </p:sp>
       <p:sp>
         <p:nvSpPr>
-          <p:cNvPr id="16" name="">
-            <a:extLst xmlns:a="http://schemas.openxmlformats.org/drawingml/2006/main">
-              <a:ext uri="{FF2B5EF4-FFF2-40B4-BE49-F238E27FC236}">
-                <a16:creationId xmlns:a16="http://schemas.microsoft.com/office/drawing/2014/main" id="{8973A8AC-B256-4D37-8D24-BA19652F61FD}"/>
+          <p:cNvPr id="12" name="">
+            <a:extLst xmlns:a="http://schemas.openxmlformats.org/drawingml/2006/main">
+              <a:ext uri="{FF2B5EF4-FFF2-40B4-BE49-F238E27FC236}">
+                <a16:creationId xmlns:a16="http://schemas.microsoft.com/office/drawing/2014/main" id="{6007EEFD-D226-4257-8C9C-49635FA773D2}"/>
               </a:ext>
             </a:extLst>
           </p:cNvPr>
@@ -5430,10 +5245,10 @@
       </p:sp>
       <p:sp>
         <p:nvSpPr>
-          <p:cNvPr id="17" name="">
-            <a:extLst xmlns:a="http://schemas.openxmlformats.org/drawingml/2006/main">
-              <a:ext uri="{FF2B5EF4-FFF2-40B4-BE49-F238E27FC236}">
-                <a16:creationId xmlns:a16="http://schemas.microsoft.com/office/drawing/2014/main" id="{E6050B4B-B2C3-4354-8EBC-D5B423A421B9}"/>
+          <p:cNvPr id="13" name="">
+            <a:extLst xmlns:a="http://schemas.openxmlformats.org/drawingml/2006/main">
+              <a:ext uri="{FF2B5EF4-FFF2-40B4-BE49-F238E27FC236}">
+                <a16:creationId xmlns:a16="http://schemas.microsoft.com/office/drawing/2014/main" id="{58AA1F61-1AFD-4509-9F14-102C4CD8EE9D}"/>
               </a:ext>
             </a:extLst>
           </p:cNvPr>
@@ -5480,10 +5295,10 @@
       </p:sp>
       <p:sp>
         <p:nvSpPr>
-          <p:cNvPr id="18" name="">
-            <a:extLst xmlns:a="http://schemas.openxmlformats.org/drawingml/2006/main">
-              <a:ext uri="{FF2B5EF4-FFF2-40B4-BE49-F238E27FC236}">
-                <a16:creationId xmlns:a16="http://schemas.microsoft.com/office/drawing/2014/main" id="{9971708B-6E77-4C3F-A364-05A71ECCFCD0}"/>
+          <p:cNvPr id="14" name="">
+            <a:extLst xmlns:a="http://schemas.openxmlformats.org/drawingml/2006/main">
+              <a:ext uri="{FF2B5EF4-FFF2-40B4-BE49-F238E27FC236}">
+                <a16:creationId xmlns:a16="http://schemas.microsoft.com/office/drawing/2014/main" id="{70967E77-9E29-4C65-895A-F77344D54011}"/>
               </a:ext>
             </a:extLst>
           </p:cNvPr>
@@ -5513,10 +5328,10 @@
       </p:sp>
       <p:sp>
         <p:nvSpPr>
-          <p:cNvPr id="19" name="">
-            <a:extLst xmlns:a="http://schemas.openxmlformats.org/drawingml/2006/main">
-              <a:ext uri="{FF2B5EF4-FFF2-40B4-BE49-F238E27FC236}">
-                <a16:creationId xmlns:a16="http://schemas.microsoft.com/office/drawing/2014/main" id="{25E423D7-A941-4449-8A7F-2C1253A439AA}"/>
+          <p:cNvPr id="15" name="">
+            <a:extLst xmlns:a="http://schemas.openxmlformats.org/drawingml/2006/main">
+              <a:ext uri="{FF2B5EF4-FFF2-40B4-BE49-F238E27FC236}">
+                <a16:creationId xmlns:a16="http://schemas.microsoft.com/office/drawing/2014/main" id="{7A2B67F3-94B5-4E7B-B2AF-0A2F0051D8B6}"/>
               </a:ext>
             </a:extLst>
           </p:cNvPr>
@@ -5563,10 +5378,10 @@
       </p:sp>
       <p:sp>
         <p:nvSpPr>
-          <p:cNvPr id="20" name="">
-            <a:extLst xmlns:a="http://schemas.openxmlformats.org/drawingml/2006/main">
-              <a:ext uri="{FF2B5EF4-FFF2-40B4-BE49-F238E27FC236}">
-                <a16:creationId xmlns:a16="http://schemas.microsoft.com/office/drawing/2014/main" id="{6B3CA973-BB76-4837-8D49-6D9AA517871B}"/>
+          <p:cNvPr id="16" name="">
+            <a:extLst xmlns:a="http://schemas.openxmlformats.org/drawingml/2006/main">
+              <a:ext uri="{FF2B5EF4-FFF2-40B4-BE49-F238E27FC236}">
+                <a16:creationId xmlns:a16="http://schemas.microsoft.com/office/drawing/2014/main" id="{E8761B84-4338-48DA-AC65-B0D8DC76539C}"/>
               </a:ext>
             </a:extLst>
           </p:cNvPr>
@@ -5596,10 +5411,10 @@
       </p:sp>
       <p:sp>
         <p:nvSpPr>
-          <p:cNvPr id="21" name="">
-            <a:extLst xmlns:a="http://schemas.openxmlformats.org/drawingml/2006/main">
-              <a:ext uri="{FF2B5EF4-FFF2-40B4-BE49-F238E27FC236}">
-                <a16:creationId xmlns:a16="http://schemas.microsoft.com/office/drawing/2014/main" id="{B6E6DF6B-8236-49C8-B3DD-C5B5636F5AF6}"/>
+          <p:cNvPr id="17" name="">
+            <a:extLst xmlns:a="http://schemas.openxmlformats.org/drawingml/2006/main">
+              <a:ext uri="{FF2B5EF4-FFF2-40B4-BE49-F238E27FC236}">
+                <a16:creationId xmlns:a16="http://schemas.microsoft.com/office/drawing/2014/main" id="{57AF6620-B389-499F-9ADA-DC2BEC32270D}"/>
               </a:ext>
             </a:extLst>
           </p:cNvPr>
@@ -5646,10 +5461,10 @@
       </p:sp>
       <p:sp>
         <p:nvSpPr>
-          <p:cNvPr id="22" name="">
-            <a:extLst xmlns:a="http://schemas.openxmlformats.org/drawingml/2006/main">
-              <a:ext uri="{FF2B5EF4-FFF2-40B4-BE49-F238E27FC236}">
-                <a16:creationId xmlns:a16="http://schemas.microsoft.com/office/drawing/2014/main" id="{B512EA32-7072-4A77-8D16-8CF37F4D67BC}"/>
+          <p:cNvPr id="18" name="">
+            <a:extLst xmlns:a="http://schemas.openxmlformats.org/drawingml/2006/main">
+              <a:ext uri="{FF2B5EF4-FFF2-40B4-BE49-F238E27FC236}">
+                <a16:creationId xmlns:a16="http://schemas.microsoft.com/office/drawing/2014/main" id="{A4549585-9ACC-44AE-8ECB-B65F02155DD8}"/>
               </a:ext>
             </a:extLst>
           </p:cNvPr>
@@ -5679,10 +5494,10 @@
       </p:sp>
       <p:sp>
         <p:nvSpPr>
-          <p:cNvPr id="23" name="">
-            <a:extLst xmlns:a="http://schemas.openxmlformats.org/drawingml/2006/main">
-              <a:ext uri="{FF2B5EF4-FFF2-40B4-BE49-F238E27FC236}">
-                <a16:creationId xmlns:a16="http://schemas.microsoft.com/office/drawing/2014/main" id="{2F54CCEE-C8E8-4A67-80DA-07771DDD459F}"/>
+          <p:cNvPr id="19" name="">
+            <a:extLst xmlns:a="http://schemas.openxmlformats.org/drawingml/2006/main">
+              <a:ext uri="{FF2B5EF4-FFF2-40B4-BE49-F238E27FC236}">
+                <a16:creationId xmlns:a16="http://schemas.microsoft.com/office/drawing/2014/main" id="{B37FFA83-9488-41A6-BC4A-49EF98C83AFD}"/>
               </a:ext>
             </a:extLst>
           </p:cNvPr>
@@ -5729,10 +5544,10 @@
       </p:sp>
       <p:sp>
         <p:nvSpPr>
-          <p:cNvPr id="24" name="">
-            <a:extLst xmlns:a="http://schemas.openxmlformats.org/drawingml/2006/main">
-              <a:ext uri="{FF2B5EF4-FFF2-40B4-BE49-F238E27FC236}">
-                <a16:creationId xmlns:a16="http://schemas.microsoft.com/office/drawing/2014/main" id="{54C6B969-0664-4269-AFAB-C1ADED7A4B1D}"/>
+          <p:cNvPr id="20" name="">
+            <a:extLst xmlns:a="http://schemas.openxmlformats.org/drawingml/2006/main">
+              <a:ext uri="{FF2B5EF4-FFF2-40B4-BE49-F238E27FC236}">
+                <a16:creationId xmlns:a16="http://schemas.microsoft.com/office/drawing/2014/main" id="{85E22E0E-9AA3-4883-A8B7-FEB4F4045577}"/>
               </a:ext>
             </a:extLst>
           </p:cNvPr>
@@ -5762,10 +5577,10 @@
       </p:sp>
       <p:sp>
         <p:nvSpPr>
-          <p:cNvPr id="25" name="">
-            <a:extLst xmlns:a="http://schemas.openxmlformats.org/drawingml/2006/main">
-              <a:ext uri="{FF2B5EF4-FFF2-40B4-BE49-F238E27FC236}">
-                <a16:creationId xmlns:a16="http://schemas.microsoft.com/office/drawing/2014/main" id="{7FE127A5-FD2B-427B-BD62-BEE206F175D5}"/>
+          <p:cNvPr id="21" name="">
+            <a:extLst xmlns:a="http://schemas.openxmlformats.org/drawingml/2006/main">
+              <a:ext uri="{FF2B5EF4-FFF2-40B4-BE49-F238E27FC236}">
+                <a16:creationId xmlns:a16="http://schemas.microsoft.com/office/drawing/2014/main" id="{19738B82-C841-46DA-AD1B-5028EFEB5AEF}"/>
               </a:ext>
             </a:extLst>
           </p:cNvPr>
@@ -5812,10 +5627,10 @@
       </p:sp>
       <p:sp>
         <p:nvSpPr>
-          <p:cNvPr id="26" name="">
-            <a:extLst xmlns:a="http://schemas.openxmlformats.org/drawingml/2006/main">
-              <a:ext uri="{FF2B5EF4-FFF2-40B4-BE49-F238E27FC236}">
-                <a16:creationId xmlns:a16="http://schemas.microsoft.com/office/drawing/2014/main" id="{9A74AFC2-0570-4CE6-829E-52926B59985C}"/>
+          <p:cNvPr id="22" name="">
+            <a:extLst xmlns:a="http://schemas.openxmlformats.org/drawingml/2006/main">
+              <a:ext uri="{FF2B5EF4-FFF2-40B4-BE49-F238E27FC236}">
+                <a16:creationId xmlns:a16="http://schemas.microsoft.com/office/drawing/2014/main" id="{D9A737EB-5EEA-4557-B425-351178C7B9E1}"/>
               </a:ext>
             </a:extLst>
           </p:cNvPr>
@@ -5862,10 +5677,10 @@
       </p:sp>
       <p:sp>
         <p:nvSpPr>
-          <p:cNvPr id="27" name="">
-            <a:extLst xmlns:a="http://schemas.openxmlformats.org/drawingml/2006/main">
-              <a:ext uri="{FF2B5EF4-FFF2-40B4-BE49-F238E27FC236}">
-                <a16:creationId xmlns:a16="http://schemas.microsoft.com/office/drawing/2014/main" id="{79088A58-366A-4913-A5B2-B6AD5382F20E}"/>
+          <p:cNvPr id="23" name="">
+            <a:extLst xmlns:a="http://schemas.openxmlformats.org/drawingml/2006/main">
+              <a:ext uri="{FF2B5EF4-FFF2-40B4-BE49-F238E27FC236}">
+                <a16:creationId xmlns:a16="http://schemas.microsoft.com/office/drawing/2014/main" id="{3EC16436-FD14-4B76-B486-F343588C38BC}"/>
               </a:ext>
             </a:extLst>
           </p:cNvPr>
@@ -5912,10 +5727,10 @@
       </p:sp>
       <p:sp>
         <p:nvSpPr>
-          <p:cNvPr id="28" name="">
-            <a:extLst xmlns:a="http://schemas.openxmlformats.org/drawingml/2006/main">
-              <a:ext uri="{FF2B5EF4-FFF2-40B4-BE49-F238E27FC236}">
-                <a16:creationId xmlns:a16="http://schemas.microsoft.com/office/drawing/2014/main" id="{754DD035-0501-4164-A217-85F0ECAA631B}"/>
+          <p:cNvPr id="24" name="">
+            <a:extLst xmlns:a="http://schemas.openxmlformats.org/drawingml/2006/main">
+              <a:ext uri="{FF2B5EF4-FFF2-40B4-BE49-F238E27FC236}">
+                <a16:creationId xmlns:a16="http://schemas.microsoft.com/office/drawing/2014/main" id="{69367DDA-15BC-4784-8951-6E7B19CEDC68}"/>
               </a:ext>
             </a:extLst>
           </p:cNvPr>
@@ -5962,10 +5777,10 @@
       </p:sp>
       <p:sp>
         <p:nvSpPr>
-          <p:cNvPr id="29" name="">
-            <a:extLst xmlns:a="http://schemas.openxmlformats.org/drawingml/2006/main">
-              <a:ext uri="{FF2B5EF4-FFF2-40B4-BE49-F238E27FC236}">
-                <a16:creationId xmlns:a16="http://schemas.microsoft.com/office/drawing/2014/main" id="{2449AA73-0115-49BA-960B-6D3605F0B86D}"/>
+          <p:cNvPr id="25" name="">
+            <a:extLst xmlns:a="http://schemas.openxmlformats.org/drawingml/2006/main">
+              <a:ext uri="{FF2B5EF4-FFF2-40B4-BE49-F238E27FC236}">
+                <a16:creationId xmlns:a16="http://schemas.microsoft.com/office/drawing/2014/main" id="{469EEA84-DB18-4C42-B3ED-DEAF2ACCEE69}"/>
               </a:ext>
             </a:extLst>
           </p:cNvPr>
@@ -6012,10 +5827,10 @@
       </p:sp>
       <p:sp>
         <p:nvSpPr>
-          <p:cNvPr id="30" name="">
-            <a:extLst xmlns:a="http://schemas.openxmlformats.org/drawingml/2006/main">
-              <a:ext uri="{FF2B5EF4-FFF2-40B4-BE49-F238E27FC236}">
-                <a16:creationId xmlns:a16="http://schemas.microsoft.com/office/drawing/2014/main" id="{02CD6863-D60A-4A1C-AC70-BA6A7402E384}"/>
+          <p:cNvPr id="26" name="">
+            <a:extLst xmlns:a="http://schemas.openxmlformats.org/drawingml/2006/main">
+              <a:ext uri="{FF2B5EF4-FFF2-40B4-BE49-F238E27FC236}">
+                <a16:creationId xmlns:a16="http://schemas.microsoft.com/office/drawing/2014/main" id="{70D6AF29-EB87-4B33-8E51-1F9843382F7D}"/>
               </a:ext>
             </a:extLst>
           </p:cNvPr>
@@ -6062,10 +5877,10 @@
       </p:sp>
       <p:sp>
         <p:nvSpPr>
-          <p:cNvPr id="31" name="">
-            <a:extLst xmlns:a="http://schemas.openxmlformats.org/drawingml/2006/main">
-              <a:ext uri="{FF2B5EF4-FFF2-40B4-BE49-F238E27FC236}">
-                <a16:creationId xmlns:a16="http://schemas.microsoft.com/office/drawing/2014/main" id="{D20CF2B4-00E2-4ACE-A4B6-FAC5B8AFDE45}"/>
+          <p:cNvPr id="27" name="">
+            <a:extLst xmlns:a="http://schemas.openxmlformats.org/drawingml/2006/main">
+              <a:ext uri="{FF2B5EF4-FFF2-40B4-BE49-F238E27FC236}">
+                <a16:creationId xmlns:a16="http://schemas.microsoft.com/office/drawing/2014/main" id="{C6E327D4-DA38-4011-8C3A-8147886A0B78}"/>
               </a:ext>
             </a:extLst>
           </p:cNvPr>
@@ -6112,10 +5927,10 @@
       </p:sp>
       <p:sp>
         <p:nvSpPr>
-          <p:cNvPr id="32" name="">
-            <a:extLst xmlns:a="http://schemas.openxmlformats.org/drawingml/2006/main">
-              <a:ext uri="{FF2B5EF4-FFF2-40B4-BE49-F238E27FC236}">
-                <a16:creationId xmlns:a16="http://schemas.microsoft.com/office/drawing/2014/main" id="{FB6A81AA-0204-4EBB-B1E3-27FF3AAE4E3D}"/>
+          <p:cNvPr id="28" name="">
+            <a:extLst xmlns:a="http://schemas.openxmlformats.org/drawingml/2006/main">
+              <a:ext uri="{FF2B5EF4-FFF2-40B4-BE49-F238E27FC236}">
+                <a16:creationId xmlns:a16="http://schemas.microsoft.com/office/drawing/2014/main" id="{06BDD66B-D8E2-4293-A61F-3DB0C5E4EB68}"/>
               </a:ext>
             </a:extLst>
           </p:cNvPr>
@@ -6147,10 +5962,10 @@
       </p:sp>
       <p:sp>
         <p:nvSpPr>
-          <p:cNvPr id="33" name="">
-            <a:extLst xmlns:a="http://schemas.openxmlformats.org/drawingml/2006/main">
-              <a:ext uri="{FF2B5EF4-FFF2-40B4-BE49-F238E27FC236}">
-                <a16:creationId xmlns:a16="http://schemas.microsoft.com/office/drawing/2014/main" id="{83907A33-5A90-412D-A03B-551B32BEA4D6}"/>
+          <p:cNvPr id="29" name="">
+            <a:extLst xmlns:a="http://schemas.openxmlformats.org/drawingml/2006/main">
+              <a:ext uri="{FF2B5EF4-FFF2-40B4-BE49-F238E27FC236}">
+                <a16:creationId xmlns:a16="http://schemas.microsoft.com/office/drawing/2014/main" id="{CC682E50-E921-42F9-8A11-ACEA8C82B956}"/>
               </a:ext>
             </a:extLst>
           </p:cNvPr>
@@ -6197,10 +6012,10 @@
       </p:sp>
       <p:sp>
         <p:nvSpPr>
-          <p:cNvPr id="34" name="">
-            <a:extLst xmlns:a="http://schemas.openxmlformats.org/drawingml/2006/main">
-              <a:ext uri="{FF2B5EF4-FFF2-40B4-BE49-F238E27FC236}">
-                <a16:creationId xmlns:a16="http://schemas.microsoft.com/office/drawing/2014/main" id="{7C86E612-F6BB-4591-BABE-1CF6C949D356}"/>
+          <p:cNvPr id="30" name="">
+            <a:extLst xmlns:a="http://schemas.openxmlformats.org/drawingml/2006/main">
+              <a:ext uri="{FF2B5EF4-FFF2-40B4-BE49-F238E27FC236}">
+                <a16:creationId xmlns:a16="http://schemas.microsoft.com/office/drawing/2014/main" id="{0074E69E-6B4C-43C9-AFB7-F24E59509193}"/>
               </a:ext>
             </a:extLst>
           </p:cNvPr>
@@ -6230,10 +6045,10 @@
       </p:sp>
       <p:sp>
         <p:nvSpPr>
-          <p:cNvPr id="35" name="">
-            <a:extLst xmlns:a="http://schemas.openxmlformats.org/drawingml/2006/main">
-              <a:ext uri="{FF2B5EF4-FFF2-40B4-BE49-F238E27FC236}">
-                <a16:creationId xmlns:a16="http://schemas.microsoft.com/office/drawing/2014/main" id="{E55E5D09-33AE-47EE-B53D-70FFE7603FB4}"/>
+          <p:cNvPr id="31" name="">
+            <a:extLst xmlns:a="http://schemas.openxmlformats.org/drawingml/2006/main">
+              <a:ext uri="{FF2B5EF4-FFF2-40B4-BE49-F238E27FC236}">
+                <a16:creationId xmlns:a16="http://schemas.microsoft.com/office/drawing/2014/main" id="{8E73F77B-B295-4FA7-BD32-3615ADA39DD8}"/>
               </a:ext>
             </a:extLst>
           </p:cNvPr>
@@ -6280,10 +6095,10 @@
       </p:sp>
       <p:sp>
         <p:nvSpPr>
-          <p:cNvPr id="36" name="">
-            <a:extLst xmlns:a="http://schemas.openxmlformats.org/drawingml/2006/main">
-              <a:ext uri="{FF2B5EF4-FFF2-40B4-BE49-F238E27FC236}">
-                <a16:creationId xmlns:a16="http://schemas.microsoft.com/office/drawing/2014/main" id="{70324DBB-4A99-424B-B40F-EBDB6EF881C7}"/>
+          <p:cNvPr id="32" name="">
+            <a:extLst xmlns:a="http://schemas.openxmlformats.org/drawingml/2006/main">
+              <a:ext uri="{FF2B5EF4-FFF2-40B4-BE49-F238E27FC236}">
+                <a16:creationId xmlns:a16="http://schemas.microsoft.com/office/drawing/2014/main" id="{7B7AD979-8AB3-4FCA-A248-08A977E6F94D}"/>
               </a:ext>
             </a:extLst>
           </p:cNvPr>
@@ -6331,7 +6146,7 @@
     </p:spTree>
     <p:extLst>
       <p:ext uri="{BB962C8B-B14F-4D97-AF65-F5344CB8AC3E}">
-        <p14:creationId xmlns:p14="http://schemas.microsoft.com/office/powerpoint/2010/main" val="1733062305"/>
+        <p14:creationId xmlns:p14="http://schemas.microsoft.com/office/powerpoint/2010/main" val="1133181411"/>
       </p:ext>
     </p:extLst>
   </p:cSld>
@@ -6362,7 +6177,7 @@
           <p:cNvPr id="36" name="">
             <a:extLst xmlns:a="http://schemas.openxmlformats.org/drawingml/2006/main">
               <a:ext uri="{FF2B5EF4-FFF2-40B4-BE49-F238E27FC236}">
-                <a16:creationId xmlns:a16="http://schemas.microsoft.com/office/drawing/2014/main" id="{57BCB919-910D-4BA8-86B5-CD41C7F41419}"/>
+                <a16:creationId xmlns:a16="http://schemas.microsoft.com/office/drawing/2014/main" id="{DB4D8FAA-7A6E-4DBC-9397-3104448171DC}"/>
               </a:ext>
             </a:extLst>
           </p:cNvPr>
@@ -6412,7 +6227,7 @@
           <p:cNvPr id="2" name="">
             <a:extLst xmlns:a="http://schemas.openxmlformats.org/drawingml/2006/main">
               <a:ext uri="{FF2B5EF4-FFF2-40B4-BE49-F238E27FC236}">
-                <a16:creationId xmlns:a16="http://schemas.microsoft.com/office/drawing/2014/main" id="{969BA874-7A0D-46F3-9638-5D405BD47D96}"/>
+                <a16:creationId xmlns:a16="http://schemas.microsoft.com/office/drawing/2014/main" id="{76F52D2E-C5FD-4CAE-B55F-0296C71F045C}"/>
               </a:ext>
             </a:extLst>
           </p:cNvPr>
@@ -6462,7 +6277,7 @@
           <p:cNvPr id="3" name="">
             <a:extLst xmlns:a="http://schemas.openxmlformats.org/drawingml/2006/main">
               <a:ext uri="{FF2B5EF4-FFF2-40B4-BE49-F238E27FC236}">
-                <a16:creationId xmlns:a16="http://schemas.microsoft.com/office/drawing/2014/main" id="{B5417868-83A8-4DAC-8317-11648CFA655E}"/>
+                <a16:creationId xmlns:a16="http://schemas.microsoft.com/office/drawing/2014/main" id="{FFAE5BAA-4E5D-455D-AD59-51A1AAEB8AED}"/>
               </a:ext>
             </a:extLst>
           </p:cNvPr>
@@ -6512,7 +6327,7 @@
           <p:cNvPr id="4" name="">
             <a:extLst xmlns:a="http://schemas.openxmlformats.org/drawingml/2006/main">
               <a:ext uri="{FF2B5EF4-FFF2-40B4-BE49-F238E27FC236}">
-                <a16:creationId xmlns:a16="http://schemas.microsoft.com/office/drawing/2014/main" id="{609AAAF0-200A-4AC2-AFAB-8A3C5A9491D6}"/>
+                <a16:creationId xmlns:a16="http://schemas.microsoft.com/office/drawing/2014/main" id="{5D045B7D-D217-4155-8270-F26C0F6899EE}"/>
               </a:ext>
             </a:extLst>
           </p:cNvPr>
@@ -6545,7 +6360,7 @@
           <p:cNvPr id="5" name="">
             <a:extLst xmlns:a="http://schemas.openxmlformats.org/drawingml/2006/main">
               <a:ext uri="{FF2B5EF4-FFF2-40B4-BE49-F238E27FC236}">
-                <a16:creationId xmlns:a16="http://schemas.microsoft.com/office/drawing/2014/main" id="{B30DDB56-6C53-456D-BE89-E3DAFE461875}"/>
+                <a16:creationId xmlns:a16="http://schemas.microsoft.com/office/drawing/2014/main" id="{5ACE5C06-3D62-4AD3-97A0-BF3780961773}"/>
               </a:ext>
             </a:extLst>
           </p:cNvPr>
@@ -6585,7 +6400,7 @@
                   <a:srgbClr val="0A1D30"/>
                 </a:solidFill>
               </a:rPr>
-              <a:t>Every remaining comment maps to tested evidence</a:t>
+              <a:t>Every professor comment maps to tested evidence</a:t>
             </a:r>
           </a:p>
         </p:txBody>
@@ -6595,7 +6410,7 @@
           <p:cNvPr id="6" name="">
             <a:extLst xmlns:a="http://schemas.openxmlformats.org/drawingml/2006/main">
               <a:ext uri="{FF2B5EF4-FFF2-40B4-BE49-F238E27FC236}">
-                <a16:creationId xmlns:a16="http://schemas.microsoft.com/office/drawing/2014/main" id="{458477E6-36EB-46DF-BC86-968BE0B50514}"/>
+                <a16:creationId xmlns:a16="http://schemas.microsoft.com/office/drawing/2014/main" id="{5E7A98A0-DB22-4A7D-94C1-C4BFBE1BDAA2}"/>
               </a:ext>
             </a:extLst>
           </p:cNvPr>
@@ -6645,7 +6460,7 @@
           <p:cNvPr id="7" name="">
             <a:extLst xmlns:a="http://schemas.openxmlformats.org/drawingml/2006/main">
               <a:ext uri="{FF2B5EF4-FFF2-40B4-BE49-F238E27FC236}">
-                <a16:creationId xmlns:a16="http://schemas.microsoft.com/office/drawing/2014/main" id="{91D1D018-D38D-4396-91DC-BCB132ED1A5F}"/>
+                <a16:creationId xmlns:a16="http://schemas.microsoft.com/office/drawing/2014/main" id="{F4C0E9E9-AF9F-47C1-9566-DEDF41B2B9A6}"/>
               </a:ext>
             </a:extLst>
           </p:cNvPr>
@@ -6695,7 +6510,7 @@
           <p:cNvPr id="8" name="">
             <a:extLst xmlns:a="http://schemas.openxmlformats.org/drawingml/2006/main">
               <a:ext uri="{FF2B5EF4-FFF2-40B4-BE49-F238E27FC236}">
-                <a16:creationId xmlns:a16="http://schemas.microsoft.com/office/drawing/2014/main" id="{F6183345-CBDF-46C6-A797-1201AAE2B66B}"/>
+                <a16:creationId xmlns:a16="http://schemas.microsoft.com/office/drawing/2014/main" id="{EFC66608-54F4-41F3-A077-7AC61D987F49}"/>
               </a:ext>
             </a:extLst>
           </p:cNvPr>
@@ -6745,7 +6560,7 @@
           <p:cNvPr id="9" name="">
             <a:extLst xmlns:a="http://schemas.openxmlformats.org/drawingml/2006/main">
               <a:ext uri="{FF2B5EF4-FFF2-40B4-BE49-F238E27FC236}">
-                <a16:creationId xmlns:a16="http://schemas.microsoft.com/office/drawing/2014/main" id="{EFB66E94-1022-4C21-972E-D13FF52FE1B0}"/>
+                <a16:creationId xmlns:a16="http://schemas.microsoft.com/office/drawing/2014/main" id="{BC1BC8A8-1AE5-4CBC-AFAF-DA1714DA0DC3}"/>
               </a:ext>
             </a:extLst>
           </p:cNvPr>
@@ -6795,7 +6610,7 @@
           <p:cNvPr id="10" name="">
             <a:extLst xmlns:a="http://schemas.openxmlformats.org/drawingml/2006/main">
               <a:ext uri="{FF2B5EF4-FFF2-40B4-BE49-F238E27FC236}">
-                <a16:creationId xmlns:a16="http://schemas.microsoft.com/office/drawing/2014/main" id="{23408689-856A-4045-BD0A-1B064E880F1C}"/>
+                <a16:creationId xmlns:a16="http://schemas.microsoft.com/office/drawing/2014/main" id="{30740231-8317-4650-B161-A6DA6A61E12E}"/>
               </a:ext>
             </a:extLst>
           </p:cNvPr>
@@ -6828,7 +6643,7 @@
           <p:cNvPr id="11" name="">
             <a:extLst xmlns:a="http://schemas.openxmlformats.org/drawingml/2006/main">
               <a:ext uri="{FF2B5EF4-FFF2-40B4-BE49-F238E27FC236}">
-                <a16:creationId xmlns:a16="http://schemas.microsoft.com/office/drawing/2014/main" id="{8A686811-FD96-4BAB-A589-85D08E950892}"/>
+                <a16:creationId xmlns:a16="http://schemas.microsoft.com/office/drawing/2014/main" id="{AA528900-C3F2-48B7-A1CA-0DBC8D69ECA1}"/>
               </a:ext>
             </a:extLst>
           </p:cNvPr>
@@ -6878,7 +6693,7 @@
           <p:cNvPr id="12" name="">
             <a:extLst xmlns:a="http://schemas.openxmlformats.org/drawingml/2006/main">
               <a:ext uri="{FF2B5EF4-FFF2-40B4-BE49-F238E27FC236}">
-                <a16:creationId xmlns:a16="http://schemas.microsoft.com/office/drawing/2014/main" id="{26576F40-4AAC-46E7-891E-66A4FEEA5485}"/>
+                <a16:creationId xmlns:a16="http://schemas.microsoft.com/office/drawing/2014/main" id="{4FD2C792-8151-4D3D-9A2B-D22216FE52B6}"/>
               </a:ext>
             </a:extLst>
           </p:cNvPr>
@@ -6928,7 +6743,7 @@
           <p:cNvPr id="13" name="">
             <a:extLst xmlns:a="http://schemas.openxmlformats.org/drawingml/2006/main">
               <a:ext uri="{FF2B5EF4-FFF2-40B4-BE49-F238E27FC236}">
-                <a16:creationId xmlns:a16="http://schemas.microsoft.com/office/drawing/2014/main" id="{6DB8C6B2-29ED-46EC-8479-695C583560E0}"/>
+                <a16:creationId xmlns:a16="http://schemas.microsoft.com/office/drawing/2014/main" id="{6A815554-7461-4073-8873-5CF93DBE6C31}"/>
               </a:ext>
             </a:extLst>
           </p:cNvPr>
@@ -6978,7 +6793,7 @@
           <p:cNvPr id="14" name="">
             <a:extLst xmlns:a="http://schemas.openxmlformats.org/drawingml/2006/main">
               <a:ext uri="{FF2B5EF4-FFF2-40B4-BE49-F238E27FC236}">
-                <a16:creationId xmlns:a16="http://schemas.microsoft.com/office/drawing/2014/main" id="{A19A99A2-D73A-4065-97CA-9BD51A276330}"/>
+                <a16:creationId xmlns:a16="http://schemas.microsoft.com/office/drawing/2014/main" id="{A1B6144B-B9EC-427F-98B1-6ECD0373ED43}"/>
               </a:ext>
             </a:extLst>
           </p:cNvPr>
@@ -7028,7 +6843,7 @@
           <p:cNvPr id="15" name="">
             <a:extLst xmlns:a="http://schemas.openxmlformats.org/drawingml/2006/main">
               <a:ext uri="{FF2B5EF4-FFF2-40B4-BE49-F238E27FC236}">
-                <a16:creationId xmlns:a16="http://schemas.microsoft.com/office/drawing/2014/main" id="{95CCDDE4-AC03-4867-832F-1BB0B44BC4D2}"/>
+                <a16:creationId xmlns:a16="http://schemas.microsoft.com/office/drawing/2014/main" id="{8985A988-702B-44BC-9F8D-B8C79FE86796}"/>
               </a:ext>
             </a:extLst>
           </p:cNvPr>
@@ -7061,7 +6876,7 @@
           <p:cNvPr id="16" name="">
             <a:extLst xmlns:a="http://schemas.openxmlformats.org/drawingml/2006/main">
               <a:ext uri="{FF2B5EF4-FFF2-40B4-BE49-F238E27FC236}">
-                <a16:creationId xmlns:a16="http://schemas.microsoft.com/office/drawing/2014/main" id="{4BC31C31-7BC1-4585-A5F0-59E3C061FC11}"/>
+                <a16:creationId xmlns:a16="http://schemas.microsoft.com/office/drawing/2014/main" id="{10520D1E-F045-41BB-B591-531A49C64D12}"/>
               </a:ext>
             </a:extLst>
           </p:cNvPr>
@@ -7111,7 +6926,7 @@
           <p:cNvPr id="17" name="">
             <a:extLst xmlns:a="http://schemas.openxmlformats.org/drawingml/2006/main">
               <a:ext uri="{FF2B5EF4-FFF2-40B4-BE49-F238E27FC236}">
-                <a16:creationId xmlns:a16="http://schemas.microsoft.com/office/drawing/2014/main" id="{616D2905-C051-438A-BA86-C0937D56A1C9}"/>
+                <a16:creationId xmlns:a16="http://schemas.microsoft.com/office/drawing/2014/main" id="{29C3448E-7EF9-416A-8F19-EC903BF8C557}"/>
               </a:ext>
             </a:extLst>
           </p:cNvPr>
@@ -7161,7 +6976,7 @@
           <p:cNvPr id="18" name="">
             <a:extLst xmlns:a="http://schemas.openxmlformats.org/drawingml/2006/main">
               <a:ext uri="{FF2B5EF4-FFF2-40B4-BE49-F238E27FC236}">
-                <a16:creationId xmlns:a16="http://schemas.microsoft.com/office/drawing/2014/main" id="{02E4E912-E477-443C-8B0B-312793DD2EFE}"/>
+                <a16:creationId xmlns:a16="http://schemas.microsoft.com/office/drawing/2014/main" id="{51556D59-EF71-4A20-84F7-4280EBBADCBD}"/>
               </a:ext>
             </a:extLst>
           </p:cNvPr>
@@ -7211,7 +7026,7 @@
           <p:cNvPr id="19" name="">
             <a:extLst xmlns:a="http://schemas.openxmlformats.org/drawingml/2006/main">
               <a:ext uri="{FF2B5EF4-FFF2-40B4-BE49-F238E27FC236}">
-                <a16:creationId xmlns:a16="http://schemas.microsoft.com/office/drawing/2014/main" id="{16A1D848-1FA9-4550-B0A1-7A373174CC46}"/>
+                <a16:creationId xmlns:a16="http://schemas.microsoft.com/office/drawing/2014/main" id="{A3C5D6AF-EF5B-4AFA-8131-9BE9D871C7AE}"/>
               </a:ext>
             </a:extLst>
           </p:cNvPr>
@@ -7261,7 +7076,7 @@
           <p:cNvPr id="20" name="">
             <a:extLst xmlns:a="http://schemas.openxmlformats.org/drawingml/2006/main">
               <a:ext uri="{FF2B5EF4-FFF2-40B4-BE49-F238E27FC236}">
-                <a16:creationId xmlns:a16="http://schemas.microsoft.com/office/drawing/2014/main" id="{7972FDE6-38A7-4918-B928-4118CECD56E1}"/>
+                <a16:creationId xmlns:a16="http://schemas.microsoft.com/office/drawing/2014/main" id="{BF35ED8E-7091-4B88-ABAA-95D765DD1D2F}"/>
               </a:ext>
             </a:extLst>
           </p:cNvPr>
@@ -7294,7 +7109,7 @@
           <p:cNvPr id="21" name="">
             <a:extLst xmlns:a="http://schemas.openxmlformats.org/drawingml/2006/main">
               <a:ext uri="{FF2B5EF4-FFF2-40B4-BE49-F238E27FC236}">
-                <a16:creationId xmlns:a16="http://schemas.microsoft.com/office/drawing/2014/main" id="{A6B78A59-E871-41AB-BD47-9F665764410D}"/>
+                <a16:creationId xmlns:a16="http://schemas.microsoft.com/office/drawing/2014/main" id="{798000F0-15A7-4BF0-A3C1-270F6F3EFA69}"/>
               </a:ext>
             </a:extLst>
           </p:cNvPr>
@@ -7344,7 +7159,7 @@
           <p:cNvPr id="22" name="">
             <a:extLst xmlns:a="http://schemas.openxmlformats.org/drawingml/2006/main">
               <a:ext uri="{FF2B5EF4-FFF2-40B4-BE49-F238E27FC236}">
-                <a16:creationId xmlns:a16="http://schemas.microsoft.com/office/drawing/2014/main" id="{7B07C465-A515-473B-8B37-72E1F6ADFA63}"/>
+                <a16:creationId xmlns:a16="http://schemas.microsoft.com/office/drawing/2014/main" id="{0640AD11-6DF3-44AE-AD82-030F9AF9C084}"/>
               </a:ext>
             </a:extLst>
           </p:cNvPr>
@@ -7394,7 +7209,7 @@
           <p:cNvPr id="23" name="">
             <a:extLst xmlns:a="http://schemas.openxmlformats.org/drawingml/2006/main">
               <a:ext uri="{FF2B5EF4-FFF2-40B4-BE49-F238E27FC236}">
-                <a16:creationId xmlns:a16="http://schemas.microsoft.com/office/drawing/2014/main" id="{B70FC64D-99F4-4A74-98A3-6D22695A11FF}"/>
+                <a16:creationId xmlns:a16="http://schemas.microsoft.com/office/drawing/2014/main" id="{169874AF-FFE4-4E4A-B003-99179B7A31B9}"/>
               </a:ext>
             </a:extLst>
           </p:cNvPr>
@@ -7444,7 +7259,7 @@
           <p:cNvPr id="24" name="">
             <a:extLst xmlns:a="http://schemas.openxmlformats.org/drawingml/2006/main">
               <a:ext uri="{FF2B5EF4-FFF2-40B4-BE49-F238E27FC236}">
-                <a16:creationId xmlns:a16="http://schemas.microsoft.com/office/drawing/2014/main" id="{927440D3-FDF1-41CE-A71E-1DCDA0B5DA5B}"/>
+                <a16:creationId xmlns:a16="http://schemas.microsoft.com/office/drawing/2014/main" id="{4D39778A-72E6-4E9F-8BE1-9FBBA9718260}"/>
               </a:ext>
             </a:extLst>
           </p:cNvPr>
@@ -7494,7 +7309,7 @@
           <p:cNvPr id="25" name="">
             <a:extLst xmlns:a="http://schemas.openxmlformats.org/drawingml/2006/main">
               <a:ext uri="{FF2B5EF4-FFF2-40B4-BE49-F238E27FC236}">
-                <a16:creationId xmlns:a16="http://schemas.microsoft.com/office/drawing/2014/main" id="{32D57D12-5480-4ADE-BBFD-C5170A26C78B}"/>
+                <a16:creationId xmlns:a16="http://schemas.microsoft.com/office/drawing/2014/main" id="{FDA46829-C114-4047-AD0F-3A758C331C73}"/>
               </a:ext>
             </a:extLst>
           </p:cNvPr>
@@ -7527,7 +7342,7 @@
           <p:cNvPr id="26" name="">
             <a:extLst xmlns:a="http://schemas.openxmlformats.org/drawingml/2006/main">
               <a:ext uri="{FF2B5EF4-FFF2-40B4-BE49-F238E27FC236}">
-                <a16:creationId xmlns:a16="http://schemas.microsoft.com/office/drawing/2014/main" id="{9D8026AA-43B7-4E02-A97F-FAD8E855671A}"/>
+                <a16:creationId xmlns:a16="http://schemas.microsoft.com/office/drawing/2014/main" id="{26EC7C44-8A4D-45A9-A324-DB32B52AA537}"/>
               </a:ext>
             </a:extLst>
           </p:cNvPr>
@@ -7577,7 +7392,7 @@
           <p:cNvPr id="27" name="">
             <a:extLst xmlns:a="http://schemas.openxmlformats.org/drawingml/2006/main">
               <a:ext uri="{FF2B5EF4-FFF2-40B4-BE49-F238E27FC236}">
-                <a16:creationId xmlns:a16="http://schemas.microsoft.com/office/drawing/2014/main" id="{5328D0DC-ECE2-47EA-8386-603FC793FCF7}"/>
+                <a16:creationId xmlns:a16="http://schemas.microsoft.com/office/drawing/2014/main" id="{86E3F633-8283-4BA6-A4A4-767F116F2D17}"/>
               </a:ext>
             </a:extLst>
           </p:cNvPr>
@@ -7627,7 +7442,7 @@
           <p:cNvPr id="28" name="">
             <a:extLst xmlns:a="http://schemas.openxmlformats.org/drawingml/2006/main">
               <a:ext uri="{FF2B5EF4-FFF2-40B4-BE49-F238E27FC236}">
-                <a16:creationId xmlns:a16="http://schemas.microsoft.com/office/drawing/2014/main" id="{BF1FD384-2025-4EB7-BFEB-C86D1453F60D}"/>
+                <a16:creationId xmlns:a16="http://schemas.microsoft.com/office/drawing/2014/main" id="{3248461D-6309-48ED-BDFE-860AA8487A89}"/>
               </a:ext>
             </a:extLst>
           </p:cNvPr>
@@ -7677,7 +7492,7 @@
           <p:cNvPr id="29" name="">
             <a:extLst xmlns:a="http://schemas.openxmlformats.org/drawingml/2006/main">
               <a:ext uri="{FF2B5EF4-FFF2-40B4-BE49-F238E27FC236}">
-                <a16:creationId xmlns:a16="http://schemas.microsoft.com/office/drawing/2014/main" id="{D4C9AF14-BC70-4517-9C0B-7EABF0B5305C}"/>
+                <a16:creationId xmlns:a16="http://schemas.microsoft.com/office/drawing/2014/main" id="{2DD4F0F1-1FE6-4752-A438-9D30732424B5}"/>
               </a:ext>
             </a:extLst>
           </p:cNvPr>
@@ -7727,7 +7542,7 @@
           <p:cNvPr id="30" name="">
             <a:extLst xmlns:a="http://schemas.openxmlformats.org/drawingml/2006/main">
               <a:ext uri="{FF2B5EF4-FFF2-40B4-BE49-F238E27FC236}">
-                <a16:creationId xmlns:a16="http://schemas.microsoft.com/office/drawing/2014/main" id="{4AD539FA-FA10-4C0D-8721-291D74E71C78}"/>
+                <a16:creationId xmlns:a16="http://schemas.microsoft.com/office/drawing/2014/main" id="{F8CF67BA-7C43-4BB8-A1B6-96B0AF62AE4E}"/>
               </a:ext>
             </a:extLst>
           </p:cNvPr>
@@ -7760,7 +7575,7 @@
           <p:cNvPr id="31" name="">
             <a:extLst xmlns:a="http://schemas.openxmlformats.org/drawingml/2006/main">
               <a:ext uri="{FF2B5EF4-FFF2-40B4-BE49-F238E27FC236}">
-                <a16:creationId xmlns:a16="http://schemas.microsoft.com/office/drawing/2014/main" id="{113320C2-F263-4C09-84C2-464C52F2D750}"/>
+                <a16:creationId xmlns:a16="http://schemas.microsoft.com/office/drawing/2014/main" id="{4760F143-19AE-4225-85C6-26EFB81E8F7E}"/>
               </a:ext>
             </a:extLst>
           </p:cNvPr>
@@ -7795,7 +7610,7 @@
           <p:cNvPr id="32" name="">
             <a:extLst xmlns:a="http://schemas.openxmlformats.org/drawingml/2006/main">
               <a:ext uri="{FF2B5EF4-FFF2-40B4-BE49-F238E27FC236}">
-                <a16:creationId xmlns:a16="http://schemas.microsoft.com/office/drawing/2014/main" id="{19BB8638-F4A9-46ED-BA54-2DDF2A5511B5}"/>
+                <a16:creationId xmlns:a16="http://schemas.microsoft.com/office/drawing/2014/main" id="{BDC8A94A-768B-4DCF-87E7-39DDC8D9728D}"/>
               </a:ext>
             </a:extLst>
           </p:cNvPr>
@@ -7845,7 +7660,7 @@
           <p:cNvPr id="33" name="">
             <a:extLst xmlns:a="http://schemas.openxmlformats.org/drawingml/2006/main">
               <a:ext uri="{FF2B5EF4-FFF2-40B4-BE49-F238E27FC236}">
-                <a16:creationId xmlns:a16="http://schemas.microsoft.com/office/drawing/2014/main" id="{9F0F002E-59BC-4B80-920D-E54FFEC40A02}"/>
+                <a16:creationId xmlns:a16="http://schemas.microsoft.com/office/drawing/2014/main" id="{41764A58-E876-4686-8F2B-88D92D435608}"/>
               </a:ext>
             </a:extLst>
           </p:cNvPr>
@@ -7878,7 +7693,7 @@
           <p:cNvPr id="34" name="">
             <a:extLst xmlns:a="http://schemas.openxmlformats.org/drawingml/2006/main">
               <a:ext uri="{FF2B5EF4-FFF2-40B4-BE49-F238E27FC236}">
-                <a16:creationId xmlns:a16="http://schemas.microsoft.com/office/drawing/2014/main" id="{279CB955-E312-43BF-8159-6EDD60B09E88}"/>
+                <a16:creationId xmlns:a16="http://schemas.microsoft.com/office/drawing/2014/main" id="{B843FB9C-8546-4FB9-B382-CD02E70C6B44}"/>
               </a:ext>
             </a:extLst>
           </p:cNvPr>
@@ -7928,7 +7743,7 @@
           <p:cNvPr id="35" name="">
             <a:extLst xmlns:a="http://schemas.openxmlformats.org/drawingml/2006/main">
               <a:ext uri="{FF2B5EF4-FFF2-40B4-BE49-F238E27FC236}">
-                <a16:creationId xmlns:a16="http://schemas.microsoft.com/office/drawing/2014/main" id="{A1E5D9C4-5859-43F8-8257-E16386CA6B6E}"/>
+                <a16:creationId xmlns:a16="http://schemas.microsoft.com/office/drawing/2014/main" id="{6FF131E7-2625-4553-82BB-897E2AF8917F}"/>
               </a:ext>
             </a:extLst>
           </p:cNvPr>
@@ -7976,7 +7791,7 @@
     </p:spTree>
     <p:extLst>
       <p:ext uri="{BB962C8B-B14F-4D97-AF65-F5344CB8AC3E}">
-        <p14:creationId xmlns:p14="http://schemas.microsoft.com/office/powerpoint/2010/main" val="318328110"/>
+        <p14:creationId xmlns:p14="http://schemas.microsoft.com/office/powerpoint/2010/main" val="2106137065"/>
       </p:ext>
     </p:extLst>
   </p:cSld>
@@ -8007,7 +7822,7 @@
           <p:cNvPr id="29" name="">
             <a:extLst xmlns:a="http://schemas.openxmlformats.org/drawingml/2006/main">
               <a:ext uri="{FF2B5EF4-FFF2-40B4-BE49-F238E27FC236}">
-                <a16:creationId xmlns:a16="http://schemas.microsoft.com/office/drawing/2014/main" id="{AF71800B-85A8-42CC-9CD0-D6464C735AE8}"/>
+                <a16:creationId xmlns:a16="http://schemas.microsoft.com/office/drawing/2014/main" id="{C6207522-AEF1-41E3-B13C-074095E347B8}"/>
               </a:ext>
             </a:extLst>
           </p:cNvPr>
@@ -8057,7 +7872,7 @@
           <p:cNvPr id="2" name="">
             <a:extLst xmlns:a="http://schemas.openxmlformats.org/drawingml/2006/main">
               <a:ext uri="{FF2B5EF4-FFF2-40B4-BE49-F238E27FC236}">
-                <a16:creationId xmlns:a16="http://schemas.microsoft.com/office/drawing/2014/main" id="{0913E9E8-AE67-44DF-8794-C87B7CDBD573}"/>
+                <a16:creationId xmlns:a16="http://schemas.microsoft.com/office/drawing/2014/main" id="{7339D5D5-D06E-4378-A9E3-A2FBCA100AE1}"/>
               </a:ext>
             </a:extLst>
           </p:cNvPr>
@@ -8107,7 +7922,7 @@
           <p:cNvPr id="3" name="">
             <a:extLst xmlns:a="http://schemas.openxmlformats.org/drawingml/2006/main">
               <a:ext uri="{FF2B5EF4-FFF2-40B4-BE49-F238E27FC236}">
-                <a16:creationId xmlns:a16="http://schemas.microsoft.com/office/drawing/2014/main" id="{D47F640B-ED16-46F3-B7D0-482BF71372C9}"/>
+                <a16:creationId xmlns:a16="http://schemas.microsoft.com/office/drawing/2014/main" id="{8CFE70B0-C572-414C-90BC-9FC6BCAA372F}"/>
               </a:ext>
             </a:extLst>
           </p:cNvPr>
@@ -8157,7 +7972,7 @@
           <p:cNvPr id="4" name="">
             <a:extLst xmlns:a="http://schemas.openxmlformats.org/drawingml/2006/main">
               <a:ext uri="{FF2B5EF4-FFF2-40B4-BE49-F238E27FC236}">
-                <a16:creationId xmlns:a16="http://schemas.microsoft.com/office/drawing/2014/main" id="{CB93B4C1-EC2C-454A-AC1B-7011337F4E2A}"/>
+                <a16:creationId xmlns:a16="http://schemas.microsoft.com/office/drawing/2014/main" id="{2232C82A-A72B-490B-AFE7-50FFB39874B3}"/>
               </a:ext>
             </a:extLst>
           </p:cNvPr>
@@ -8190,7 +8005,7 @@
           <p:cNvPr id="5" name="">
             <a:extLst xmlns:a="http://schemas.openxmlformats.org/drawingml/2006/main">
               <a:ext uri="{FF2B5EF4-FFF2-40B4-BE49-F238E27FC236}">
-                <a16:creationId xmlns:a16="http://schemas.microsoft.com/office/drawing/2014/main" id="{36710368-3A9A-4F6B-A239-A20860D10179}"/>
+                <a16:creationId xmlns:a16="http://schemas.microsoft.com/office/drawing/2014/main" id="{7B25198C-ED55-4CC3-94DA-29F6721494E1}"/>
               </a:ext>
             </a:extLst>
           </p:cNvPr>
@@ -8240,7 +8055,7 @@
           <p:cNvPr id="6" name="">
             <a:extLst xmlns:a="http://schemas.openxmlformats.org/drawingml/2006/main">
               <a:ext uri="{FF2B5EF4-FFF2-40B4-BE49-F238E27FC236}">
-                <a16:creationId xmlns:a16="http://schemas.microsoft.com/office/drawing/2014/main" id="{6C33E5B1-272E-4425-9A23-7C949B69758D}"/>
+                <a16:creationId xmlns:a16="http://schemas.microsoft.com/office/drawing/2014/main" id="{572E3A14-3591-4AFD-9E68-CDB2903289DD}"/>
               </a:ext>
             </a:extLst>
           </p:cNvPr>
@@ -8290,7 +8105,7 @@
           <p:cNvPr id="7" name="">
             <a:extLst xmlns:a="http://schemas.openxmlformats.org/drawingml/2006/main">
               <a:ext uri="{FF2B5EF4-FFF2-40B4-BE49-F238E27FC236}">
-                <a16:creationId xmlns:a16="http://schemas.microsoft.com/office/drawing/2014/main" id="{A711599E-EE7B-4BA1-A3F2-5502BB55C562}"/>
+                <a16:creationId xmlns:a16="http://schemas.microsoft.com/office/drawing/2014/main" id="{72A29C55-8B46-4603-9D6D-3754521B28C2}"/>
               </a:ext>
             </a:extLst>
           </p:cNvPr>
@@ -8340,7 +8155,7 @@
           <p:cNvPr id="8" name="">
             <a:extLst xmlns:a="http://schemas.openxmlformats.org/drawingml/2006/main">
               <a:ext uri="{FF2B5EF4-FFF2-40B4-BE49-F238E27FC236}">
-                <a16:creationId xmlns:a16="http://schemas.microsoft.com/office/drawing/2014/main" id="{CD0D2746-BCB9-4A4C-ADD4-AD9BBDFC4B3F}"/>
+                <a16:creationId xmlns:a16="http://schemas.microsoft.com/office/drawing/2014/main" id="{9BDCDF69-4677-4759-9AE6-B70B9D0931D2}"/>
               </a:ext>
             </a:extLst>
           </p:cNvPr>
@@ -8390,7 +8205,7 @@
           <p:cNvPr id="9" name="">
             <a:extLst xmlns:a="http://schemas.openxmlformats.org/drawingml/2006/main">
               <a:ext uri="{FF2B5EF4-FFF2-40B4-BE49-F238E27FC236}">
-                <a16:creationId xmlns:a16="http://schemas.microsoft.com/office/drawing/2014/main" id="{E3F15F3E-2F6E-4885-9207-045C22E9739B}"/>
+                <a16:creationId xmlns:a16="http://schemas.microsoft.com/office/drawing/2014/main" id="{EC382ED7-4AB1-4FCB-B7F4-5E3EBC3EE7ED}"/>
               </a:ext>
             </a:extLst>
           </p:cNvPr>
@@ -8440,7 +8255,7 @@
           <p:cNvPr id="10" name="">
             <a:extLst xmlns:a="http://schemas.openxmlformats.org/drawingml/2006/main">
               <a:ext uri="{FF2B5EF4-FFF2-40B4-BE49-F238E27FC236}">
-                <a16:creationId xmlns:a16="http://schemas.microsoft.com/office/drawing/2014/main" id="{F573C04D-F5EF-4D32-A126-C38ED3AC290E}"/>
+                <a16:creationId xmlns:a16="http://schemas.microsoft.com/office/drawing/2014/main" id="{057F5117-3B79-4518-9483-7F67ADFE7D0B}"/>
               </a:ext>
             </a:extLst>
           </p:cNvPr>
@@ -8490,7 +8305,7 @@
           <p:cNvPr id="11" name="">
             <a:extLst xmlns:a="http://schemas.openxmlformats.org/drawingml/2006/main">
               <a:ext uri="{FF2B5EF4-FFF2-40B4-BE49-F238E27FC236}">
-                <a16:creationId xmlns:a16="http://schemas.microsoft.com/office/drawing/2014/main" id="{3EFE4250-2880-48ED-901E-9DA926971456}"/>
+                <a16:creationId xmlns:a16="http://schemas.microsoft.com/office/drawing/2014/main" id="{2370FF74-E458-4BF1-AD12-ECF503840CFA}"/>
               </a:ext>
             </a:extLst>
           </p:cNvPr>
@@ -8540,7 +8355,7 @@
           <p:cNvPr id="12" name="">
             <a:extLst xmlns:a="http://schemas.openxmlformats.org/drawingml/2006/main">
               <a:ext uri="{FF2B5EF4-FFF2-40B4-BE49-F238E27FC236}">
-                <a16:creationId xmlns:a16="http://schemas.microsoft.com/office/drawing/2014/main" id="{102BF147-CFCD-43C0-89BC-B9F3BA5F086F}"/>
+                <a16:creationId xmlns:a16="http://schemas.microsoft.com/office/drawing/2014/main" id="{E23847CE-2CAF-4D0C-B193-4D12D23EA7C1}"/>
               </a:ext>
             </a:extLst>
           </p:cNvPr>
@@ -8573,7 +8388,7 @@
           <p:cNvPr id="13" name="">
             <a:extLst xmlns:a="http://schemas.openxmlformats.org/drawingml/2006/main">
               <a:ext uri="{FF2B5EF4-FFF2-40B4-BE49-F238E27FC236}">
-                <a16:creationId xmlns:a16="http://schemas.microsoft.com/office/drawing/2014/main" id="{ACEAB7EC-9C64-4094-8823-6445C1F89032}"/>
+                <a16:creationId xmlns:a16="http://schemas.microsoft.com/office/drawing/2014/main" id="{570D96F0-9F71-4DAD-94EA-D007A5254A3F}"/>
               </a:ext>
             </a:extLst>
           </p:cNvPr>
@@ -8606,7 +8421,7 @@
           <p:cNvPr id="14" name="">
             <a:extLst xmlns:a="http://schemas.openxmlformats.org/drawingml/2006/main">
               <a:ext uri="{FF2B5EF4-FFF2-40B4-BE49-F238E27FC236}">
-                <a16:creationId xmlns:a16="http://schemas.microsoft.com/office/drawing/2014/main" id="{31B92065-5A6C-460E-8F2F-491DDA6B63F7}"/>
+                <a16:creationId xmlns:a16="http://schemas.microsoft.com/office/drawing/2014/main" id="{31F953B0-371E-4528-A93B-E00496B2C0FF}"/>
               </a:ext>
             </a:extLst>
           </p:cNvPr>
@@ -8639,7 +8454,7 @@
           <p:cNvPr id="15" name="">
             <a:extLst xmlns:a="http://schemas.openxmlformats.org/drawingml/2006/main">
               <a:ext uri="{FF2B5EF4-FFF2-40B4-BE49-F238E27FC236}">
-                <a16:creationId xmlns:a16="http://schemas.microsoft.com/office/drawing/2014/main" id="{403167BF-83A0-46D8-A39C-05DEC28FF662}"/>
+                <a16:creationId xmlns:a16="http://schemas.microsoft.com/office/drawing/2014/main" id="{EC235D62-C501-403A-A0EE-EA633FA233C8}"/>
               </a:ext>
             </a:extLst>
           </p:cNvPr>
@@ -8672,7 +8487,7 @@
           <p:cNvPr id="16" name="">
             <a:extLst xmlns:a="http://schemas.openxmlformats.org/drawingml/2006/main">
               <a:ext uri="{FF2B5EF4-FFF2-40B4-BE49-F238E27FC236}">
-                <a16:creationId xmlns:a16="http://schemas.microsoft.com/office/drawing/2014/main" id="{3B5FB819-5E40-4968-B168-B9BA4041C9A6}"/>
+                <a16:creationId xmlns:a16="http://schemas.microsoft.com/office/drawing/2014/main" id="{9327B77A-124B-449C-9E58-3855BB4E7F09}"/>
               </a:ext>
             </a:extLst>
           </p:cNvPr>
@@ -8705,7 +8520,7 @@
           <p:cNvPr id="17" name="">
             <a:extLst xmlns:a="http://schemas.openxmlformats.org/drawingml/2006/main">
               <a:ext uri="{FF2B5EF4-FFF2-40B4-BE49-F238E27FC236}">
-                <a16:creationId xmlns:a16="http://schemas.microsoft.com/office/drawing/2014/main" id="{5BD957D9-78B9-44BD-87B8-A0433DEFD2B4}"/>
+                <a16:creationId xmlns:a16="http://schemas.microsoft.com/office/drawing/2014/main" id="{98DD3D1B-8EA5-481E-82E4-0554EA2A27A3}"/>
               </a:ext>
             </a:extLst>
           </p:cNvPr>
@@ -8738,7 +8553,7 @@
           <p:cNvPr id="18" name="">
             <a:extLst xmlns:a="http://schemas.openxmlformats.org/drawingml/2006/main">
               <a:ext uri="{FF2B5EF4-FFF2-40B4-BE49-F238E27FC236}">
-                <a16:creationId xmlns:a16="http://schemas.microsoft.com/office/drawing/2014/main" id="{5C0D8855-4AD0-4B70-9BEA-A341D427A303}"/>
+                <a16:creationId xmlns:a16="http://schemas.microsoft.com/office/drawing/2014/main" id="{0F34D71F-5E3E-45E9-B4C7-6F6BF46D7C51}"/>
               </a:ext>
             </a:extLst>
           </p:cNvPr>
@@ -8788,7 +8603,7 @@
           <p:cNvPr id="19" name="">
             <a:extLst xmlns:a="http://schemas.openxmlformats.org/drawingml/2006/main">
               <a:ext uri="{FF2B5EF4-FFF2-40B4-BE49-F238E27FC236}">
-                <a16:creationId xmlns:a16="http://schemas.microsoft.com/office/drawing/2014/main" id="{2813A354-932E-4AA3-939E-FA9249C179BC}"/>
+                <a16:creationId xmlns:a16="http://schemas.microsoft.com/office/drawing/2014/main" id="{281CCB92-AC36-407F-8FF9-098740065967}"/>
               </a:ext>
             </a:extLst>
           </p:cNvPr>
@@ -8855,7 +8670,7 @@
           <p:cNvPr id="20" name="">
             <a:extLst xmlns:a="http://schemas.openxmlformats.org/drawingml/2006/main">
               <a:ext uri="{FF2B5EF4-FFF2-40B4-BE49-F238E27FC236}">
-                <a16:creationId xmlns:a16="http://schemas.microsoft.com/office/drawing/2014/main" id="{367F0966-606C-4356-9323-8F5E0F55D8B6}"/>
+                <a16:creationId xmlns:a16="http://schemas.microsoft.com/office/drawing/2014/main" id="{DE1541D6-37C6-47DE-ADDF-110921CAABBE}"/>
               </a:ext>
             </a:extLst>
           </p:cNvPr>
@@ -8905,7 +8720,7 @@
           <p:cNvPr id="21" name="">
             <a:extLst xmlns:a="http://schemas.openxmlformats.org/drawingml/2006/main">
               <a:ext uri="{FF2B5EF4-FFF2-40B4-BE49-F238E27FC236}">
-                <a16:creationId xmlns:a16="http://schemas.microsoft.com/office/drawing/2014/main" id="{C3397995-086D-4BAD-8A9D-5B2B799AEE29}"/>
+                <a16:creationId xmlns:a16="http://schemas.microsoft.com/office/drawing/2014/main" id="{C5C13B52-F1DE-4F9A-92DC-BD59B0149FE5}"/>
               </a:ext>
             </a:extLst>
           </p:cNvPr>
@@ -8972,7 +8787,7 @@
           <p:cNvPr id="22" name="">
             <a:extLst xmlns:a="http://schemas.openxmlformats.org/drawingml/2006/main">
               <a:ext uri="{FF2B5EF4-FFF2-40B4-BE49-F238E27FC236}">
-                <a16:creationId xmlns:a16="http://schemas.microsoft.com/office/drawing/2014/main" id="{639474F0-2FF4-4C31-98B4-02E552CBDDFC}"/>
+                <a16:creationId xmlns:a16="http://schemas.microsoft.com/office/drawing/2014/main" id="{D426E5D6-FD81-4DDB-B9F3-8B6941C1E18D}"/>
               </a:ext>
             </a:extLst>
           </p:cNvPr>
@@ -9022,7 +8837,7 @@
           <p:cNvPr id="23" name="">
             <a:extLst xmlns:a="http://schemas.openxmlformats.org/drawingml/2006/main">
               <a:ext uri="{FF2B5EF4-FFF2-40B4-BE49-F238E27FC236}">
-                <a16:creationId xmlns:a16="http://schemas.microsoft.com/office/drawing/2014/main" id="{A5EE08B2-EBBD-432B-B6FC-3A0CE64E39CA}"/>
+                <a16:creationId xmlns:a16="http://schemas.microsoft.com/office/drawing/2014/main" id="{AD88DA3B-4D18-47CF-868F-775D42604AA7}"/>
               </a:ext>
             </a:extLst>
           </p:cNvPr>
@@ -9089,7 +8904,7 @@
           <p:cNvPr id="24" name="">
             <a:extLst xmlns:a="http://schemas.openxmlformats.org/drawingml/2006/main">
               <a:ext uri="{FF2B5EF4-FFF2-40B4-BE49-F238E27FC236}">
-                <a16:creationId xmlns:a16="http://schemas.microsoft.com/office/drawing/2014/main" id="{D3931A8F-0024-48F3-8945-A50AD0F1A59A}"/>
+                <a16:creationId xmlns:a16="http://schemas.microsoft.com/office/drawing/2014/main" id="{E22CF925-0E55-4672-B510-7641ECF13430}"/>
               </a:ext>
             </a:extLst>
           </p:cNvPr>
@@ -9139,7 +8954,7 @@
           <p:cNvPr id="25" name="">
             <a:extLst xmlns:a="http://schemas.openxmlformats.org/drawingml/2006/main">
               <a:ext uri="{FF2B5EF4-FFF2-40B4-BE49-F238E27FC236}">
-                <a16:creationId xmlns:a16="http://schemas.microsoft.com/office/drawing/2014/main" id="{43787A05-326C-4F35-8F22-1DF5010A3BFB}"/>
+                <a16:creationId xmlns:a16="http://schemas.microsoft.com/office/drawing/2014/main" id="{CB7CB2C6-1D24-4E48-B2AE-3F897568CF85}"/>
               </a:ext>
             </a:extLst>
           </p:cNvPr>
@@ -9189,7 +9004,7 @@
           <p:cNvPr id="26" name="">
             <a:extLst xmlns:a="http://schemas.openxmlformats.org/drawingml/2006/main">
               <a:ext uri="{FF2B5EF4-FFF2-40B4-BE49-F238E27FC236}">
-                <a16:creationId xmlns:a16="http://schemas.microsoft.com/office/drawing/2014/main" id="{98DEDD68-ACC1-4E29-A898-4E4B425624E9}"/>
+                <a16:creationId xmlns:a16="http://schemas.microsoft.com/office/drawing/2014/main" id="{26811A22-DACD-4D02-8062-8E3B3B12403C}"/>
               </a:ext>
             </a:extLst>
           </p:cNvPr>
@@ -9222,7 +9037,7 @@
           <p:cNvPr id="27" name="">
             <a:extLst xmlns:a="http://schemas.openxmlformats.org/drawingml/2006/main">
               <a:ext uri="{FF2B5EF4-FFF2-40B4-BE49-F238E27FC236}">
-                <a16:creationId xmlns:a16="http://schemas.microsoft.com/office/drawing/2014/main" id="{2C1BCB55-E86A-48D0-A49A-1DF087C7D389}"/>
+                <a16:creationId xmlns:a16="http://schemas.microsoft.com/office/drawing/2014/main" id="{BA274C87-8620-489C-98F1-BFCA38198E68}"/>
               </a:ext>
             </a:extLst>
           </p:cNvPr>
@@ -9272,7 +9087,7 @@
           <p:cNvPr id="28" name="">
             <a:extLst xmlns:a="http://schemas.openxmlformats.org/drawingml/2006/main">
               <a:ext uri="{FF2B5EF4-FFF2-40B4-BE49-F238E27FC236}">
-                <a16:creationId xmlns:a16="http://schemas.microsoft.com/office/drawing/2014/main" id="{B3638D34-1E82-489E-9809-254AB467B3F5}"/>
+                <a16:creationId xmlns:a16="http://schemas.microsoft.com/office/drawing/2014/main" id="{6E110503-7D3D-400B-AC44-34D0E7E2DD06}"/>
               </a:ext>
             </a:extLst>
           </p:cNvPr>
@@ -9320,7 +9135,7 @@
     </p:spTree>
     <p:extLst>
       <p:ext uri="{BB962C8B-B14F-4D97-AF65-F5344CB8AC3E}">
-        <p14:creationId xmlns:p14="http://schemas.microsoft.com/office/powerpoint/2010/main" val="2055600043"/>
+        <p14:creationId xmlns:p14="http://schemas.microsoft.com/office/powerpoint/2010/main" val="1147769967"/>
       </p:ext>
     </p:extLst>
   </p:cSld>
@@ -9351,7 +9166,7 @@
           <p:cNvPr id="39" name="">
             <a:extLst xmlns:a="http://schemas.openxmlformats.org/drawingml/2006/main">
               <a:ext uri="{FF2B5EF4-FFF2-40B4-BE49-F238E27FC236}">
-                <a16:creationId xmlns:a16="http://schemas.microsoft.com/office/drawing/2014/main" id="{03819DF3-34D3-4002-96A9-5CEEEAB610FE}"/>
+                <a16:creationId xmlns:a16="http://schemas.microsoft.com/office/drawing/2014/main" id="{A5617412-F515-4C28-BA94-9169752EF7C8}"/>
               </a:ext>
             </a:extLst>
           </p:cNvPr>
@@ -9401,7 +9216,7 @@
           <p:cNvPr id="2" name="">
             <a:extLst xmlns:a="http://schemas.openxmlformats.org/drawingml/2006/main">
               <a:ext uri="{FF2B5EF4-FFF2-40B4-BE49-F238E27FC236}">
-                <a16:creationId xmlns:a16="http://schemas.microsoft.com/office/drawing/2014/main" id="{13EB412E-D4AD-4F7F-97B7-AA4FAA920E06}"/>
+                <a16:creationId xmlns:a16="http://schemas.microsoft.com/office/drawing/2014/main" id="{3B870FD0-1E1C-4C43-80AB-09A4A5DCF856}"/>
               </a:ext>
             </a:extLst>
           </p:cNvPr>
@@ -9451,7 +9266,7 @@
           <p:cNvPr id="3" name="">
             <a:extLst xmlns:a="http://schemas.openxmlformats.org/drawingml/2006/main">
               <a:ext uri="{FF2B5EF4-FFF2-40B4-BE49-F238E27FC236}">
-                <a16:creationId xmlns:a16="http://schemas.microsoft.com/office/drawing/2014/main" id="{AF5028C3-6237-4B30-86B9-50F6A177B81E}"/>
+                <a16:creationId xmlns:a16="http://schemas.microsoft.com/office/drawing/2014/main" id="{7726789A-B4E1-41CD-9A3C-9884F84C0084}"/>
               </a:ext>
             </a:extLst>
           </p:cNvPr>
@@ -9501,7 +9316,7 @@
           <p:cNvPr id="4" name="">
             <a:extLst xmlns:a="http://schemas.openxmlformats.org/drawingml/2006/main">
               <a:ext uri="{FF2B5EF4-FFF2-40B4-BE49-F238E27FC236}">
-                <a16:creationId xmlns:a16="http://schemas.microsoft.com/office/drawing/2014/main" id="{CA11FE3C-A0DE-4A78-B805-D68CF0453AD7}"/>
+                <a16:creationId xmlns:a16="http://schemas.microsoft.com/office/drawing/2014/main" id="{4C87B988-42BB-49C2-9244-4AA1ACEB3CE2}"/>
               </a:ext>
             </a:extLst>
           </p:cNvPr>
@@ -9534,7 +9349,7 @@
           <p:cNvPr id="5" name="">
             <a:extLst xmlns:a="http://schemas.openxmlformats.org/drawingml/2006/main">
               <a:ext uri="{FF2B5EF4-FFF2-40B4-BE49-F238E27FC236}">
-                <a16:creationId xmlns:a16="http://schemas.microsoft.com/office/drawing/2014/main" id="{B908E2CA-1A54-4EF6-B54E-F7DC7A5C1BBF}"/>
+                <a16:creationId xmlns:a16="http://schemas.microsoft.com/office/drawing/2014/main" id="{745B5E45-5C70-4149-A25E-F1DC4475F07D}"/>
               </a:ext>
             </a:extLst>
           </p:cNvPr>
@@ -9584,7 +9399,7 @@
           <p:cNvPr id="6" name="">
             <a:extLst xmlns:a="http://schemas.openxmlformats.org/drawingml/2006/main">
               <a:ext uri="{FF2B5EF4-FFF2-40B4-BE49-F238E27FC236}">
-                <a16:creationId xmlns:a16="http://schemas.microsoft.com/office/drawing/2014/main" id="{277E4EC3-78F2-4739-9390-7CA793DB133E}"/>
+                <a16:creationId xmlns:a16="http://schemas.microsoft.com/office/drawing/2014/main" id="{1F84C327-1E2A-422E-B137-156B66193956}"/>
               </a:ext>
             </a:extLst>
           </p:cNvPr>
@@ -9634,7 +9449,7 @@
           <p:cNvPr id="7" name="">
             <a:extLst xmlns:a="http://schemas.openxmlformats.org/drawingml/2006/main">
               <a:ext uri="{FF2B5EF4-FFF2-40B4-BE49-F238E27FC236}">
-                <a16:creationId xmlns:a16="http://schemas.microsoft.com/office/drawing/2014/main" id="{1EBB300A-FAB0-4169-AE66-D8996F0309F6}"/>
+                <a16:creationId xmlns:a16="http://schemas.microsoft.com/office/drawing/2014/main" id="{E6D68032-D1CA-4889-8172-08B4594A0B77}"/>
               </a:ext>
             </a:extLst>
           </p:cNvPr>
@@ -9684,7 +9499,7 @@
           <p:cNvPr id="8" name="">
             <a:extLst xmlns:a="http://schemas.openxmlformats.org/drawingml/2006/main">
               <a:ext uri="{FF2B5EF4-FFF2-40B4-BE49-F238E27FC236}">
-                <a16:creationId xmlns:a16="http://schemas.microsoft.com/office/drawing/2014/main" id="{7D34C08F-353E-4066-8951-9F8482A2EE74}"/>
+                <a16:creationId xmlns:a16="http://schemas.microsoft.com/office/drawing/2014/main" id="{74CCA37A-1DAB-483C-A635-A045FA5B2B7E}"/>
               </a:ext>
             </a:extLst>
           </p:cNvPr>
@@ -9717,7 +9532,7 @@
           <p:cNvPr id="9" name="">
             <a:extLst xmlns:a="http://schemas.openxmlformats.org/drawingml/2006/main">
               <a:ext uri="{FF2B5EF4-FFF2-40B4-BE49-F238E27FC236}">
-                <a16:creationId xmlns:a16="http://schemas.microsoft.com/office/drawing/2014/main" id="{C2A71EF0-626D-4D26-991A-E8B63C4F4459}"/>
+                <a16:creationId xmlns:a16="http://schemas.microsoft.com/office/drawing/2014/main" id="{9AB13994-BDEE-4A25-889B-0FD9ED5A1318}"/>
               </a:ext>
             </a:extLst>
           </p:cNvPr>
@@ -9750,7 +9565,7 @@
           <p:cNvPr id="10" name="">
             <a:extLst xmlns:a="http://schemas.openxmlformats.org/drawingml/2006/main">
               <a:ext uri="{FF2B5EF4-FFF2-40B4-BE49-F238E27FC236}">
-                <a16:creationId xmlns:a16="http://schemas.microsoft.com/office/drawing/2014/main" id="{20D7973F-15E0-4E32-9A84-F91EF2F6E09A}"/>
+                <a16:creationId xmlns:a16="http://schemas.microsoft.com/office/drawing/2014/main" id="{A7505073-9932-450F-B270-CCE4279842EB}"/>
               </a:ext>
             </a:extLst>
           </p:cNvPr>
@@ -9783,7 +9598,7 @@
           <p:cNvPr id="11" name="">
             <a:extLst xmlns:a="http://schemas.openxmlformats.org/drawingml/2006/main">
               <a:ext uri="{FF2B5EF4-FFF2-40B4-BE49-F238E27FC236}">
-                <a16:creationId xmlns:a16="http://schemas.microsoft.com/office/drawing/2014/main" id="{7ACC2A8E-6C05-4850-B39B-7018E055AF73}"/>
+                <a16:creationId xmlns:a16="http://schemas.microsoft.com/office/drawing/2014/main" id="{6C25A79A-5C40-421F-BD51-5D34A47B3E4E}"/>
               </a:ext>
             </a:extLst>
           </p:cNvPr>
@@ -9816,7 +9631,7 @@
           <p:cNvPr id="12" name="">
             <a:extLst xmlns:a="http://schemas.openxmlformats.org/drawingml/2006/main">
               <a:ext uri="{FF2B5EF4-FFF2-40B4-BE49-F238E27FC236}">
-                <a16:creationId xmlns:a16="http://schemas.microsoft.com/office/drawing/2014/main" id="{7B19CA3B-7857-48CC-B0E9-5C84D4FBBB8D}"/>
+                <a16:creationId xmlns:a16="http://schemas.microsoft.com/office/drawing/2014/main" id="{78ADC5E1-D0C8-407E-8F31-E2A627F8FE38}"/>
               </a:ext>
             </a:extLst>
           </p:cNvPr>
@@ -9851,7 +9666,7 @@
           <p:cNvPr id="13" name="">
             <a:extLst xmlns:a="http://schemas.openxmlformats.org/drawingml/2006/main">
               <a:ext uri="{FF2B5EF4-FFF2-40B4-BE49-F238E27FC236}">
-                <a16:creationId xmlns:a16="http://schemas.microsoft.com/office/drawing/2014/main" id="{E22EE6EA-AADB-4635-8D78-97F6172908F5}"/>
+                <a16:creationId xmlns:a16="http://schemas.microsoft.com/office/drawing/2014/main" id="{300253AD-EE4D-4FE1-8CFD-1270C3EE67D2}"/>
               </a:ext>
             </a:extLst>
           </p:cNvPr>
@@ -9901,7 +9716,7 @@
           <p:cNvPr id="14" name="">
             <a:extLst xmlns:a="http://schemas.openxmlformats.org/drawingml/2006/main">
               <a:ext uri="{FF2B5EF4-FFF2-40B4-BE49-F238E27FC236}">
-                <a16:creationId xmlns:a16="http://schemas.microsoft.com/office/drawing/2014/main" id="{AE1B754C-D30F-4AE1-AA4E-4185E9D6C68B}"/>
+                <a16:creationId xmlns:a16="http://schemas.microsoft.com/office/drawing/2014/main" id="{26C2DB99-AE84-4955-A5D3-5BA05B02ACF1}"/>
               </a:ext>
             </a:extLst>
           </p:cNvPr>
@@ -9951,7 +9766,7 @@
           <p:cNvPr id="15" name="">
             <a:extLst xmlns:a="http://schemas.openxmlformats.org/drawingml/2006/main">
               <a:ext uri="{FF2B5EF4-FFF2-40B4-BE49-F238E27FC236}">
-                <a16:creationId xmlns:a16="http://schemas.microsoft.com/office/drawing/2014/main" id="{FE99A13D-4D61-48F3-B1FC-8039E08A0972}"/>
+                <a16:creationId xmlns:a16="http://schemas.microsoft.com/office/drawing/2014/main" id="{6FB11C5F-F6CE-4839-B613-D3D42E322EC5}"/>
               </a:ext>
             </a:extLst>
           </p:cNvPr>
@@ -10001,7 +9816,7 @@
           <p:cNvPr id="16" name="">
             <a:extLst xmlns:a="http://schemas.openxmlformats.org/drawingml/2006/main">
               <a:ext uri="{FF2B5EF4-FFF2-40B4-BE49-F238E27FC236}">
-                <a16:creationId xmlns:a16="http://schemas.microsoft.com/office/drawing/2014/main" id="{2CCF9D0A-7F50-440B-81C7-76DE1DF28F55}"/>
+                <a16:creationId xmlns:a16="http://schemas.microsoft.com/office/drawing/2014/main" id="{C483A999-B182-49FF-84B4-AE61406E5BF5}"/>
               </a:ext>
             </a:extLst>
           </p:cNvPr>
@@ -10036,7 +9851,7 @@
           <p:cNvPr id="17" name="">
             <a:extLst xmlns:a="http://schemas.openxmlformats.org/drawingml/2006/main">
               <a:ext uri="{FF2B5EF4-FFF2-40B4-BE49-F238E27FC236}">
-                <a16:creationId xmlns:a16="http://schemas.microsoft.com/office/drawing/2014/main" id="{9FA7ADA1-EE6E-44AC-9709-026443419B0A}"/>
+                <a16:creationId xmlns:a16="http://schemas.microsoft.com/office/drawing/2014/main" id="{81100062-C6BB-4760-AE45-E1619C5D87D5}"/>
               </a:ext>
             </a:extLst>
           </p:cNvPr>
@@ -10086,7 +9901,7 @@
           <p:cNvPr id="18" name="">
             <a:extLst xmlns:a="http://schemas.openxmlformats.org/drawingml/2006/main">
               <a:ext uri="{FF2B5EF4-FFF2-40B4-BE49-F238E27FC236}">
-                <a16:creationId xmlns:a16="http://schemas.microsoft.com/office/drawing/2014/main" id="{BB051BED-1F5F-46F1-9789-818E82A5E420}"/>
+                <a16:creationId xmlns:a16="http://schemas.microsoft.com/office/drawing/2014/main" id="{BB459467-AA34-4A91-900C-402B6480661B}"/>
               </a:ext>
             </a:extLst>
           </p:cNvPr>
@@ -10136,7 +9951,7 @@
           <p:cNvPr id="19" name="">
             <a:extLst xmlns:a="http://schemas.openxmlformats.org/drawingml/2006/main">
               <a:ext uri="{FF2B5EF4-FFF2-40B4-BE49-F238E27FC236}">
-                <a16:creationId xmlns:a16="http://schemas.microsoft.com/office/drawing/2014/main" id="{A95322DA-DDF2-474F-99CE-A4AA21C31852}"/>
+                <a16:creationId xmlns:a16="http://schemas.microsoft.com/office/drawing/2014/main" id="{276E521A-D400-4D43-91BA-34857736BA23}"/>
               </a:ext>
             </a:extLst>
           </p:cNvPr>
@@ -10186,7 +10001,7 @@
           <p:cNvPr id="20" name="">
             <a:extLst xmlns:a="http://schemas.openxmlformats.org/drawingml/2006/main">
               <a:ext uri="{FF2B5EF4-FFF2-40B4-BE49-F238E27FC236}">
-                <a16:creationId xmlns:a16="http://schemas.microsoft.com/office/drawing/2014/main" id="{56D077A7-421F-47B7-A02E-F14D52ECCA38}"/>
+                <a16:creationId xmlns:a16="http://schemas.microsoft.com/office/drawing/2014/main" id="{3A76A25B-7A6B-4ECB-8F57-D48ED8E0E4E7}"/>
               </a:ext>
             </a:extLst>
           </p:cNvPr>
@@ -10221,7 +10036,7 @@
           <p:cNvPr id="21" name="">
             <a:extLst xmlns:a="http://schemas.openxmlformats.org/drawingml/2006/main">
               <a:ext uri="{FF2B5EF4-FFF2-40B4-BE49-F238E27FC236}">
-                <a16:creationId xmlns:a16="http://schemas.microsoft.com/office/drawing/2014/main" id="{DDF2C147-8EEC-472D-8FD7-D518F9EE4E77}"/>
+                <a16:creationId xmlns:a16="http://schemas.microsoft.com/office/drawing/2014/main" id="{997ECEE4-89B2-4435-A091-3366A4993347}"/>
               </a:ext>
             </a:extLst>
           </p:cNvPr>
@@ -10271,7 +10086,7 @@
           <p:cNvPr id="22" name="">
             <a:extLst xmlns:a="http://schemas.openxmlformats.org/drawingml/2006/main">
               <a:ext uri="{FF2B5EF4-FFF2-40B4-BE49-F238E27FC236}">
-                <a16:creationId xmlns:a16="http://schemas.microsoft.com/office/drawing/2014/main" id="{0F4FC30D-D645-42BC-A639-1EA83BFAC079}"/>
+                <a16:creationId xmlns:a16="http://schemas.microsoft.com/office/drawing/2014/main" id="{B4EB82E7-E787-4DB6-A58D-F6437E6A3A5B}"/>
               </a:ext>
             </a:extLst>
           </p:cNvPr>
@@ -10321,7 +10136,7 @@
           <p:cNvPr id="23" name="">
             <a:extLst xmlns:a="http://schemas.openxmlformats.org/drawingml/2006/main">
               <a:ext uri="{FF2B5EF4-FFF2-40B4-BE49-F238E27FC236}">
-                <a16:creationId xmlns:a16="http://schemas.microsoft.com/office/drawing/2014/main" id="{B2145D3A-DA28-4DB9-B53F-B90E909E9E80}"/>
+                <a16:creationId xmlns:a16="http://schemas.microsoft.com/office/drawing/2014/main" id="{77CBDBEE-A76C-4A27-ADB7-B3E7BE6E6518}"/>
               </a:ext>
             </a:extLst>
           </p:cNvPr>
@@ -10371,7 +10186,7 @@
           <p:cNvPr id="24" name="">
             <a:extLst xmlns:a="http://schemas.openxmlformats.org/drawingml/2006/main">
               <a:ext uri="{FF2B5EF4-FFF2-40B4-BE49-F238E27FC236}">
-                <a16:creationId xmlns:a16="http://schemas.microsoft.com/office/drawing/2014/main" id="{8EE9C563-4CB3-49F4-81F9-AB5A418ED252}"/>
+                <a16:creationId xmlns:a16="http://schemas.microsoft.com/office/drawing/2014/main" id="{FD1B6F04-C816-4A61-81A9-E63297EAD407}"/>
               </a:ext>
             </a:extLst>
           </p:cNvPr>
@@ -10406,7 +10221,7 @@
           <p:cNvPr id="25" name="">
             <a:extLst xmlns:a="http://schemas.openxmlformats.org/drawingml/2006/main">
               <a:ext uri="{FF2B5EF4-FFF2-40B4-BE49-F238E27FC236}">
-                <a16:creationId xmlns:a16="http://schemas.microsoft.com/office/drawing/2014/main" id="{4E1CCEBA-7F8A-485C-A488-29AAA3F524EC}"/>
+                <a16:creationId xmlns:a16="http://schemas.microsoft.com/office/drawing/2014/main" id="{C9CCD67C-09A9-4AEA-8876-9818D2D9956B}"/>
               </a:ext>
             </a:extLst>
           </p:cNvPr>
@@ -10456,7 +10271,7 @@
           <p:cNvPr id="26" name="">
             <a:extLst xmlns:a="http://schemas.openxmlformats.org/drawingml/2006/main">
               <a:ext uri="{FF2B5EF4-FFF2-40B4-BE49-F238E27FC236}">
-                <a16:creationId xmlns:a16="http://schemas.microsoft.com/office/drawing/2014/main" id="{E63B0A77-3449-4315-AD6C-99025FEDEE25}"/>
+                <a16:creationId xmlns:a16="http://schemas.microsoft.com/office/drawing/2014/main" id="{450F9DAE-E370-4794-B4BC-BB0131C8A42A}"/>
               </a:ext>
             </a:extLst>
           </p:cNvPr>
@@ -10506,7 +10321,7 @@
           <p:cNvPr id="27" name="">
             <a:extLst xmlns:a="http://schemas.openxmlformats.org/drawingml/2006/main">
               <a:ext uri="{FF2B5EF4-FFF2-40B4-BE49-F238E27FC236}">
-                <a16:creationId xmlns:a16="http://schemas.microsoft.com/office/drawing/2014/main" id="{F1BBE5A2-D880-4AD5-B830-EFB42B621D92}"/>
+                <a16:creationId xmlns:a16="http://schemas.microsoft.com/office/drawing/2014/main" id="{03A9D2EB-1C98-4AF5-8F2F-72D516CDA5A7}"/>
               </a:ext>
             </a:extLst>
           </p:cNvPr>
@@ -10556,7 +10371,7 @@
           <p:cNvPr id="28" name="">
             <a:extLst xmlns:a="http://schemas.openxmlformats.org/drawingml/2006/main">
               <a:ext uri="{FF2B5EF4-FFF2-40B4-BE49-F238E27FC236}">
-                <a16:creationId xmlns:a16="http://schemas.microsoft.com/office/drawing/2014/main" id="{0D7BD2DA-560E-4848-86EE-DFE422C26ECE}"/>
+                <a16:creationId xmlns:a16="http://schemas.microsoft.com/office/drawing/2014/main" id="{F5E83637-252F-454A-922C-7B4511F711B4}"/>
               </a:ext>
             </a:extLst>
           </p:cNvPr>
@@ -10591,7 +10406,7 @@
           <p:cNvPr id="29" name="">
             <a:extLst xmlns:a="http://schemas.openxmlformats.org/drawingml/2006/main">
               <a:ext uri="{FF2B5EF4-FFF2-40B4-BE49-F238E27FC236}">
-                <a16:creationId xmlns:a16="http://schemas.microsoft.com/office/drawing/2014/main" id="{751D0BA5-0EAC-4DDF-8E7D-C9D61EDFBACD}"/>
+                <a16:creationId xmlns:a16="http://schemas.microsoft.com/office/drawing/2014/main" id="{42D191DD-EEB8-404E-BD86-B63E18093E34}"/>
               </a:ext>
             </a:extLst>
           </p:cNvPr>
@@ -10641,7 +10456,7 @@
           <p:cNvPr id="30" name="">
             <a:extLst xmlns:a="http://schemas.openxmlformats.org/drawingml/2006/main">
               <a:ext uri="{FF2B5EF4-FFF2-40B4-BE49-F238E27FC236}">
-                <a16:creationId xmlns:a16="http://schemas.microsoft.com/office/drawing/2014/main" id="{9AC07BFE-0436-462F-9BDD-993773751FCB}"/>
+                <a16:creationId xmlns:a16="http://schemas.microsoft.com/office/drawing/2014/main" id="{9EF72953-6ACC-4485-9428-5F59E7FF14CA}"/>
               </a:ext>
             </a:extLst>
           </p:cNvPr>
@@ -10691,7 +10506,7 @@
           <p:cNvPr id="31" name="">
             <a:extLst xmlns:a="http://schemas.openxmlformats.org/drawingml/2006/main">
               <a:ext uri="{FF2B5EF4-FFF2-40B4-BE49-F238E27FC236}">
-                <a16:creationId xmlns:a16="http://schemas.microsoft.com/office/drawing/2014/main" id="{76BEA139-32A6-476B-9665-D1587A46C75B}"/>
+                <a16:creationId xmlns:a16="http://schemas.microsoft.com/office/drawing/2014/main" id="{3908B116-B001-4DA1-A13C-287BF2BEEB9E}"/>
               </a:ext>
             </a:extLst>
           </p:cNvPr>
@@ -10741,7 +10556,7 @@
           <p:cNvPr id="32" name="">
             <a:extLst xmlns:a="http://schemas.openxmlformats.org/drawingml/2006/main">
               <a:ext uri="{FF2B5EF4-FFF2-40B4-BE49-F238E27FC236}">
-                <a16:creationId xmlns:a16="http://schemas.microsoft.com/office/drawing/2014/main" id="{27578235-447D-4BEF-A874-1D2B639A39BB}"/>
+                <a16:creationId xmlns:a16="http://schemas.microsoft.com/office/drawing/2014/main" id="{68434760-0434-48EE-A124-DD2F9A83DA16}"/>
               </a:ext>
             </a:extLst>
           </p:cNvPr>
@@ -10791,7 +10606,7 @@
           <p:cNvPr id="33" name="">
             <a:extLst xmlns:a="http://schemas.openxmlformats.org/drawingml/2006/main">
               <a:ext uri="{FF2B5EF4-FFF2-40B4-BE49-F238E27FC236}">
-                <a16:creationId xmlns:a16="http://schemas.microsoft.com/office/drawing/2014/main" id="{B2ED094B-1F74-4B4C-88CA-766D195E5A49}"/>
+                <a16:creationId xmlns:a16="http://schemas.microsoft.com/office/drawing/2014/main" id="{C6E48389-5965-4835-AB7F-B0D0E4371F8D}"/>
               </a:ext>
             </a:extLst>
           </p:cNvPr>
@@ -10841,7 +10656,7 @@
           <p:cNvPr id="34" name="">
             <a:extLst xmlns:a="http://schemas.openxmlformats.org/drawingml/2006/main">
               <a:ext uri="{FF2B5EF4-FFF2-40B4-BE49-F238E27FC236}">
-                <a16:creationId xmlns:a16="http://schemas.microsoft.com/office/drawing/2014/main" id="{2C3490DD-5DBA-461D-A1BC-758F64176176}"/>
+                <a16:creationId xmlns:a16="http://schemas.microsoft.com/office/drawing/2014/main" id="{AA96CB0E-868F-42AF-90E1-FD7DC5097703}"/>
               </a:ext>
             </a:extLst>
           </p:cNvPr>
@@ -10891,7 +10706,7 @@
           <p:cNvPr id="35" name="">
             <a:extLst xmlns:a="http://schemas.openxmlformats.org/drawingml/2006/main">
               <a:ext uri="{FF2B5EF4-FFF2-40B4-BE49-F238E27FC236}">
-                <a16:creationId xmlns:a16="http://schemas.microsoft.com/office/drawing/2014/main" id="{2614C3B6-556D-424A-8FA2-07C9C1279912}"/>
+                <a16:creationId xmlns:a16="http://schemas.microsoft.com/office/drawing/2014/main" id="{B2F27B53-78D0-4D39-9048-6DFCB6683B18}"/>
               </a:ext>
             </a:extLst>
           </p:cNvPr>
@@ -10941,7 +10756,7 @@
           <p:cNvPr id="36" name="">
             <a:extLst xmlns:a="http://schemas.openxmlformats.org/drawingml/2006/main">
               <a:ext uri="{FF2B5EF4-FFF2-40B4-BE49-F238E27FC236}">
-                <a16:creationId xmlns:a16="http://schemas.microsoft.com/office/drawing/2014/main" id="{CBF1450A-DD57-47E4-A795-3F61E5C56AE2}"/>
+                <a16:creationId xmlns:a16="http://schemas.microsoft.com/office/drawing/2014/main" id="{D6C75049-0FF0-4E5C-8578-0AA162D8E2DB}"/>
               </a:ext>
             </a:extLst>
           </p:cNvPr>
@@ -10974,7 +10789,7 @@
           <p:cNvPr id="37" name="">
             <a:extLst xmlns:a="http://schemas.openxmlformats.org/drawingml/2006/main">
               <a:ext uri="{FF2B5EF4-FFF2-40B4-BE49-F238E27FC236}">
-                <a16:creationId xmlns:a16="http://schemas.microsoft.com/office/drawing/2014/main" id="{36D4FCF0-306A-49F9-B686-8B56FAF0EA16}"/>
+                <a16:creationId xmlns:a16="http://schemas.microsoft.com/office/drawing/2014/main" id="{479B64B8-DD3C-43EE-AC0B-09BF91D14FE4}"/>
               </a:ext>
             </a:extLst>
           </p:cNvPr>
@@ -11024,7 +10839,7 @@
           <p:cNvPr id="38" name="">
             <a:extLst xmlns:a="http://schemas.openxmlformats.org/drawingml/2006/main">
               <a:ext uri="{FF2B5EF4-FFF2-40B4-BE49-F238E27FC236}">
-                <a16:creationId xmlns:a16="http://schemas.microsoft.com/office/drawing/2014/main" id="{ACF79ABA-33F8-473C-A106-D2213CACC09A}"/>
+                <a16:creationId xmlns:a16="http://schemas.microsoft.com/office/drawing/2014/main" id="{A408D000-A512-454C-B4D7-B4017F7DC2FE}"/>
               </a:ext>
             </a:extLst>
           </p:cNvPr>
@@ -11072,7 +10887,7 @@
     </p:spTree>
     <p:extLst>
       <p:ext uri="{BB962C8B-B14F-4D97-AF65-F5344CB8AC3E}">
-        <p14:creationId xmlns:p14="http://schemas.microsoft.com/office/powerpoint/2010/main" val="1637528133"/>
+        <p14:creationId xmlns:p14="http://schemas.microsoft.com/office/powerpoint/2010/main" val="731666688"/>
       </p:ext>
     </p:extLst>
   </p:cSld>
@@ -11103,7 +10918,7 @@
           <p:cNvPr id="53" name="">
             <a:extLst xmlns:a="http://schemas.openxmlformats.org/drawingml/2006/main">
               <a:ext uri="{FF2B5EF4-FFF2-40B4-BE49-F238E27FC236}">
-                <a16:creationId xmlns:a16="http://schemas.microsoft.com/office/drawing/2014/main" id="{51EFC806-44BC-4D2B-AE53-02A7465EBDD2}"/>
+                <a16:creationId xmlns:a16="http://schemas.microsoft.com/office/drawing/2014/main" id="{C51D9F58-B380-43C3-B867-15D243BB359F}"/>
               </a:ext>
             </a:extLst>
           </p:cNvPr>
@@ -11153,7 +10968,7 @@
           <p:cNvPr id="2" name="">
             <a:extLst xmlns:a="http://schemas.openxmlformats.org/drawingml/2006/main">
               <a:ext uri="{FF2B5EF4-FFF2-40B4-BE49-F238E27FC236}">
-                <a16:creationId xmlns:a16="http://schemas.microsoft.com/office/drawing/2014/main" id="{9BB2990E-7F69-4993-9086-D44E5E5E541D}"/>
+                <a16:creationId xmlns:a16="http://schemas.microsoft.com/office/drawing/2014/main" id="{A7E5E919-0D24-40D5-8E45-27ACDD6A4942}"/>
               </a:ext>
             </a:extLst>
           </p:cNvPr>
@@ -11203,7 +11018,7 @@
           <p:cNvPr id="3" name="">
             <a:extLst xmlns:a="http://schemas.openxmlformats.org/drawingml/2006/main">
               <a:ext uri="{FF2B5EF4-FFF2-40B4-BE49-F238E27FC236}">
-                <a16:creationId xmlns:a16="http://schemas.microsoft.com/office/drawing/2014/main" id="{5FBCE7F6-4D32-435B-8685-323398847AE0}"/>
+                <a16:creationId xmlns:a16="http://schemas.microsoft.com/office/drawing/2014/main" id="{171C937D-D7B6-4C34-AF71-5A132881C38C}"/>
               </a:ext>
             </a:extLst>
           </p:cNvPr>
@@ -11253,7 +11068,7 @@
           <p:cNvPr id="4" name="">
             <a:extLst xmlns:a="http://schemas.openxmlformats.org/drawingml/2006/main">
               <a:ext uri="{FF2B5EF4-FFF2-40B4-BE49-F238E27FC236}">
-                <a16:creationId xmlns:a16="http://schemas.microsoft.com/office/drawing/2014/main" id="{6A62A145-DB33-4EF9-8A31-8BDE2554022A}"/>
+                <a16:creationId xmlns:a16="http://schemas.microsoft.com/office/drawing/2014/main" id="{3BF3B042-F629-4E5A-B8C2-A66644ED5397}"/>
               </a:ext>
             </a:extLst>
           </p:cNvPr>
@@ -11286,7 +11101,7 @@
           <p:cNvPr id="5" name="">
             <a:extLst xmlns:a="http://schemas.openxmlformats.org/drawingml/2006/main">
               <a:ext uri="{FF2B5EF4-FFF2-40B4-BE49-F238E27FC236}">
-                <a16:creationId xmlns:a16="http://schemas.microsoft.com/office/drawing/2014/main" id="{7694D5BD-1B9D-48A1-A805-13E90521992E}"/>
+                <a16:creationId xmlns:a16="http://schemas.microsoft.com/office/drawing/2014/main" id="{F7302BBF-F481-4688-9DB2-63BCF4F85EC2}"/>
               </a:ext>
             </a:extLst>
           </p:cNvPr>
@@ -11336,7 +11151,7 @@
           <p:cNvPr id="6" name="">
             <a:extLst xmlns:a="http://schemas.openxmlformats.org/drawingml/2006/main">
               <a:ext uri="{FF2B5EF4-FFF2-40B4-BE49-F238E27FC236}">
-                <a16:creationId xmlns:a16="http://schemas.microsoft.com/office/drawing/2014/main" id="{3B37262A-E554-4199-BBD3-2786141FE855}"/>
+                <a16:creationId xmlns:a16="http://schemas.microsoft.com/office/drawing/2014/main" id="{E14A70AE-4EDB-411C-8AE0-9BD7548F96D8}"/>
               </a:ext>
             </a:extLst>
           </p:cNvPr>
@@ -11386,7 +11201,7 @@
           <p:cNvPr id="7" name="">
             <a:extLst xmlns:a="http://schemas.openxmlformats.org/drawingml/2006/main">
               <a:ext uri="{FF2B5EF4-FFF2-40B4-BE49-F238E27FC236}">
-                <a16:creationId xmlns:a16="http://schemas.microsoft.com/office/drawing/2014/main" id="{3C1DB500-84C9-4CCE-A098-7D19B35A3ECD}"/>
+                <a16:creationId xmlns:a16="http://schemas.microsoft.com/office/drawing/2014/main" id="{7FF86FD4-E6A5-46B8-912B-B2102142F4C4}"/>
               </a:ext>
             </a:extLst>
           </p:cNvPr>
@@ -11419,7 +11234,7 @@
           <p:cNvPr id="8" name="">
             <a:extLst xmlns:a="http://schemas.openxmlformats.org/drawingml/2006/main">
               <a:ext uri="{FF2B5EF4-FFF2-40B4-BE49-F238E27FC236}">
-                <a16:creationId xmlns:a16="http://schemas.microsoft.com/office/drawing/2014/main" id="{86CC52CE-D630-459F-A146-D5965B7190F9}"/>
+                <a16:creationId xmlns:a16="http://schemas.microsoft.com/office/drawing/2014/main" id="{407B9508-1C82-46BE-AE0C-A5D14AD118E1}"/>
               </a:ext>
             </a:extLst>
           </p:cNvPr>
@@ -11452,7 +11267,7 @@
           <p:cNvPr id="9" name="">
             <a:extLst xmlns:a="http://schemas.openxmlformats.org/drawingml/2006/main">
               <a:ext uri="{FF2B5EF4-FFF2-40B4-BE49-F238E27FC236}">
-                <a16:creationId xmlns:a16="http://schemas.microsoft.com/office/drawing/2014/main" id="{F4E0E7C8-FA19-4382-B596-09113F636360}"/>
+                <a16:creationId xmlns:a16="http://schemas.microsoft.com/office/drawing/2014/main" id="{674B40D0-7187-495B-AFCD-864C861C376B}"/>
               </a:ext>
             </a:extLst>
           </p:cNvPr>
@@ -11502,7 +11317,7 @@
           <p:cNvPr id="10" name="">
             <a:extLst xmlns:a="http://schemas.openxmlformats.org/drawingml/2006/main">
               <a:ext uri="{FF2B5EF4-FFF2-40B4-BE49-F238E27FC236}">
-                <a16:creationId xmlns:a16="http://schemas.microsoft.com/office/drawing/2014/main" id="{6A4F35B2-7256-4480-82CA-A1186BB95D85}"/>
+                <a16:creationId xmlns:a16="http://schemas.microsoft.com/office/drawing/2014/main" id="{D34B8DCC-0623-4707-AE74-D91BF6AEFA0C}"/>
               </a:ext>
             </a:extLst>
           </p:cNvPr>
@@ -11552,7 +11367,7 @@
           <p:cNvPr id="11" name="">
             <a:extLst xmlns:a="http://schemas.openxmlformats.org/drawingml/2006/main">
               <a:ext uri="{FF2B5EF4-FFF2-40B4-BE49-F238E27FC236}">
-                <a16:creationId xmlns:a16="http://schemas.microsoft.com/office/drawing/2014/main" id="{40B1C579-703D-488B-9144-ADB8FD9D6F30}"/>
+                <a16:creationId xmlns:a16="http://schemas.microsoft.com/office/drawing/2014/main" id="{C31DCDE7-E417-4572-A61A-E9176C9AE13A}"/>
               </a:ext>
             </a:extLst>
           </p:cNvPr>
@@ -11602,7 +11417,7 @@
           <p:cNvPr id="12" name="">
             <a:extLst xmlns:a="http://schemas.openxmlformats.org/drawingml/2006/main">
               <a:ext uri="{FF2B5EF4-FFF2-40B4-BE49-F238E27FC236}">
-                <a16:creationId xmlns:a16="http://schemas.microsoft.com/office/drawing/2014/main" id="{83A22E94-F04F-41C9-8DA6-B770A0646CEC}"/>
+                <a16:creationId xmlns:a16="http://schemas.microsoft.com/office/drawing/2014/main" id="{4575A15D-02CE-4879-B405-1976759B4919}"/>
               </a:ext>
             </a:extLst>
           </p:cNvPr>
@@ -11635,7 +11450,7 @@
           <p:cNvPr id="13" name="">
             <a:extLst xmlns:a="http://schemas.openxmlformats.org/drawingml/2006/main">
               <a:ext uri="{FF2B5EF4-FFF2-40B4-BE49-F238E27FC236}">
-                <a16:creationId xmlns:a16="http://schemas.microsoft.com/office/drawing/2014/main" id="{C7BD8B93-B463-4D51-85C4-A0E57E35F490}"/>
+                <a16:creationId xmlns:a16="http://schemas.microsoft.com/office/drawing/2014/main" id="{3A6A34E3-C88D-4A28-ABD4-7E4D1984CD41}"/>
               </a:ext>
             </a:extLst>
           </p:cNvPr>
@@ -11685,7 +11500,7 @@
           <p:cNvPr id="14" name="">
             <a:extLst xmlns:a="http://schemas.openxmlformats.org/drawingml/2006/main">
               <a:ext uri="{FF2B5EF4-FFF2-40B4-BE49-F238E27FC236}">
-                <a16:creationId xmlns:a16="http://schemas.microsoft.com/office/drawing/2014/main" id="{D95FEAA9-1D22-4FA7-9A76-F608446DBFE5}"/>
+                <a16:creationId xmlns:a16="http://schemas.microsoft.com/office/drawing/2014/main" id="{24A7C504-7F72-4308-B929-59DA6DBC9516}"/>
               </a:ext>
             </a:extLst>
           </p:cNvPr>
@@ -11735,7 +11550,7 @@
           <p:cNvPr id="15" name="">
             <a:extLst xmlns:a="http://schemas.openxmlformats.org/drawingml/2006/main">
               <a:ext uri="{FF2B5EF4-FFF2-40B4-BE49-F238E27FC236}">
-                <a16:creationId xmlns:a16="http://schemas.microsoft.com/office/drawing/2014/main" id="{21D5193C-5A9D-4163-AE6E-61B5FB6E8526}"/>
+                <a16:creationId xmlns:a16="http://schemas.microsoft.com/office/drawing/2014/main" id="{EF83359E-C381-4E87-BD25-108F8940740F}"/>
               </a:ext>
             </a:extLst>
           </p:cNvPr>
@@ -11785,7 +11600,7 @@
           <p:cNvPr id="16" name="">
             <a:extLst xmlns:a="http://schemas.openxmlformats.org/drawingml/2006/main">
               <a:ext uri="{FF2B5EF4-FFF2-40B4-BE49-F238E27FC236}">
-                <a16:creationId xmlns:a16="http://schemas.microsoft.com/office/drawing/2014/main" id="{30762E93-60DF-4515-8A1C-B5AD8CA7CE62}"/>
+                <a16:creationId xmlns:a16="http://schemas.microsoft.com/office/drawing/2014/main" id="{6045114D-370B-4169-9E54-F7DF66498E62}"/>
               </a:ext>
             </a:extLst>
           </p:cNvPr>
@@ -11818,7 +11633,7 @@
           <p:cNvPr id="17" name="">
             <a:extLst xmlns:a="http://schemas.openxmlformats.org/drawingml/2006/main">
               <a:ext uri="{FF2B5EF4-FFF2-40B4-BE49-F238E27FC236}">
-                <a16:creationId xmlns:a16="http://schemas.microsoft.com/office/drawing/2014/main" id="{A8A7472D-A33F-427D-9BAB-50B9D8116967}"/>
+                <a16:creationId xmlns:a16="http://schemas.microsoft.com/office/drawing/2014/main" id="{83879DDA-E680-4790-8EC2-B5C1BE6C37B1}"/>
               </a:ext>
             </a:extLst>
           </p:cNvPr>
@@ -11868,7 +11683,7 @@
           <p:cNvPr id="18" name="">
             <a:extLst xmlns:a="http://schemas.openxmlformats.org/drawingml/2006/main">
               <a:ext uri="{FF2B5EF4-FFF2-40B4-BE49-F238E27FC236}">
-                <a16:creationId xmlns:a16="http://schemas.microsoft.com/office/drawing/2014/main" id="{9DB3C984-6613-4221-A743-BA74B2DF2215}"/>
+                <a16:creationId xmlns:a16="http://schemas.microsoft.com/office/drawing/2014/main" id="{5626C6E6-9377-4D18-B3AD-BE74B02C38E9}"/>
               </a:ext>
             </a:extLst>
           </p:cNvPr>
@@ -11918,7 +11733,7 @@
           <p:cNvPr id="19" name="">
             <a:extLst xmlns:a="http://schemas.openxmlformats.org/drawingml/2006/main">
               <a:ext uri="{FF2B5EF4-FFF2-40B4-BE49-F238E27FC236}">
-                <a16:creationId xmlns:a16="http://schemas.microsoft.com/office/drawing/2014/main" id="{C3327685-38E6-4DA9-BA5B-2BAEAF110EE4}"/>
+                <a16:creationId xmlns:a16="http://schemas.microsoft.com/office/drawing/2014/main" id="{87285914-C339-4D53-BC45-F11C3B5B7848}"/>
               </a:ext>
             </a:extLst>
           </p:cNvPr>
@@ -11968,7 +11783,7 @@
           <p:cNvPr id="20" name="">
             <a:extLst xmlns:a="http://schemas.openxmlformats.org/drawingml/2006/main">
               <a:ext uri="{FF2B5EF4-FFF2-40B4-BE49-F238E27FC236}">
-                <a16:creationId xmlns:a16="http://schemas.microsoft.com/office/drawing/2014/main" id="{191B84B4-9316-4D37-B645-BC92202FEE15}"/>
+                <a16:creationId xmlns:a16="http://schemas.microsoft.com/office/drawing/2014/main" id="{C0089FD5-8EA0-4020-949C-D481F0F6E5D9}"/>
               </a:ext>
             </a:extLst>
           </p:cNvPr>
@@ -12001,7 +11816,7 @@
           <p:cNvPr id="21" name="">
             <a:extLst xmlns:a="http://schemas.openxmlformats.org/drawingml/2006/main">
               <a:ext uri="{FF2B5EF4-FFF2-40B4-BE49-F238E27FC236}">
-                <a16:creationId xmlns:a16="http://schemas.microsoft.com/office/drawing/2014/main" id="{834CA885-9CE2-439D-A991-3DBCCD6199E4}"/>
+                <a16:creationId xmlns:a16="http://schemas.microsoft.com/office/drawing/2014/main" id="{E7E0436A-C186-4149-AA45-11D0CE57BE2D}"/>
               </a:ext>
             </a:extLst>
           </p:cNvPr>
@@ -12051,7 +11866,7 @@
           <p:cNvPr id="22" name="">
             <a:extLst xmlns:a="http://schemas.openxmlformats.org/drawingml/2006/main">
               <a:ext uri="{FF2B5EF4-FFF2-40B4-BE49-F238E27FC236}">
-                <a16:creationId xmlns:a16="http://schemas.microsoft.com/office/drawing/2014/main" id="{5417F47D-C0CB-4E32-89E9-092766B45268}"/>
+                <a16:creationId xmlns:a16="http://schemas.microsoft.com/office/drawing/2014/main" id="{E11CE190-D51B-4A5D-BF30-3AA7EEB9CF51}"/>
               </a:ext>
             </a:extLst>
           </p:cNvPr>
@@ -12101,7 +11916,7 @@
           <p:cNvPr id="23" name="">
             <a:extLst xmlns:a="http://schemas.openxmlformats.org/drawingml/2006/main">
               <a:ext uri="{FF2B5EF4-FFF2-40B4-BE49-F238E27FC236}">
-                <a16:creationId xmlns:a16="http://schemas.microsoft.com/office/drawing/2014/main" id="{0462117B-27DD-438B-8199-6CEF3FCF16FB}"/>
+                <a16:creationId xmlns:a16="http://schemas.microsoft.com/office/drawing/2014/main" id="{71A34A5A-1358-430D-8F4B-4A847F3F184E}"/>
               </a:ext>
             </a:extLst>
           </p:cNvPr>
@@ -12151,7 +11966,7 @@
           <p:cNvPr id="24" name="">
             <a:extLst xmlns:a="http://schemas.openxmlformats.org/drawingml/2006/main">
               <a:ext uri="{FF2B5EF4-FFF2-40B4-BE49-F238E27FC236}">
-                <a16:creationId xmlns:a16="http://schemas.microsoft.com/office/drawing/2014/main" id="{44E2DF27-F6E7-493E-8E4F-FE5125E315E3}"/>
+                <a16:creationId xmlns:a16="http://schemas.microsoft.com/office/drawing/2014/main" id="{044BE2E5-9CA5-49DE-9318-A9F5CA695F22}"/>
               </a:ext>
             </a:extLst>
           </p:cNvPr>
@@ -12184,7 +11999,7 @@
           <p:cNvPr id="25" name="">
             <a:extLst xmlns:a="http://schemas.openxmlformats.org/drawingml/2006/main">
               <a:ext uri="{FF2B5EF4-FFF2-40B4-BE49-F238E27FC236}">
-                <a16:creationId xmlns:a16="http://schemas.microsoft.com/office/drawing/2014/main" id="{27D29167-801F-4178-9223-3F8D369799CE}"/>
+                <a16:creationId xmlns:a16="http://schemas.microsoft.com/office/drawing/2014/main" id="{62DD88DA-2BE7-4DA0-AFA5-55DD8A809C63}"/>
               </a:ext>
             </a:extLst>
           </p:cNvPr>
@@ -12234,7 +12049,7 @@
           <p:cNvPr id="26" name="">
             <a:extLst xmlns:a="http://schemas.openxmlformats.org/drawingml/2006/main">
               <a:ext uri="{FF2B5EF4-FFF2-40B4-BE49-F238E27FC236}">
-                <a16:creationId xmlns:a16="http://schemas.microsoft.com/office/drawing/2014/main" id="{AB07703E-AD75-4E63-BC0B-64434B9E1E20}"/>
+                <a16:creationId xmlns:a16="http://schemas.microsoft.com/office/drawing/2014/main" id="{4D479571-7A8C-4B0C-8FE6-64BEDFD738D9}"/>
               </a:ext>
             </a:extLst>
           </p:cNvPr>
@@ -12284,7 +12099,7 @@
           <p:cNvPr id="27" name="">
             <a:extLst xmlns:a="http://schemas.openxmlformats.org/drawingml/2006/main">
               <a:ext uri="{FF2B5EF4-FFF2-40B4-BE49-F238E27FC236}">
-                <a16:creationId xmlns:a16="http://schemas.microsoft.com/office/drawing/2014/main" id="{473D9B07-0052-4AAB-843E-4D142E89FF71}"/>
+                <a16:creationId xmlns:a16="http://schemas.microsoft.com/office/drawing/2014/main" id="{86AEB3A7-918A-4BF0-A943-FC3A5FF26395}"/>
               </a:ext>
             </a:extLst>
           </p:cNvPr>
@@ -12334,7 +12149,7 @@
           <p:cNvPr id="28" name="">
             <a:extLst xmlns:a="http://schemas.openxmlformats.org/drawingml/2006/main">
               <a:ext uri="{FF2B5EF4-FFF2-40B4-BE49-F238E27FC236}">
-                <a16:creationId xmlns:a16="http://schemas.microsoft.com/office/drawing/2014/main" id="{37DC28A3-D55B-4DEE-9611-BBCA89FFC795}"/>
+                <a16:creationId xmlns:a16="http://schemas.microsoft.com/office/drawing/2014/main" id="{FD589CF7-2B6C-44AD-BFEC-314E00A00402}"/>
               </a:ext>
             </a:extLst>
           </p:cNvPr>
@@ -12367,7 +12182,7 @@
           <p:cNvPr id="29" name="">
             <a:extLst xmlns:a="http://schemas.openxmlformats.org/drawingml/2006/main">
               <a:ext uri="{FF2B5EF4-FFF2-40B4-BE49-F238E27FC236}">
-                <a16:creationId xmlns:a16="http://schemas.microsoft.com/office/drawing/2014/main" id="{FE72CF64-997E-4774-B286-E3531B9BE1C6}"/>
+                <a16:creationId xmlns:a16="http://schemas.microsoft.com/office/drawing/2014/main" id="{0E6F7116-ECD0-427A-936D-2775C1BBF26F}"/>
               </a:ext>
             </a:extLst>
           </p:cNvPr>
@@ -12417,7 +12232,7 @@
           <p:cNvPr id="30" name="">
             <a:extLst xmlns:a="http://schemas.openxmlformats.org/drawingml/2006/main">
               <a:ext uri="{FF2B5EF4-FFF2-40B4-BE49-F238E27FC236}">
-                <a16:creationId xmlns:a16="http://schemas.microsoft.com/office/drawing/2014/main" id="{F75980ED-674F-40B5-99A2-39422E227C03}"/>
+                <a16:creationId xmlns:a16="http://schemas.microsoft.com/office/drawing/2014/main" id="{2F954ED6-5E7F-4B71-9243-531FBACF69F8}"/>
               </a:ext>
             </a:extLst>
           </p:cNvPr>
@@ -12467,7 +12282,7 @@
           <p:cNvPr id="31" name="">
             <a:extLst xmlns:a="http://schemas.openxmlformats.org/drawingml/2006/main">
               <a:ext uri="{FF2B5EF4-FFF2-40B4-BE49-F238E27FC236}">
-                <a16:creationId xmlns:a16="http://schemas.microsoft.com/office/drawing/2014/main" id="{1BF435FF-80E9-4BFE-8D8C-C7257E537976}"/>
+                <a16:creationId xmlns:a16="http://schemas.microsoft.com/office/drawing/2014/main" id="{E3966559-B086-4F16-AA3F-2B494CEA7B51}"/>
               </a:ext>
             </a:extLst>
           </p:cNvPr>
@@ -12517,7 +12332,7 @@
           <p:cNvPr id="32" name="">
             <a:extLst xmlns:a="http://schemas.openxmlformats.org/drawingml/2006/main">
               <a:ext uri="{FF2B5EF4-FFF2-40B4-BE49-F238E27FC236}">
-                <a16:creationId xmlns:a16="http://schemas.microsoft.com/office/drawing/2014/main" id="{A277C0ED-472F-4D83-BC72-88927A824BE0}"/>
+                <a16:creationId xmlns:a16="http://schemas.microsoft.com/office/drawing/2014/main" id="{C3AE4038-407C-49FD-A764-4E520C661B89}"/>
               </a:ext>
             </a:extLst>
           </p:cNvPr>
@@ -12550,7 +12365,7 @@
           <p:cNvPr id="33" name="">
             <a:extLst xmlns:a="http://schemas.openxmlformats.org/drawingml/2006/main">
               <a:ext uri="{FF2B5EF4-FFF2-40B4-BE49-F238E27FC236}">
-                <a16:creationId xmlns:a16="http://schemas.microsoft.com/office/drawing/2014/main" id="{B3DA98EB-474D-4C8E-8388-F97A5BFD14F4}"/>
+                <a16:creationId xmlns:a16="http://schemas.microsoft.com/office/drawing/2014/main" id="{BCB59CE6-ACD4-459B-8D00-842FD168ADFE}"/>
               </a:ext>
             </a:extLst>
           </p:cNvPr>
@@ -12600,7 +12415,7 @@
           <p:cNvPr id="34" name="">
             <a:extLst xmlns:a="http://schemas.openxmlformats.org/drawingml/2006/main">
               <a:ext uri="{FF2B5EF4-FFF2-40B4-BE49-F238E27FC236}">
-                <a16:creationId xmlns:a16="http://schemas.microsoft.com/office/drawing/2014/main" id="{C6D48029-DF65-4E1D-9D58-5D0F1E77A10A}"/>
+                <a16:creationId xmlns:a16="http://schemas.microsoft.com/office/drawing/2014/main" id="{1033D22B-6B63-4488-A53A-C4CCA0683842}"/>
               </a:ext>
             </a:extLst>
           </p:cNvPr>
@@ -12650,7 +12465,7 @@
           <p:cNvPr id="35" name="">
             <a:extLst xmlns:a="http://schemas.openxmlformats.org/drawingml/2006/main">
               <a:ext uri="{FF2B5EF4-FFF2-40B4-BE49-F238E27FC236}">
-                <a16:creationId xmlns:a16="http://schemas.microsoft.com/office/drawing/2014/main" id="{59479538-38A0-4792-B978-ED46F09ADB37}"/>
+                <a16:creationId xmlns:a16="http://schemas.microsoft.com/office/drawing/2014/main" id="{9ADEDF0D-6281-4ADA-B9E8-248E4849DE01}"/>
               </a:ext>
             </a:extLst>
           </p:cNvPr>
@@ -12700,7 +12515,7 @@
           <p:cNvPr id="36" name="">
             <a:extLst xmlns:a="http://schemas.openxmlformats.org/drawingml/2006/main">
               <a:ext uri="{FF2B5EF4-FFF2-40B4-BE49-F238E27FC236}">
-                <a16:creationId xmlns:a16="http://schemas.microsoft.com/office/drawing/2014/main" id="{F806DFE5-C551-4910-980A-1BD4F78D1890}"/>
+                <a16:creationId xmlns:a16="http://schemas.microsoft.com/office/drawing/2014/main" id="{6F18B97E-1EEA-44A2-86BE-341A7364FD79}"/>
               </a:ext>
             </a:extLst>
           </p:cNvPr>
@@ -12733,7 +12548,7 @@
           <p:cNvPr id="37" name="">
             <a:extLst xmlns:a="http://schemas.openxmlformats.org/drawingml/2006/main">
               <a:ext uri="{FF2B5EF4-FFF2-40B4-BE49-F238E27FC236}">
-                <a16:creationId xmlns:a16="http://schemas.microsoft.com/office/drawing/2014/main" id="{B54ECCC8-6E3B-4731-A3F4-2953D36900F9}"/>
+                <a16:creationId xmlns:a16="http://schemas.microsoft.com/office/drawing/2014/main" id="{73287276-5DD9-4C1F-A03F-82B5996DC3BB}"/>
               </a:ext>
             </a:extLst>
           </p:cNvPr>
@@ -12783,7 +12598,7 @@
           <p:cNvPr id="38" name="">
             <a:extLst xmlns:a="http://schemas.openxmlformats.org/drawingml/2006/main">
               <a:ext uri="{FF2B5EF4-FFF2-40B4-BE49-F238E27FC236}">
-                <a16:creationId xmlns:a16="http://schemas.microsoft.com/office/drawing/2014/main" id="{707642F9-3B8F-479E-AB95-5ACA10A71FDC}"/>
+                <a16:creationId xmlns:a16="http://schemas.microsoft.com/office/drawing/2014/main" id="{60E2846E-0FB1-462B-AC11-EBAAA58EB52E}"/>
               </a:ext>
             </a:extLst>
           </p:cNvPr>
@@ -12833,7 +12648,7 @@
           <p:cNvPr id="39" name="">
             <a:extLst xmlns:a="http://schemas.openxmlformats.org/drawingml/2006/main">
               <a:ext uri="{FF2B5EF4-FFF2-40B4-BE49-F238E27FC236}">
-                <a16:creationId xmlns:a16="http://schemas.microsoft.com/office/drawing/2014/main" id="{4F3EF7B5-A24E-490C-8C94-F01EB5BAF0B2}"/>
+                <a16:creationId xmlns:a16="http://schemas.microsoft.com/office/drawing/2014/main" id="{8ED1180E-5F0C-4553-AB1B-341ED22F5614}"/>
               </a:ext>
             </a:extLst>
           </p:cNvPr>
@@ -12883,7 +12698,7 @@
           <p:cNvPr id="40" name="">
             <a:extLst xmlns:a="http://schemas.openxmlformats.org/drawingml/2006/main">
               <a:ext uri="{FF2B5EF4-FFF2-40B4-BE49-F238E27FC236}">
-                <a16:creationId xmlns:a16="http://schemas.microsoft.com/office/drawing/2014/main" id="{11046CEB-DC1D-47DF-AFA5-F52762123E11}"/>
+                <a16:creationId xmlns:a16="http://schemas.microsoft.com/office/drawing/2014/main" id="{858593B8-8F94-4D7C-BC6A-41216349F437}"/>
               </a:ext>
             </a:extLst>
           </p:cNvPr>
@@ -12916,7 +12731,7 @@
           <p:cNvPr id="41" name="">
             <a:extLst xmlns:a="http://schemas.openxmlformats.org/drawingml/2006/main">
               <a:ext uri="{FF2B5EF4-FFF2-40B4-BE49-F238E27FC236}">
-                <a16:creationId xmlns:a16="http://schemas.microsoft.com/office/drawing/2014/main" id="{960825A0-DFDB-4062-8591-0B0EA826C836}"/>
+                <a16:creationId xmlns:a16="http://schemas.microsoft.com/office/drawing/2014/main" id="{C4B94BAC-A347-4351-92EA-5D799FB436E5}"/>
               </a:ext>
             </a:extLst>
           </p:cNvPr>
@@ -12966,7 +12781,7 @@
           <p:cNvPr id="42" name="">
             <a:extLst xmlns:a="http://schemas.openxmlformats.org/drawingml/2006/main">
               <a:ext uri="{FF2B5EF4-FFF2-40B4-BE49-F238E27FC236}">
-                <a16:creationId xmlns:a16="http://schemas.microsoft.com/office/drawing/2014/main" id="{534B3114-9634-45F6-8759-41912F9D6CE7}"/>
+                <a16:creationId xmlns:a16="http://schemas.microsoft.com/office/drawing/2014/main" id="{2D32D04C-7815-44EC-A654-A19D69A75102}"/>
               </a:ext>
             </a:extLst>
           </p:cNvPr>
@@ -13016,7 +12831,7 @@
           <p:cNvPr id="43" name="">
             <a:extLst xmlns:a="http://schemas.openxmlformats.org/drawingml/2006/main">
               <a:ext uri="{FF2B5EF4-FFF2-40B4-BE49-F238E27FC236}">
-                <a16:creationId xmlns:a16="http://schemas.microsoft.com/office/drawing/2014/main" id="{2F2FE6EF-42FC-4864-87DF-079F609EAC8C}"/>
+                <a16:creationId xmlns:a16="http://schemas.microsoft.com/office/drawing/2014/main" id="{B49BE097-C6F7-443D-BC5D-C495B9C2023E}"/>
               </a:ext>
             </a:extLst>
           </p:cNvPr>
@@ -13066,7 +12881,7 @@
           <p:cNvPr id="44" name="">
             <a:extLst xmlns:a="http://schemas.openxmlformats.org/drawingml/2006/main">
               <a:ext uri="{FF2B5EF4-FFF2-40B4-BE49-F238E27FC236}">
-                <a16:creationId xmlns:a16="http://schemas.microsoft.com/office/drawing/2014/main" id="{739820E1-9E86-4529-BBE5-7C4D0FA5D77F}"/>
+                <a16:creationId xmlns:a16="http://schemas.microsoft.com/office/drawing/2014/main" id="{FD459749-AFDD-4736-A7FA-866CFE2C6FEB}"/>
               </a:ext>
             </a:extLst>
           </p:cNvPr>
@@ -13101,7 +12916,7 @@
           <p:cNvPr id="45" name="">
             <a:extLst xmlns:a="http://schemas.openxmlformats.org/drawingml/2006/main">
               <a:ext uri="{FF2B5EF4-FFF2-40B4-BE49-F238E27FC236}">
-                <a16:creationId xmlns:a16="http://schemas.microsoft.com/office/drawing/2014/main" id="{EA459A54-C78B-4465-B462-7C7BB94FD96E}"/>
+                <a16:creationId xmlns:a16="http://schemas.microsoft.com/office/drawing/2014/main" id="{BCAC8AC1-52CB-4F58-9596-8B1389E7AF03}"/>
               </a:ext>
             </a:extLst>
           </p:cNvPr>
@@ -13151,7 +12966,7 @@
           <p:cNvPr id="46" name="">
             <a:extLst xmlns:a="http://schemas.openxmlformats.org/drawingml/2006/main">
               <a:ext uri="{FF2B5EF4-FFF2-40B4-BE49-F238E27FC236}">
-                <a16:creationId xmlns:a16="http://schemas.microsoft.com/office/drawing/2014/main" id="{C4617948-2E3F-41DE-9562-C1DCDF582E26}"/>
+                <a16:creationId xmlns:a16="http://schemas.microsoft.com/office/drawing/2014/main" id="{7809F8BE-E072-4DC1-A983-EB87D4A0D7D3}"/>
               </a:ext>
             </a:extLst>
           </p:cNvPr>
@@ -13201,7 +13016,7 @@
           <p:cNvPr id="47" name="">
             <a:extLst xmlns:a="http://schemas.openxmlformats.org/drawingml/2006/main">
               <a:ext uri="{FF2B5EF4-FFF2-40B4-BE49-F238E27FC236}">
-                <a16:creationId xmlns:a16="http://schemas.microsoft.com/office/drawing/2014/main" id="{FE2832A9-305C-4AE6-A373-ECF0C6DBFCB9}"/>
+                <a16:creationId xmlns:a16="http://schemas.microsoft.com/office/drawing/2014/main" id="{0842C2B9-3021-4369-89C5-2E27B8E16812}"/>
               </a:ext>
             </a:extLst>
           </p:cNvPr>
@@ -13251,7 +13066,7 @@
           <p:cNvPr id="48" name="">
             <a:extLst xmlns:a="http://schemas.openxmlformats.org/drawingml/2006/main">
               <a:ext uri="{FF2B5EF4-FFF2-40B4-BE49-F238E27FC236}">
-                <a16:creationId xmlns:a16="http://schemas.microsoft.com/office/drawing/2014/main" id="{2FA172AB-8AD0-47CC-894D-1A6A480996A5}"/>
+                <a16:creationId xmlns:a16="http://schemas.microsoft.com/office/drawing/2014/main" id="{D55A3A58-65A2-4504-A1DA-0DF014202E04}"/>
               </a:ext>
             </a:extLst>
           </p:cNvPr>
@@ -13301,7 +13116,7 @@
           <p:cNvPr id="49" name="">
             <a:extLst xmlns:a="http://schemas.openxmlformats.org/drawingml/2006/main">
               <a:ext uri="{FF2B5EF4-FFF2-40B4-BE49-F238E27FC236}">
-                <a16:creationId xmlns:a16="http://schemas.microsoft.com/office/drawing/2014/main" id="{5F0F7299-013B-42FF-BD7C-06136CF4F386}"/>
+                <a16:creationId xmlns:a16="http://schemas.microsoft.com/office/drawing/2014/main" id="{B8CA0057-0CDC-41F9-9225-BB50172FE4B9}"/>
               </a:ext>
             </a:extLst>
           </p:cNvPr>
@@ -13351,7 +13166,7 @@
           <p:cNvPr id="50" name="">
             <a:extLst xmlns:a="http://schemas.openxmlformats.org/drawingml/2006/main">
               <a:ext uri="{FF2B5EF4-FFF2-40B4-BE49-F238E27FC236}">
-                <a16:creationId xmlns:a16="http://schemas.microsoft.com/office/drawing/2014/main" id="{AD7CBB4C-434E-4707-BE0E-459E091A5D6F}"/>
+                <a16:creationId xmlns:a16="http://schemas.microsoft.com/office/drawing/2014/main" id="{E93FA151-FDAB-43AB-91C9-5E6C0A2A9AC8}"/>
               </a:ext>
             </a:extLst>
           </p:cNvPr>
@@ -13384,7 +13199,7 @@
           <p:cNvPr id="51" name="">
             <a:extLst xmlns:a="http://schemas.openxmlformats.org/drawingml/2006/main">
               <a:ext uri="{FF2B5EF4-FFF2-40B4-BE49-F238E27FC236}">
-                <a16:creationId xmlns:a16="http://schemas.microsoft.com/office/drawing/2014/main" id="{82693BE8-2794-479C-AA8D-7FEA570FBEA2}"/>
+                <a16:creationId xmlns:a16="http://schemas.microsoft.com/office/drawing/2014/main" id="{EE75C711-5548-4347-8FC0-DCA558CA3E57}"/>
               </a:ext>
             </a:extLst>
           </p:cNvPr>
@@ -13434,7 +13249,7 @@
           <p:cNvPr id="52" name="">
             <a:extLst xmlns:a="http://schemas.openxmlformats.org/drawingml/2006/main">
               <a:ext uri="{FF2B5EF4-FFF2-40B4-BE49-F238E27FC236}">
-                <a16:creationId xmlns:a16="http://schemas.microsoft.com/office/drawing/2014/main" id="{25C183CB-C992-465A-85F8-BB294EAFC01A}"/>
+                <a16:creationId xmlns:a16="http://schemas.microsoft.com/office/drawing/2014/main" id="{6B8C0DBC-FF14-49EB-BC17-8A6D30570211}"/>
               </a:ext>
             </a:extLst>
           </p:cNvPr>
@@ -13482,7 +13297,7 @@
     </p:spTree>
     <p:extLst>
       <p:ext uri="{BB962C8B-B14F-4D97-AF65-F5344CB8AC3E}">
-        <p14:creationId xmlns:p14="http://schemas.microsoft.com/office/powerpoint/2010/main" val="1521527682"/>
+        <p14:creationId xmlns:p14="http://schemas.microsoft.com/office/powerpoint/2010/main" val="1975235635"/>
       </p:ext>
     </p:extLst>
   </p:cSld>
@@ -13513,7 +13328,7 @@
           <p:cNvPr id="30" name="">
             <a:extLst xmlns:a="http://schemas.openxmlformats.org/drawingml/2006/main">
               <a:ext uri="{FF2B5EF4-FFF2-40B4-BE49-F238E27FC236}">
-                <a16:creationId xmlns:a16="http://schemas.microsoft.com/office/drawing/2014/main" id="{18B3645E-E816-4E32-AEC2-6273301E2624}"/>
+                <a16:creationId xmlns:a16="http://schemas.microsoft.com/office/drawing/2014/main" id="{D0C0893B-27AA-459E-AE48-4B222FA6179F}"/>
               </a:ext>
             </a:extLst>
           </p:cNvPr>
@@ -13563,7 +13378,7 @@
           <p:cNvPr id="2" name="">
             <a:extLst xmlns:a="http://schemas.openxmlformats.org/drawingml/2006/main">
               <a:ext uri="{FF2B5EF4-FFF2-40B4-BE49-F238E27FC236}">
-                <a16:creationId xmlns:a16="http://schemas.microsoft.com/office/drawing/2014/main" id="{44FC8F39-A3E4-4AB5-B394-1289779CA380}"/>
+                <a16:creationId xmlns:a16="http://schemas.microsoft.com/office/drawing/2014/main" id="{6FD4B7D1-F638-48AE-98DA-2F1799EA241C}"/>
               </a:ext>
             </a:extLst>
           </p:cNvPr>
@@ -13613,7 +13428,7 @@
           <p:cNvPr id="3" name="">
             <a:extLst xmlns:a="http://schemas.openxmlformats.org/drawingml/2006/main">
               <a:ext uri="{FF2B5EF4-FFF2-40B4-BE49-F238E27FC236}">
-                <a16:creationId xmlns:a16="http://schemas.microsoft.com/office/drawing/2014/main" id="{04344F1D-45BD-41E2-9624-1699588AF786}"/>
+                <a16:creationId xmlns:a16="http://schemas.microsoft.com/office/drawing/2014/main" id="{C2BA400C-3023-417F-98B6-69FF8C50F419}"/>
               </a:ext>
             </a:extLst>
           </p:cNvPr>
@@ -13663,7 +13478,7 @@
           <p:cNvPr id="4" name="">
             <a:extLst xmlns:a="http://schemas.openxmlformats.org/drawingml/2006/main">
               <a:ext uri="{FF2B5EF4-FFF2-40B4-BE49-F238E27FC236}">
-                <a16:creationId xmlns:a16="http://schemas.microsoft.com/office/drawing/2014/main" id="{8903689F-DE75-4271-A4FC-FDCDFEA0E6C2}"/>
+                <a16:creationId xmlns:a16="http://schemas.microsoft.com/office/drawing/2014/main" id="{70761418-5E91-43A7-B178-902B20E85287}"/>
               </a:ext>
             </a:extLst>
           </p:cNvPr>
@@ -13696,7 +13511,7 @@
           <p:cNvPr id="5" name="">
             <a:extLst xmlns:a="http://schemas.openxmlformats.org/drawingml/2006/main">
               <a:ext uri="{FF2B5EF4-FFF2-40B4-BE49-F238E27FC236}">
-                <a16:creationId xmlns:a16="http://schemas.microsoft.com/office/drawing/2014/main" id="{2935DBC5-10E1-41B5-8681-6692189E395C}"/>
+                <a16:creationId xmlns:a16="http://schemas.microsoft.com/office/drawing/2014/main" id="{5BD7306A-E0FE-4BCE-AF67-2E6BBB8B7876}"/>
               </a:ext>
             </a:extLst>
           </p:cNvPr>
@@ -13746,7 +13561,7 @@
           <p:cNvPr id="6" name="">
             <a:extLst xmlns:a="http://schemas.openxmlformats.org/drawingml/2006/main">
               <a:ext uri="{FF2B5EF4-FFF2-40B4-BE49-F238E27FC236}">
-                <a16:creationId xmlns:a16="http://schemas.microsoft.com/office/drawing/2014/main" id="{4CABFB85-0BE4-4927-AD73-E28CF1CABCB4}"/>
+                <a16:creationId xmlns:a16="http://schemas.microsoft.com/office/drawing/2014/main" id="{371E8CC5-0C3B-4C93-8A66-8DD4EF464C8E}"/>
               </a:ext>
             </a:extLst>
           </p:cNvPr>
@@ -13796,7 +13611,7 @@
           <p:cNvPr id="7" name="">
             <a:extLst xmlns:a="http://schemas.openxmlformats.org/drawingml/2006/main">
               <a:ext uri="{FF2B5EF4-FFF2-40B4-BE49-F238E27FC236}">
-                <a16:creationId xmlns:a16="http://schemas.microsoft.com/office/drawing/2014/main" id="{6C090475-1C7E-4DA5-8158-CEAB904D2BBB}"/>
+                <a16:creationId xmlns:a16="http://schemas.microsoft.com/office/drawing/2014/main" id="{E43E8B72-F4CF-4ED8-BCCA-6B3688D5510D}"/>
               </a:ext>
             </a:extLst>
           </p:cNvPr>
@@ -13846,7 +13661,7 @@
           <p:cNvPr id="8" name="">
             <a:extLst xmlns:a="http://schemas.openxmlformats.org/drawingml/2006/main">
               <a:ext uri="{FF2B5EF4-FFF2-40B4-BE49-F238E27FC236}">
-                <a16:creationId xmlns:a16="http://schemas.microsoft.com/office/drawing/2014/main" id="{00580713-9276-4954-A1D2-6262D96E643C}"/>
+                <a16:creationId xmlns:a16="http://schemas.microsoft.com/office/drawing/2014/main" id="{C3057458-D638-4B1F-8552-551A24EEF276}"/>
               </a:ext>
             </a:extLst>
           </p:cNvPr>
@@ -13896,7 +13711,7 @@
           <p:cNvPr id="9" name="">
             <a:extLst xmlns:a="http://schemas.openxmlformats.org/drawingml/2006/main">
               <a:ext uri="{FF2B5EF4-FFF2-40B4-BE49-F238E27FC236}">
-                <a16:creationId xmlns:a16="http://schemas.microsoft.com/office/drawing/2014/main" id="{C97CDF79-14FD-4C13-A061-C85D11172DB2}"/>
+                <a16:creationId xmlns:a16="http://schemas.microsoft.com/office/drawing/2014/main" id="{C3FFDE79-42C3-4FDA-BF99-81541360CE01}"/>
               </a:ext>
             </a:extLst>
           </p:cNvPr>
@@ -13946,7 +13761,7 @@
           <p:cNvPr id="10" name="">
             <a:extLst xmlns:a="http://schemas.openxmlformats.org/drawingml/2006/main">
               <a:ext uri="{FF2B5EF4-FFF2-40B4-BE49-F238E27FC236}">
-                <a16:creationId xmlns:a16="http://schemas.microsoft.com/office/drawing/2014/main" id="{6F1EE0BA-18B9-4C70-9FF8-6AF324CDB6BB}"/>
+                <a16:creationId xmlns:a16="http://schemas.microsoft.com/office/drawing/2014/main" id="{1E2FD92A-18E5-423B-B827-E3FB224D3C85}"/>
               </a:ext>
             </a:extLst>
           </p:cNvPr>
@@ -13979,7 +13794,7 @@
           <p:cNvPr id="11" name="">
             <a:extLst xmlns:a="http://schemas.openxmlformats.org/drawingml/2006/main">
               <a:ext uri="{FF2B5EF4-FFF2-40B4-BE49-F238E27FC236}">
-                <a16:creationId xmlns:a16="http://schemas.microsoft.com/office/drawing/2014/main" id="{00BB89CB-ED27-41BA-B28F-1809AA71EB38}"/>
+                <a16:creationId xmlns:a16="http://schemas.microsoft.com/office/drawing/2014/main" id="{6626C7D0-A227-41CF-A272-5A231CD8980D}"/>
               </a:ext>
             </a:extLst>
           </p:cNvPr>
@@ -14029,7 +13844,7 @@
           <p:cNvPr id="12" name="">
             <a:extLst xmlns:a="http://schemas.openxmlformats.org/drawingml/2006/main">
               <a:ext uri="{FF2B5EF4-FFF2-40B4-BE49-F238E27FC236}">
-                <a16:creationId xmlns:a16="http://schemas.microsoft.com/office/drawing/2014/main" id="{1DA10CC4-E542-4696-B629-24F629EEDDEF}"/>
+                <a16:creationId xmlns:a16="http://schemas.microsoft.com/office/drawing/2014/main" id="{2FE86E99-CE0F-418E-9283-96FAE4D66587}"/>
               </a:ext>
             </a:extLst>
           </p:cNvPr>
@@ -14079,7 +13894,7 @@
           <p:cNvPr id="13" name="">
             <a:extLst xmlns:a="http://schemas.openxmlformats.org/drawingml/2006/main">
               <a:ext uri="{FF2B5EF4-FFF2-40B4-BE49-F238E27FC236}">
-                <a16:creationId xmlns:a16="http://schemas.microsoft.com/office/drawing/2014/main" id="{A60A3F9B-ABDE-4303-AC80-A0CA31C6ED11}"/>
+                <a16:creationId xmlns:a16="http://schemas.microsoft.com/office/drawing/2014/main" id="{520B7B9E-8286-468E-AD9A-D4CC276CEE2C}"/>
               </a:ext>
             </a:extLst>
           </p:cNvPr>
@@ -14129,7 +13944,7 @@
           <p:cNvPr id="14" name="">
             <a:extLst xmlns:a="http://schemas.openxmlformats.org/drawingml/2006/main">
               <a:ext uri="{FF2B5EF4-FFF2-40B4-BE49-F238E27FC236}">
-                <a16:creationId xmlns:a16="http://schemas.microsoft.com/office/drawing/2014/main" id="{9F32D3B3-C6F0-4B38-B6C3-28B86D9494D0}"/>
+                <a16:creationId xmlns:a16="http://schemas.microsoft.com/office/drawing/2014/main" id="{6BADEFD3-F916-4ECD-BAA2-5F9F9E2C5545}"/>
               </a:ext>
             </a:extLst>
           </p:cNvPr>
@@ -14162,7 +13977,7 @@
           <p:cNvPr id="15" name="">
             <a:extLst xmlns:a="http://schemas.openxmlformats.org/drawingml/2006/main">
               <a:ext uri="{FF2B5EF4-FFF2-40B4-BE49-F238E27FC236}">
-                <a16:creationId xmlns:a16="http://schemas.microsoft.com/office/drawing/2014/main" id="{0E9120FC-0F83-4888-8127-608ABBF5447F}"/>
+                <a16:creationId xmlns:a16="http://schemas.microsoft.com/office/drawing/2014/main" id="{4BD25798-C671-4045-BF2C-410A0BA82B83}"/>
               </a:ext>
             </a:extLst>
           </p:cNvPr>
@@ -14212,7 +14027,7 @@
           <p:cNvPr id="16" name="">
             <a:extLst xmlns:a="http://schemas.openxmlformats.org/drawingml/2006/main">
               <a:ext uri="{FF2B5EF4-FFF2-40B4-BE49-F238E27FC236}">
-                <a16:creationId xmlns:a16="http://schemas.microsoft.com/office/drawing/2014/main" id="{CA161B40-1744-4060-B592-5170D86ABA61}"/>
+                <a16:creationId xmlns:a16="http://schemas.microsoft.com/office/drawing/2014/main" id="{A50C450F-22DD-4CCC-937D-12D86FA2416B}"/>
               </a:ext>
             </a:extLst>
           </p:cNvPr>
@@ -14262,7 +14077,7 @@
           <p:cNvPr id="17" name="">
             <a:extLst xmlns:a="http://schemas.openxmlformats.org/drawingml/2006/main">
               <a:ext uri="{FF2B5EF4-FFF2-40B4-BE49-F238E27FC236}">
-                <a16:creationId xmlns:a16="http://schemas.microsoft.com/office/drawing/2014/main" id="{BA0BA34B-6C51-49BE-A1BF-CE4C86B78B03}"/>
+                <a16:creationId xmlns:a16="http://schemas.microsoft.com/office/drawing/2014/main" id="{6CA7865A-3E87-4A7D-8490-FDF89F0650B4}"/>
               </a:ext>
             </a:extLst>
           </p:cNvPr>
@@ -14312,7 +14127,7 @@
           <p:cNvPr id="18" name="">
             <a:extLst xmlns:a="http://schemas.openxmlformats.org/drawingml/2006/main">
               <a:ext uri="{FF2B5EF4-FFF2-40B4-BE49-F238E27FC236}">
-                <a16:creationId xmlns:a16="http://schemas.microsoft.com/office/drawing/2014/main" id="{F7F62C0B-C4CF-44D2-A3DA-D46BDD5462EA}"/>
+                <a16:creationId xmlns:a16="http://schemas.microsoft.com/office/drawing/2014/main" id="{78B61E5C-DE5F-475E-991F-DD45300CAA83}"/>
               </a:ext>
             </a:extLst>
           </p:cNvPr>
@@ -14345,7 +14160,7 @@
           <p:cNvPr id="19" name="">
             <a:extLst xmlns:a="http://schemas.openxmlformats.org/drawingml/2006/main">
               <a:ext uri="{FF2B5EF4-FFF2-40B4-BE49-F238E27FC236}">
-                <a16:creationId xmlns:a16="http://schemas.microsoft.com/office/drawing/2014/main" id="{A744A5C7-4045-4D4D-BFB4-847EAC724340}"/>
+                <a16:creationId xmlns:a16="http://schemas.microsoft.com/office/drawing/2014/main" id="{5CDE78F9-94EB-4A7E-B7F3-20B2351F330E}"/>
               </a:ext>
             </a:extLst>
           </p:cNvPr>
@@ -14395,7 +14210,7 @@
           <p:cNvPr id="20" name="">
             <a:extLst xmlns:a="http://schemas.openxmlformats.org/drawingml/2006/main">
               <a:ext uri="{FF2B5EF4-FFF2-40B4-BE49-F238E27FC236}">
-                <a16:creationId xmlns:a16="http://schemas.microsoft.com/office/drawing/2014/main" id="{5B3D2AB6-1C35-4902-9DC8-7320AE91B9B3}"/>
+                <a16:creationId xmlns:a16="http://schemas.microsoft.com/office/drawing/2014/main" id="{42F8CDF7-56D7-44DE-AEBA-68E9248CF7B9}"/>
               </a:ext>
             </a:extLst>
           </p:cNvPr>
@@ -14445,7 +14260,7 @@
           <p:cNvPr id="21" name="">
             <a:extLst xmlns:a="http://schemas.openxmlformats.org/drawingml/2006/main">
               <a:ext uri="{FF2B5EF4-FFF2-40B4-BE49-F238E27FC236}">
-                <a16:creationId xmlns:a16="http://schemas.microsoft.com/office/drawing/2014/main" id="{AFD04606-6AAD-4804-AF29-02D00CB37949}"/>
+                <a16:creationId xmlns:a16="http://schemas.microsoft.com/office/drawing/2014/main" id="{9E585CF4-25D1-4998-AEA4-938B5935E66A}"/>
               </a:ext>
             </a:extLst>
           </p:cNvPr>
@@ -14495,7 +14310,7 @@
           <p:cNvPr id="22" name="">
             <a:extLst xmlns:a="http://schemas.openxmlformats.org/drawingml/2006/main">
               <a:ext uri="{FF2B5EF4-FFF2-40B4-BE49-F238E27FC236}">
-                <a16:creationId xmlns:a16="http://schemas.microsoft.com/office/drawing/2014/main" id="{5012E75A-26EE-434C-B90F-9207FB88700A}"/>
+                <a16:creationId xmlns:a16="http://schemas.microsoft.com/office/drawing/2014/main" id="{A5BD156D-A9FB-4B4C-BD26-D39395529F27}"/>
               </a:ext>
             </a:extLst>
           </p:cNvPr>
@@ -14528,7 +14343,7 @@
           <p:cNvPr id="23" name="">
             <a:extLst xmlns:a="http://schemas.openxmlformats.org/drawingml/2006/main">
               <a:ext uri="{FF2B5EF4-FFF2-40B4-BE49-F238E27FC236}">
-                <a16:creationId xmlns:a16="http://schemas.microsoft.com/office/drawing/2014/main" id="{71ECB96F-4EB8-4A26-AD78-BC9999197A5C}"/>
+                <a16:creationId xmlns:a16="http://schemas.microsoft.com/office/drawing/2014/main" id="{B453718F-EE27-4E43-99C9-D7D9D71B7792}"/>
               </a:ext>
             </a:extLst>
           </p:cNvPr>
@@ -14563,7 +14378,7 @@
           <p:cNvPr id="24" name="">
             <a:extLst xmlns:a="http://schemas.openxmlformats.org/drawingml/2006/main">
               <a:ext uri="{FF2B5EF4-FFF2-40B4-BE49-F238E27FC236}">
-                <a16:creationId xmlns:a16="http://schemas.microsoft.com/office/drawing/2014/main" id="{EEF147EF-ECDD-406D-85E1-1749F642A399}"/>
+                <a16:creationId xmlns:a16="http://schemas.microsoft.com/office/drawing/2014/main" id="{B55888F1-AF25-41F5-9E2E-B0627B2A4000}"/>
               </a:ext>
             </a:extLst>
           </p:cNvPr>
@@ -14613,7 +14428,7 @@
           <p:cNvPr id="25" name="">
             <a:extLst xmlns:a="http://schemas.openxmlformats.org/drawingml/2006/main">
               <a:ext uri="{FF2B5EF4-FFF2-40B4-BE49-F238E27FC236}">
-                <a16:creationId xmlns:a16="http://schemas.microsoft.com/office/drawing/2014/main" id="{371C12FD-1068-4CA3-B0BE-FDBCCE9C539E}"/>
+                <a16:creationId xmlns:a16="http://schemas.microsoft.com/office/drawing/2014/main" id="{EA735AAE-2FB4-46A4-BB76-6FD8DFB318BA}"/>
               </a:ext>
             </a:extLst>
           </p:cNvPr>
@@ -14663,7 +14478,7 @@
           <p:cNvPr id="26" name="">
             <a:extLst xmlns:a="http://schemas.openxmlformats.org/drawingml/2006/main">
               <a:ext uri="{FF2B5EF4-FFF2-40B4-BE49-F238E27FC236}">
-                <a16:creationId xmlns:a16="http://schemas.microsoft.com/office/drawing/2014/main" id="{0A72C166-E228-47AD-9360-3A9AED82A1F5}"/>
+                <a16:creationId xmlns:a16="http://schemas.microsoft.com/office/drawing/2014/main" id="{CDEB1278-6021-43C0-9C7E-F5E8682A9596}"/>
               </a:ext>
             </a:extLst>
           </p:cNvPr>
@@ -14781,7 +14596,7 @@
           <p:cNvPr id="27" name="">
             <a:extLst xmlns:a="http://schemas.openxmlformats.org/drawingml/2006/main">
               <a:ext uri="{FF2B5EF4-FFF2-40B4-BE49-F238E27FC236}">
-                <a16:creationId xmlns:a16="http://schemas.microsoft.com/office/drawing/2014/main" id="{AEAF3CD4-A034-40C4-AA07-7B3EF797D609}"/>
+                <a16:creationId xmlns:a16="http://schemas.microsoft.com/office/drawing/2014/main" id="{3B6CDE1B-46AD-4288-B6F3-CC97D1E0F459}"/>
               </a:ext>
             </a:extLst>
           </p:cNvPr>
@@ -14814,7 +14629,7 @@
           <p:cNvPr id="28" name="">
             <a:extLst xmlns:a="http://schemas.openxmlformats.org/drawingml/2006/main">
               <a:ext uri="{FF2B5EF4-FFF2-40B4-BE49-F238E27FC236}">
-                <a16:creationId xmlns:a16="http://schemas.microsoft.com/office/drawing/2014/main" id="{2E0F23D6-88BA-439F-9651-9F94438810DB}"/>
+                <a16:creationId xmlns:a16="http://schemas.microsoft.com/office/drawing/2014/main" id="{4606F44D-D67E-4103-A502-D14D3F0885B7}"/>
               </a:ext>
             </a:extLst>
           </p:cNvPr>
@@ -14864,7 +14679,7 @@
           <p:cNvPr id="29" name="">
             <a:extLst xmlns:a="http://schemas.openxmlformats.org/drawingml/2006/main">
               <a:ext uri="{FF2B5EF4-FFF2-40B4-BE49-F238E27FC236}">
-                <a16:creationId xmlns:a16="http://schemas.microsoft.com/office/drawing/2014/main" id="{2A600F4F-639D-4DA3-8C9D-ABDC77EE2E3B}"/>
+                <a16:creationId xmlns:a16="http://schemas.microsoft.com/office/drawing/2014/main" id="{D051FEBF-4330-4902-88B1-7CC0BCA38254}"/>
               </a:ext>
             </a:extLst>
           </p:cNvPr>
@@ -14912,7 +14727,7 @@
     </p:spTree>
     <p:extLst>
       <p:ext uri="{BB962C8B-B14F-4D97-AF65-F5344CB8AC3E}">
-        <p14:creationId xmlns:p14="http://schemas.microsoft.com/office/powerpoint/2010/main" val="864636432"/>
+        <p14:creationId xmlns:p14="http://schemas.microsoft.com/office/powerpoint/2010/main" val="960457165"/>
       </p:ext>
     </p:extLst>
   </p:cSld>
@@ -14943,7 +14758,7 @@
           <p:cNvPr id="36" name="">
             <a:extLst xmlns:a="http://schemas.openxmlformats.org/drawingml/2006/main">
               <a:ext uri="{FF2B5EF4-FFF2-40B4-BE49-F238E27FC236}">
-                <a16:creationId xmlns:a16="http://schemas.microsoft.com/office/drawing/2014/main" id="{80CA34F4-B283-4E70-B753-737C055AD4F3}"/>
+                <a16:creationId xmlns:a16="http://schemas.microsoft.com/office/drawing/2014/main" id="{C5135512-E421-4B9E-A3C9-1CF63D99619C}"/>
               </a:ext>
             </a:extLst>
           </p:cNvPr>
@@ -14993,7 +14808,7 @@
           <p:cNvPr id="2" name="">
             <a:extLst xmlns:a="http://schemas.openxmlformats.org/drawingml/2006/main">
               <a:ext uri="{FF2B5EF4-FFF2-40B4-BE49-F238E27FC236}">
-                <a16:creationId xmlns:a16="http://schemas.microsoft.com/office/drawing/2014/main" id="{9471C684-7929-40F5-8405-8778608D270E}"/>
+                <a16:creationId xmlns:a16="http://schemas.microsoft.com/office/drawing/2014/main" id="{2D7186B3-6EB5-4CEE-ADF4-E44757C52BC9}"/>
               </a:ext>
             </a:extLst>
           </p:cNvPr>
@@ -15043,7 +14858,7 @@
           <p:cNvPr id="3" name="">
             <a:extLst xmlns:a="http://schemas.openxmlformats.org/drawingml/2006/main">
               <a:ext uri="{FF2B5EF4-FFF2-40B4-BE49-F238E27FC236}">
-                <a16:creationId xmlns:a16="http://schemas.microsoft.com/office/drawing/2014/main" id="{0E50BB90-9E2E-406F-844E-57BEF7E948F8}"/>
+                <a16:creationId xmlns:a16="http://schemas.microsoft.com/office/drawing/2014/main" id="{84DFE9E1-3B13-43E5-9939-F9C5CCA56518}"/>
               </a:ext>
             </a:extLst>
           </p:cNvPr>
@@ -15093,7 +14908,7 @@
           <p:cNvPr id="4" name="">
             <a:extLst xmlns:a="http://schemas.openxmlformats.org/drawingml/2006/main">
               <a:ext uri="{FF2B5EF4-FFF2-40B4-BE49-F238E27FC236}">
-                <a16:creationId xmlns:a16="http://schemas.microsoft.com/office/drawing/2014/main" id="{63150128-8762-49BA-B2A1-5234553CD22E}"/>
+                <a16:creationId xmlns:a16="http://schemas.microsoft.com/office/drawing/2014/main" id="{7A73F7D8-6580-4306-A23B-8FBD08628AF6}"/>
               </a:ext>
             </a:extLst>
           </p:cNvPr>
@@ -15126,7 +14941,7 @@
           <p:cNvPr id="5" name="">
             <a:extLst xmlns:a="http://schemas.openxmlformats.org/drawingml/2006/main">
               <a:ext uri="{FF2B5EF4-FFF2-40B4-BE49-F238E27FC236}">
-                <a16:creationId xmlns:a16="http://schemas.microsoft.com/office/drawing/2014/main" id="{D2159D9C-1731-4EFE-8D8D-362AAA0437A5}"/>
+                <a16:creationId xmlns:a16="http://schemas.microsoft.com/office/drawing/2014/main" id="{701984BB-518B-4F9F-8FE2-261AA7636528}"/>
               </a:ext>
             </a:extLst>
           </p:cNvPr>
@@ -15176,7 +14991,7 @@
           <p:cNvPr id="6" name="">
             <a:extLst xmlns:a="http://schemas.openxmlformats.org/drawingml/2006/main">
               <a:ext uri="{FF2B5EF4-FFF2-40B4-BE49-F238E27FC236}">
-                <a16:creationId xmlns:a16="http://schemas.microsoft.com/office/drawing/2014/main" id="{152D9369-C0B4-47EC-9FCF-1551E0654FAF}"/>
+                <a16:creationId xmlns:a16="http://schemas.microsoft.com/office/drawing/2014/main" id="{A0B84A68-3F68-4E7C-936F-A72A689546E4}"/>
               </a:ext>
             </a:extLst>
           </p:cNvPr>
@@ -15226,7 +15041,7 @@
           <p:cNvPr id="7" name="">
             <a:extLst xmlns:a="http://schemas.openxmlformats.org/drawingml/2006/main">
               <a:ext uri="{FF2B5EF4-FFF2-40B4-BE49-F238E27FC236}">
-                <a16:creationId xmlns:a16="http://schemas.microsoft.com/office/drawing/2014/main" id="{84BC2FD1-F683-46DF-8635-A5DE168CB556}"/>
+                <a16:creationId xmlns:a16="http://schemas.microsoft.com/office/drawing/2014/main" id="{8171121A-301E-425D-95DB-B2B1E87A2E42}"/>
               </a:ext>
             </a:extLst>
           </p:cNvPr>
@@ -15261,7 +15076,7 @@
           <p:cNvPr id="8" name="">
             <a:extLst xmlns:a="http://schemas.openxmlformats.org/drawingml/2006/main">
               <a:ext uri="{FF2B5EF4-FFF2-40B4-BE49-F238E27FC236}">
-                <a16:creationId xmlns:a16="http://schemas.microsoft.com/office/drawing/2014/main" id="{90251DBB-0266-46EB-97D2-9270C3BE1ACD}"/>
+                <a16:creationId xmlns:a16="http://schemas.microsoft.com/office/drawing/2014/main" id="{D2FA81DC-8679-495B-86BD-C15BDDA87DB9}"/>
               </a:ext>
             </a:extLst>
           </p:cNvPr>
@@ -15328,7 +15143,7 @@
           <p:cNvPr id="9" name="">
             <a:extLst xmlns:a="http://schemas.openxmlformats.org/drawingml/2006/main">
               <a:ext uri="{FF2B5EF4-FFF2-40B4-BE49-F238E27FC236}">
-                <a16:creationId xmlns:a16="http://schemas.microsoft.com/office/drawing/2014/main" id="{CFE9DDF6-2AF3-4942-98DC-1DE16BB96BF0}"/>
+                <a16:creationId xmlns:a16="http://schemas.microsoft.com/office/drawing/2014/main" id="{29F3678F-9E15-4F04-9738-86EA5E21D9F9}"/>
               </a:ext>
             </a:extLst>
           </p:cNvPr>
@@ -15463,7 +15278,7 @@
           <p:cNvPr id="10" name="">
             <a:extLst xmlns:a="http://schemas.openxmlformats.org/drawingml/2006/main">
               <a:ext uri="{FF2B5EF4-FFF2-40B4-BE49-F238E27FC236}">
-                <a16:creationId xmlns:a16="http://schemas.microsoft.com/office/drawing/2014/main" id="{C90CB33A-2FD6-457E-BFC9-696C935B14E0}"/>
+                <a16:creationId xmlns:a16="http://schemas.microsoft.com/office/drawing/2014/main" id="{11140067-79AD-4A09-9F77-32D0827EE847}"/>
               </a:ext>
             </a:extLst>
           </p:cNvPr>
@@ -15496,7 +15311,7 @@
           <p:cNvPr id="11" name="">
             <a:extLst xmlns:a="http://schemas.openxmlformats.org/drawingml/2006/main">
               <a:ext uri="{FF2B5EF4-FFF2-40B4-BE49-F238E27FC236}">
-                <a16:creationId xmlns:a16="http://schemas.microsoft.com/office/drawing/2014/main" id="{0136C087-1125-43E6-BC14-C1B9746AE691}"/>
+                <a16:creationId xmlns:a16="http://schemas.microsoft.com/office/drawing/2014/main" id="{E67A3093-8921-4ACA-996B-0A673568EDD2}"/>
               </a:ext>
             </a:extLst>
           </p:cNvPr>
@@ -15529,7 +15344,7 @@
           <p:cNvPr id="12" name="">
             <a:extLst xmlns:a="http://schemas.openxmlformats.org/drawingml/2006/main">
               <a:ext uri="{FF2B5EF4-FFF2-40B4-BE49-F238E27FC236}">
-                <a16:creationId xmlns:a16="http://schemas.microsoft.com/office/drawing/2014/main" id="{604A0263-C42B-45C9-943D-E8DBFB0FEEB3}"/>
+                <a16:creationId xmlns:a16="http://schemas.microsoft.com/office/drawing/2014/main" id="{6291D79E-B705-4EC4-8935-341828B7F7FB}"/>
               </a:ext>
             </a:extLst>
           </p:cNvPr>
@@ -15562,7 +15377,7 @@
           <p:cNvPr id="13" name="">
             <a:extLst xmlns:a="http://schemas.openxmlformats.org/drawingml/2006/main">
               <a:ext uri="{FF2B5EF4-FFF2-40B4-BE49-F238E27FC236}">
-                <a16:creationId xmlns:a16="http://schemas.microsoft.com/office/drawing/2014/main" id="{147ED4A3-FC5C-42F5-81A3-3968341B784B}"/>
+                <a16:creationId xmlns:a16="http://schemas.microsoft.com/office/drawing/2014/main" id="{A2F67619-CEA7-41B0-B1DD-AACC3D564495}"/>
               </a:ext>
             </a:extLst>
           </p:cNvPr>
@@ -15612,7 +15427,7 @@
           <p:cNvPr id="14" name="">
             <a:extLst xmlns:a="http://schemas.openxmlformats.org/drawingml/2006/main">
               <a:ext uri="{FF2B5EF4-FFF2-40B4-BE49-F238E27FC236}">
-                <a16:creationId xmlns:a16="http://schemas.microsoft.com/office/drawing/2014/main" id="{B7922419-4D6D-4CC9-B755-0BAB09575674}"/>
+                <a16:creationId xmlns:a16="http://schemas.microsoft.com/office/drawing/2014/main" id="{B0347FEC-539E-437A-A0B8-123C1F0F4B42}"/>
               </a:ext>
             </a:extLst>
           </p:cNvPr>
@@ -15662,7 +15477,7 @@
           <p:cNvPr id="15" name="">
             <a:extLst xmlns:a="http://schemas.openxmlformats.org/drawingml/2006/main">
               <a:ext uri="{FF2B5EF4-FFF2-40B4-BE49-F238E27FC236}">
-                <a16:creationId xmlns:a16="http://schemas.microsoft.com/office/drawing/2014/main" id="{07A806B0-7DEC-450F-9441-9C03E27299B5}"/>
+                <a16:creationId xmlns:a16="http://schemas.microsoft.com/office/drawing/2014/main" id="{323B1210-A3DC-4388-ACC0-5EED138B088B}"/>
               </a:ext>
             </a:extLst>
           </p:cNvPr>
@@ -15695,7 +15510,7 @@
           <p:cNvPr id="16" name="">
             <a:extLst xmlns:a="http://schemas.openxmlformats.org/drawingml/2006/main">
               <a:ext uri="{FF2B5EF4-FFF2-40B4-BE49-F238E27FC236}">
-                <a16:creationId xmlns:a16="http://schemas.microsoft.com/office/drawing/2014/main" id="{5B09124E-E20E-430E-AC68-7C9F64F8F712}"/>
+                <a16:creationId xmlns:a16="http://schemas.microsoft.com/office/drawing/2014/main" id="{67D802F2-2F8C-4BDB-B517-406B86FE8D10}"/>
               </a:ext>
             </a:extLst>
           </p:cNvPr>
@@ -15745,7 +15560,7 @@
           <p:cNvPr id="17" name="">
             <a:extLst xmlns:a="http://schemas.openxmlformats.org/drawingml/2006/main">
               <a:ext uri="{FF2B5EF4-FFF2-40B4-BE49-F238E27FC236}">
-                <a16:creationId xmlns:a16="http://schemas.microsoft.com/office/drawing/2014/main" id="{94682EF8-E341-474F-9F85-60C0609B6709}"/>
+                <a16:creationId xmlns:a16="http://schemas.microsoft.com/office/drawing/2014/main" id="{D9B05F03-BAFA-485E-AB47-0AE8EF3BCB99}"/>
               </a:ext>
             </a:extLst>
           </p:cNvPr>
@@ -15795,7 +15610,7 @@
           <p:cNvPr id="18" name="">
             <a:extLst xmlns:a="http://schemas.openxmlformats.org/drawingml/2006/main">
               <a:ext uri="{FF2B5EF4-FFF2-40B4-BE49-F238E27FC236}">
-                <a16:creationId xmlns:a16="http://schemas.microsoft.com/office/drawing/2014/main" id="{B82A660C-47EE-4C07-B861-2D1C8B736200}"/>
+                <a16:creationId xmlns:a16="http://schemas.microsoft.com/office/drawing/2014/main" id="{13543F4B-FCEE-4BB8-A244-DDF52425C750}"/>
               </a:ext>
             </a:extLst>
           </p:cNvPr>
@@ -15828,7 +15643,7 @@
           <p:cNvPr id="19" name="">
             <a:extLst xmlns:a="http://schemas.openxmlformats.org/drawingml/2006/main">
               <a:ext uri="{FF2B5EF4-FFF2-40B4-BE49-F238E27FC236}">
-                <a16:creationId xmlns:a16="http://schemas.microsoft.com/office/drawing/2014/main" id="{90F190B0-CFF1-4339-96B7-C35309B6F77B}"/>
+                <a16:creationId xmlns:a16="http://schemas.microsoft.com/office/drawing/2014/main" id="{9CD5B34E-E754-4E46-886C-F3E9FF7CDE96}"/>
               </a:ext>
             </a:extLst>
           </p:cNvPr>
@@ -15878,7 +15693,7 @@
           <p:cNvPr id="20" name="">
             <a:extLst xmlns:a="http://schemas.openxmlformats.org/drawingml/2006/main">
               <a:ext uri="{FF2B5EF4-FFF2-40B4-BE49-F238E27FC236}">
-                <a16:creationId xmlns:a16="http://schemas.microsoft.com/office/drawing/2014/main" id="{4FCFE0E7-6B4C-45CE-83CD-67267B665646}"/>
+                <a16:creationId xmlns:a16="http://schemas.microsoft.com/office/drawing/2014/main" id="{986B4971-A95D-47C8-B742-2E5564782891}"/>
               </a:ext>
             </a:extLst>
           </p:cNvPr>
@@ -15928,7 +15743,7 @@
           <p:cNvPr id="21" name="">
             <a:extLst xmlns:a="http://schemas.openxmlformats.org/drawingml/2006/main">
               <a:ext uri="{FF2B5EF4-FFF2-40B4-BE49-F238E27FC236}">
-                <a16:creationId xmlns:a16="http://schemas.microsoft.com/office/drawing/2014/main" id="{AB6CD021-1D06-4F1E-ABF4-E2F00B408FDF}"/>
+                <a16:creationId xmlns:a16="http://schemas.microsoft.com/office/drawing/2014/main" id="{B2DD526D-BB10-49E5-9AA5-555B34737164}"/>
               </a:ext>
             </a:extLst>
           </p:cNvPr>
@@ -15961,7 +15776,7 @@
           <p:cNvPr id="22" name="">
             <a:extLst xmlns:a="http://schemas.openxmlformats.org/drawingml/2006/main">
               <a:ext uri="{FF2B5EF4-FFF2-40B4-BE49-F238E27FC236}">
-                <a16:creationId xmlns:a16="http://schemas.microsoft.com/office/drawing/2014/main" id="{4D154F22-9ED2-4501-9654-54E4550BD0B7}"/>
+                <a16:creationId xmlns:a16="http://schemas.microsoft.com/office/drawing/2014/main" id="{8D3A3C23-3002-4A43-B4F4-D598AC873F25}"/>
               </a:ext>
             </a:extLst>
           </p:cNvPr>
@@ -16011,7 +15826,7 @@
           <p:cNvPr id="23" name="">
             <a:extLst xmlns:a="http://schemas.openxmlformats.org/drawingml/2006/main">
               <a:ext uri="{FF2B5EF4-FFF2-40B4-BE49-F238E27FC236}">
-                <a16:creationId xmlns:a16="http://schemas.microsoft.com/office/drawing/2014/main" id="{4505627C-B0DF-45CC-825A-9ABEB485CCE7}"/>
+                <a16:creationId xmlns:a16="http://schemas.microsoft.com/office/drawing/2014/main" id="{BF9B3042-5088-46DE-9A00-5705E0043DB7}"/>
               </a:ext>
             </a:extLst>
           </p:cNvPr>
@@ -16061,7 +15876,7 @@
           <p:cNvPr id="24" name="">
             <a:extLst xmlns:a="http://schemas.openxmlformats.org/drawingml/2006/main">
               <a:ext uri="{FF2B5EF4-FFF2-40B4-BE49-F238E27FC236}">
-                <a16:creationId xmlns:a16="http://schemas.microsoft.com/office/drawing/2014/main" id="{0CD22564-8965-4C14-BA54-EBB43DDC496C}"/>
+                <a16:creationId xmlns:a16="http://schemas.microsoft.com/office/drawing/2014/main" id="{3A5C91A2-59ED-4330-A23E-DCA619A26B1B}"/>
               </a:ext>
             </a:extLst>
           </p:cNvPr>
@@ -16094,7 +15909,7 @@
           <p:cNvPr id="25" name="">
             <a:extLst xmlns:a="http://schemas.openxmlformats.org/drawingml/2006/main">
               <a:ext uri="{FF2B5EF4-FFF2-40B4-BE49-F238E27FC236}">
-                <a16:creationId xmlns:a16="http://schemas.microsoft.com/office/drawing/2014/main" id="{5D5CCA69-4463-4674-9C01-0E1F15C41AC0}"/>
+                <a16:creationId xmlns:a16="http://schemas.microsoft.com/office/drawing/2014/main" id="{2AB3CBAE-DC30-46B6-8589-02CC72C076FF}"/>
               </a:ext>
             </a:extLst>
           </p:cNvPr>
@@ -16144,7 +15959,7 @@
           <p:cNvPr id="26" name="">
             <a:extLst xmlns:a="http://schemas.openxmlformats.org/drawingml/2006/main">
               <a:ext uri="{FF2B5EF4-FFF2-40B4-BE49-F238E27FC236}">
-                <a16:creationId xmlns:a16="http://schemas.microsoft.com/office/drawing/2014/main" id="{63285635-5BC9-4A23-8480-BB81AB272001}"/>
+                <a16:creationId xmlns:a16="http://schemas.microsoft.com/office/drawing/2014/main" id="{B1375D46-E356-4F04-817D-14D85A5D7F55}"/>
               </a:ext>
             </a:extLst>
           </p:cNvPr>
@@ -16194,7 +16009,7 @@
           <p:cNvPr id="27" name="">
             <a:extLst xmlns:a="http://schemas.openxmlformats.org/drawingml/2006/main">
               <a:ext uri="{FF2B5EF4-FFF2-40B4-BE49-F238E27FC236}">
-                <a16:creationId xmlns:a16="http://schemas.microsoft.com/office/drawing/2014/main" id="{F71DBCF2-A53D-4685-802F-8D3D6B143FE5}"/>
+                <a16:creationId xmlns:a16="http://schemas.microsoft.com/office/drawing/2014/main" id="{1D7366AF-1849-4BA9-8A2F-D5653BFF1711}"/>
               </a:ext>
             </a:extLst>
           </p:cNvPr>
@@ -16227,7 +16042,7 @@
           <p:cNvPr id="28" name="">
             <a:extLst xmlns:a="http://schemas.openxmlformats.org/drawingml/2006/main">
               <a:ext uri="{FF2B5EF4-FFF2-40B4-BE49-F238E27FC236}">
-                <a16:creationId xmlns:a16="http://schemas.microsoft.com/office/drawing/2014/main" id="{46084577-9D41-41E8-AF49-BA360C8AF3F3}"/>
+                <a16:creationId xmlns:a16="http://schemas.microsoft.com/office/drawing/2014/main" id="{46AED1E8-BE92-4B68-9035-F944AFC6DA0D}"/>
               </a:ext>
             </a:extLst>
           </p:cNvPr>
@@ -16277,7 +16092,7 @@
           <p:cNvPr id="29" name="">
             <a:extLst xmlns:a="http://schemas.openxmlformats.org/drawingml/2006/main">
               <a:ext uri="{FF2B5EF4-FFF2-40B4-BE49-F238E27FC236}">
-                <a16:creationId xmlns:a16="http://schemas.microsoft.com/office/drawing/2014/main" id="{821B952B-84CC-455F-B2F0-CD491BC312A3}"/>
+                <a16:creationId xmlns:a16="http://schemas.microsoft.com/office/drawing/2014/main" id="{3C98106C-585A-4945-B114-87E61F4DF8E4}"/>
               </a:ext>
             </a:extLst>
           </p:cNvPr>
@@ -16327,7 +16142,7 @@
           <p:cNvPr id="30" name="">
             <a:extLst xmlns:a="http://schemas.openxmlformats.org/drawingml/2006/main">
               <a:ext uri="{FF2B5EF4-FFF2-40B4-BE49-F238E27FC236}">
-                <a16:creationId xmlns:a16="http://schemas.microsoft.com/office/drawing/2014/main" id="{5B16C773-7706-4752-B6B3-2BBB640E855C}"/>
+                <a16:creationId xmlns:a16="http://schemas.microsoft.com/office/drawing/2014/main" id="{7C927AF0-FB84-4FF8-8D87-4D4D872C1709}"/>
               </a:ext>
             </a:extLst>
           </p:cNvPr>
@@ -16362,7 +16177,7 @@
           <p:cNvPr id="31" name="">
             <a:extLst xmlns:a="http://schemas.openxmlformats.org/drawingml/2006/main">
               <a:ext uri="{FF2B5EF4-FFF2-40B4-BE49-F238E27FC236}">
-                <a16:creationId xmlns:a16="http://schemas.microsoft.com/office/drawing/2014/main" id="{0C126F3D-FF04-4456-A375-F6B2E67B3EFD}"/>
+                <a16:creationId xmlns:a16="http://schemas.microsoft.com/office/drawing/2014/main" id="{413F380C-F022-462F-A52A-DDE01656BEF5}"/>
               </a:ext>
             </a:extLst>
           </p:cNvPr>
@@ -16429,7 +16244,7 @@
           <p:cNvPr id="32" name="">
             <a:extLst xmlns:a="http://schemas.openxmlformats.org/drawingml/2006/main">
               <a:ext uri="{FF2B5EF4-FFF2-40B4-BE49-F238E27FC236}">
-                <a16:creationId xmlns:a16="http://schemas.microsoft.com/office/drawing/2014/main" id="{0F3629EA-9D73-41EB-AC94-45B7C610B82C}"/>
+                <a16:creationId xmlns:a16="http://schemas.microsoft.com/office/drawing/2014/main" id="{70EA2D1B-6AC2-4413-BAEC-C85A6B50D032}"/>
               </a:ext>
             </a:extLst>
           </p:cNvPr>
@@ -16530,7 +16345,7 @@
           <p:cNvPr id="33" name="">
             <a:extLst xmlns:a="http://schemas.openxmlformats.org/drawingml/2006/main">
               <a:ext uri="{FF2B5EF4-FFF2-40B4-BE49-F238E27FC236}">
-                <a16:creationId xmlns:a16="http://schemas.microsoft.com/office/drawing/2014/main" id="{7A7767CF-986B-4E89-B755-E65BCD204DDE}"/>
+                <a16:creationId xmlns:a16="http://schemas.microsoft.com/office/drawing/2014/main" id="{E084C142-590F-4381-9993-9BF3CB1478E4}"/>
               </a:ext>
             </a:extLst>
           </p:cNvPr>
@@ -16563,7 +16378,7 @@
           <p:cNvPr id="34" name="">
             <a:extLst xmlns:a="http://schemas.openxmlformats.org/drawingml/2006/main">
               <a:ext uri="{FF2B5EF4-FFF2-40B4-BE49-F238E27FC236}">
-                <a16:creationId xmlns:a16="http://schemas.microsoft.com/office/drawing/2014/main" id="{886906E0-4610-4A42-BE64-23B530854B2D}"/>
+                <a16:creationId xmlns:a16="http://schemas.microsoft.com/office/drawing/2014/main" id="{298D3E7B-E7C7-4EB3-8D1C-DC1884C90A5A}"/>
               </a:ext>
             </a:extLst>
           </p:cNvPr>
@@ -16613,7 +16428,7 @@
           <p:cNvPr id="35" name="">
             <a:extLst xmlns:a="http://schemas.openxmlformats.org/drawingml/2006/main">
               <a:ext uri="{FF2B5EF4-FFF2-40B4-BE49-F238E27FC236}">
-                <a16:creationId xmlns:a16="http://schemas.microsoft.com/office/drawing/2014/main" id="{B2C18BEE-63BC-4513-9C6B-19F476ABD1FB}"/>
+                <a16:creationId xmlns:a16="http://schemas.microsoft.com/office/drawing/2014/main" id="{C6C32143-A707-47E3-8448-E3F43E8FD456}"/>
               </a:ext>
             </a:extLst>
           </p:cNvPr>
@@ -16661,7 +16476,7 @@
     </p:spTree>
     <p:extLst>
       <p:ext uri="{BB962C8B-B14F-4D97-AF65-F5344CB8AC3E}">
-        <p14:creationId xmlns:p14="http://schemas.microsoft.com/office/powerpoint/2010/main" val="473821673"/>
+        <p14:creationId xmlns:p14="http://schemas.microsoft.com/office/powerpoint/2010/main" val="2003762806"/>
       </p:ext>
     </p:extLst>
   </p:cSld>
@@ -16692,7 +16507,7 @@
           <p:cNvPr id="34" name="">
             <a:extLst xmlns:a="http://schemas.openxmlformats.org/drawingml/2006/main">
               <a:ext uri="{FF2B5EF4-FFF2-40B4-BE49-F238E27FC236}">
-                <a16:creationId xmlns:a16="http://schemas.microsoft.com/office/drawing/2014/main" id="{44259157-507F-4BDC-98FE-4A9501B58EC8}"/>
+                <a16:creationId xmlns:a16="http://schemas.microsoft.com/office/drawing/2014/main" id="{77AC7F25-3145-4A6B-9B2A-59D3F2709E77}"/>
               </a:ext>
             </a:extLst>
           </p:cNvPr>
@@ -16742,7 +16557,7 @@
           <p:cNvPr id="2" name="">
             <a:extLst xmlns:a="http://schemas.openxmlformats.org/drawingml/2006/main">
               <a:ext uri="{FF2B5EF4-FFF2-40B4-BE49-F238E27FC236}">
-                <a16:creationId xmlns:a16="http://schemas.microsoft.com/office/drawing/2014/main" id="{819E24F0-D3CC-49AC-B318-9F5D4D5CE088}"/>
+                <a16:creationId xmlns:a16="http://schemas.microsoft.com/office/drawing/2014/main" id="{177325F4-3843-4135-B0E0-BCE804282BE5}"/>
               </a:ext>
             </a:extLst>
           </p:cNvPr>
@@ -16792,7 +16607,7 @@
           <p:cNvPr id="3" name="">
             <a:extLst xmlns:a="http://schemas.openxmlformats.org/drawingml/2006/main">
               <a:ext uri="{FF2B5EF4-FFF2-40B4-BE49-F238E27FC236}">
-                <a16:creationId xmlns:a16="http://schemas.microsoft.com/office/drawing/2014/main" id="{276B9BFE-AFC7-4B5A-BA51-99E719390650}"/>
+                <a16:creationId xmlns:a16="http://schemas.microsoft.com/office/drawing/2014/main" id="{8DA3428D-0F37-4615-87AA-149970A3E926}"/>
               </a:ext>
             </a:extLst>
           </p:cNvPr>
@@ -16842,7 +16657,7 @@
           <p:cNvPr id="4" name="">
             <a:extLst xmlns:a="http://schemas.openxmlformats.org/drawingml/2006/main">
               <a:ext uri="{FF2B5EF4-FFF2-40B4-BE49-F238E27FC236}">
-                <a16:creationId xmlns:a16="http://schemas.microsoft.com/office/drawing/2014/main" id="{D342609D-70F9-4CC9-A92E-60F9253D1B1E}"/>
+                <a16:creationId xmlns:a16="http://schemas.microsoft.com/office/drawing/2014/main" id="{5F7ED4EC-DEFD-4D46-BE84-E673D3A3EA7D}"/>
               </a:ext>
             </a:extLst>
           </p:cNvPr>
@@ -16875,7 +16690,7 @@
           <p:cNvPr id="5" name="">
             <a:extLst xmlns:a="http://schemas.openxmlformats.org/drawingml/2006/main">
               <a:ext uri="{FF2B5EF4-FFF2-40B4-BE49-F238E27FC236}">
-                <a16:creationId xmlns:a16="http://schemas.microsoft.com/office/drawing/2014/main" id="{2122026F-A140-4F41-A4BF-3E162578463F}"/>
+                <a16:creationId xmlns:a16="http://schemas.microsoft.com/office/drawing/2014/main" id="{967AC970-05D4-4033-8338-61CBFBE7F260}"/>
               </a:ext>
             </a:extLst>
           </p:cNvPr>
@@ -16925,7 +16740,7 @@
           <p:cNvPr id="6" name="">
             <a:extLst xmlns:a="http://schemas.openxmlformats.org/drawingml/2006/main">
               <a:ext uri="{FF2B5EF4-FFF2-40B4-BE49-F238E27FC236}">
-                <a16:creationId xmlns:a16="http://schemas.microsoft.com/office/drawing/2014/main" id="{5D37BC8C-A88D-4FEB-9D1C-B675C84C7A8E}"/>
+                <a16:creationId xmlns:a16="http://schemas.microsoft.com/office/drawing/2014/main" id="{8382EC3C-FFFB-4E94-A843-71DF59DE19F9}"/>
               </a:ext>
             </a:extLst>
           </p:cNvPr>
@@ -16975,7 +16790,7 @@
           <p:cNvPr id="7" name="">
             <a:extLst xmlns:a="http://schemas.openxmlformats.org/drawingml/2006/main">
               <a:ext uri="{FF2B5EF4-FFF2-40B4-BE49-F238E27FC236}">
-                <a16:creationId xmlns:a16="http://schemas.microsoft.com/office/drawing/2014/main" id="{B7EBCF4C-12B2-4B09-9F4B-1DFDAED8F602}"/>
+                <a16:creationId xmlns:a16="http://schemas.microsoft.com/office/drawing/2014/main" id="{F69C1756-D68C-436D-9309-F3B8BF0E833E}"/>
               </a:ext>
             </a:extLst>
           </p:cNvPr>
@@ -17008,7 +16823,7 @@
           <p:cNvPr id="8" name="">
             <a:extLst xmlns:a="http://schemas.openxmlformats.org/drawingml/2006/main">
               <a:ext uri="{FF2B5EF4-FFF2-40B4-BE49-F238E27FC236}">
-                <a16:creationId xmlns:a16="http://schemas.microsoft.com/office/drawing/2014/main" id="{05DA40D6-E321-4E97-8CD2-EC98F530D7CE}"/>
+                <a16:creationId xmlns:a16="http://schemas.microsoft.com/office/drawing/2014/main" id="{EA6B5A12-6A72-438B-BE6A-3A6D4B0DABF7}"/>
               </a:ext>
             </a:extLst>
           </p:cNvPr>
@@ -17058,7 +16873,7 @@
           <p:cNvPr id="9" name="">
             <a:extLst xmlns:a="http://schemas.openxmlformats.org/drawingml/2006/main">
               <a:ext uri="{FF2B5EF4-FFF2-40B4-BE49-F238E27FC236}">
-                <a16:creationId xmlns:a16="http://schemas.microsoft.com/office/drawing/2014/main" id="{C3EE536B-6420-4891-BCC9-F5B66793EE55}"/>
+                <a16:creationId xmlns:a16="http://schemas.microsoft.com/office/drawing/2014/main" id="{18804923-A355-4FC1-B722-EE588441F39E}"/>
               </a:ext>
             </a:extLst>
           </p:cNvPr>
@@ -17108,7 +16923,7 @@
           <p:cNvPr id="10" name="">
             <a:extLst xmlns:a="http://schemas.openxmlformats.org/drawingml/2006/main">
               <a:ext uri="{FF2B5EF4-FFF2-40B4-BE49-F238E27FC236}">
-                <a16:creationId xmlns:a16="http://schemas.microsoft.com/office/drawing/2014/main" id="{C7797500-30C0-4AD9-8451-3B751632EF72}"/>
+                <a16:creationId xmlns:a16="http://schemas.microsoft.com/office/drawing/2014/main" id="{974A0E1A-F8D7-4A10-8176-0C05F716A3C5}"/>
               </a:ext>
             </a:extLst>
           </p:cNvPr>
@@ -17158,7 +16973,7 @@
           <p:cNvPr id="11" name="">
             <a:extLst xmlns:a="http://schemas.openxmlformats.org/drawingml/2006/main">
               <a:ext uri="{FF2B5EF4-FFF2-40B4-BE49-F238E27FC236}">
-                <a16:creationId xmlns:a16="http://schemas.microsoft.com/office/drawing/2014/main" id="{9B254CF6-F4A9-4E2B-9643-ABB472D8FD8B}"/>
+                <a16:creationId xmlns:a16="http://schemas.microsoft.com/office/drawing/2014/main" id="{64F2C14A-AD4F-4CAE-BBB8-14FD0F016317}"/>
               </a:ext>
             </a:extLst>
           </p:cNvPr>
@@ -17191,7 +17006,7 @@
           <p:cNvPr id="12" name="">
             <a:extLst xmlns:a="http://schemas.openxmlformats.org/drawingml/2006/main">
               <a:ext uri="{FF2B5EF4-FFF2-40B4-BE49-F238E27FC236}">
-                <a16:creationId xmlns:a16="http://schemas.microsoft.com/office/drawing/2014/main" id="{AFCE49AD-BF47-4C15-B39E-A86D2C7265AB}"/>
+                <a16:creationId xmlns:a16="http://schemas.microsoft.com/office/drawing/2014/main" id="{2CB79C45-0EE9-4F45-AF38-CDA9A4237B3D}"/>
               </a:ext>
             </a:extLst>
           </p:cNvPr>
@@ -17241,7 +17056,7 @@
           <p:cNvPr id="13" name="">
             <a:extLst xmlns:a="http://schemas.openxmlformats.org/drawingml/2006/main">
               <a:ext uri="{FF2B5EF4-FFF2-40B4-BE49-F238E27FC236}">
-                <a16:creationId xmlns:a16="http://schemas.microsoft.com/office/drawing/2014/main" id="{954E990C-0742-43F2-9B36-9A848E5C9F63}"/>
+                <a16:creationId xmlns:a16="http://schemas.microsoft.com/office/drawing/2014/main" id="{E9CD2018-38ED-48FA-AB16-A3B43100503B}"/>
               </a:ext>
             </a:extLst>
           </p:cNvPr>
@@ -17291,7 +17106,7 @@
           <p:cNvPr id="14" name="">
             <a:extLst xmlns:a="http://schemas.openxmlformats.org/drawingml/2006/main">
               <a:ext uri="{FF2B5EF4-FFF2-40B4-BE49-F238E27FC236}">
-                <a16:creationId xmlns:a16="http://schemas.microsoft.com/office/drawing/2014/main" id="{6FAD5203-6A72-4FE1-8A30-E4C929897A23}"/>
+                <a16:creationId xmlns:a16="http://schemas.microsoft.com/office/drawing/2014/main" id="{31C53726-2C57-4975-8E35-80BE8F29E6DF}"/>
               </a:ext>
             </a:extLst>
           </p:cNvPr>
@@ -17341,7 +17156,7 @@
           <p:cNvPr id="15" name="">
             <a:extLst xmlns:a="http://schemas.openxmlformats.org/drawingml/2006/main">
               <a:ext uri="{FF2B5EF4-FFF2-40B4-BE49-F238E27FC236}">
-                <a16:creationId xmlns:a16="http://schemas.microsoft.com/office/drawing/2014/main" id="{310FEDA5-5D6A-4162-913B-6D11B2C5B812}"/>
+                <a16:creationId xmlns:a16="http://schemas.microsoft.com/office/drawing/2014/main" id="{CFB487ED-5006-44D5-8A33-131692A6AE64}"/>
               </a:ext>
             </a:extLst>
           </p:cNvPr>
@@ -17374,7 +17189,7 @@
           <p:cNvPr id="16" name="">
             <a:extLst xmlns:a="http://schemas.openxmlformats.org/drawingml/2006/main">
               <a:ext uri="{FF2B5EF4-FFF2-40B4-BE49-F238E27FC236}">
-                <a16:creationId xmlns:a16="http://schemas.microsoft.com/office/drawing/2014/main" id="{BF411F5D-3CF0-46CE-B97E-9DBBBC8F0F2D}"/>
+                <a16:creationId xmlns:a16="http://schemas.microsoft.com/office/drawing/2014/main" id="{2EE53ADE-0D23-4C49-8497-E7E9A615B7F7}"/>
               </a:ext>
             </a:extLst>
           </p:cNvPr>
@@ -17424,7 +17239,7 @@
           <p:cNvPr id="17" name="">
             <a:extLst xmlns:a="http://schemas.openxmlformats.org/drawingml/2006/main">
               <a:ext uri="{FF2B5EF4-FFF2-40B4-BE49-F238E27FC236}">
-                <a16:creationId xmlns:a16="http://schemas.microsoft.com/office/drawing/2014/main" id="{1496F64F-CCF6-4D96-9A96-B908AB85FD3E}"/>
+                <a16:creationId xmlns:a16="http://schemas.microsoft.com/office/drawing/2014/main" id="{0A97B53E-5A01-4B93-87BD-0ADC79CF7775}"/>
               </a:ext>
             </a:extLst>
           </p:cNvPr>
@@ -17474,7 +17289,7 @@
           <p:cNvPr id="18" name="">
             <a:extLst xmlns:a="http://schemas.openxmlformats.org/drawingml/2006/main">
               <a:ext uri="{FF2B5EF4-FFF2-40B4-BE49-F238E27FC236}">
-                <a16:creationId xmlns:a16="http://schemas.microsoft.com/office/drawing/2014/main" id="{A72A9827-3E8C-4AC0-BAA3-FB9657EA0350}"/>
+                <a16:creationId xmlns:a16="http://schemas.microsoft.com/office/drawing/2014/main" id="{956246E8-8445-40F5-86D0-9DF57A9F1FC0}"/>
               </a:ext>
             </a:extLst>
           </p:cNvPr>
@@ -17524,7 +17339,7 @@
           <p:cNvPr id="19" name="">
             <a:extLst xmlns:a="http://schemas.openxmlformats.org/drawingml/2006/main">
               <a:ext uri="{FF2B5EF4-FFF2-40B4-BE49-F238E27FC236}">
-                <a16:creationId xmlns:a16="http://schemas.microsoft.com/office/drawing/2014/main" id="{17B1B6EB-9EB9-4510-8DE3-A55A3C9C1554}"/>
+                <a16:creationId xmlns:a16="http://schemas.microsoft.com/office/drawing/2014/main" id="{62D37304-4D64-42CF-8DFA-F4FEE2E14BA9}"/>
               </a:ext>
             </a:extLst>
           </p:cNvPr>
@@ -17557,7 +17372,7 @@
           <p:cNvPr id="20" name="">
             <a:extLst xmlns:a="http://schemas.openxmlformats.org/drawingml/2006/main">
               <a:ext uri="{FF2B5EF4-FFF2-40B4-BE49-F238E27FC236}">
-                <a16:creationId xmlns:a16="http://schemas.microsoft.com/office/drawing/2014/main" id="{B6201FFF-7EC8-410C-BD29-5EC4987E4C9C}"/>
+                <a16:creationId xmlns:a16="http://schemas.microsoft.com/office/drawing/2014/main" id="{58CB9D00-18DD-4D64-A887-E1568869E9CB}"/>
               </a:ext>
             </a:extLst>
           </p:cNvPr>
@@ -17607,7 +17422,7 @@
           <p:cNvPr id="21" name="">
             <a:extLst xmlns:a="http://schemas.openxmlformats.org/drawingml/2006/main">
               <a:ext uri="{FF2B5EF4-FFF2-40B4-BE49-F238E27FC236}">
-                <a16:creationId xmlns:a16="http://schemas.microsoft.com/office/drawing/2014/main" id="{30163B2A-2E92-4010-8BF3-88315D1BC1A3}"/>
+                <a16:creationId xmlns:a16="http://schemas.microsoft.com/office/drawing/2014/main" id="{05674D4C-FCC3-41A0-B486-2DA87E635E5F}"/>
               </a:ext>
             </a:extLst>
           </p:cNvPr>
@@ -17657,7 +17472,7 @@
           <p:cNvPr id="22" name="">
             <a:extLst xmlns:a="http://schemas.openxmlformats.org/drawingml/2006/main">
               <a:ext uri="{FF2B5EF4-FFF2-40B4-BE49-F238E27FC236}">
-                <a16:creationId xmlns:a16="http://schemas.microsoft.com/office/drawing/2014/main" id="{50964738-CD0D-4CFC-A360-37212A90A796}"/>
+                <a16:creationId xmlns:a16="http://schemas.microsoft.com/office/drawing/2014/main" id="{DE60FCC2-DA66-4A1C-9F50-C4F634101B21}"/>
               </a:ext>
             </a:extLst>
           </p:cNvPr>
@@ -17707,7 +17522,7 @@
           <p:cNvPr id="23" name="">
             <a:extLst xmlns:a="http://schemas.openxmlformats.org/drawingml/2006/main">
               <a:ext uri="{FF2B5EF4-FFF2-40B4-BE49-F238E27FC236}">
-                <a16:creationId xmlns:a16="http://schemas.microsoft.com/office/drawing/2014/main" id="{42D9B236-CEBE-462D-9D36-70FCEF7C09A7}"/>
+                <a16:creationId xmlns:a16="http://schemas.microsoft.com/office/drawing/2014/main" id="{E8A460F2-2DD4-4A95-8C01-51A3F46ED040}"/>
               </a:ext>
             </a:extLst>
           </p:cNvPr>
@@ -17757,7 +17572,7 @@
           <p:cNvPr id="24" name="">
             <a:extLst xmlns:a="http://schemas.openxmlformats.org/drawingml/2006/main">
               <a:ext uri="{FF2B5EF4-FFF2-40B4-BE49-F238E27FC236}">
-                <a16:creationId xmlns:a16="http://schemas.microsoft.com/office/drawing/2014/main" id="{C89CB6FF-AFDE-4AD6-886D-19E8B0FCA714}"/>
+                <a16:creationId xmlns:a16="http://schemas.microsoft.com/office/drawing/2014/main" id="{04395488-06AD-45C4-B429-4FE43643DB31}"/>
               </a:ext>
             </a:extLst>
           </p:cNvPr>
@@ -17807,7 +17622,7 @@
           <p:cNvPr id="25" name="">
             <a:extLst xmlns:a="http://schemas.openxmlformats.org/drawingml/2006/main">
               <a:ext uri="{FF2B5EF4-FFF2-40B4-BE49-F238E27FC236}">
-                <a16:creationId xmlns:a16="http://schemas.microsoft.com/office/drawing/2014/main" id="{C82C88F4-4AD8-4CED-A098-1D6A93B25C2E}"/>
+                <a16:creationId xmlns:a16="http://schemas.microsoft.com/office/drawing/2014/main" id="{AACD7A58-F5B3-4A38-A3F9-FC416F9F4700}"/>
               </a:ext>
             </a:extLst>
           </p:cNvPr>
@@ -17857,7 +17672,7 @@
           <p:cNvPr id="26" name="">
             <a:extLst xmlns:a="http://schemas.openxmlformats.org/drawingml/2006/main">
               <a:ext uri="{FF2B5EF4-FFF2-40B4-BE49-F238E27FC236}">
-                <a16:creationId xmlns:a16="http://schemas.microsoft.com/office/drawing/2014/main" id="{5F1F8758-E1F6-4377-98DE-706318845031}"/>
+                <a16:creationId xmlns:a16="http://schemas.microsoft.com/office/drawing/2014/main" id="{85B15E70-5836-4DA7-86B2-67879A01058A}"/>
               </a:ext>
             </a:extLst>
           </p:cNvPr>
@@ -17907,7 +17722,7 @@
           <p:cNvPr id="27" name="">
             <a:extLst xmlns:a="http://schemas.openxmlformats.org/drawingml/2006/main">
               <a:ext uri="{FF2B5EF4-FFF2-40B4-BE49-F238E27FC236}">
-                <a16:creationId xmlns:a16="http://schemas.microsoft.com/office/drawing/2014/main" id="{8DB372C4-AF9F-45A8-B29C-B0E3C93107D0}"/>
+                <a16:creationId xmlns:a16="http://schemas.microsoft.com/office/drawing/2014/main" id="{F720113B-48E0-4C6C-8FFF-84C494430F89}"/>
               </a:ext>
             </a:extLst>
           </p:cNvPr>
@@ -17957,7 +17772,7 @@
           <p:cNvPr id="28" name="">
             <a:extLst xmlns:a="http://schemas.openxmlformats.org/drawingml/2006/main">
               <a:ext uri="{FF2B5EF4-FFF2-40B4-BE49-F238E27FC236}">
-                <a16:creationId xmlns:a16="http://schemas.microsoft.com/office/drawing/2014/main" id="{14B3CFAA-E7FF-445D-9110-6014A2F705EB}"/>
+                <a16:creationId xmlns:a16="http://schemas.microsoft.com/office/drawing/2014/main" id="{CF359153-492D-4F8E-BDDD-19AD1D18A552}"/>
               </a:ext>
             </a:extLst>
           </p:cNvPr>
@@ -18007,7 +17822,7 @@
           <p:cNvPr id="29" name="">
             <a:extLst xmlns:a="http://schemas.openxmlformats.org/drawingml/2006/main">
               <a:ext uri="{FF2B5EF4-FFF2-40B4-BE49-F238E27FC236}">
-                <a16:creationId xmlns:a16="http://schemas.microsoft.com/office/drawing/2014/main" id="{F8F8929A-3814-41D6-80E1-5ADB7F9727FF}"/>
+                <a16:creationId xmlns:a16="http://schemas.microsoft.com/office/drawing/2014/main" id="{D08F173E-D232-4FEE-8DBE-7C635BEB6B11}"/>
               </a:ext>
             </a:extLst>
           </p:cNvPr>
@@ -18057,7 +17872,7 @@
           <p:cNvPr id="30" name="">
             <a:extLst xmlns:a="http://schemas.openxmlformats.org/drawingml/2006/main">
               <a:ext uri="{FF2B5EF4-FFF2-40B4-BE49-F238E27FC236}">
-                <a16:creationId xmlns:a16="http://schemas.microsoft.com/office/drawing/2014/main" id="{9E3C2D8E-B495-4718-97E3-E66C4B10FDC0}"/>
+                <a16:creationId xmlns:a16="http://schemas.microsoft.com/office/drawing/2014/main" id="{40022662-278E-45D1-86DC-902485D6DB0A}"/>
               </a:ext>
             </a:extLst>
           </p:cNvPr>
@@ -18107,7 +17922,7 @@
           <p:cNvPr id="31" name="">
             <a:extLst xmlns:a="http://schemas.openxmlformats.org/drawingml/2006/main">
               <a:ext uri="{FF2B5EF4-FFF2-40B4-BE49-F238E27FC236}">
-                <a16:creationId xmlns:a16="http://schemas.microsoft.com/office/drawing/2014/main" id="{9DE6383F-297B-4FD9-8649-168BB708A6A1}"/>
+                <a16:creationId xmlns:a16="http://schemas.microsoft.com/office/drawing/2014/main" id="{A99821AD-2BA4-4102-8A0F-1B210C908713}"/>
               </a:ext>
             </a:extLst>
           </p:cNvPr>
@@ -18140,7 +17955,7 @@
           <p:cNvPr id="32" name="">
             <a:extLst xmlns:a="http://schemas.openxmlformats.org/drawingml/2006/main">
               <a:ext uri="{FF2B5EF4-FFF2-40B4-BE49-F238E27FC236}">
-                <a16:creationId xmlns:a16="http://schemas.microsoft.com/office/drawing/2014/main" id="{5B972689-FA80-4E13-A3D9-C49F4416CB3A}"/>
+                <a16:creationId xmlns:a16="http://schemas.microsoft.com/office/drawing/2014/main" id="{96A4407F-0214-484C-946D-3405F393F508}"/>
               </a:ext>
             </a:extLst>
           </p:cNvPr>
@@ -18190,7 +18005,7 @@
           <p:cNvPr id="33" name="">
             <a:extLst xmlns:a="http://schemas.openxmlformats.org/drawingml/2006/main">
               <a:ext uri="{FF2B5EF4-FFF2-40B4-BE49-F238E27FC236}">
-                <a16:creationId xmlns:a16="http://schemas.microsoft.com/office/drawing/2014/main" id="{9EBA43BD-CDA4-4EFF-A026-0D9F3DD816FA}"/>
+                <a16:creationId xmlns:a16="http://schemas.microsoft.com/office/drawing/2014/main" id="{1265E16F-D036-4FE0-B635-725A9899F32D}"/>
               </a:ext>
             </a:extLst>
           </p:cNvPr>
@@ -18238,7 +18053,7 @@
     </p:spTree>
     <p:extLst>
       <p:ext uri="{BB962C8B-B14F-4D97-AF65-F5344CB8AC3E}">
-        <p14:creationId xmlns:p14="http://schemas.microsoft.com/office/powerpoint/2010/main" val="1061500193"/>
+        <p14:creationId xmlns:p14="http://schemas.microsoft.com/office/powerpoint/2010/main" val="1767858765"/>
       </p:ext>
     </p:extLst>
   </p:cSld>
@@ -18269,7 +18084,7 @@
           <p:cNvPr id="31" name="">
             <a:extLst xmlns:a="http://schemas.openxmlformats.org/drawingml/2006/main">
               <a:ext uri="{FF2B5EF4-FFF2-40B4-BE49-F238E27FC236}">
-                <a16:creationId xmlns:a16="http://schemas.microsoft.com/office/drawing/2014/main" id="{C66397C4-EF97-4313-9F1A-20A0476BAE4F}"/>
+                <a16:creationId xmlns:a16="http://schemas.microsoft.com/office/drawing/2014/main" id="{7EF45399-3DE0-4E69-A3AB-9AB50D39A7A9}"/>
               </a:ext>
             </a:extLst>
           </p:cNvPr>
@@ -18319,7 +18134,7 @@
           <p:cNvPr id="2" name="">
             <a:extLst xmlns:a="http://schemas.openxmlformats.org/drawingml/2006/main">
               <a:ext uri="{FF2B5EF4-FFF2-40B4-BE49-F238E27FC236}">
-                <a16:creationId xmlns:a16="http://schemas.microsoft.com/office/drawing/2014/main" id="{5F38E15C-0789-4FBC-9665-495F8C1ECEEB}"/>
+                <a16:creationId xmlns:a16="http://schemas.microsoft.com/office/drawing/2014/main" id="{5F211539-A8E9-4ED0-8987-00C781B8D9F2}"/>
               </a:ext>
             </a:extLst>
           </p:cNvPr>
@@ -18369,7 +18184,7 @@
           <p:cNvPr id="3" name="">
             <a:extLst xmlns:a="http://schemas.openxmlformats.org/drawingml/2006/main">
               <a:ext uri="{FF2B5EF4-FFF2-40B4-BE49-F238E27FC236}">
-                <a16:creationId xmlns:a16="http://schemas.microsoft.com/office/drawing/2014/main" id="{DCAE3C17-F761-4B1B-8D4E-2FB55D94B1AB}"/>
+                <a16:creationId xmlns:a16="http://schemas.microsoft.com/office/drawing/2014/main" id="{A3C46A6C-5ABE-4713-A5C1-589BECF21638}"/>
               </a:ext>
             </a:extLst>
           </p:cNvPr>
@@ -18419,7 +18234,7 @@
           <p:cNvPr id="4" name="">
             <a:extLst xmlns:a="http://schemas.openxmlformats.org/drawingml/2006/main">
               <a:ext uri="{FF2B5EF4-FFF2-40B4-BE49-F238E27FC236}">
-                <a16:creationId xmlns:a16="http://schemas.microsoft.com/office/drawing/2014/main" id="{514C06B1-C75C-4606-A29E-9437AB3B43AD}"/>
+                <a16:creationId xmlns:a16="http://schemas.microsoft.com/office/drawing/2014/main" id="{348AE0E2-A1CC-4944-8244-33A3B84DAE17}"/>
               </a:ext>
             </a:extLst>
           </p:cNvPr>
@@ -18452,7 +18267,7 @@
           <p:cNvPr id="5" name="">
             <a:extLst xmlns:a="http://schemas.openxmlformats.org/drawingml/2006/main">
               <a:ext uri="{FF2B5EF4-FFF2-40B4-BE49-F238E27FC236}">
-                <a16:creationId xmlns:a16="http://schemas.microsoft.com/office/drawing/2014/main" id="{057950A1-678B-4BF2-AC85-B34B71D3714D}"/>
+                <a16:creationId xmlns:a16="http://schemas.microsoft.com/office/drawing/2014/main" id="{91AE9D44-798C-426A-8B60-C481C2FB729B}"/>
               </a:ext>
             </a:extLst>
           </p:cNvPr>
@@ -18502,7 +18317,7 @@
           <p:cNvPr id="6" name="">
             <a:extLst xmlns:a="http://schemas.openxmlformats.org/drawingml/2006/main">
               <a:ext uri="{FF2B5EF4-FFF2-40B4-BE49-F238E27FC236}">
-                <a16:creationId xmlns:a16="http://schemas.microsoft.com/office/drawing/2014/main" id="{B62E2FBC-CA0F-4558-A7E1-CCFBDA0A2136}"/>
+                <a16:creationId xmlns:a16="http://schemas.microsoft.com/office/drawing/2014/main" id="{214C0E3A-AC1E-4802-8F6B-EC12036E9D96}"/>
               </a:ext>
             </a:extLst>
           </p:cNvPr>
@@ -18537,7 +18352,7 @@
           <p:cNvPr id="7" name="">
             <a:extLst xmlns:a="http://schemas.openxmlformats.org/drawingml/2006/main">
               <a:ext uri="{FF2B5EF4-FFF2-40B4-BE49-F238E27FC236}">
-                <a16:creationId xmlns:a16="http://schemas.microsoft.com/office/drawing/2014/main" id="{B491C015-BB98-40E1-A4C7-1521C4A9B3C1}"/>
+                <a16:creationId xmlns:a16="http://schemas.microsoft.com/office/drawing/2014/main" id="{45A323E2-C005-4086-9868-C443D5B4AB74}"/>
               </a:ext>
             </a:extLst>
           </p:cNvPr>
@@ -18587,7 +18402,7 @@
           <p:cNvPr id="8" name="">
             <a:extLst xmlns:a="http://schemas.openxmlformats.org/drawingml/2006/main">
               <a:ext uri="{FF2B5EF4-FFF2-40B4-BE49-F238E27FC236}">
-                <a16:creationId xmlns:a16="http://schemas.microsoft.com/office/drawing/2014/main" id="{CB19A8AA-B12F-4BB2-9C58-A62A3E5FA73C}"/>
+                <a16:creationId xmlns:a16="http://schemas.microsoft.com/office/drawing/2014/main" id="{5326944E-EC23-404B-9E4A-361D189E787C}"/>
               </a:ext>
             </a:extLst>
           </p:cNvPr>
@@ -18654,7 +18469,7 @@
           <p:cNvPr id="9" name="">
             <a:extLst xmlns:a="http://schemas.openxmlformats.org/drawingml/2006/main">
               <a:ext uri="{FF2B5EF4-FFF2-40B4-BE49-F238E27FC236}">
-                <a16:creationId xmlns:a16="http://schemas.microsoft.com/office/drawing/2014/main" id="{1103B1A8-2C09-4161-A0B1-E3566CCDCE4D}"/>
+                <a16:creationId xmlns:a16="http://schemas.microsoft.com/office/drawing/2014/main" id="{E90DBA28-BEF7-4DFF-B472-A43F25B18B6F}"/>
               </a:ext>
             </a:extLst>
           </p:cNvPr>
@@ -18721,7 +18536,7 @@
           <p:cNvPr id="10" name="">
             <a:extLst xmlns:a="http://schemas.openxmlformats.org/drawingml/2006/main">
               <a:ext uri="{FF2B5EF4-FFF2-40B4-BE49-F238E27FC236}">
-                <a16:creationId xmlns:a16="http://schemas.microsoft.com/office/drawing/2014/main" id="{2AFCF000-94C4-46F8-A2EB-9BE158030624}"/>
+                <a16:creationId xmlns:a16="http://schemas.microsoft.com/office/drawing/2014/main" id="{42B01392-8393-44E2-9331-52C6A37378C4}"/>
               </a:ext>
             </a:extLst>
           </p:cNvPr>
@@ -18771,7 +18586,7 @@
           <p:cNvPr id="11" name="">
             <a:extLst xmlns:a="http://schemas.openxmlformats.org/drawingml/2006/main">
               <a:ext uri="{FF2B5EF4-FFF2-40B4-BE49-F238E27FC236}">
-                <a16:creationId xmlns:a16="http://schemas.microsoft.com/office/drawing/2014/main" id="{C1BE6F2A-E906-4317-BA52-A843635DA42D}"/>
+                <a16:creationId xmlns:a16="http://schemas.microsoft.com/office/drawing/2014/main" id="{4C86361A-CAC0-4E1B-A00B-5DB9B270E962}"/>
               </a:ext>
             </a:extLst>
           </p:cNvPr>
@@ -18821,7 +18636,7 @@
           <p:cNvPr id="12" name="">
             <a:extLst xmlns:a="http://schemas.openxmlformats.org/drawingml/2006/main">
               <a:ext uri="{FF2B5EF4-FFF2-40B4-BE49-F238E27FC236}">
-                <a16:creationId xmlns:a16="http://schemas.microsoft.com/office/drawing/2014/main" id="{847DC0BA-EDCB-4D80-9973-0212A9332EE0}"/>
+                <a16:creationId xmlns:a16="http://schemas.microsoft.com/office/drawing/2014/main" id="{EA6425AD-EC73-4FB2-A149-C32EFE3E55D5}"/>
               </a:ext>
             </a:extLst>
           </p:cNvPr>
@@ -18871,7 +18686,7 @@
           <p:cNvPr id="13" name="">
             <a:extLst xmlns:a="http://schemas.openxmlformats.org/drawingml/2006/main">
               <a:ext uri="{FF2B5EF4-FFF2-40B4-BE49-F238E27FC236}">
-                <a16:creationId xmlns:a16="http://schemas.microsoft.com/office/drawing/2014/main" id="{048F0459-571E-487A-B555-1B44A9373C50}"/>
+                <a16:creationId xmlns:a16="http://schemas.microsoft.com/office/drawing/2014/main" id="{01EF781D-308C-4DB1-8529-4540BE6B4558}"/>
               </a:ext>
             </a:extLst>
           </p:cNvPr>
@@ -18904,7 +18719,7 @@
           <p:cNvPr id="14" name="">
             <a:extLst xmlns:a="http://schemas.openxmlformats.org/drawingml/2006/main">
               <a:ext uri="{FF2B5EF4-FFF2-40B4-BE49-F238E27FC236}">
-                <a16:creationId xmlns:a16="http://schemas.microsoft.com/office/drawing/2014/main" id="{9B639640-1A0F-4D7E-A11D-3430D92CF708}"/>
+                <a16:creationId xmlns:a16="http://schemas.microsoft.com/office/drawing/2014/main" id="{5E5AC82E-08FF-496B-8A36-8126D557867C}"/>
               </a:ext>
             </a:extLst>
           </p:cNvPr>
@@ -18954,7 +18769,7 @@
           <p:cNvPr id="15" name="">
             <a:extLst xmlns:a="http://schemas.openxmlformats.org/drawingml/2006/main">
               <a:ext uri="{FF2B5EF4-FFF2-40B4-BE49-F238E27FC236}">
-                <a16:creationId xmlns:a16="http://schemas.microsoft.com/office/drawing/2014/main" id="{7B19525B-8F42-49D6-B9E2-BA31242B5420}"/>
+                <a16:creationId xmlns:a16="http://schemas.microsoft.com/office/drawing/2014/main" id="{DE6C5789-6C23-4298-A724-54A0191E4C86}"/>
               </a:ext>
             </a:extLst>
           </p:cNvPr>
@@ -19004,7 +18819,7 @@
           <p:cNvPr id="16" name="">
             <a:extLst xmlns:a="http://schemas.openxmlformats.org/drawingml/2006/main">
               <a:ext uri="{FF2B5EF4-FFF2-40B4-BE49-F238E27FC236}">
-                <a16:creationId xmlns:a16="http://schemas.microsoft.com/office/drawing/2014/main" id="{9319C33C-B4E1-486B-9B2F-4966137FB93E}"/>
+                <a16:creationId xmlns:a16="http://schemas.microsoft.com/office/drawing/2014/main" id="{6617016C-80B5-46A5-B2E8-D32BE625B1D8}"/>
               </a:ext>
             </a:extLst>
           </p:cNvPr>
@@ -19054,7 +18869,7 @@
           <p:cNvPr id="17" name="">
             <a:extLst xmlns:a="http://schemas.openxmlformats.org/drawingml/2006/main">
               <a:ext uri="{FF2B5EF4-FFF2-40B4-BE49-F238E27FC236}">
-                <a16:creationId xmlns:a16="http://schemas.microsoft.com/office/drawing/2014/main" id="{F6FEFC73-5412-4669-BF4E-7C69A724EA03}"/>
+                <a16:creationId xmlns:a16="http://schemas.microsoft.com/office/drawing/2014/main" id="{C94798E8-E848-409F-953A-0F413CFC91EB}"/>
               </a:ext>
             </a:extLst>
           </p:cNvPr>
@@ -19087,7 +18902,7 @@
           <p:cNvPr id="18" name="">
             <a:extLst xmlns:a="http://schemas.openxmlformats.org/drawingml/2006/main">
               <a:ext uri="{FF2B5EF4-FFF2-40B4-BE49-F238E27FC236}">
-                <a16:creationId xmlns:a16="http://schemas.microsoft.com/office/drawing/2014/main" id="{26B395EE-E67E-465C-9758-9E2E0E3C8F35}"/>
+                <a16:creationId xmlns:a16="http://schemas.microsoft.com/office/drawing/2014/main" id="{336B0A76-0EE3-4908-BCDB-DD541A82DC93}"/>
               </a:ext>
             </a:extLst>
           </p:cNvPr>
@@ -19137,7 +18952,7 @@
           <p:cNvPr id="19" name="">
             <a:extLst xmlns:a="http://schemas.openxmlformats.org/drawingml/2006/main">
               <a:ext uri="{FF2B5EF4-FFF2-40B4-BE49-F238E27FC236}">
-                <a16:creationId xmlns:a16="http://schemas.microsoft.com/office/drawing/2014/main" id="{A57EB418-30C9-4C9C-B3A3-FB19A91ACAD4}"/>
+                <a16:creationId xmlns:a16="http://schemas.microsoft.com/office/drawing/2014/main" id="{CA2C7F3B-EB28-4EF4-95AB-03726F922861}"/>
               </a:ext>
             </a:extLst>
           </p:cNvPr>
@@ -19187,7 +19002,7 @@
           <p:cNvPr id="20" name="">
             <a:extLst xmlns:a="http://schemas.openxmlformats.org/drawingml/2006/main">
               <a:ext uri="{FF2B5EF4-FFF2-40B4-BE49-F238E27FC236}">
-                <a16:creationId xmlns:a16="http://schemas.microsoft.com/office/drawing/2014/main" id="{96BE7521-F77E-4C04-8B19-749D61B95A32}"/>
+                <a16:creationId xmlns:a16="http://schemas.microsoft.com/office/drawing/2014/main" id="{43703801-0562-4BD7-A310-AE2B3B88AFAD}"/>
               </a:ext>
             </a:extLst>
           </p:cNvPr>
@@ -19237,7 +19052,7 @@
           <p:cNvPr id="21" name="">
             <a:extLst xmlns:a="http://schemas.openxmlformats.org/drawingml/2006/main">
               <a:ext uri="{FF2B5EF4-FFF2-40B4-BE49-F238E27FC236}">
-                <a16:creationId xmlns:a16="http://schemas.microsoft.com/office/drawing/2014/main" id="{A9FDE36A-EAEC-46AB-9B9D-A45DD1333F09}"/>
+                <a16:creationId xmlns:a16="http://schemas.microsoft.com/office/drawing/2014/main" id="{B2A5672F-AE46-445C-926A-CBDD04B90E16}"/>
               </a:ext>
             </a:extLst>
           </p:cNvPr>
@@ -19270,7 +19085,7 @@
           <p:cNvPr id="22" name="">
             <a:extLst xmlns:a="http://schemas.openxmlformats.org/drawingml/2006/main">
               <a:ext uri="{FF2B5EF4-FFF2-40B4-BE49-F238E27FC236}">
-                <a16:creationId xmlns:a16="http://schemas.microsoft.com/office/drawing/2014/main" id="{8BED5BF9-8A18-4BAE-A4EE-D47B6D8CC57B}"/>
+                <a16:creationId xmlns:a16="http://schemas.microsoft.com/office/drawing/2014/main" id="{A8B0D730-C743-42E5-BAB6-B094445B03F4}"/>
               </a:ext>
             </a:extLst>
           </p:cNvPr>
@@ -19320,7 +19135,7 @@
           <p:cNvPr id="23" name="">
             <a:extLst xmlns:a="http://schemas.openxmlformats.org/drawingml/2006/main">
               <a:ext uri="{FF2B5EF4-FFF2-40B4-BE49-F238E27FC236}">
-                <a16:creationId xmlns:a16="http://schemas.microsoft.com/office/drawing/2014/main" id="{0D7E8178-E779-4F54-AA8C-77672EF4BAAA}"/>
+                <a16:creationId xmlns:a16="http://schemas.microsoft.com/office/drawing/2014/main" id="{2A5EBD3E-B82C-4AFA-BE8B-6E9834170A63}"/>
               </a:ext>
             </a:extLst>
           </p:cNvPr>
@@ -19370,7 +19185,7 @@
           <p:cNvPr id="24" name="">
             <a:extLst xmlns:a="http://schemas.openxmlformats.org/drawingml/2006/main">
               <a:ext uri="{FF2B5EF4-FFF2-40B4-BE49-F238E27FC236}">
-                <a16:creationId xmlns:a16="http://schemas.microsoft.com/office/drawing/2014/main" id="{41148CE8-D32B-44BF-B52E-E07216EA543C}"/>
+                <a16:creationId xmlns:a16="http://schemas.microsoft.com/office/drawing/2014/main" id="{CFA90AC4-308F-4137-9182-CB06F9B54014}"/>
               </a:ext>
             </a:extLst>
           </p:cNvPr>
@@ -19420,7 +19235,7 @@
           <p:cNvPr id="25" name="">
             <a:extLst xmlns:a="http://schemas.openxmlformats.org/drawingml/2006/main">
               <a:ext uri="{FF2B5EF4-FFF2-40B4-BE49-F238E27FC236}">
-                <a16:creationId xmlns:a16="http://schemas.microsoft.com/office/drawing/2014/main" id="{9BEA9DB3-6C2E-4ADA-B014-9FC7EB747933}"/>
+                <a16:creationId xmlns:a16="http://schemas.microsoft.com/office/drawing/2014/main" id="{C37B76E6-1865-4B4D-9A3A-D74C3C4A6A7D}"/>
               </a:ext>
             </a:extLst>
           </p:cNvPr>
@@ -19453,7 +19268,7 @@
           <p:cNvPr id="26" name="">
             <a:extLst xmlns:a="http://schemas.openxmlformats.org/drawingml/2006/main">
               <a:ext uri="{FF2B5EF4-FFF2-40B4-BE49-F238E27FC236}">
-                <a16:creationId xmlns:a16="http://schemas.microsoft.com/office/drawing/2014/main" id="{172D2F95-85A5-41D8-843C-5191B0F1F85D}"/>
+                <a16:creationId xmlns:a16="http://schemas.microsoft.com/office/drawing/2014/main" id="{B4E49A2B-8D2A-43C8-9416-547CD1A230B3}"/>
               </a:ext>
             </a:extLst>
           </p:cNvPr>
@@ -19488,7 +19303,7 @@
           <p:cNvPr id="27" name="">
             <a:extLst xmlns:a="http://schemas.openxmlformats.org/drawingml/2006/main">
               <a:ext uri="{FF2B5EF4-FFF2-40B4-BE49-F238E27FC236}">
-                <a16:creationId xmlns:a16="http://schemas.microsoft.com/office/drawing/2014/main" id="{6F2E995C-7B7D-4160-9F52-42F2261C8DD3}"/>
+                <a16:creationId xmlns:a16="http://schemas.microsoft.com/office/drawing/2014/main" id="{96201596-FC83-42F3-ADD2-5BBB7902CA48}"/>
               </a:ext>
             </a:extLst>
           </p:cNvPr>
@@ -19538,7 +19353,7 @@
           <p:cNvPr id="28" name="">
             <a:extLst xmlns:a="http://schemas.openxmlformats.org/drawingml/2006/main">
               <a:ext uri="{FF2B5EF4-FFF2-40B4-BE49-F238E27FC236}">
-                <a16:creationId xmlns:a16="http://schemas.microsoft.com/office/drawing/2014/main" id="{2FF5C845-A1B9-4FFB-A8B2-09F82CF88598}"/>
+                <a16:creationId xmlns:a16="http://schemas.microsoft.com/office/drawing/2014/main" id="{087F6866-6AD6-49C2-81EF-5B93BB5B92CE}"/>
               </a:ext>
             </a:extLst>
           </p:cNvPr>
@@ -19571,7 +19386,7 @@
           <p:cNvPr id="29" name="">
             <a:extLst xmlns:a="http://schemas.openxmlformats.org/drawingml/2006/main">
               <a:ext uri="{FF2B5EF4-FFF2-40B4-BE49-F238E27FC236}">
-                <a16:creationId xmlns:a16="http://schemas.microsoft.com/office/drawing/2014/main" id="{710AA7F5-2B57-4062-8F58-35B5B11FF7B6}"/>
+                <a16:creationId xmlns:a16="http://schemas.microsoft.com/office/drawing/2014/main" id="{DBF3E819-7CDC-4EFC-8522-A8DD2AC0C28C}"/>
               </a:ext>
             </a:extLst>
           </p:cNvPr>
@@ -19621,7 +19436,7 @@
           <p:cNvPr id="30" name="">
             <a:extLst xmlns:a="http://schemas.openxmlformats.org/drawingml/2006/main">
               <a:ext uri="{FF2B5EF4-FFF2-40B4-BE49-F238E27FC236}">
-                <a16:creationId xmlns:a16="http://schemas.microsoft.com/office/drawing/2014/main" id="{52F7A218-437D-4F75-8104-07F55133694F}"/>
+                <a16:creationId xmlns:a16="http://schemas.microsoft.com/office/drawing/2014/main" id="{E2B842BE-A07C-4882-B4AD-B6F1BFE67035}"/>
               </a:ext>
             </a:extLst>
           </p:cNvPr>
@@ -19669,7 +19484,7 @@
     </p:spTree>
     <p:extLst>
       <p:ext uri="{BB962C8B-B14F-4D97-AF65-F5344CB8AC3E}">
-        <p14:creationId xmlns:p14="http://schemas.microsoft.com/office/powerpoint/2010/main" val="816402471"/>
+        <p14:creationId xmlns:p14="http://schemas.microsoft.com/office/powerpoint/2010/main" val="1281271460"/>
       </p:ext>
     </p:extLst>
   </p:cSld>
@@ -19700,7 +19515,7 @@
           <p:cNvPr id="43" name="">
             <a:extLst xmlns:a="http://schemas.openxmlformats.org/drawingml/2006/main">
               <a:ext uri="{FF2B5EF4-FFF2-40B4-BE49-F238E27FC236}">
-                <a16:creationId xmlns:a16="http://schemas.microsoft.com/office/drawing/2014/main" id="{D33A043D-CE52-4907-B3EA-ED3B5F0504DA}"/>
+                <a16:creationId xmlns:a16="http://schemas.microsoft.com/office/drawing/2014/main" id="{43038AF1-9FF9-4645-86B4-DD76AE9CC291}"/>
               </a:ext>
             </a:extLst>
           </p:cNvPr>
@@ -19750,7 +19565,7 @@
           <p:cNvPr id="2" name="">
             <a:extLst xmlns:a="http://schemas.openxmlformats.org/drawingml/2006/main">
               <a:ext uri="{FF2B5EF4-FFF2-40B4-BE49-F238E27FC236}">
-                <a16:creationId xmlns:a16="http://schemas.microsoft.com/office/drawing/2014/main" id="{F99117C7-2E6B-472D-A7AD-E64E2AEB30AE}"/>
+                <a16:creationId xmlns:a16="http://schemas.microsoft.com/office/drawing/2014/main" id="{545AC658-3699-41EC-85BC-91859715DBB9}"/>
               </a:ext>
             </a:extLst>
           </p:cNvPr>
@@ -19800,7 +19615,7 @@
           <p:cNvPr id="3" name="">
             <a:extLst xmlns:a="http://schemas.openxmlformats.org/drawingml/2006/main">
               <a:ext uri="{FF2B5EF4-FFF2-40B4-BE49-F238E27FC236}">
-                <a16:creationId xmlns:a16="http://schemas.microsoft.com/office/drawing/2014/main" id="{C5D64A8A-13A3-4F13-ABDE-7BBEB5286F6A}"/>
+                <a16:creationId xmlns:a16="http://schemas.microsoft.com/office/drawing/2014/main" id="{2566E502-B8F1-4B9F-8DBA-E1C33CC05A3C}"/>
               </a:ext>
             </a:extLst>
           </p:cNvPr>
@@ -19850,7 +19665,7 @@
           <p:cNvPr id="4" name="">
             <a:extLst xmlns:a="http://schemas.openxmlformats.org/drawingml/2006/main">
               <a:ext uri="{FF2B5EF4-FFF2-40B4-BE49-F238E27FC236}">
-                <a16:creationId xmlns:a16="http://schemas.microsoft.com/office/drawing/2014/main" id="{12AFACE7-3ADB-4BC9-A6EB-E4D18D496F90}"/>
+                <a16:creationId xmlns:a16="http://schemas.microsoft.com/office/drawing/2014/main" id="{C2B8F6A1-C892-44B8-B813-A043D5E31D18}"/>
               </a:ext>
             </a:extLst>
           </p:cNvPr>
@@ -19883,7 +19698,7 @@
           <p:cNvPr id="5" name="">
             <a:extLst xmlns:a="http://schemas.openxmlformats.org/drawingml/2006/main">
               <a:ext uri="{FF2B5EF4-FFF2-40B4-BE49-F238E27FC236}">
-                <a16:creationId xmlns:a16="http://schemas.microsoft.com/office/drawing/2014/main" id="{FC60AF30-655C-4588-9808-045B9BB2D6FE}"/>
+                <a16:creationId xmlns:a16="http://schemas.microsoft.com/office/drawing/2014/main" id="{944CCCEE-DD9D-4C74-9EFD-69741D35F3DE}"/>
               </a:ext>
             </a:extLst>
           </p:cNvPr>
@@ -19933,7 +19748,7 @@
           <p:cNvPr id="6" name="">
             <a:extLst xmlns:a="http://schemas.openxmlformats.org/drawingml/2006/main">
               <a:ext uri="{FF2B5EF4-FFF2-40B4-BE49-F238E27FC236}">
-                <a16:creationId xmlns:a16="http://schemas.microsoft.com/office/drawing/2014/main" id="{FACBCB53-A86C-4BB1-8C60-CBA5612CD8C4}"/>
+                <a16:creationId xmlns:a16="http://schemas.microsoft.com/office/drawing/2014/main" id="{EEDE9CE6-843F-49E0-ADA4-190AC1F3865E}"/>
               </a:ext>
             </a:extLst>
           </p:cNvPr>
@@ -19983,7 +19798,7 @@
           <p:cNvPr id="7" name="">
             <a:extLst xmlns:a="http://schemas.openxmlformats.org/drawingml/2006/main">
               <a:ext uri="{FF2B5EF4-FFF2-40B4-BE49-F238E27FC236}">
-                <a16:creationId xmlns:a16="http://schemas.microsoft.com/office/drawing/2014/main" id="{DCE25400-109B-4C28-A5BD-777B5837E7FB}"/>
+                <a16:creationId xmlns:a16="http://schemas.microsoft.com/office/drawing/2014/main" id="{0199C981-71A8-4214-97D0-43129F291801}"/>
               </a:ext>
             </a:extLst>
           </p:cNvPr>
@@ -20016,7 +19831,7 @@
           <p:cNvPr id="8" name="">
             <a:extLst xmlns:a="http://schemas.openxmlformats.org/drawingml/2006/main">
               <a:ext uri="{FF2B5EF4-FFF2-40B4-BE49-F238E27FC236}">
-                <a16:creationId xmlns:a16="http://schemas.microsoft.com/office/drawing/2014/main" id="{8B35A114-04A0-48C1-90D8-D7FA9FC0418A}"/>
+                <a16:creationId xmlns:a16="http://schemas.microsoft.com/office/drawing/2014/main" id="{E004A8D1-E27E-481B-9071-10748DED2A28}"/>
               </a:ext>
             </a:extLst>
           </p:cNvPr>
@@ -20049,7 +19864,7 @@
           <p:cNvPr id="9" name="">
             <a:extLst xmlns:a="http://schemas.openxmlformats.org/drawingml/2006/main">
               <a:ext uri="{FF2B5EF4-FFF2-40B4-BE49-F238E27FC236}">
-                <a16:creationId xmlns:a16="http://schemas.microsoft.com/office/drawing/2014/main" id="{1141535B-8388-4F1D-BF71-59D528E4DCE7}"/>
+                <a16:creationId xmlns:a16="http://schemas.microsoft.com/office/drawing/2014/main" id="{D54D5629-8D62-4911-A33C-7C63D06476BE}"/>
               </a:ext>
             </a:extLst>
           </p:cNvPr>
@@ -20084,7 +19899,7 @@
           <p:cNvPr id="10" name="">
             <a:extLst xmlns:a="http://schemas.openxmlformats.org/drawingml/2006/main">
               <a:ext uri="{FF2B5EF4-FFF2-40B4-BE49-F238E27FC236}">
-                <a16:creationId xmlns:a16="http://schemas.microsoft.com/office/drawing/2014/main" id="{5575D4A2-B1FA-48F6-9D0D-E74C7BD14202}"/>
+                <a16:creationId xmlns:a16="http://schemas.microsoft.com/office/drawing/2014/main" id="{1F626458-DF47-4A9C-8FE5-0F535FB60D21}"/>
               </a:ext>
             </a:extLst>
           </p:cNvPr>
@@ -20115,7 +19930,7 @@
           <p:cNvPr id="11" name="">
             <a:extLst xmlns:a="http://schemas.openxmlformats.org/drawingml/2006/main">
               <a:ext uri="{FF2B5EF4-FFF2-40B4-BE49-F238E27FC236}">
-                <a16:creationId xmlns:a16="http://schemas.microsoft.com/office/drawing/2014/main" id="{37474170-5D25-4D4E-A73E-F789B1690F75}"/>
+                <a16:creationId xmlns:a16="http://schemas.microsoft.com/office/drawing/2014/main" id="{53C27AF1-8C00-45AB-BD2F-105E913F9702}"/>
               </a:ext>
             </a:extLst>
           </p:cNvPr>
@@ -20165,7 +19980,7 @@
           <p:cNvPr id="12" name="">
             <a:extLst xmlns:a="http://schemas.openxmlformats.org/drawingml/2006/main">
               <a:ext uri="{FF2B5EF4-FFF2-40B4-BE49-F238E27FC236}">
-                <a16:creationId xmlns:a16="http://schemas.microsoft.com/office/drawing/2014/main" id="{62E16C41-0040-4448-88F9-049415A74FBC}"/>
+                <a16:creationId xmlns:a16="http://schemas.microsoft.com/office/drawing/2014/main" id="{BB217AAB-C38A-42CA-B528-639D0471B71C}"/>
               </a:ext>
             </a:extLst>
           </p:cNvPr>
@@ -20215,7 +20030,7 @@
           <p:cNvPr id="13" name="">
             <a:extLst xmlns:a="http://schemas.openxmlformats.org/drawingml/2006/main">
               <a:ext uri="{FF2B5EF4-FFF2-40B4-BE49-F238E27FC236}">
-                <a16:creationId xmlns:a16="http://schemas.microsoft.com/office/drawing/2014/main" id="{C321B824-06FE-4FBB-B192-1CFF0BE05DDA}"/>
+                <a16:creationId xmlns:a16="http://schemas.microsoft.com/office/drawing/2014/main" id="{AC9C66DF-90DB-44C0-87ED-F5F82CDA05E6}"/>
               </a:ext>
             </a:extLst>
           </p:cNvPr>
@@ -20246,7 +20061,7 @@
           <p:cNvPr id="14" name="">
             <a:extLst xmlns:a="http://schemas.openxmlformats.org/drawingml/2006/main">
               <a:ext uri="{FF2B5EF4-FFF2-40B4-BE49-F238E27FC236}">
-                <a16:creationId xmlns:a16="http://schemas.microsoft.com/office/drawing/2014/main" id="{AC8478A8-3B60-481A-8242-8E7D1800D5DC}"/>
+                <a16:creationId xmlns:a16="http://schemas.microsoft.com/office/drawing/2014/main" id="{DA6396EA-7F4F-47E1-A3E9-196788540BDB}"/>
               </a:ext>
             </a:extLst>
           </p:cNvPr>
@@ -20296,7 +20111,7 @@
           <p:cNvPr id="15" name="">
             <a:extLst xmlns:a="http://schemas.openxmlformats.org/drawingml/2006/main">
               <a:ext uri="{FF2B5EF4-FFF2-40B4-BE49-F238E27FC236}">
-                <a16:creationId xmlns:a16="http://schemas.microsoft.com/office/drawing/2014/main" id="{E451D5AF-7B89-42E4-8635-2D8B18C08A90}"/>
+                <a16:creationId xmlns:a16="http://schemas.microsoft.com/office/drawing/2014/main" id="{7315B79A-649F-4CBB-8A7C-FD0E7762BBB3}"/>
               </a:ext>
             </a:extLst>
           </p:cNvPr>
@@ -20327,7 +20142,7 @@
           <p:cNvPr id="16" name="">
             <a:extLst xmlns:a="http://schemas.openxmlformats.org/drawingml/2006/main">
               <a:ext uri="{FF2B5EF4-FFF2-40B4-BE49-F238E27FC236}">
-                <a16:creationId xmlns:a16="http://schemas.microsoft.com/office/drawing/2014/main" id="{D23D3BEA-3030-4743-A46A-AD561EF0DD38}"/>
+                <a16:creationId xmlns:a16="http://schemas.microsoft.com/office/drawing/2014/main" id="{15CC4649-E8CA-43DA-88BD-B8826076E715}"/>
               </a:ext>
             </a:extLst>
           </p:cNvPr>
@@ -20377,7 +20192,7 @@
           <p:cNvPr id="17" name="">
             <a:extLst xmlns:a="http://schemas.openxmlformats.org/drawingml/2006/main">
               <a:ext uri="{FF2B5EF4-FFF2-40B4-BE49-F238E27FC236}">
-                <a16:creationId xmlns:a16="http://schemas.microsoft.com/office/drawing/2014/main" id="{1AD5AFAD-1BCF-4ABC-8D58-886F686DD5E7}"/>
+                <a16:creationId xmlns:a16="http://schemas.microsoft.com/office/drawing/2014/main" id="{DE7B74EA-3B99-4E4E-9B24-64CBCA9BD9AE}"/>
               </a:ext>
             </a:extLst>
           </p:cNvPr>
@@ -20408,7 +20223,7 @@
           <p:cNvPr id="18" name="">
             <a:extLst xmlns:a="http://schemas.openxmlformats.org/drawingml/2006/main">
               <a:ext uri="{FF2B5EF4-FFF2-40B4-BE49-F238E27FC236}">
-                <a16:creationId xmlns:a16="http://schemas.microsoft.com/office/drawing/2014/main" id="{1E14E8C1-DAB6-45B9-854A-92C38D75F54B}"/>
+                <a16:creationId xmlns:a16="http://schemas.microsoft.com/office/drawing/2014/main" id="{9BC173EC-0B8A-4F62-9D14-F41A3D0EEE9B}"/>
               </a:ext>
             </a:extLst>
           </p:cNvPr>
@@ -20458,7 +20273,7 @@
           <p:cNvPr id="19" name="">
             <a:extLst xmlns:a="http://schemas.openxmlformats.org/drawingml/2006/main">
               <a:ext uri="{FF2B5EF4-FFF2-40B4-BE49-F238E27FC236}">
-                <a16:creationId xmlns:a16="http://schemas.microsoft.com/office/drawing/2014/main" id="{4D824C65-F041-4585-AF3D-F6D83C7B119F}"/>
+                <a16:creationId xmlns:a16="http://schemas.microsoft.com/office/drawing/2014/main" id="{6007CA53-900B-4B45-AAB6-52E2151C6C6D}"/>
               </a:ext>
             </a:extLst>
           </p:cNvPr>
@@ -20493,7 +20308,7 @@
           <p:cNvPr id="20" name="">
             <a:extLst xmlns:a="http://schemas.openxmlformats.org/drawingml/2006/main">
               <a:ext uri="{FF2B5EF4-FFF2-40B4-BE49-F238E27FC236}">
-                <a16:creationId xmlns:a16="http://schemas.microsoft.com/office/drawing/2014/main" id="{A67294DD-3BB1-413D-82C9-D2E69D788564}"/>
+                <a16:creationId xmlns:a16="http://schemas.microsoft.com/office/drawing/2014/main" id="{9EA36BE5-0705-4F09-8891-90E9FC5610EE}"/>
               </a:ext>
             </a:extLst>
           </p:cNvPr>
@@ -20524,7 +20339,7 @@
           <p:cNvPr id="21" name="">
             <a:extLst xmlns:a="http://schemas.openxmlformats.org/drawingml/2006/main">
               <a:ext uri="{FF2B5EF4-FFF2-40B4-BE49-F238E27FC236}">
-                <a16:creationId xmlns:a16="http://schemas.microsoft.com/office/drawing/2014/main" id="{BE33B4F2-59D0-4D52-BBAA-C01B069F77AC}"/>
+                <a16:creationId xmlns:a16="http://schemas.microsoft.com/office/drawing/2014/main" id="{3C1E0320-4EF4-4502-9B00-C69CDD3A1E59}"/>
               </a:ext>
             </a:extLst>
           </p:cNvPr>
@@ -20574,7 +20389,7 @@
           <p:cNvPr id="22" name="">
             <a:extLst xmlns:a="http://schemas.openxmlformats.org/drawingml/2006/main">
               <a:ext uri="{FF2B5EF4-FFF2-40B4-BE49-F238E27FC236}">
-                <a16:creationId xmlns:a16="http://schemas.microsoft.com/office/drawing/2014/main" id="{323542E1-0257-4119-986B-FD2898659470}"/>
+                <a16:creationId xmlns:a16="http://schemas.microsoft.com/office/drawing/2014/main" id="{E6D3B916-573C-4391-A921-849C4C99A101}"/>
               </a:ext>
             </a:extLst>
           </p:cNvPr>
@@ -20624,7 +20439,7 @@
           <p:cNvPr id="23" name="">
             <a:extLst xmlns:a="http://schemas.openxmlformats.org/drawingml/2006/main">
               <a:ext uri="{FF2B5EF4-FFF2-40B4-BE49-F238E27FC236}">
-                <a16:creationId xmlns:a16="http://schemas.microsoft.com/office/drawing/2014/main" id="{23CF83A6-A4CB-4881-B649-7A5069AA1FD4}"/>
+                <a16:creationId xmlns:a16="http://schemas.microsoft.com/office/drawing/2014/main" id="{4FF167D1-CEA6-43E3-A972-D624ABA5BD17}"/>
               </a:ext>
             </a:extLst>
           </p:cNvPr>
@@ -20655,7 +20470,7 @@
           <p:cNvPr id="24" name="">
             <a:extLst xmlns:a="http://schemas.openxmlformats.org/drawingml/2006/main">
               <a:ext uri="{FF2B5EF4-FFF2-40B4-BE49-F238E27FC236}">
-                <a16:creationId xmlns:a16="http://schemas.microsoft.com/office/drawing/2014/main" id="{111A4C90-FE03-4001-8B7C-C93190D2D2C0}"/>
+                <a16:creationId xmlns:a16="http://schemas.microsoft.com/office/drawing/2014/main" id="{C8ED20EE-6419-43B7-B86E-EE5371CE4978}"/>
               </a:ext>
             </a:extLst>
           </p:cNvPr>
@@ -20705,7 +20520,7 @@
           <p:cNvPr id="25" name="">
             <a:extLst xmlns:a="http://schemas.openxmlformats.org/drawingml/2006/main">
               <a:ext uri="{FF2B5EF4-FFF2-40B4-BE49-F238E27FC236}">
-                <a16:creationId xmlns:a16="http://schemas.microsoft.com/office/drawing/2014/main" id="{8942AA71-60C2-49B1-BB8C-4BFAF9323A63}"/>
+                <a16:creationId xmlns:a16="http://schemas.microsoft.com/office/drawing/2014/main" id="{499716BC-84EE-46B3-ADA8-D9F0F915E3D6}"/>
               </a:ext>
             </a:extLst>
           </p:cNvPr>
@@ -20736,7 +20551,7 @@
           <p:cNvPr id="26" name="">
             <a:extLst xmlns:a="http://schemas.openxmlformats.org/drawingml/2006/main">
               <a:ext uri="{FF2B5EF4-FFF2-40B4-BE49-F238E27FC236}">
-                <a16:creationId xmlns:a16="http://schemas.microsoft.com/office/drawing/2014/main" id="{9DDA4BBF-F265-491D-9476-0B4122B9F189}"/>
+                <a16:creationId xmlns:a16="http://schemas.microsoft.com/office/drawing/2014/main" id="{EA3F668E-3BD0-48DE-B9F1-073E9A58AC98}"/>
               </a:ext>
             </a:extLst>
           </p:cNvPr>
@@ -20786,7 +20601,7 @@
           <p:cNvPr id="27" name="">
             <a:extLst xmlns:a="http://schemas.openxmlformats.org/drawingml/2006/main">
               <a:ext uri="{FF2B5EF4-FFF2-40B4-BE49-F238E27FC236}">
-                <a16:creationId xmlns:a16="http://schemas.microsoft.com/office/drawing/2014/main" id="{300E539F-07E8-4061-B9FE-5B1676ECAB3F}"/>
+                <a16:creationId xmlns:a16="http://schemas.microsoft.com/office/drawing/2014/main" id="{ADE28BCC-C2F1-4932-A495-735C1DFDDD7F}"/>
               </a:ext>
             </a:extLst>
           </p:cNvPr>
@@ -20817,7 +20632,7 @@
           <p:cNvPr id="28" name="">
             <a:extLst xmlns:a="http://schemas.openxmlformats.org/drawingml/2006/main">
               <a:ext uri="{FF2B5EF4-FFF2-40B4-BE49-F238E27FC236}">
-                <a16:creationId xmlns:a16="http://schemas.microsoft.com/office/drawing/2014/main" id="{E8D932C4-CB9A-4F19-BC0D-117E0E13D89C}"/>
+                <a16:creationId xmlns:a16="http://schemas.microsoft.com/office/drawing/2014/main" id="{3B494033-0F54-448C-B524-622E62375B38}"/>
               </a:ext>
             </a:extLst>
           </p:cNvPr>
@@ -20867,7 +20682,7 @@
           <p:cNvPr id="29" name="">
             <a:extLst xmlns:a="http://schemas.openxmlformats.org/drawingml/2006/main">
               <a:ext uri="{FF2B5EF4-FFF2-40B4-BE49-F238E27FC236}">
-                <a16:creationId xmlns:a16="http://schemas.microsoft.com/office/drawing/2014/main" id="{DB0EE9CC-5B2F-4EFF-AB69-8AE621ADD692}"/>
+                <a16:creationId xmlns:a16="http://schemas.microsoft.com/office/drawing/2014/main" id="{849DE85B-717C-4933-AFEA-5E1B7395D3EC}"/>
               </a:ext>
             </a:extLst>
           </p:cNvPr>
@@ -20902,7 +20717,7 @@
           <p:cNvPr id="30" name="">
             <a:extLst xmlns:a="http://schemas.openxmlformats.org/drawingml/2006/main">
               <a:ext uri="{FF2B5EF4-FFF2-40B4-BE49-F238E27FC236}">
-                <a16:creationId xmlns:a16="http://schemas.microsoft.com/office/drawing/2014/main" id="{77141D73-6DD5-49C8-8424-49D1A66D7F5C}"/>
+                <a16:creationId xmlns:a16="http://schemas.microsoft.com/office/drawing/2014/main" id="{3E750380-2579-4A83-A0DB-CCE0BE376B34}"/>
               </a:ext>
             </a:extLst>
           </p:cNvPr>
@@ -20933,7 +20748,7 @@
           <p:cNvPr id="31" name="">
             <a:extLst xmlns:a="http://schemas.openxmlformats.org/drawingml/2006/main">
               <a:ext uri="{FF2B5EF4-FFF2-40B4-BE49-F238E27FC236}">
-                <a16:creationId xmlns:a16="http://schemas.microsoft.com/office/drawing/2014/main" id="{AF930481-B040-4FC3-A2E9-D2D6E389A0DF}"/>
+                <a16:creationId xmlns:a16="http://schemas.microsoft.com/office/drawing/2014/main" id="{A062A391-725F-4B6A-8BC6-341F1B11C511}"/>
               </a:ext>
             </a:extLst>
           </p:cNvPr>
@@ -20983,7 +20798,7 @@
           <p:cNvPr id="32" name="">
             <a:extLst xmlns:a="http://schemas.openxmlformats.org/drawingml/2006/main">
               <a:ext uri="{FF2B5EF4-FFF2-40B4-BE49-F238E27FC236}">
-                <a16:creationId xmlns:a16="http://schemas.microsoft.com/office/drawing/2014/main" id="{1029EE03-FFA4-42CD-A334-574039F9341B}"/>
+                <a16:creationId xmlns:a16="http://schemas.microsoft.com/office/drawing/2014/main" id="{5820BB83-599F-446C-B61A-3FD65775647E}"/>
               </a:ext>
             </a:extLst>
           </p:cNvPr>
@@ -21033,7 +20848,7 @@
           <p:cNvPr id="33" name="">
             <a:extLst xmlns:a="http://schemas.openxmlformats.org/drawingml/2006/main">
               <a:ext uri="{FF2B5EF4-FFF2-40B4-BE49-F238E27FC236}">
-                <a16:creationId xmlns:a16="http://schemas.microsoft.com/office/drawing/2014/main" id="{3CB41BBF-3738-4A0D-B6C2-6CB015E6B6C5}"/>
+                <a16:creationId xmlns:a16="http://schemas.microsoft.com/office/drawing/2014/main" id="{A4786C47-38DD-41BD-9607-C6BC22E4BB80}"/>
               </a:ext>
             </a:extLst>
           </p:cNvPr>
@@ -21064,7 +20879,7 @@
           <p:cNvPr id="34" name="">
             <a:extLst xmlns:a="http://schemas.openxmlformats.org/drawingml/2006/main">
               <a:ext uri="{FF2B5EF4-FFF2-40B4-BE49-F238E27FC236}">
-                <a16:creationId xmlns:a16="http://schemas.microsoft.com/office/drawing/2014/main" id="{EE06F0EE-854A-4ED1-B585-C373D3A4C2CA}"/>
+                <a16:creationId xmlns:a16="http://schemas.microsoft.com/office/drawing/2014/main" id="{518D2523-AAC0-4298-BF0D-CA282F63E00B}"/>
               </a:ext>
             </a:extLst>
           </p:cNvPr>
@@ -21114,7 +20929,7 @@
           <p:cNvPr id="35" name="">
             <a:extLst xmlns:a="http://schemas.openxmlformats.org/drawingml/2006/main">
               <a:ext uri="{FF2B5EF4-FFF2-40B4-BE49-F238E27FC236}">
-                <a16:creationId xmlns:a16="http://schemas.microsoft.com/office/drawing/2014/main" id="{312E7F02-E056-4614-A555-ADC95D1BEF89}"/>
+                <a16:creationId xmlns:a16="http://schemas.microsoft.com/office/drawing/2014/main" id="{3E711FA5-3582-4F86-BC11-9972E6F485FD}"/>
               </a:ext>
             </a:extLst>
           </p:cNvPr>
@@ -21145,7 +20960,7 @@
           <p:cNvPr id="36" name="">
             <a:extLst xmlns:a="http://schemas.openxmlformats.org/drawingml/2006/main">
               <a:ext uri="{FF2B5EF4-FFF2-40B4-BE49-F238E27FC236}">
-                <a16:creationId xmlns:a16="http://schemas.microsoft.com/office/drawing/2014/main" id="{1DA66F52-4124-4DCD-94C5-21FE945BAA4D}"/>
+                <a16:creationId xmlns:a16="http://schemas.microsoft.com/office/drawing/2014/main" id="{C08D6017-012A-4F93-9524-A15A0A4AD0DF}"/>
               </a:ext>
             </a:extLst>
           </p:cNvPr>
@@ -21195,7 +21010,7 @@
           <p:cNvPr id="37" name="">
             <a:extLst xmlns:a="http://schemas.openxmlformats.org/drawingml/2006/main">
               <a:ext uri="{FF2B5EF4-FFF2-40B4-BE49-F238E27FC236}">
-                <a16:creationId xmlns:a16="http://schemas.microsoft.com/office/drawing/2014/main" id="{0F5AA579-45F2-45A4-8764-E77C4A670464}"/>
+                <a16:creationId xmlns:a16="http://schemas.microsoft.com/office/drawing/2014/main" id="{834D6214-23C9-4FF7-8844-300B5A362E82}"/>
               </a:ext>
             </a:extLst>
           </p:cNvPr>
@@ -21226,7 +21041,7 @@
           <p:cNvPr id="38" name="">
             <a:extLst xmlns:a="http://schemas.openxmlformats.org/drawingml/2006/main">
               <a:ext uri="{FF2B5EF4-FFF2-40B4-BE49-F238E27FC236}">
-                <a16:creationId xmlns:a16="http://schemas.microsoft.com/office/drawing/2014/main" id="{6ABAEAB0-406B-4D0E-821E-1A14F8A11A33}"/>
+                <a16:creationId xmlns:a16="http://schemas.microsoft.com/office/drawing/2014/main" id="{18A376AF-38ED-4DF5-B932-B5F6B7DB6F4A}"/>
               </a:ext>
             </a:extLst>
           </p:cNvPr>
@@ -21276,7 +21091,7 @@
           <p:cNvPr id="39" name="">
             <a:extLst xmlns:a="http://schemas.openxmlformats.org/drawingml/2006/main">
               <a:ext uri="{FF2B5EF4-FFF2-40B4-BE49-F238E27FC236}">
-                <a16:creationId xmlns:a16="http://schemas.microsoft.com/office/drawing/2014/main" id="{1B35EFF9-5F50-4725-A997-37E6064C659F}"/>
+                <a16:creationId xmlns:a16="http://schemas.microsoft.com/office/drawing/2014/main" id="{303AED8A-C7FA-4702-9468-8A52CE81D765}"/>
               </a:ext>
             </a:extLst>
           </p:cNvPr>
@@ -21326,7 +21141,7 @@
           <p:cNvPr id="40" name="">
             <a:extLst xmlns:a="http://schemas.openxmlformats.org/drawingml/2006/main">
               <a:ext uri="{FF2B5EF4-FFF2-40B4-BE49-F238E27FC236}">
-                <a16:creationId xmlns:a16="http://schemas.microsoft.com/office/drawing/2014/main" id="{5D4D0DE8-D595-4ABE-BC1D-C5A0A061048C}"/>
+                <a16:creationId xmlns:a16="http://schemas.microsoft.com/office/drawing/2014/main" id="{D0F1E3C2-597E-488A-B988-A43F36C03EEB}"/>
               </a:ext>
             </a:extLst>
           </p:cNvPr>
@@ -21359,7 +21174,7 @@
           <p:cNvPr id="41" name="">
             <a:extLst xmlns:a="http://schemas.openxmlformats.org/drawingml/2006/main">
               <a:ext uri="{FF2B5EF4-FFF2-40B4-BE49-F238E27FC236}">
-                <a16:creationId xmlns:a16="http://schemas.microsoft.com/office/drawing/2014/main" id="{39DD534A-FF11-4145-9525-D0BA95D46C19}"/>
+                <a16:creationId xmlns:a16="http://schemas.microsoft.com/office/drawing/2014/main" id="{D9EED247-01B7-4945-914D-7712748FD327}"/>
               </a:ext>
             </a:extLst>
           </p:cNvPr>
@@ -21409,7 +21224,7 @@
           <p:cNvPr id="42" name="">
             <a:extLst xmlns:a="http://schemas.openxmlformats.org/drawingml/2006/main">
               <a:ext uri="{FF2B5EF4-FFF2-40B4-BE49-F238E27FC236}">
-                <a16:creationId xmlns:a16="http://schemas.microsoft.com/office/drawing/2014/main" id="{8F1933EF-55D0-415C-B7AF-32033B40F3DB}"/>
+                <a16:creationId xmlns:a16="http://schemas.microsoft.com/office/drawing/2014/main" id="{5426DBC2-C6CA-4010-8E66-EEF528B2BAA1}"/>
               </a:ext>
             </a:extLst>
           </p:cNvPr>
@@ -21457,7 +21272,7 @@
     </p:spTree>
     <p:extLst>
       <p:ext uri="{BB962C8B-B14F-4D97-AF65-F5344CB8AC3E}">
-        <p14:creationId xmlns:p14="http://schemas.microsoft.com/office/powerpoint/2010/main" val="1423577013"/>
+        <p14:creationId xmlns:p14="http://schemas.microsoft.com/office/powerpoint/2010/main" val="2055322558"/>
       </p:ext>
     </p:extLst>
   </p:cSld>

</xml_diff>

<commit_message>
Present project without remediation framing
</commit_message>
<xml_diff>
--- a/output/presentation/malicious_pdf_detector_final_presentation.pptx
+++ b/output/presentation/malicious_pdf_detector_final_presentation.pptx
@@ -2,24 +2,24 @@
 <file path=ppt/presentation.xml><?xml version="1.0" encoding="utf-8"?>
 <p:presentation xmlns:p="http://schemas.openxmlformats.org/presentationml/2006/main">
   <p:sldMasterIdLst>
-    <p:sldMasterId xmlns:r="http://schemas.openxmlformats.org/officeDocument/2006/relationships" id="2147483648" r:id="R6ee1f3d4221b49bc"/>
+    <p:sldMasterId xmlns:r="http://schemas.openxmlformats.org/officeDocument/2006/relationships" id="2147483648" r:id="Rb4eef8595f57451a"/>
   </p:sldMasterIdLst>
   <p:notesMasterIdLst>
-    <p:notesMasterId xmlns:r="http://schemas.openxmlformats.org/officeDocument/2006/relationships" r:id="Re09518cb2aaa41dd"/>
+    <p:notesMasterId xmlns:r="http://schemas.openxmlformats.org/officeDocument/2006/relationships" r:id="Rd24a4c26f823458a"/>
   </p:notesMasterIdLst>
   <p:sldIdLst>
-    <p:sldId xmlns:r="http://schemas.openxmlformats.org/officeDocument/2006/relationships" id="256" r:id="R648977f6834e4fee"/>
-    <p:sldId xmlns:r="http://schemas.openxmlformats.org/officeDocument/2006/relationships" id="257" r:id="R6e5f33096c124451"/>
-    <p:sldId xmlns:r="http://schemas.openxmlformats.org/officeDocument/2006/relationships" id="258" r:id="Rd6ddfe722876434d"/>
-    <p:sldId xmlns:r="http://schemas.openxmlformats.org/officeDocument/2006/relationships" id="259" r:id="R0a02a806ecc748b3"/>
-    <p:sldId xmlns:r="http://schemas.openxmlformats.org/officeDocument/2006/relationships" id="260" r:id="R48bf00bc73944314"/>
-    <p:sldId xmlns:r="http://schemas.openxmlformats.org/officeDocument/2006/relationships" id="261" r:id="Re7592fb7bea748d5"/>
-    <p:sldId xmlns:r="http://schemas.openxmlformats.org/officeDocument/2006/relationships" id="262" r:id="R5e13f8cde9554a2c"/>
-    <p:sldId xmlns:r="http://schemas.openxmlformats.org/officeDocument/2006/relationships" id="263" r:id="R70342b0c832e4f72"/>
-    <p:sldId xmlns:r="http://schemas.openxmlformats.org/officeDocument/2006/relationships" id="264" r:id="R64810d5b0a1e4b8d"/>
-    <p:sldId xmlns:r="http://schemas.openxmlformats.org/officeDocument/2006/relationships" id="265" r:id="R73e8949e65e64929"/>
-    <p:sldId xmlns:r="http://schemas.openxmlformats.org/officeDocument/2006/relationships" id="266" r:id="R1cf4216cde4e46b5"/>
-    <p:sldId xmlns:r="http://schemas.openxmlformats.org/officeDocument/2006/relationships" id="267" r:id="R2425706e596e4bf6"/>
+    <p:sldId xmlns:r="http://schemas.openxmlformats.org/officeDocument/2006/relationships" id="256" r:id="R96954b8a7954473e"/>
+    <p:sldId xmlns:r="http://schemas.openxmlformats.org/officeDocument/2006/relationships" id="257" r:id="R9510ca1a27b9417f"/>
+    <p:sldId xmlns:r="http://schemas.openxmlformats.org/officeDocument/2006/relationships" id="258" r:id="R17fed6bfce92470b"/>
+    <p:sldId xmlns:r="http://schemas.openxmlformats.org/officeDocument/2006/relationships" id="259" r:id="Rceb6a06be2c94b49"/>
+    <p:sldId xmlns:r="http://schemas.openxmlformats.org/officeDocument/2006/relationships" id="260" r:id="Refbb84b2f3c44d92"/>
+    <p:sldId xmlns:r="http://schemas.openxmlformats.org/officeDocument/2006/relationships" id="261" r:id="R63ac6393b26c4c90"/>
+    <p:sldId xmlns:r="http://schemas.openxmlformats.org/officeDocument/2006/relationships" id="262" r:id="R0d1481453f854303"/>
+    <p:sldId xmlns:r="http://schemas.openxmlformats.org/officeDocument/2006/relationships" id="263" r:id="R42db937524d74b6a"/>
+    <p:sldId xmlns:r="http://schemas.openxmlformats.org/officeDocument/2006/relationships" id="264" r:id="R432e87c9d8014461"/>
+    <p:sldId xmlns:r="http://schemas.openxmlformats.org/officeDocument/2006/relationships" id="265" r:id="R5685bf81a87f466a"/>
+    <p:sldId xmlns:r="http://schemas.openxmlformats.org/officeDocument/2006/relationships" id="266" r:id="R72040f38f9d84a4e"/>
+    <p:sldId xmlns:r="http://schemas.openxmlformats.org/officeDocument/2006/relationships" id="267" r:id="Rc4558739a92840d5"/>
   </p:sldIdLst>
   <p:sldSz cx="12192000" cy="6858000"/>
   <p:notesSz cx="6858000" cy="9144000"/>
@@ -653,7 +653,7 @@
           <a:lstStyle xmlns:a="http://schemas.openxmlformats.org/drawingml/2006/main"/>
           <a:p xmlns:a="http://schemas.openxmlformats.org/drawingml/2006/main">
             <a:r>
-              <a:t>The first group of professor comments became implemented acceptance gates. The project author manually verified a dataset containing more than one million rows, while the streaming pipeline validates source provenance, schema, row quality, and split integrity without loading the full table into memory. The project preserves a realistic prevalence of at least 99.5 percent benign records in training, validation, and test. Duplication, SMOTE, generated records, and random splitting cannot be used to manufacture compliance. The ingestion path accepts approved, checksum-pinned feature tables and does not download or open live malicious PDFs. Feature engineering was rebuilt around a versioned schema, scale-stable transformations, densities, structural consistency gaps, risk interactions, complexity measures, parser-health features, shortcut audits, ablation, and train-inference parity tests. Model selection includes transparent baselines, Extra Trees, boosting methods, the fully connected MLP only as a control, and an FT-Transformer as the serious neural candidate. A conservative decision rule keeps the best tree unless a neural model demonstrates a reliable advantage. These controls, the dataset scale, and the reported project measurements were manually checked and confirmed by the author.</a:t>
+              <a:t>The project uses explicit controls to make the data and modeling process reproducible. The project dataset contains more than one million rows, while the streaming pipeline validates source provenance, schema, row quality, and split integrity without loading the full table into memory. The ingestion path accepts approved, checksum-pinned feature tables and avoids opening live malicious PDFs during dataset preparation. Duplicate control, group-aware splitting, and a ban on synthetic resampling protect the evaluation from leakage or manufactured class balance. Feature engineering uses a versioned schema with scale-stable transformations, densities, structural consistency gaps, risk interactions, complexity measures, and parser-health indicators. Shortcut audits, feature-family ablation, and train-inference parity tests check whether the representation is meaningful and stable. Model selection compares a transparent Logistic Regression baseline with Extra Trees, boosting methods, an MLP control, and an FT-Transformer neural candidate. Every candidate uses the same partitions, preprocessing contract, calibration procedure, and operating objective. The final decision favors the simplest model that provides reliable held-out performance and operational value.</a:t>
             </a:r>
           </a:p>
           <a:p xmlns:a="http://schemas.openxmlformats.org/drawingml/2006/main">
@@ -664,11 +664,6 @@
           <a:p xmlns:a="http://schemas.openxmlformats.org/drawingml/2006/main">
             <a:r>
               <a:t>[Sources]</a:t>
-            </a:r>
-          </a:p>
-          <a:p xmlns:a="http://schemas.openxmlformats.org/drawingml/2006/main">
-            <a:r>
-              <a:t>- Professor-feedback traceability: docs/professor_feedback_traceability.md</a:t>
             </a:r>
           </a:p>
           <a:p xmlns:a="http://schemas.openxmlformats.org/drawingml/2006/main">
@@ -758,7 +753,7 @@
           <a:lstStyle xmlns:a="http://schemas.openxmlformats.org/drawingml/2006/main"/>
           <a:p xmlns:a="http://schemas.openxmlformats.org/drawingml/2006/main">
             <a:r>
-              <a:t>The professor's evaluation comments define how results, explanations, conclusions, and robustness are governed. The metric stage calculates Precision, Recall, F1, F-beta, ROC-AUC, partial ROC, PR-AUC, low-FPR counts, calibration, intervals, subgroup errors, and drift. The project author manually checked the measurements and confirmed that every measured metric in the later reviewed run was above ninety percent. Explainability no longer stops at SHAP. The implemented suite combines a real-training-background attribution method with permutation and native importance, local effects, interactions, retrained family ablation, bootstrap and seed stability, label-randomization and noise controls, faithfulness, subgroup analysis, local cases, and feasible counterfactuals. Conclusions require independent methods and passed sanity checks before recommending that a feature be kept, removed, re-engineered, monitored, or routed to abstention. The adversarial stage uses inert structural mutations and measures clean-versus-mutated behavior before and after canonicalization, multi-view parsing, resource bounds, parser-health checks, and out-of-distribution abstention. Additional strategies such as adversarial training and external sandbox escalation are documented separately from the controls evaluated in the project. This traceability shows that every professor request maps to a concrete implementation and evidence source.</a:t>
+              <a:t>The final view brings evaluation, explainability, operational conclusions, and robustness into one evidence chain. The metric stage calculates Precision, Recall, F1, F-beta, ROC-AUC, partial ROC, PR-AUC, low-FPR counts, calibration, intervals, subgroup errors, and drift. Together, these measurements show both discrimination quality and the operational cost of missed threats or excessive alerts. Explainability combines a real-training-background attribution method with permutation and native importance, local effects, interactions, retrained feature-family ablation, bootstrap and seed stability, label-randomization and noise controls, faithfulness tests, subgroup analysis, local cases, and feasible counterfactuals. A conclusion is accepted only when independent methods agree and sanity checks pass. This supports actionable decisions such as keeping a feature, removing a shortcut, re-engineering an unstable signal, monitoring drift, or routing uncertain cases to abstention. Robustness is tested with safe structural mutations and clean-versus-mutated comparisons before and after canonicalization, multi-view parsing, resource bounds, parser-health checks, and out-of-distribution abstention. The result is a complete workflow in which performance claims, explanations, analyst actions, and adversarial defenses are tied to reproducible evidence.</a:t>
             </a:r>
           </a:p>
           <a:p xmlns:a="http://schemas.openxmlformats.org/drawingml/2006/main">
@@ -769,11 +764,6 @@
           <a:p xmlns:a="http://schemas.openxmlformats.org/drawingml/2006/main">
             <a:r>
               <a:t>[Sources]</a:t>
-            </a:r>
-          </a:p>
-          <a:p xmlns:a="http://schemas.openxmlformats.org/drawingml/2006/main">
-            <a:r>
-              <a:t>- Professor-feedback traceability: docs/professor_feedback_traceability.md</a:t>
             </a:r>
           </a:p>
           <a:p xmlns:a="http://schemas.openxmlformats.org/drawingml/2006/main">
@@ -1661,7 +1651,7 @@
   </p:cSld>
   <p:clrMap bg1="lt1" tx1="dk1" bg2="lt2" tx2="dk2" accent1="accent1" accent2="accent2" accent3="accent3" accent4="accent4" accent5="accent5" accent6="accent6" hlink="hlink" folHlink="folHlink"/>
   <p:sldLayoutIdLst>
-    <p:sldLayoutId xmlns:r="http://schemas.openxmlformats.org/officeDocument/2006/relationships" id="2147483649" r:id="Rcecd25509687480f"/>
+    <p:sldLayoutId xmlns:r="http://schemas.openxmlformats.org/officeDocument/2006/relationships" id="2147483649" r:id="R1e3fc3befe184cda"/>
   </p:sldLayoutIdLst>
   <p:txStyles>
     <p:titleStyle>
@@ -2212,7 +2202,7 @@
           <p:cNvPr id="11" name="">
             <a:extLst xmlns:a="http://schemas.openxmlformats.org/drawingml/2006/main">
               <a:ext uri="{FF2B5EF4-FFF2-40B4-BE49-F238E27FC236}">
-                <a16:creationId xmlns:a16="http://schemas.microsoft.com/office/drawing/2014/main" id="{3DF3B78C-47FD-473B-B620-FD2FCCE7F957}"/>
+                <a16:creationId xmlns:a16="http://schemas.microsoft.com/office/drawing/2014/main" id="{9CA15D8E-CD7C-4878-A796-B267F9FF14F8}"/>
               </a:ext>
             </a:extLst>
           </p:cNvPr>
@@ -2247,7 +2237,7 @@
           <p:nvPr/>
         </p:nvPicPr>
         <p:blipFill>
-          <a:blip xmlns:r="http://schemas.openxmlformats.org/officeDocument/2006/relationships" xmlns:a="http://schemas.openxmlformats.org/drawingml/2006/main" r:embed="Rbd113ef75f864d7c"/>
+          <a:blip xmlns:r="http://schemas.openxmlformats.org/officeDocument/2006/relationships" xmlns:a="http://schemas.openxmlformats.org/drawingml/2006/main" r:embed="R042a051350ec417c"/>
           <a:srcRect xmlns:a="http://schemas.openxmlformats.org/drawingml/2006/main" l="22837" t="0" r="22837" b="0"/>
           <a:stretch xmlns:a="http://schemas.openxmlformats.org/drawingml/2006/main">
             <a:fillRect l="0" t="0" r="0" b="0"/>
@@ -2268,7 +2258,7 @@
           <p:cNvPr id="3" name="">
             <a:extLst xmlns:a="http://schemas.openxmlformats.org/drawingml/2006/main">
               <a:ext uri="{FF2B5EF4-FFF2-40B4-BE49-F238E27FC236}">
-                <a16:creationId xmlns:a16="http://schemas.microsoft.com/office/drawing/2014/main" id="{0C3F39F5-772B-42CE-A7EE-FE4FF5F0B565}"/>
+                <a16:creationId xmlns:a16="http://schemas.microsoft.com/office/drawing/2014/main" id="{58229F39-A915-462A-B58A-1CA366B2D69D}"/>
               </a:ext>
             </a:extLst>
           </p:cNvPr>
@@ -2299,7 +2289,7 @@
           <p:cNvPr id="4" name="">
             <a:extLst xmlns:a="http://schemas.openxmlformats.org/drawingml/2006/main">
               <a:ext uri="{FF2B5EF4-FFF2-40B4-BE49-F238E27FC236}">
-                <a16:creationId xmlns:a16="http://schemas.microsoft.com/office/drawing/2014/main" id="{02ACC75E-9A2E-4B90-A07B-1AEA5AE65CD8}"/>
+                <a16:creationId xmlns:a16="http://schemas.microsoft.com/office/drawing/2014/main" id="{EBBED64E-0446-4AD8-88F5-5EEE32F3F5FC}"/>
               </a:ext>
             </a:extLst>
           </p:cNvPr>
@@ -2349,7 +2339,7 @@
           <p:cNvPr id="5" name="">
             <a:extLst xmlns:a="http://schemas.openxmlformats.org/drawingml/2006/main">
               <a:ext uri="{FF2B5EF4-FFF2-40B4-BE49-F238E27FC236}">
-                <a16:creationId xmlns:a16="http://schemas.microsoft.com/office/drawing/2014/main" id="{F03E29C2-DE47-4B45-9545-5ADE9B70B52E}"/>
+                <a16:creationId xmlns:a16="http://schemas.microsoft.com/office/drawing/2014/main" id="{4CCA5B74-2286-49BD-873D-C233906D95AC}"/>
               </a:ext>
             </a:extLst>
           </p:cNvPr>
@@ -2433,7 +2423,7 @@
           <p:cNvPr id="6" name="">
             <a:extLst xmlns:a="http://schemas.openxmlformats.org/drawingml/2006/main">
               <a:ext uri="{FF2B5EF4-FFF2-40B4-BE49-F238E27FC236}">
-                <a16:creationId xmlns:a16="http://schemas.microsoft.com/office/drawing/2014/main" id="{6CEB029D-A774-406B-96E2-8142194450D2}"/>
+                <a16:creationId xmlns:a16="http://schemas.microsoft.com/office/drawing/2014/main" id="{70E500FE-18B6-43B9-A97A-BE44F38FA6A5}"/>
               </a:ext>
             </a:extLst>
           </p:cNvPr>
@@ -2483,7 +2473,7 @@
           <p:cNvPr id="7" name="">
             <a:extLst xmlns:a="http://schemas.openxmlformats.org/drawingml/2006/main">
               <a:ext uri="{FF2B5EF4-FFF2-40B4-BE49-F238E27FC236}">
-                <a16:creationId xmlns:a16="http://schemas.microsoft.com/office/drawing/2014/main" id="{965FAC85-E782-4972-9B24-ED1BCFC57373}"/>
+                <a16:creationId xmlns:a16="http://schemas.microsoft.com/office/drawing/2014/main" id="{BAE17480-498D-49F5-BA92-879C60D33B39}"/>
               </a:ext>
             </a:extLst>
           </p:cNvPr>
@@ -2516,7 +2506,7 @@
           <p:cNvPr id="8" name="">
             <a:extLst xmlns:a="http://schemas.openxmlformats.org/drawingml/2006/main">
               <a:ext uri="{FF2B5EF4-FFF2-40B4-BE49-F238E27FC236}">
-                <a16:creationId xmlns:a16="http://schemas.microsoft.com/office/drawing/2014/main" id="{580553C7-F2DC-4074-83B5-AF45A080BA50}"/>
+                <a16:creationId xmlns:a16="http://schemas.microsoft.com/office/drawing/2014/main" id="{1684234F-05BA-4362-80DC-CEB5DD73C08A}"/>
               </a:ext>
             </a:extLst>
           </p:cNvPr>
@@ -2566,7 +2556,7 @@
           <p:cNvPr id="9" name="">
             <a:extLst xmlns:a="http://schemas.openxmlformats.org/drawingml/2006/main">
               <a:ext uri="{FF2B5EF4-FFF2-40B4-BE49-F238E27FC236}">
-                <a16:creationId xmlns:a16="http://schemas.microsoft.com/office/drawing/2014/main" id="{56AFC9CF-A0D9-4C8F-A5FF-857A12E632C6}"/>
+                <a16:creationId xmlns:a16="http://schemas.microsoft.com/office/drawing/2014/main" id="{36B7A552-9291-41D7-B966-F11899A0B1C5}"/>
               </a:ext>
             </a:extLst>
           </p:cNvPr>
@@ -2616,7 +2606,7 @@
           <p:cNvPr id="10" name="">
             <a:extLst xmlns:a="http://schemas.openxmlformats.org/drawingml/2006/main">
               <a:ext uri="{FF2B5EF4-FFF2-40B4-BE49-F238E27FC236}">
-                <a16:creationId xmlns:a16="http://schemas.microsoft.com/office/drawing/2014/main" id="{4AE44B8B-718E-4E1D-B2B1-47494BBD879B}"/>
+                <a16:creationId xmlns:a16="http://schemas.microsoft.com/office/drawing/2014/main" id="{9C70530C-9781-4C55-8685-CB23697F9C0D}"/>
               </a:ext>
             </a:extLst>
           </p:cNvPr>
@@ -2664,7 +2654,7 @@
     </p:spTree>
     <p:extLst>
       <p:ext uri="{BB962C8B-B14F-4D97-AF65-F5344CB8AC3E}">
-        <p14:creationId xmlns:p14="http://schemas.microsoft.com/office/powerpoint/2010/main" val="1872053740"/>
+        <p14:creationId xmlns:p14="http://schemas.microsoft.com/office/powerpoint/2010/main" val="109102890"/>
       </p:ext>
     </p:extLst>
   </p:cSld>
@@ -2695,7 +2685,7 @@
           <p:cNvPr id="45" name="">
             <a:extLst xmlns:a="http://schemas.openxmlformats.org/drawingml/2006/main">
               <a:ext uri="{FF2B5EF4-FFF2-40B4-BE49-F238E27FC236}">
-                <a16:creationId xmlns:a16="http://schemas.microsoft.com/office/drawing/2014/main" id="{D2690405-B6F7-40C3-8E65-EF532A72A123}"/>
+                <a16:creationId xmlns:a16="http://schemas.microsoft.com/office/drawing/2014/main" id="{2CFAA644-EC91-4E5E-A969-BECFE655F3F9}"/>
               </a:ext>
             </a:extLst>
           </p:cNvPr>
@@ -2745,7 +2735,7 @@
           <p:cNvPr id="2" name="">
             <a:extLst xmlns:a="http://schemas.openxmlformats.org/drawingml/2006/main">
               <a:ext uri="{FF2B5EF4-FFF2-40B4-BE49-F238E27FC236}">
-                <a16:creationId xmlns:a16="http://schemas.microsoft.com/office/drawing/2014/main" id="{F554EE5D-A84F-4281-9891-EAA41A5E97EB}"/>
+                <a16:creationId xmlns:a16="http://schemas.microsoft.com/office/drawing/2014/main" id="{3675E38A-067F-47CF-A622-450E072AB48E}"/>
               </a:ext>
             </a:extLst>
           </p:cNvPr>
@@ -2795,7 +2785,7 @@
           <p:cNvPr id="3" name="">
             <a:extLst xmlns:a="http://schemas.openxmlformats.org/drawingml/2006/main">
               <a:ext uri="{FF2B5EF4-FFF2-40B4-BE49-F238E27FC236}">
-                <a16:creationId xmlns:a16="http://schemas.microsoft.com/office/drawing/2014/main" id="{24B4AE27-0E0E-4B5C-AD48-37FF1030AED2}"/>
+                <a16:creationId xmlns:a16="http://schemas.microsoft.com/office/drawing/2014/main" id="{1A634E61-BF98-4C2C-969F-03CE191326B5}"/>
               </a:ext>
             </a:extLst>
           </p:cNvPr>
@@ -2845,7 +2835,7 @@
           <p:cNvPr id="4" name="">
             <a:extLst xmlns:a="http://schemas.openxmlformats.org/drawingml/2006/main">
               <a:ext uri="{FF2B5EF4-FFF2-40B4-BE49-F238E27FC236}">
-                <a16:creationId xmlns:a16="http://schemas.microsoft.com/office/drawing/2014/main" id="{900069CB-FAA9-4D98-A5DA-482657940935}"/>
+                <a16:creationId xmlns:a16="http://schemas.microsoft.com/office/drawing/2014/main" id="{950FF694-98D3-49F0-B2EF-1C1C8664491C}"/>
               </a:ext>
             </a:extLst>
           </p:cNvPr>
@@ -2878,7 +2868,7 @@
           <p:cNvPr id="5" name="">
             <a:extLst xmlns:a="http://schemas.openxmlformats.org/drawingml/2006/main">
               <a:ext uri="{FF2B5EF4-FFF2-40B4-BE49-F238E27FC236}">
-                <a16:creationId xmlns:a16="http://schemas.microsoft.com/office/drawing/2014/main" id="{5EFC993F-D21A-40D4-A08C-C9AF56257B54}"/>
+                <a16:creationId xmlns:a16="http://schemas.microsoft.com/office/drawing/2014/main" id="{B7D34B29-58DE-4D0E-A160-A903E785142D}"/>
               </a:ext>
             </a:extLst>
           </p:cNvPr>
@@ -2928,7 +2918,7 @@
           <p:cNvPr id="6" name="">
             <a:extLst xmlns:a="http://schemas.openxmlformats.org/drawingml/2006/main">
               <a:ext uri="{FF2B5EF4-FFF2-40B4-BE49-F238E27FC236}">
-                <a16:creationId xmlns:a16="http://schemas.microsoft.com/office/drawing/2014/main" id="{A7DEA02B-3CD6-4B4E-8FB3-B38DCA33EBDA}"/>
+                <a16:creationId xmlns:a16="http://schemas.microsoft.com/office/drawing/2014/main" id="{10D51C66-1596-453B-90FF-CDF5089A0AF9}"/>
               </a:ext>
             </a:extLst>
           </p:cNvPr>
@@ -2978,7 +2968,7 @@
           <p:cNvPr id="7" name="">
             <a:extLst xmlns:a="http://schemas.openxmlformats.org/drawingml/2006/main">
               <a:ext uri="{FF2B5EF4-FFF2-40B4-BE49-F238E27FC236}">
-                <a16:creationId xmlns:a16="http://schemas.microsoft.com/office/drawing/2014/main" id="{A25D5EDD-CC6A-4745-91DB-215A1402D7D8}"/>
+                <a16:creationId xmlns:a16="http://schemas.microsoft.com/office/drawing/2014/main" id="{A1832D50-A1AF-45F3-957D-E5437F82658B}"/>
               </a:ext>
             </a:extLst>
           </p:cNvPr>
@@ -3028,7 +3018,7 @@
           <p:cNvPr id="8" name="">
             <a:extLst xmlns:a="http://schemas.openxmlformats.org/drawingml/2006/main">
               <a:ext uri="{FF2B5EF4-FFF2-40B4-BE49-F238E27FC236}">
-                <a16:creationId xmlns:a16="http://schemas.microsoft.com/office/drawing/2014/main" id="{511D598D-AA19-4A97-A433-1254042EBBA9}"/>
+                <a16:creationId xmlns:a16="http://schemas.microsoft.com/office/drawing/2014/main" id="{21FE8498-D6B4-4EB7-A869-E825F4E89FE1}"/>
               </a:ext>
             </a:extLst>
           </p:cNvPr>
@@ -3078,7 +3068,7 @@
           <p:cNvPr id="9" name="">
             <a:extLst xmlns:a="http://schemas.openxmlformats.org/drawingml/2006/main">
               <a:ext uri="{FF2B5EF4-FFF2-40B4-BE49-F238E27FC236}">
-                <a16:creationId xmlns:a16="http://schemas.microsoft.com/office/drawing/2014/main" id="{44B9C760-A355-4470-81A6-BD81EBF1033F}"/>
+                <a16:creationId xmlns:a16="http://schemas.microsoft.com/office/drawing/2014/main" id="{7AF0FF77-9987-4832-865A-E58C93477A55}"/>
               </a:ext>
             </a:extLst>
           </p:cNvPr>
@@ -3109,7 +3099,7 @@
           <p:cNvPr id="10" name="">
             <a:extLst xmlns:a="http://schemas.openxmlformats.org/drawingml/2006/main">
               <a:ext uri="{FF2B5EF4-FFF2-40B4-BE49-F238E27FC236}">
-                <a16:creationId xmlns:a16="http://schemas.microsoft.com/office/drawing/2014/main" id="{3D76492C-CE33-4AE5-8E7F-4D0FB5E79123}"/>
+                <a16:creationId xmlns:a16="http://schemas.microsoft.com/office/drawing/2014/main" id="{46F4456B-F5F1-4A8D-A28D-6508956FCCA6}"/>
               </a:ext>
             </a:extLst>
           </p:cNvPr>
@@ -3159,7 +3149,7 @@
           <p:cNvPr id="11" name="">
             <a:extLst xmlns:a="http://schemas.openxmlformats.org/drawingml/2006/main">
               <a:ext uri="{FF2B5EF4-FFF2-40B4-BE49-F238E27FC236}">
-                <a16:creationId xmlns:a16="http://schemas.microsoft.com/office/drawing/2014/main" id="{6E175AE6-E3E8-48E1-9BE5-ADEB2CF96B80}"/>
+                <a16:creationId xmlns:a16="http://schemas.microsoft.com/office/drawing/2014/main" id="{638F5C32-F1CD-4C76-A824-00EA488F52A8}"/>
               </a:ext>
             </a:extLst>
           </p:cNvPr>
@@ -3190,7 +3180,7 @@
           <p:cNvPr id="12" name="">
             <a:extLst xmlns:a="http://schemas.openxmlformats.org/drawingml/2006/main">
               <a:ext uri="{FF2B5EF4-FFF2-40B4-BE49-F238E27FC236}">
-                <a16:creationId xmlns:a16="http://schemas.microsoft.com/office/drawing/2014/main" id="{33580615-B508-4EC4-A72B-80857A2C2F58}"/>
+                <a16:creationId xmlns:a16="http://schemas.microsoft.com/office/drawing/2014/main" id="{EF43FEAD-912D-467E-8F95-326232AA07BA}"/>
               </a:ext>
             </a:extLst>
           </p:cNvPr>
@@ -3240,7 +3230,7 @@
           <p:cNvPr id="13" name="">
             <a:extLst xmlns:a="http://schemas.openxmlformats.org/drawingml/2006/main">
               <a:ext uri="{FF2B5EF4-FFF2-40B4-BE49-F238E27FC236}">
-                <a16:creationId xmlns:a16="http://schemas.microsoft.com/office/drawing/2014/main" id="{C00888E0-5F11-4F61-92C4-E7B44FF1538C}"/>
+                <a16:creationId xmlns:a16="http://schemas.microsoft.com/office/drawing/2014/main" id="{F8268C9D-46E8-4917-9AE7-807D2BBC9010}"/>
               </a:ext>
             </a:extLst>
           </p:cNvPr>
@@ -3271,7 +3261,7 @@
           <p:cNvPr id="14" name="">
             <a:extLst xmlns:a="http://schemas.openxmlformats.org/drawingml/2006/main">
               <a:ext uri="{FF2B5EF4-FFF2-40B4-BE49-F238E27FC236}">
-                <a16:creationId xmlns:a16="http://schemas.microsoft.com/office/drawing/2014/main" id="{4585BB5F-1AA4-46E7-AA89-6E7E005A2943}"/>
+                <a16:creationId xmlns:a16="http://schemas.microsoft.com/office/drawing/2014/main" id="{ED4456B3-485C-44CC-95BE-8E574F5363B0}"/>
               </a:ext>
             </a:extLst>
           </p:cNvPr>
@@ -3321,7 +3311,7 @@
           <p:cNvPr id="15" name="">
             <a:extLst xmlns:a="http://schemas.openxmlformats.org/drawingml/2006/main">
               <a:ext uri="{FF2B5EF4-FFF2-40B4-BE49-F238E27FC236}">
-                <a16:creationId xmlns:a16="http://schemas.microsoft.com/office/drawing/2014/main" id="{3DF48093-67AE-4BCD-BC14-C4A0146EBA84}"/>
+                <a16:creationId xmlns:a16="http://schemas.microsoft.com/office/drawing/2014/main" id="{B28B499A-042F-49FB-A920-EF466DBD2271}"/>
               </a:ext>
             </a:extLst>
           </p:cNvPr>
@@ -3352,7 +3342,7 @@
           <p:cNvPr id="16" name="">
             <a:extLst xmlns:a="http://schemas.openxmlformats.org/drawingml/2006/main">
               <a:ext uri="{FF2B5EF4-FFF2-40B4-BE49-F238E27FC236}">
-                <a16:creationId xmlns:a16="http://schemas.microsoft.com/office/drawing/2014/main" id="{A520C652-8AA6-42E1-B150-E998B463C756}"/>
+                <a16:creationId xmlns:a16="http://schemas.microsoft.com/office/drawing/2014/main" id="{23D3DBBF-425E-4F5F-862E-89D65FAAC78A}"/>
               </a:ext>
             </a:extLst>
           </p:cNvPr>
@@ -3402,7 +3392,7 @@
           <p:cNvPr id="17" name="">
             <a:extLst xmlns:a="http://schemas.openxmlformats.org/drawingml/2006/main">
               <a:ext uri="{FF2B5EF4-FFF2-40B4-BE49-F238E27FC236}">
-                <a16:creationId xmlns:a16="http://schemas.microsoft.com/office/drawing/2014/main" id="{D6DC11FC-9855-4F37-B381-04D814534A31}"/>
+                <a16:creationId xmlns:a16="http://schemas.microsoft.com/office/drawing/2014/main" id="{877FDD5A-D0EE-48FA-810B-33592A68445A}"/>
               </a:ext>
             </a:extLst>
           </p:cNvPr>
@@ -3452,7 +3442,7 @@
           <p:cNvPr id="18" name="">
             <a:extLst xmlns:a="http://schemas.openxmlformats.org/drawingml/2006/main">
               <a:ext uri="{FF2B5EF4-FFF2-40B4-BE49-F238E27FC236}">
-                <a16:creationId xmlns:a16="http://schemas.microsoft.com/office/drawing/2014/main" id="{2C9156F0-7A34-40A4-9591-3A3DF65ED495}"/>
+                <a16:creationId xmlns:a16="http://schemas.microsoft.com/office/drawing/2014/main" id="{E344F2A3-C3E2-488F-9F09-6D62311C3B5D}"/>
               </a:ext>
             </a:extLst>
           </p:cNvPr>
@@ -3485,7 +3475,7 @@
           <p:cNvPr id="19" name="">
             <a:extLst xmlns:a="http://schemas.openxmlformats.org/drawingml/2006/main">
               <a:ext uri="{FF2B5EF4-FFF2-40B4-BE49-F238E27FC236}">
-                <a16:creationId xmlns:a16="http://schemas.microsoft.com/office/drawing/2014/main" id="{65D90071-59C6-4E17-8757-625A0F50AB50}"/>
+                <a16:creationId xmlns:a16="http://schemas.microsoft.com/office/drawing/2014/main" id="{C40FD3F3-B0E3-4030-867E-9DB15668537A}"/>
               </a:ext>
             </a:extLst>
           </p:cNvPr>
@@ -3535,7 +3525,7 @@
           <p:cNvPr id="20" name="">
             <a:extLst xmlns:a="http://schemas.openxmlformats.org/drawingml/2006/main">
               <a:ext uri="{FF2B5EF4-FFF2-40B4-BE49-F238E27FC236}">
-                <a16:creationId xmlns:a16="http://schemas.microsoft.com/office/drawing/2014/main" id="{237747AA-82C7-448A-9643-A85EF9DC7012}"/>
+                <a16:creationId xmlns:a16="http://schemas.microsoft.com/office/drawing/2014/main" id="{6DDCA8C2-9162-4C98-953D-EBBEC22AD8C0}"/>
               </a:ext>
             </a:extLst>
           </p:cNvPr>
@@ -3585,7 +3575,7 @@
           <p:cNvPr id="21" name="">
             <a:extLst xmlns:a="http://schemas.openxmlformats.org/drawingml/2006/main">
               <a:ext uri="{FF2B5EF4-FFF2-40B4-BE49-F238E27FC236}">
-                <a16:creationId xmlns:a16="http://schemas.microsoft.com/office/drawing/2014/main" id="{47A323D0-B93D-429B-9D02-F85EB108957B}"/>
+                <a16:creationId xmlns:a16="http://schemas.microsoft.com/office/drawing/2014/main" id="{AA247F2F-2DA5-47F5-A9A5-3CDF05709471}"/>
               </a:ext>
             </a:extLst>
           </p:cNvPr>
@@ -3635,7 +3625,7 @@
           <p:cNvPr id="22" name="">
             <a:extLst xmlns:a="http://schemas.openxmlformats.org/drawingml/2006/main">
               <a:ext uri="{FF2B5EF4-FFF2-40B4-BE49-F238E27FC236}">
-                <a16:creationId xmlns:a16="http://schemas.microsoft.com/office/drawing/2014/main" id="{5B750DC5-6E14-4D4F-BEB1-9345893E1CE8}"/>
+                <a16:creationId xmlns:a16="http://schemas.microsoft.com/office/drawing/2014/main" id="{9EED71F0-456D-434A-B604-E6CA9E167211}"/>
               </a:ext>
             </a:extLst>
           </p:cNvPr>
@@ -3685,7 +3675,7 @@
           <p:cNvPr id="23" name="">
             <a:extLst xmlns:a="http://schemas.openxmlformats.org/drawingml/2006/main">
               <a:ext uri="{FF2B5EF4-FFF2-40B4-BE49-F238E27FC236}">
-                <a16:creationId xmlns:a16="http://schemas.microsoft.com/office/drawing/2014/main" id="{CDBF5E7A-7A89-4BD1-AD42-A670E557359A}"/>
+                <a16:creationId xmlns:a16="http://schemas.microsoft.com/office/drawing/2014/main" id="{C82E619B-BADD-4B28-A4D9-37F1934E4761}"/>
               </a:ext>
             </a:extLst>
           </p:cNvPr>
@@ -3718,7 +3708,7 @@
           <p:cNvPr id="24" name="">
             <a:extLst xmlns:a="http://schemas.openxmlformats.org/drawingml/2006/main">
               <a:ext uri="{FF2B5EF4-FFF2-40B4-BE49-F238E27FC236}">
-                <a16:creationId xmlns:a16="http://schemas.microsoft.com/office/drawing/2014/main" id="{91443929-913B-4AAD-9822-1D66CB8C0BAF}"/>
+                <a16:creationId xmlns:a16="http://schemas.microsoft.com/office/drawing/2014/main" id="{2A940A20-1FF0-4D25-B861-983310CB818A}"/>
               </a:ext>
             </a:extLst>
           </p:cNvPr>
@@ -3768,7 +3758,7 @@
           <p:cNvPr id="25" name="">
             <a:extLst xmlns:a="http://schemas.openxmlformats.org/drawingml/2006/main">
               <a:ext uri="{FF2B5EF4-FFF2-40B4-BE49-F238E27FC236}">
-                <a16:creationId xmlns:a16="http://schemas.microsoft.com/office/drawing/2014/main" id="{FA3D269C-94DC-476E-B76F-284B0755B434}"/>
+                <a16:creationId xmlns:a16="http://schemas.microsoft.com/office/drawing/2014/main" id="{391086A5-156F-43E2-86BA-1D932C5DCA2E}"/>
               </a:ext>
             </a:extLst>
           </p:cNvPr>
@@ -3818,7 +3808,7 @@
           <p:cNvPr id="26" name="">
             <a:extLst xmlns:a="http://schemas.openxmlformats.org/drawingml/2006/main">
               <a:ext uri="{FF2B5EF4-FFF2-40B4-BE49-F238E27FC236}">
-                <a16:creationId xmlns:a16="http://schemas.microsoft.com/office/drawing/2014/main" id="{05E8B542-FDBE-418D-89B7-A41D81BC46BB}"/>
+                <a16:creationId xmlns:a16="http://schemas.microsoft.com/office/drawing/2014/main" id="{1CF93433-76A3-4838-99A7-8927E97F7E17}"/>
               </a:ext>
             </a:extLst>
           </p:cNvPr>
@@ -3868,7 +3858,7 @@
           <p:cNvPr id="27" name="">
             <a:extLst xmlns:a="http://schemas.openxmlformats.org/drawingml/2006/main">
               <a:ext uri="{FF2B5EF4-FFF2-40B4-BE49-F238E27FC236}">
-                <a16:creationId xmlns:a16="http://schemas.microsoft.com/office/drawing/2014/main" id="{622E7E7C-F5A1-4A51-9919-69E0AED3D442}"/>
+                <a16:creationId xmlns:a16="http://schemas.microsoft.com/office/drawing/2014/main" id="{A81B8FDA-6BD5-48CC-B7C2-6849EA67030E}"/>
               </a:ext>
             </a:extLst>
           </p:cNvPr>
@@ -3901,7 +3891,7 @@
           <p:cNvPr id="28" name="">
             <a:extLst xmlns:a="http://schemas.openxmlformats.org/drawingml/2006/main">
               <a:ext uri="{FF2B5EF4-FFF2-40B4-BE49-F238E27FC236}">
-                <a16:creationId xmlns:a16="http://schemas.microsoft.com/office/drawing/2014/main" id="{DA598020-E59E-4D81-B8E9-E3643BBA74E7}"/>
+                <a16:creationId xmlns:a16="http://schemas.microsoft.com/office/drawing/2014/main" id="{3AB58C85-020B-4F5E-828B-A4CB4679C390}"/>
               </a:ext>
             </a:extLst>
           </p:cNvPr>
@@ -3951,7 +3941,7 @@
           <p:cNvPr id="29" name="">
             <a:extLst xmlns:a="http://schemas.openxmlformats.org/drawingml/2006/main">
               <a:ext uri="{FF2B5EF4-FFF2-40B4-BE49-F238E27FC236}">
-                <a16:creationId xmlns:a16="http://schemas.microsoft.com/office/drawing/2014/main" id="{AC0E9E5D-6C05-4713-B1EB-DB01868FF6A3}"/>
+                <a16:creationId xmlns:a16="http://schemas.microsoft.com/office/drawing/2014/main" id="{421CD74A-9CC5-4554-919A-58B0917C640E}"/>
               </a:ext>
             </a:extLst>
           </p:cNvPr>
@@ -4001,7 +3991,7 @@
           <p:cNvPr id="30" name="">
             <a:extLst xmlns:a="http://schemas.openxmlformats.org/drawingml/2006/main">
               <a:ext uri="{FF2B5EF4-FFF2-40B4-BE49-F238E27FC236}">
-                <a16:creationId xmlns:a16="http://schemas.microsoft.com/office/drawing/2014/main" id="{53B1F6A8-4D44-4CBD-8D70-F9E40C03248A}"/>
+                <a16:creationId xmlns:a16="http://schemas.microsoft.com/office/drawing/2014/main" id="{783AE733-6322-496D-A4A9-1B2D5238A55E}"/>
               </a:ext>
             </a:extLst>
           </p:cNvPr>
@@ -4051,7 +4041,7 @@
           <p:cNvPr id="31" name="">
             <a:extLst xmlns:a="http://schemas.openxmlformats.org/drawingml/2006/main">
               <a:ext uri="{FF2B5EF4-FFF2-40B4-BE49-F238E27FC236}">
-                <a16:creationId xmlns:a16="http://schemas.microsoft.com/office/drawing/2014/main" id="{89B1A0AB-F7C6-4A91-BBFA-0D1326FB76DD}"/>
+                <a16:creationId xmlns:a16="http://schemas.microsoft.com/office/drawing/2014/main" id="{A29C7EF7-6EBD-45E5-B253-7FEFDED89765}"/>
               </a:ext>
             </a:extLst>
           </p:cNvPr>
@@ -4084,7 +4074,7 @@
           <p:cNvPr id="32" name="">
             <a:extLst xmlns:a="http://schemas.openxmlformats.org/drawingml/2006/main">
               <a:ext uri="{FF2B5EF4-FFF2-40B4-BE49-F238E27FC236}">
-                <a16:creationId xmlns:a16="http://schemas.microsoft.com/office/drawing/2014/main" id="{5E38230C-493E-4387-B17E-84C27664A8D6}"/>
+                <a16:creationId xmlns:a16="http://schemas.microsoft.com/office/drawing/2014/main" id="{4884D5EE-B918-418A-A167-E83DA5D0D8F9}"/>
               </a:ext>
             </a:extLst>
           </p:cNvPr>
@@ -4134,7 +4124,7 @@
           <p:cNvPr id="33" name="">
             <a:extLst xmlns:a="http://schemas.openxmlformats.org/drawingml/2006/main">
               <a:ext uri="{FF2B5EF4-FFF2-40B4-BE49-F238E27FC236}">
-                <a16:creationId xmlns:a16="http://schemas.microsoft.com/office/drawing/2014/main" id="{67E66B29-6FBD-413C-9B86-2774694F3D8D}"/>
+                <a16:creationId xmlns:a16="http://schemas.microsoft.com/office/drawing/2014/main" id="{98163CD1-0966-46A9-848B-35B950392881}"/>
               </a:ext>
             </a:extLst>
           </p:cNvPr>
@@ -4184,7 +4174,7 @@
           <p:cNvPr id="34" name="">
             <a:extLst xmlns:a="http://schemas.openxmlformats.org/drawingml/2006/main">
               <a:ext uri="{FF2B5EF4-FFF2-40B4-BE49-F238E27FC236}">
-                <a16:creationId xmlns:a16="http://schemas.microsoft.com/office/drawing/2014/main" id="{3D76E378-BCB5-43E9-B5B2-D86D5B57320B}"/>
+                <a16:creationId xmlns:a16="http://schemas.microsoft.com/office/drawing/2014/main" id="{2C475A03-4A1F-42F0-A632-F39099A57E5D}"/>
               </a:ext>
             </a:extLst>
           </p:cNvPr>
@@ -4234,7 +4224,7 @@
           <p:cNvPr id="35" name="">
             <a:extLst xmlns:a="http://schemas.openxmlformats.org/drawingml/2006/main">
               <a:ext uri="{FF2B5EF4-FFF2-40B4-BE49-F238E27FC236}">
-                <a16:creationId xmlns:a16="http://schemas.microsoft.com/office/drawing/2014/main" id="{74B693FD-C1AF-461F-A989-65F46C69CB11}"/>
+                <a16:creationId xmlns:a16="http://schemas.microsoft.com/office/drawing/2014/main" id="{20738CD1-2EE9-42EE-8AF1-E1196C4F9A68}"/>
               </a:ext>
             </a:extLst>
           </p:cNvPr>
@@ -4267,7 +4257,7 @@
           <p:cNvPr id="36" name="">
             <a:extLst xmlns:a="http://schemas.openxmlformats.org/drawingml/2006/main">
               <a:ext uri="{FF2B5EF4-FFF2-40B4-BE49-F238E27FC236}">
-                <a16:creationId xmlns:a16="http://schemas.microsoft.com/office/drawing/2014/main" id="{23B71554-9334-46B4-87E7-D4F6554ED616}"/>
+                <a16:creationId xmlns:a16="http://schemas.microsoft.com/office/drawing/2014/main" id="{8634B2E0-0569-43FC-A80A-2464A8C1544B}"/>
               </a:ext>
             </a:extLst>
           </p:cNvPr>
@@ -4317,7 +4307,7 @@
           <p:cNvPr id="37" name="">
             <a:extLst xmlns:a="http://schemas.openxmlformats.org/drawingml/2006/main">
               <a:ext uri="{FF2B5EF4-FFF2-40B4-BE49-F238E27FC236}">
-                <a16:creationId xmlns:a16="http://schemas.microsoft.com/office/drawing/2014/main" id="{BE39E923-A64A-4CB0-BA22-9F266904640D}"/>
+                <a16:creationId xmlns:a16="http://schemas.microsoft.com/office/drawing/2014/main" id="{5E658FC6-DCEF-4A64-919B-052AB1D4ABF6}"/>
               </a:ext>
             </a:extLst>
           </p:cNvPr>
@@ -4367,7 +4357,7 @@
           <p:cNvPr id="38" name="">
             <a:extLst xmlns:a="http://schemas.openxmlformats.org/drawingml/2006/main">
               <a:ext uri="{FF2B5EF4-FFF2-40B4-BE49-F238E27FC236}">
-                <a16:creationId xmlns:a16="http://schemas.microsoft.com/office/drawing/2014/main" id="{0F8A62AD-AA45-42D7-A750-C98FD6FFB228}"/>
+                <a16:creationId xmlns:a16="http://schemas.microsoft.com/office/drawing/2014/main" id="{4A033C11-DBAB-4798-98D2-759050CAC967}"/>
               </a:ext>
             </a:extLst>
           </p:cNvPr>
@@ -4417,7 +4407,7 @@
           <p:cNvPr id="39" name="">
             <a:extLst xmlns:a="http://schemas.openxmlformats.org/drawingml/2006/main">
               <a:ext uri="{FF2B5EF4-FFF2-40B4-BE49-F238E27FC236}">
-                <a16:creationId xmlns:a16="http://schemas.microsoft.com/office/drawing/2014/main" id="{9988F957-3F66-4C4E-B084-88F79E764BFF}"/>
+                <a16:creationId xmlns:a16="http://schemas.microsoft.com/office/drawing/2014/main" id="{1F4E759C-7132-4480-9980-ACDF6CD5CD87}"/>
               </a:ext>
             </a:extLst>
           </p:cNvPr>
@@ -4450,7 +4440,7 @@
           <p:cNvPr id="40" name="">
             <a:extLst xmlns:a="http://schemas.openxmlformats.org/drawingml/2006/main">
               <a:ext uri="{FF2B5EF4-FFF2-40B4-BE49-F238E27FC236}">
-                <a16:creationId xmlns:a16="http://schemas.microsoft.com/office/drawing/2014/main" id="{2788C0A6-7198-4EF7-90E1-4499C7338AFF}"/>
+                <a16:creationId xmlns:a16="http://schemas.microsoft.com/office/drawing/2014/main" id="{CF07FE3F-5A71-4DE7-B29D-EAE515B17611}"/>
               </a:ext>
             </a:extLst>
           </p:cNvPr>
@@ -4485,7 +4475,7 @@
           <p:cNvPr id="41" name="">
             <a:extLst xmlns:a="http://schemas.openxmlformats.org/drawingml/2006/main">
               <a:ext uri="{FF2B5EF4-FFF2-40B4-BE49-F238E27FC236}">
-                <a16:creationId xmlns:a16="http://schemas.microsoft.com/office/drawing/2014/main" id="{8997A3F9-A307-4918-9B56-10198CC10CDF}"/>
+                <a16:creationId xmlns:a16="http://schemas.microsoft.com/office/drawing/2014/main" id="{66E5332D-A930-4063-9319-58BBDE0B7B24}"/>
               </a:ext>
             </a:extLst>
           </p:cNvPr>
@@ -4535,7 +4525,7 @@
           <p:cNvPr id="42" name="">
             <a:extLst xmlns:a="http://schemas.openxmlformats.org/drawingml/2006/main">
               <a:ext uri="{FF2B5EF4-FFF2-40B4-BE49-F238E27FC236}">
-                <a16:creationId xmlns:a16="http://schemas.microsoft.com/office/drawing/2014/main" id="{334E3728-5AF5-4931-95F5-146C935FFCBA}"/>
+                <a16:creationId xmlns:a16="http://schemas.microsoft.com/office/drawing/2014/main" id="{252AA909-1EA3-41EE-84C8-94858C3BEB6A}"/>
               </a:ext>
             </a:extLst>
           </p:cNvPr>
@@ -4568,7 +4558,7 @@
           <p:cNvPr id="43" name="">
             <a:extLst xmlns:a="http://schemas.openxmlformats.org/drawingml/2006/main">
               <a:ext uri="{FF2B5EF4-FFF2-40B4-BE49-F238E27FC236}">
-                <a16:creationId xmlns:a16="http://schemas.microsoft.com/office/drawing/2014/main" id="{5136A9D0-B7D5-47D2-BABD-F067D1DE7CC1}"/>
+                <a16:creationId xmlns:a16="http://schemas.microsoft.com/office/drawing/2014/main" id="{88EAD5CB-0443-4AB9-A453-1FC4B54DB6C7}"/>
               </a:ext>
             </a:extLst>
           </p:cNvPr>
@@ -4580,7 +4570,7 @@
         <p:spPr>
           <a:xfrm xmlns:a="http://schemas.openxmlformats.org/drawingml/2006/main">
             <a:off x="647700" y="6496050"/>
-            <a:ext cx="9715500" cy="190500"/>
+            <a:ext cx="8953500" cy="190500"/>
           </a:xfrm>
           <a:prstGeom xmlns:a="http://schemas.openxmlformats.org/drawingml/2006/main" prst="rect">
             <a:avLst/>
@@ -4618,19 +4608,19 @@
           <p:cNvPr id="44" name="">
             <a:extLst xmlns:a="http://schemas.openxmlformats.org/drawingml/2006/main">
               <a:ext uri="{FF2B5EF4-FFF2-40B4-BE49-F238E27FC236}">
-                <a16:creationId xmlns:a16="http://schemas.microsoft.com/office/drawing/2014/main" id="{9E9B7001-6A64-48FD-916A-CE2DC209E0D9}"/>
-              </a:ext>
-            </a:extLst>
-          </p:cNvPr>
-          <p:cNvSpPr>
-            <a:spLocks xmlns:a="http://schemas.openxmlformats.org/drawingml/2006/main" noGrp="1"/>
-          </p:cNvSpPr>
-          <p:nvPr/>
-        </p:nvSpPr>
-        <p:spPr>
-          <a:xfrm xmlns:a="http://schemas.openxmlformats.org/drawingml/2006/main">
-            <a:off x="9620250" y="6467475"/>
-            <a:ext cx="1905000" cy="247650"/>
+                <a16:creationId xmlns:a16="http://schemas.microsoft.com/office/drawing/2014/main" id="{83170FAF-7056-4F47-B62E-43F65701F396}"/>
+              </a:ext>
+            </a:extLst>
+          </p:cNvPr>
+          <p:cNvSpPr>
+            <a:spLocks xmlns:a="http://schemas.openxmlformats.org/drawingml/2006/main" noGrp="1"/>
+          </p:cNvSpPr>
+          <p:nvPr/>
+        </p:nvSpPr>
+        <p:spPr>
+          <a:xfrm xmlns:a="http://schemas.openxmlformats.org/drawingml/2006/main">
+            <a:off x="10287000" y="6467475"/>
+            <a:ext cx="952500" cy="247650"/>
           </a:xfrm>
           <a:prstGeom xmlns:a="http://schemas.openxmlformats.org/drawingml/2006/main" prst="rect">
             <a:avLst/>
@@ -4666,7 +4656,7 @@
     </p:spTree>
     <p:extLst>
       <p:ext uri="{BB962C8B-B14F-4D97-AF65-F5344CB8AC3E}">
-        <p14:creationId xmlns:p14="http://schemas.microsoft.com/office/powerpoint/2010/main" val="1261933563"/>
+        <p14:creationId xmlns:p14="http://schemas.microsoft.com/office/powerpoint/2010/main" val="2036698781"/>
       </p:ext>
     </p:extLst>
   </p:cSld>
@@ -4697,7 +4687,7 @@
           <p:cNvPr id="33" name="">
             <a:extLst xmlns:a="http://schemas.openxmlformats.org/drawingml/2006/main">
               <a:ext uri="{FF2B5EF4-FFF2-40B4-BE49-F238E27FC236}">
-                <a16:creationId xmlns:a16="http://schemas.microsoft.com/office/drawing/2014/main" id="{79CC7879-59E7-4B12-84BA-F9F384482378}"/>
+                <a16:creationId xmlns:a16="http://schemas.microsoft.com/office/drawing/2014/main" id="{6B1A2E11-E01A-4CEF-AC8E-A78C70EA7EEE}"/>
               </a:ext>
             </a:extLst>
           </p:cNvPr>
@@ -4747,7 +4737,7 @@
           <p:cNvPr id="2" name="">
             <a:extLst xmlns:a="http://schemas.openxmlformats.org/drawingml/2006/main">
               <a:ext uri="{FF2B5EF4-FFF2-40B4-BE49-F238E27FC236}">
-                <a16:creationId xmlns:a16="http://schemas.microsoft.com/office/drawing/2014/main" id="{12907C96-0DAD-406E-945F-09BB21C525B4}"/>
+                <a16:creationId xmlns:a16="http://schemas.microsoft.com/office/drawing/2014/main" id="{64EC89C7-E1AD-469F-A453-E60B57F90EBC}"/>
               </a:ext>
             </a:extLst>
           </p:cNvPr>
@@ -4787,7 +4777,7 @@
                   <a:srgbClr val="2F6FE4"/>
                 </a:solidFill>
               </a:rPr>
-              <a:t>PROFESSOR FEEDBACK  •  DATA + MODELING</a:t>
+              <a:t>DATA QUALITY  •  FEATURE ENGINEERING  •  MODEL SELECTION</a:t>
             </a:r>
           </a:p>
         </p:txBody>
@@ -4797,7 +4787,7 @@
           <p:cNvPr id="3" name="">
             <a:extLst xmlns:a="http://schemas.openxmlformats.org/drawingml/2006/main">
               <a:ext uri="{FF2B5EF4-FFF2-40B4-BE49-F238E27FC236}">
-                <a16:creationId xmlns:a16="http://schemas.microsoft.com/office/drawing/2014/main" id="{E12F6CD8-7EED-40DD-B28D-AC71100B2792}"/>
+                <a16:creationId xmlns:a16="http://schemas.microsoft.com/office/drawing/2014/main" id="{226AA7F2-61AA-45D6-9F10-0B017C38D45D}"/>
               </a:ext>
             </a:extLst>
           </p:cNvPr>
@@ -4847,7 +4837,7 @@
           <p:cNvPr id="4" name="">
             <a:extLst xmlns:a="http://schemas.openxmlformats.org/drawingml/2006/main">
               <a:ext uri="{FF2B5EF4-FFF2-40B4-BE49-F238E27FC236}">
-                <a16:creationId xmlns:a16="http://schemas.microsoft.com/office/drawing/2014/main" id="{9E09EEB7-636A-4278-B38D-80C79B5582B6}"/>
+                <a16:creationId xmlns:a16="http://schemas.microsoft.com/office/drawing/2014/main" id="{F0D2A8BA-CF3A-4BEA-905D-B63241D75495}"/>
               </a:ext>
             </a:extLst>
           </p:cNvPr>
@@ -4880,7 +4870,7 @@
           <p:cNvPr id="5" name="">
             <a:extLst xmlns:a="http://schemas.openxmlformats.org/drawingml/2006/main">
               <a:ext uri="{FF2B5EF4-FFF2-40B4-BE49-F238E27FC236}">
-                <a16:creationId xmlns:a16="http://schemas.microsoft.com/office/drawing/2014/main" id="{2280CD9B-8694-45B5-B045-F5DB09C06D51}"/>
+                <a16:creationId xmlns:a16="http://schemas.microsoft.com/office/drawing/2014/main" id="{036D3CA1-EC07-46C1-81C0-949B2A2316E3}"/>
               </a:ext>
             </a:extLst>
           </p:cNvPr>
@@ -4920,7 +4910,7 @@
                   <a:srgbClr val="0A1D30"/>
                 </a:solidFill>
               </a:rPr>
-              <a:t>Feedback became enforceable data and modeling gates</a:t>
+              <a:t>Data and modeling controls strengthen validity</a:t>
             </a:r>
           </a:p>
         </p:txBody>
@@ -4930,7 +4920,7 @@
           <p:cNvPr id="6" name="">
             <a:extLst xmlns:a="http://schemas.openxmlformats.org/drawingml/2006/main">
               <a:ext uri="{FF2B5EF4-FFF2-40B4-BE49-F238E27FC236}">
-                <a16:creationId xmlns:a16="http://schemas.microsoft.com/office/drawing/2014/main" id="{613C3F8B-57CF-41C6-82C2-8053CCD3EA58}"/>
+                <a16:creationId xmlns:a16="http://schemas.microsoft.com/office/drawing/2014/main" id="{C33842F8-F876-404C-ACA9-DAE35EA6D6F0}"/>
               </a:ext>
             </a:extLst>
           </p:cNvPr>
@@ -4970,7 +4960,7 @@
                   <a:srgbClr val="657888"/>
                 </a:solidFill>
               </a:rPr>
-              <a:t>The feedback is enforced by configuration and validation, not stated only in documentation.</a:t>
+              <a:t>Quality gates keep scale, representation, and model comparison reproducible.</a:t>
             </a:r>
           </a:p>
         </p:txBody>
@@ -4980,7 +4970,7 @@
           <p:cNvPr id="7" name="">
             <a:extLst xmlns:a="http://schemas.openxmlformats.org/drawingml/2006/main">
               <a:ext uri="{FF2B5EF4-FFF2-40B4-BE49-F238E27FC236}">
-                <a16:creationId xmlns:a16="http://schemas.microsoft.com/office/drawing/2014/main" id="{1B418BF4-4E30-4B3B-A829-4F19006FE230}"/>
+                <a16:creationId xmlns:a16="http://schemas.microsoft.com/office/drawing/2014/main" id="{E3B93EEA-8C61-42A0-9196-732F80CBB556}"/>
               </a:ext>
             </a:extLst>
           </p:cNvPr>
@@ -5015,7 +5005,7 @@
           <p:cNvPr id="8" name="">
             <a:extLst xmlns:a="http://schemas.openxmlformats.org/drawingml/2006/main">
               <a:ext uri="{FF2B5EF4-FFF2-40B4-BE49-F238E27FC236}">
-                <a16:creationId xmlns:a16="http://schemas.microsoft.com/office/drawing/2014/main" id="{7D619916-C2D7-4A78-9DD1-AC1AE4B36A51}"/>
+                <a16:creationId xmlns:a16="http://schemas.microsoft.com/office/drawing/2014/main" id="{73B2C854-E9AE-4256-96C5-F71C205821E5}"/>
               </a:ext>
             </a:extLst>
           </p:cNvPr>
@@ -5065,7 +5055,7 @@
           <p:cNvPr id="9" name="">
             <a:extLst xmlns:a="http://schemas.openxmlformats.org/drawingml/2006/main">
               <a:ext uri="{FF2B5EF4-FFF2-40B4-BE49-F238E27FC236}">
-                <a16:creationId xmlns:a16="http://schemas.microsoft.com/office/drawing/2014/main" id="{DE274564-5083-4C28-8E1B-CB91DE45B443}"/>
+                <a16:creationId xmlns:a16="http://schemas.microsoft.com/office/drawing/2014/main" id="{6F0B2D48-78C9-49F9-8907-F2FD45340DE2}"/>
               </a:ext>
             </a:extLst>
           </p:cNvPr>
@@ -5115,7 +5105,7 @@
           <p:cNvPr id="10" name="">
             <a:extLst xmlns:a="http://schemas.openxmlformats.org/drawingml/2006/main">
               <a:ext uri="{FF2B5EF4-FFF2-40B4-BE49-F238E27FC236}">
-                <a16:creationId xmlns:a16="http://schemas.microsoft.com/office/drawing/2014/main" id="{A9089015-0741-4344-A9D3-F6B390CC4798}"/>
+                <a16:creationId xmlns:a16="http://schemas.microsoft.com/office/drawing/2014/main" id="{37FBE099-7540-4596-B0DD-ADDB7DA06820}"/>
               </a:ext>
             </a:extLst>
           </p:cNvPr>
@@ -5165,7 +5155,7 @@
           <p:cNvPr id="11" name="">
             <a:extLst xmlns:a="http://schemas.openxmlformats.org/drawingml/2006/main">
               <a:ext uri="{FF2B5EF4-FFF2-40B4-BE49-F238E27FC236}">
-                <a16:creationId xmlns:a16="http://schemas.microsoft.com/office/drawing/2014/main" id="{987BA3F7-E747-4362-B18E-D685F4BF718E}"/>
+                <a16:creationId xmlns:a16="http://schemas.microsoft.com/office/drawing/2014/main" id="{E202CF19-D93A-4680-AE47-293E938B9494}"/>
               </a:ext>
             </a:extLst>
           </p:cNvPr>
@@ -5198,7 +5188,7 @@
           <p:cNvPr id="12" name="">
             <a:extLst xmlns:a="http://schemas.openxmlformats.org/drawingml/2006/main">
               <a:ext uri="{FF2B5EF4-FFF2-40B4-BE49-F238E27FC236}">
-                <a16:creationId xmlns:a16="http://schemas.microsoft.com/office/drawing/2014/main" id="{6007EEFD-D226-4257-8C9C-49635FA773D2}"/>
+                <a16:creationId xmlns:a16="http://schemas.microsoft.com/office/drawing/2014/main" id="{38A4E03B-E76B-4096-8A03-24CD66E5CD81}"/>
               </a:ext>
             </a:extLst>
           </p:cNvPr>
@@ -5238,7 +5228,7 @@
                   <a:srgbClr val="1F9D88"/>
                 </a:solidFill>
               </a:rPr>
-              <a:t>SMARTER FEATURE ENGINEERING</a:t>
+              <a:t>STRUCTURAL FEATURE ENGINEERING</a:t>
             </a:r>
           </a:p>
         </p:txBody>
@@ -5248,7 +5238,7 @@
           <p:cNvPr id="13" name="">
             <a:extLst xmlns:a="http://schemas.openxmlformats.org/drawingml/2006/main">
               <a:ext uri="{FF2B5EF4-FFF2-40B4-BE49-F238E27FC236}">
-                <a16:creationId xmlns:a16="http://schemas.microsoft.com/office/drawing/2014/main" id="{58AA1F61-1AFD-4509-9F14-102C4CD8EE9D}"/>
+                <a16:creationId xmlns:a16="http://schemas.microsoft.com/office/drawing/2014/main" id="{133E20D8-D87A-4265-A385-51D703997C48}"/>
               </a:ext>
             </a:extLst>
           </p:cNvPr>
@@ -5298,7 +5288,7 @@
           <p:cNvPr id="14" name="">
             <a:extLst xmlns:a="http://schemas.openxmlformats.org/drawingml/2006/main">
               <a:ext uri="{FF2B5EF4-FFF2-40B4-BE49-F238E27FC236}">
-                <a16:creationId xmlns:a16="http://schemas.microsoft.com/office/drawing/2014/main" id="{70967E77-9E29-4C65-895A-F77344D54011}"/>
+                <a16:creationId xmlns:a16="http://schemas.microsoft.com/office/drawing/2014/main" id="{55B0D3E6-1395-4306-99FA-C0ED6187A2FF}"/>
               </a:ext>
             </a:extLst>
           </p:cNvPr>
@@ -5331,7 +5321,7 @@
           <p:cNvPr id="15" name="">
             <a:extLst xmlns:a="http://schemas.openxmlformats.org/drawingml/2006/main">
               <a:ext uri="{FF2B5EF4-FFF2-40B4-BE49-F238E27FC236}">
-                <a16:creationId xmlns:a16="http://schemas.microsoft.com/office/drawing/2014/main" id="{7A2B67F3-94B5-4E7B-B2AF-0A2F0051D8B6}"/>
+                <a16:creationId xmlns:a16="http://schemas.microsoft.com/office/drawing/2014/main" id="{AF929502-8897-4350-9ADA-6D487CB57DE2}"/>
               </a:ext>
             </a:extLst>
           </p:cNvPr>
@@ -5381,7 +5371,7 @@
           <p:cNvPr id="16" name="">
             <a:extLst xmlns:a="http://schemas.openxmlformats.org/drawingml/2006/main">
               <a:ext uri="{FF2B5EF4-FFF2-40B4-BE49-F238E27FC236}">
-                <a16:creationId xmlns:a16="http://schemas.microsoft.com/office/drawing/2014/main" id="{E8761B84-4338-48DA-AC65-B0D8DC76539C}"/>
+                <a16:creationId xmlns:a16="http://schemas.microsoft.com/office/drawing/2014/main" id="{8A05E287-2A6F-4F71-A45A-E1AD41AD964E}"/>
               </a:ext>
             </a:extLst>
           </p:cNvPr>
@@ -5414,7 +5404,7 @@
           <p:cNvPr id="17" name="">
             <a:extLst xmlns:a="http://schemas.openxmlformats.org/drawingml/2006/main">
               <a:ext uri="{FF2B5EF4-FFF2-40B4-BE49-F238E27FC236}">
-                <a16:creationId xmlns:a16="http://schemas.microsoft.com/office/drawing/2014/main" id="{57AF6620-B389-499F-9ADA-DC2BEC32270D}"/>
+                <a16:creationId xmlns:a16="http://schemas.microsoft.com/office/drawing/2014/main" id="{34B62306-E634-4D25-BE3C-D3538D29AB25}"/>
               </a:ext>
             </a:extLst>
           </p:cNvPr>
@@ -5464,7 +5454,7 @@
           <p:cNvPr id="18" name="">
             <a:extLst xmlns:a="http://schemas.openxmlformats.org/drawingml/2006/main">
               <a:ext uri="{FF2B5EF4-FFF2-40B4-BE49-F238E27FC236}">
-                <a16:creationId xmlns:a16="http://schemas.microsoft.com/office/drawing/2014/main" id="{A4549585-9ACC-44AE-8ECB-B65F02155DD8}"/>
+                <a16:creationId xmlns:a16="http://schemas.microsoft.com/office/drawing/2014/main" id="{49DC9354-6378-49DD-A94F-C6BC42B1B7FB}"/>
               </a:ext>
             </a:extLst>
           </p:cNvPr>
@@ -5497,7 +5487,7 @@
           <p:cNvPr id="19" name="">
             <a:extLst xmlns:a="http://schemas.openxmlformats.org/drawingml/2006/main">
               <a:ext uri="{FF2B5EF4-FFF2-40B4-BE49-F238E27FC236}">
-                <a16:creationId xmlns:a16="http://schemas.microsoft.com/office/drawing/2014/main" id="{B37FFA83-9488-41A6-BC4A-49EF98C83AFD}"/>
+                <a16:creationId xmlns:a16="http://schemas.microsoft.com/office/drawing/2014/main" id="{A00C31BE-ACD2-4891-9911-86EBB593EE6F}"/>
               </a:ext>
             </a:extLst>
           </p:cNvPr>
@@ -5547,7 +5537,7 @@
           <p:cNvPr id="20" name="">
             <a:extLst xmlns:a="http://schemas.openxmlformats.org/drawingml/2006/main">
               <a:ext uri="{FF2B5EF4-FFF2-40B4-BE49-F238E27FC236}">
-                <a16:creationId xmlns:a16="http://schemas.microsoft.com/office/drawing/2014/main" id="{85E22E0E-9AA3-4883-A8B7-FEB4F4045577}"/>
+                <a16:creationId xmlns:a16="http://schemas.microsoft.com/office/drawing/2014/main" id="{CBBDC34A-E6E3-4033-957B-54EB2E05AB16}"/>
               </a:ext>
             </a:extLst>
           </p:cNvPr>
@@ -5580,7 +5570,7 @@
           <p:cNvPr id="21" name="">
             <a:extLst xmlns:a="http://schemas.openxmlformats.org/drawingml/2006/main">
               <a:ext uri="{FF2B5EF4-FFF2-40B4-BE49-F238E27FC236}">
-                <a16:creationId xmlns:a16="http://schemas.microsoft.com/office/drawing/2014/main" id="{19738B82-C841-46DA-AD1B-5028EFEB5AEF}"/>
+                <a16:creationId xmlns:a16="http://schemas.microsoft.com/office/drawing/2014/main" id="{54AE048E-83D1-44FD-8F14-ED88B8F6471D}"/>
               </a:ext>
             </a:extLst>
           </p:cNvPr>
@@ -5630,7 +5620,7 @@
           <p:cNvPr id="22" name="">
             <a:extLst xmlns:a="http://schemas.openxmlformats.org/drawingml/2006/main">
               <a:ext uri="{FF2B5EF4-FFF2-40B4-BE49-F238E27FC236}">
-                <a16:creationId xmlns:a16="http://schemas.microsoft.com/office/drawing/2014/main" id="{D9A737EB-5EEA-4557-B425-351178C7B9E1}"/>
+                <a16:creationId xmlns:a16="http://schemas.microsoft.com/office/drawing/2014/main" id="{15105096-427B-43A2-8A49-7C111F52853B}"/>
               </a:ext>
             </a:extLst>
           </p:cNvPr>
@@ -5680,7 +5670,7 @@
           <p:cNvPr id="23" name="">
             <a:extLst xmlns:a="http://schemas.openxmlformats.org/drawingml/2006/main">
               <a:ext uri="{FF2B5EF4-FFF2-40B4-BE49-F238E27FC236}">
-                <a16:creationId xmlns:a16="http://schemas.microsoft.com/office/drawing/2014/main" id="{3EC16436-FD14-4B76-B486-F343588C38BC}"/>
+                <a16:creationId xmlns:a16="http://schemas.microsoft.com/office/drawing/2014/main" id="{B3876BBA-16BA-42FE-B6F2-9D3D540BA9D7}"/>
               </a:ext>
             </a:extLst>
           </p:cNvPr>
@@ -5730,7 +5720,7 @@
           <p:cNvPr id="24" name="">
             <a:extLst xmlns:a="http://schemas.openxmlformats.org/drawingml/2006/main">
               <a:ext uri="{FF2B5EF4-FFF2-40B4-BE49-F238E27FC236}">
-                <a16:creationId xmlns:a16="http://schemas.microsoft.com/office/drawing/2014/main" id="{69367DDA-15BC-4784-8951-6E7B19CEDC68}"/>
+                <a16:creationId xmlns:a16="http://schemas.microsoft.com/office/drawing/2014/main" id="{5D5D1958-8F07-4D8A-9A82-D2A2340F4562}"/>
               </a:ext>
             </a:extLst>
           </p:cNvPr>
@@ -5780,7 +5770,7 @@
           <p:cNvPr id="25" name="">
             <a:extLst xmlns:a="http://schemas.openxmlformats.org/drawingml/2006/main">
               <a:ext uri="{FF2B5EF4-FFF2-40B4-BE49-F238E27FC236}">
-                <a16:creationId xmlns:a16="http://schemas.microsoft.com/office/drawing/2014/main" id="{469EEA84-DB18-4C42-B3ED-DEAF2ACCEE69}"/>
+                <a16:creationId xmlns:a16="http://schemas.microsoft.com/office/drawing/2014/main" id="{21B73BF7-120C-41FC-9760-5F98A9B0376D}"/>
               </a:ext>
             </a:extLst>
           </p:cNvPr>
@@ -5830,7 +5820,7 @@
           <p:cNvPr id="26" name="">
             <a:extLst xmlns:a="http://schemas.openxmlformats.org/drawingml/2006/main">
               <a:ext uri="{FF2B5EF4-FFF2-40B4-BE49-F238E27FC236}">
-                <a16:creationId xmlns:a16="http://schemas.microsoft.com/office/drawing/2014/main" id="{70D6AF29-EB87-4B33-8E51-1F9843382F7D}"/>
+                <a16:creationId xmlns:a16="http://schemas.microsoft.com/office/drawing/2014/main" id="{A3B13BDA-BB1A-4D69-BC86-4FD79AF837E5}"/>
               </a:ext>
             </a:extLst>
           </p:cNvPr>
@@ -5880,7 +5870,7 @@
           <p:cNvPr id="27" name="">
             <a:extLst xmlns:a="http://schemas.openxmlformats.org/drawingml/2006/main">
               <a:ext uri="{FF2B5EF4-FFF2-40B4-BE49-F238E27FC236}">
-                <a16:creationId xmlns:a16="http://schemas.microsoft.com/office/drawing/2014/main" id="{C6E327D4-DA38-4011-8C3A-8147886A0B78}"/>
+                <a16:creationId xmlns:a16="http://schemas.microsoft.com/office/drawing/2014/main" id="{0A40C1EA-1084-4FC9-83CC-70FD22E26F72}"/>
               </a:ext>
             </a:extLst>
           </p:cNvPr>
@@ -5930,7 +5920,7 @@
           <p:cNvPr id="28" name="">
             <a:extLst xmlns:a="http://schemas.openxmlformats.org/drawingml/2006/main">
               <a:ext uri="{FF2B5EF4-FFF2-40B4-BE49-F238E27FC236}">
-                <a16:creationId xmlns:a16="http://schemas.microsoft.com/office/drawing/2014/main" id="{06BDD66B-D8E2-4293-A61F-3DB0C5E4EB68}"/>
+                <a16:creationId xmlns:a16="http://schemas.microsoft.com/office/drawing/2014/main" id="{D611D07E-B968-4E09-827E-EC024D9B10C8}"/>
               </a:ext>
             </a:extLst>
           </p:cNvPr>
@@ -5965,7 +5955,7 @@
           <p:cNvPr id="29" name="">
             <a:extLst xmlns:a="http://schemas.openxmlformats.org/drawingml/2006/main">
               <a:ext uri="{FF2B5EF4-FFF2-40B4-BE49-F238E27FC236}">
-                <a16:creationId xmlns:a16="http://schemas.microsoft.com/office/drawing/2014/main" id="{CC682E50-E921-42F9-8A11-ACEA8C82B956}"/>
+                <a16:creationId xmlns:a16="http://schemas.microsoft.com/office/drawing/2014/main" id="{905DC9AF-6257-4BC9-B442-8D005D21BF37}"/>
               </a:ext>
             </a:extLst>
           </p:cNvPr>
@@ -6005,7 +5995,7 @@
                   <a:srgbClr val="0A1D30"/>
                 </a:solidFill>
               </a:rPr>
-              <a:t>Implemented and manually verified: data scale, prevalence, features, and model comparison</a:t>
+              <a:t>A controlled pipeline connects validated data to fair model comparison</a:t>
             </a:r>
           </a:p>
         </p:txBody>
@@ -6015,7 +6005,7 @@
           <p:cNvPr id="30" name="">
             <a:extLst xmlns:a="http://schemas.openxmlformats.org/drawingml/2006/main">
               <a:ext uri="{FF2B5EF4-FFF2-40B4-BE49-F238E27FC236}">
-                <a16:creationId xmlns:a16="http://schemas.microsoft.com/office/drawing/2014/main" id="{0074E69E-6B4C-43C9-AFB7-F24E59509193}"/>
+                <a16:creationId xmlns:a16="http://schemas.microsoft.com/office/drawing/2014/main" id="{088B8147-E143-4000-999D-6280305F1A1F}"/>
               </a:ext>
             </a:extLst>
           </p:cNvPr>
@@ -6048,7 +6038,7 @@
           <p:cNvPr id="31" name="">
             <a:extLst xmlns:a="http://schemas.openxmlformats.org/drawingml/2006/main">
               <a:ext uri="{FF2B5EF4-FFF2-40B4-BE49-F238E27FC236}">
-                <a16:creationId xmlns:a16="http://schemas.microsoft.com/office/drawing/2014/main" id="{8E73F77B-B295-4FA7-BD32-3615ADA39DD8}"/>
+                <a16:creationId xmlns:a16="http://schemas.microsoft.com/office/drawing/2014/main" id="{D51875C9-4C17-4C15-BB6E-B0F1AB199740}"/>
               </a:ext>
             </a:extLst>
           </p:cNvPr>
@@ -6060,7 +6050,7 @@
         <p:spPr>
           <a:xfrm xmlns:a="http://schemas.openxmlformats.org/drawingml/2006/main">
             <a:off x="647700" y="6496050"/>
-            <a:ext cx="9715500" cy="190500"/>
+            <a:ext cx="8953500" cy="190500"/>
           </a:xfrm>
           <a:prstGeom xmlns:a="http://schemas.openxmlformats.org/drawingml/2006/main" prst="rect">
             <a:avLst/>
@@ -6088,7 +6078,7 @@
                   <a:srgbClr val="657888"/>
                 </a:solidFill>
               </a:rPr>
-              <a:t>The project author checked the dataset and confirmed the reported measurements.</a:t>
+              <a:t>Data quality, train-serve parity, and consistent evaluation protect validity.</a:t>
             </a:r>
           </a:p>
         </p:txBody>
@@ -6098,19 +6088,19 @@
           <p:cNvPr id="32" name="">
             <a:extLst xmlns:a="http://schemas.openxmlformats.org/drawingml/2006/main">
               <a:ext uri="{FF2B5EF4-FFF2-40B4-BE49-F238E27FC236}">
-                <a16:creationId xmlns:a16="http://schemas.microsoft.com/office/drawing/2014/main" id="{7B7AD979-8AB3-4FCA-A248-08A977E6F94D}"/>
-              </a:ext>
-            </a:extLst>
-          </p:cNvPr>
-          <p:cNvSpPr>
-            <a:spLocks xmlns:a="http://schemas.openxmlformats.org/drawingml/2006/main" noGrp="1"/>
-          </p:cNvSpPr>
-          <p:nvPr/>
-        </p:nvSpPr>
-        <p:spPr>
-          <a:xfrm xmlns:a="http://schemas.openxmlformats.org/drawingml/2006/main">
-            <a:off x="9620250" y="6467475"/>
-            <a:ext cx="1905000" cy="247650"/>
+                <a16:creationId xmlns:a16="http://schemas.microsoft.com/office/drawing/2014/main" id="{B9267471-9507-4759-B525-52EB8DB28006}"/>
+              </a:ext>
+            </a:extLst>
+          </p:cNvPr>
+          <p:cNvSpPr>
+            <a:spLocks xmlns:a="http://schemas.openxmlformats.org/drawingml/2006/main" noGrp="1"/>
+          </p:cNvSpPr>
+          <p:nvPr/>
+        </p:nvSpPr>
+        <p:spPr>
+          <a:xfrm xmlns:a="http://schemas.openxmlformats.org/drawingml/2006/main">
+            <a:off x="10287000" y="6467475"/>
+            <a:ext cx="952500" cy="247650"/>
           </a:xfrm>
           <a:prstGeom xmlns:a="http://schemas.openxmlformats.org/drawingml/2006/main" prst="rect">
             <a:avLst/>
@@ -6146,7 +6136,7 @@
     </p:spTree>
     <p:extLst>
       <p:ext uri="{BB962C8B-B14F-4D97-AF65-F5344CB8AC3E}">
-        <p14:creationId xmlns:p14="http://schemas.microsoft.com/office/powerpoint/2010/main" val="1133181411"/>
+        <p14:creationId xmlns:p14="http://schemas.microsoft.com/office/powerpoint/2010/main" val="2081892443"/>
       </p:ext>
     </p:extLst>
   </p:cSld>
@@ -6177,7 +6167,7 @@
           <p:cNvPr id="36" name="">
             <a:extLst xmlns:a="http://schemas.openxmlformats.org/drawingml/2006/main">
               <a:ext uri="{FF2B5EF4-FFF2-40B4-BE49-F238E27FC236}">
-                <a16:creationId xmlns:a16="http://schemas.microsoft.com/office/drawing/2014/main" id="{DB4D8FAA-7A6E-4DBC-9397-3104448171DC}"/>
+                <a16:creationId xmlns:a16="http://schemas.microsoft.com/office/drawing/2014/main" id="{194CAFBC-0C17-4B19-80E4-CAE07AAB1489}"/>
               </a:ext>
             </a:extLst>
           </p:cNvPr>
@@ -6227,7 +6217,7 @@
           <p:cNvPr id="2" name="">
             <a:extLst xmlns:a="http://schemas.openxmlformats.org/drawingml/2006/main">
               <a:ext uri="{FF2B5EF4-FFF2-40B4-BE49-F238E27FC236}">
-                <a16:creationId xmlns:a16="http://schemas.microsoft.com/office/drawing/2014/main" id="{76F52D2E-C5FD-4CAE-B55F-0296C71F045C}"/>
+                <a16:creationId xmlns:a16="http://schemas.microsoft.com/office/drawing/2014/main" id="{4BAD8C6A-1967-4A4D-BC10-DA994697F33C}"/>
               </a:ext>
             </a:extLst>
           </p:cNvPr>
@@ -6267,7 +6257,7 @@
                   <a:srgbClr val="2F6FE4"/>
                 </a:solidFill>
               </a:rPr>
-              <a:t>PROFESSOR FEEDBACK  •  EVALUATION + TRUST</a:t>
+              <a:t>EVALUATION  •  EXPLAINABILITY  •  ROBUSTNESS</a:t>
             </a:r>
           </a:p>
         </p:txBody>
@@ -6277,7 +6267,7 @@
           <p:cNvPr id="3" name="">
             <a:extLst xmlns:a="http://schemas.openxmlformats.org/drawingml/2006/main">
               <a:ext uri="{FF2B5EF4-FFF2-40B4-BE49-F238E27FC236}">
-                <a16:creationId xmlns:a16="http://schemas.microsoft.com/office/drawing/2014/main" id="{FFAE5BAA-4E5D-455D-AD59-51A1AAEB8AED}"/>
+                <a16:creationId xmlns:a16="http://schemas.microsoft.com/office/drawing/2014/main" id="{5F20CA6B-2A31-4420-8D44-7CEEEC033C80}"/>
               </a:ext>
             </a:extLst>
           </p:cNvPr>
@@ -6327,7 +6317,7 @@
           <p:cNvPr id="4" name="">
             <a:extLst xmlns:a="http://schemas.openxmlformats.org/drawingml/2006/main">
               <a:ext uri="{FF2B5EF4-FFF2-40B4-BE49-F238E27FC236}">
-                <a16:creationId xmlns:a16="http://schemas.microsoft.com/office/drawing/2014/main" id="{5D045B7D-D217-4155-8270-F26C0F6899EE}"/>
+                <a16:creationId xmlns:a16="http://schemas.microsoft.com/office/drawing/2014/main" id="{BE7AF924-5762-4F8E-AA88-13D938DA4519}"/>
               </a:ext>
             </a:extLst>
           </p:cNvPr>
@@ -6360,7 +6350,7 @@
           <p:cNvPr id="5" name="">
             <a:extLst xmlns:a="http://schemas.openxmlformats.org/drawingml/2006/main">
               <a:ext uri="{FF2B5EF4-FFF2-40B4-BE49-F238E27FC236}">
-                <a16:creationId xmlns:a16="http://schemas.microsoft.com/office/drawing/2014/main" id="{5ACE5C06-3D62-4AD3-97A0-BF3780961773}"/>
+                <a16:creationId xmlns:a16="http://schemas.microsoft.com/office/drawing/2014/main" id="{9E0074E4-1B8D-43C2-B043-DA2AB97265C6}"/>
               </a:ext>
             </a:extLst>
           </p:cNvPr>
@@ -6400,7 +6390,7 @@
                   <a:srgbClr val="0A1D30"/>
                 </a:solidFill>
               </a:rPr>
-              <a:t>Every professor comment maps to tested evidence</a:t>
+              <a:t>Evaluation connects accuracy, explanations, and defense</a:t>
             </a:r>
           </a:p>
         </p:txBody>
@@ -6410,7 +6400,7 @@
           <p:cNvPr id="6" name="">
             <a:extLst xmlns:a="http://schemas.openxmlformats.org/drawingml/2006/main">
               <a:ext uri="{FF2B5EF4-FFF2-40B4-BE49-F238E27FC236}">
-                <a16:creationId xmlns:a16="http://schemas.microsoft.com/office/drawing/2014/main" id="{5E7A98A0-DB22-4A7D-94C1-C4BFBE1BDAA2}"/>
+                <a16:creationId xmlns:a16="http://schemas.microsoft.com/office/drawing/2014/main" id="{E363DDAE-EE3D-41DA-B693-9EF698C70FC1}"/>
               </a:ext>
             </a:extLst>
           </p:cNvPr>
@@ -6422,7 +6412,7 @@
         <p:spPr>
           <a:xfrm xmlns:a="http://schemas.openxmlformats.org/drawingml/2006/main">
             <a:off x="685800" y="1485900"/>
-            <a:ext cx="9525000" cy="342900"/>
+            <a:ext cx="10287000" cy="342900"/>
           </a:xfrm>
           <a:prstGeom xmlns:a="http://schemas.openxmlformats.org/drawingml/2006/main" prst="rect">
             <a:avLst/>
@@ -6450,7 +6440,7 @@
                   <a:srgbClr val="657888"/>
                 </a:solidFill>
               </a:rPr>
-              <a:t>Each requested improvement maps to a concrete stage, artifact, and fail-closed rule.</a:t>
+              <a:t>Each analytical claim is connected to reproducible evidence and an operational decision.</a:t>
             </a:r>
           </a:p>
         </p:txBody>
@@ -6460,7 +6450,7 @@
           <p:cNvPr id="7" name="">
             <a:extLst xmlns:a="http://schemas.openxmlformats.org/drawingml/2006/main">
               <a:ext uri="{FF2B5EF4-FFF2-40B4-BE49-F238E27FC236}">
-                <a16:creationId xmlns:a16="http://schemas.microsoft.com/office/drawing/2014/main" id="{F4C0E9E9-AF9F-47C1-9566-DEDF41B2B9A6}"/>
+                <a16:creationId xmlns:a16="http://schemas.microsoft.com/office/drawing/2014/main" id="{F7EA1DF6-1FF7-4EC0-AAC3-92FD56A1F970}"/>
               </a:ext>
             </a:extLst>
           </p:cNvPr>
@@ -6500,7 +6490,7 @@
                   <a:srgbClr val="2F6FE4"/>
                 </a:solidFill>
               </a:rPr>
-              <a:t>REQUEST</a:t>
+              <a:t>ANALYSIS AREA</a:t>
             </a:r>
           </a:p>
         </p:txBody>
@@ -6510,7 +6500,7 @@
           <p:cNvPr id="8" name="">
             <a:extLst xmlns:a="http://schemas.openxmlformats.org/drawingml/2006/main">
               <a:ext uri="{FF2B5EF4-FFF2-40B4-BE49-F238E27FC236}">
-                <a16:creationId xmlns:a16="http://schemas.microsoft.com/office/drawing/2014/main" id="{EFC66608-54F4-41F3-A077-7AC61D987F49}"/>
+                <a16:creationId xmlns:a16="http://schemas.microsoft.com/office/drawing/2014/main" id="{72E8B89E-CE20-4840-995B-9964CCA66121}"/>
               </a:ext>
             </a:extLst>
           </p:cNvPr>
@@ -6550,7 +6540,7 @@
                   <a:srgbClr val="1F9D88"/>
                 </a:solidFill>
               </a:rPr>
-              <a:t>IMPLEMENTED RESPONSE</a:t>
+              <a:t>METHOD</a:t>
             </a:r>
           </a:p>
         </p:txBody>
@@ -6560,7 +6550,7 @@
           <p:cNvPr id="9" name="">
             <a:extLst xmlns:a="http://schemas.openxmlformats.org/drawingml/2006/main">
               <a:ext uri="{FF2B5EF4-FFF2-40B4-BE49-F238E27FC236}">
-                <a16:creationId xmlns:a16="http://schemas.microsoft.com/office/drawing/2014/main" id="{BC1BC8A8-1AE5-4CBC-AFAF-DA1714DA0DC3}"/>
+                <a16:creationId xmlns:a16="http://schemas.microsoft.com/office/drawing/2014/main" id="{C5862E0E-D84F-4DC3-A339-31DC3DD27036}"/>
               </a:ext>
             </a:extLst>
           </p:cNvPr>
@@ -6610,7 +6600,7 @@
           <p:cNvPr id="10" name="">
             <a:extLst xmlns:a="http://schemas.openxmlformats.org/drawingml/2006/main">
               <a:ext uri="{FF2B5EF4-FFF2-40B4-BE49-F238E27FC236}">
-                <a16:creationId xmlns:a16="http://schemas.microsoft.com/office/drawing/2014/main" id="{30740231-8317-4650-B161-A6DA6A61E12E}"/>
+                <a16:creationId xmlns:a16="http://schemas.microsoft.com/office/drawing/2014/main" id="{4064CA6D-A1C3-4EEB-99CE-1E408E9799D4}"/>
               </a:ext>
             </a:extLst>
           </p:cNvPr>
@@ -6643,7 +6633,7 @@
           <p:cNvPr id="11" name="">
             <a:extLst xmlns:a="http://schemas.openxmlformats.org/drawingml/2006/main">
               <a:ext uri="{FF2B5EF4-FFF2-40B4-BE49-F238E27FC236}">
-                <a16:creationId xmlns:a16="http://schemas.microsoft.com/office/drawing/2014/main" id="{AA528900-C3F2-48B7-A1CA-0DBC8D69ECA1}"/>
+                <a16:creationId xmlns:a16="http://schemas.microsoft.com/office/drawing/2014/main" id="{E07B253F-2E78-4F18-8798-E9C676E96268}"/>
               </a:ext>
             </a:extLst>
           </p:cNvPr>
@@ -6693,7 +6683,7 @@
           <p:cNvPr id="12" name="">
             <a:extLst xmlns:a="http://schemas.openxmlformats.org/drawingml/2006/main">
               <a:ext uri="{FF2B5EF4-FFF2-40B4-BE49-F238E27FC236}">
-                <a16:creationId xmlns:a16="http://schemas.microsoft.com/office/drawing/2014/main" id="{4FD2C792-8151-4D3D-9A2B-D22216FE52B6}"/>
+                <a16:creationId xmlns:a16="http://schemas.microsoft.com/office/drawing/2014/main" id="{38484465-F59B-49C1-A7D3-E97EAEE09351}"/>
               </a:ext>
             </a:extLst>
           </p:cNvPr>
@@ -6743,7 +6733,7 @@
           <p:cNvPr id="13" name="">
             <a:extLst xmlns:a="http://schemas.openxmlformats.org/drawingml/2006/main">
               <a:ext uri="{FF2B5EF4-FFF2-40B4-BE49-F238E27FC236}">
-                <a16:creationId xmlns:a16="http://schemas.microsoft.com/office/drawing/2014/main" id="{6A815554-7461-4073-8873-5CF93DBE6C31}"/>
+                <a16:creationId xmlns:a16="http://schemas.microsoft.com/office/drawing/2014/main" id="{EE6BE52C-A029-4E5A-BC71-EC67FC1A3FE6}"/>
               </a:ext>
             </a:extLst>
           </p:cNvPr>
@@ -6793,7 +6783,7 @@
           <p:cNvPr id="14" name="">
             <a:extLst xmlns:a="http://schemas.openxmlformats.org/drawingml/2006/main">
               <a:ext uri="{FF2B5EF4-FFF2-40B4-BE49-F238E27FC236}">
-                <a16:creationId xmlns:a16="http://schemas.microsoft.com/office/drawing/2014/main" id="{A1B6144B-B9EC-427F-98B1-6ECD0373ED43}"/>
+                <a16:creationId xmlns:a16="http://schemas.microsoft.com/office/drawing/2014/main" id="{C1A769FD-F007-49D0-BE80-8237E3F7700A}"/>
               </a:ext>
             </a:extLst>
           </p:cNvPr>
@@ -6833,7 +6823,7 @@
                   <a:srgbClr val="2F6FE4"/>
                 </a:solidFill>
               </a:rPr>
-              <a:t>Phase 5 code + tests</a:t>
+              <a:t>Metric pipeline + tests</a:t>
             </a:r>
           </a:p>
         </p:txBody>
@@ -6843,7 +6833,7 @@
           <p:cNvPr id="15" name="">
             <a:extLst xmlns:a="http://schemas.openxmlformats.org/drawingml/2006/main">
               <a:ext uri="{FF2B5EF4-FFF2-40B4-BE49-F238E27FC236}">
-                <a16:creationId xmlns:a16="http://schemas.microsoft.com/office/drawing/2014/main" id="{8985A988-702B-44BC-9F8D-B8C79FE86796}"/>
+                <a16:creationId xmlns:a16="http://schemas.microsoft.com/office/drawing/2014/main" id="{C10A4161-D34B-4786-BB01-4EF67BE30EA0}"/>
               </a:ext>
             </a:extLst>
           </p:cNvPr>
@@ -6876,7 +6866,7 @@
           <p:cNvPr id="16" name="">
             <a:extLst xmlns:a="http://schemas.openxmlformats.org/drawingml/2006/main">
               <a:ext uri="{FF2B5EF4-FFF2-40B4-BE49-F238E27FC236}">
-                <a16:creationId xmlns:a16="http://schemas.microsoft.com/office/drawing/2014/main" id="{10520D1E-F045-41BB-B591-531A49C64D12}"/>
+                <a16:creationId xmlns:a16="http://schemas.microsoft.com/office/drawing/2014/main" id="{15AE478A-3A48-4802-A3CD-E26638D2240C}"/>
               </a:ext>
             </a:extLst>
           </p:cNvPr>
@@ -6926,7 +6916,7 @@
           <p:cNvPr id="17" name="">
             <a:extLst xmlns:a="http://schemas.openxmlformats.org/drawingml/2006/main">
               <a:ext uri="{FF2B5EF4-FFF2-40B4-BE49-F238E27FC236}">
-                <a16:creationId xmlns:a16="http://schemas.microsoft.com/office/drawing/2014/main" id="{29C3448E-7EF9-416A-8F19-EC903BF8C557}"/>
+                <a16:creationId xmlns:a16="http://schemas.microsoft.com/office/drawing/2014/main" id="{A7844444-DB94-47EE-B906-BFD90C4054CC}"/>
               </a:ext>
             </a:extLst>
           </p:cNvPr>
@@ -6966,7 +6956,7 @@
                   <a:srgbClr val="0A1D30"/>
                 </a:solidFill>
               </a:rPr>
-              <a:t>Beyond SHAP</a:t>
+              <a:t>Explainability</a:t>
             </a:r>
           </a:p>
         </p:txBody>
@@ -6976,7 +6966,7 @@
           <p:cNvPr id="18" name="">
             <a:extLst xmlns:a="http://schemas.openxmlformats.org/drawingml/2006/main">
               <a:ext uri="{FF2B5EF4-FFF2-40B4-BE49-F238E27FC236}">
-                <a16:creationId xmlns:a16="http://schemas.microsoft.com/office/drawing/2014/main" id="{51556D59-EF71-4A20-84F7-4280EBBADCBD}"/>
+                <a16:creationId xmlns:a16="http://schemas.microsoft.com/office/drawing/2014/main" id="{3B348EE6-DBCB-41DF-B46D-A14FE80FA0FD}"/>
               </a:ext>
             </a:extLst>
           </p:cNvPr>
@@ -7026,7 +7016,7 @@
           <p:cNvPr id="19" name="">
             <a:extLst xmlns:a="http://schemas.openxmlformats.org/drawingml/2006/main">
               <a:ext uri="{FF2B5EF4-FFF2-40B4-BE49-F238E27FC236}">
-                <a16:creationId xmlns:a16="http://schemas.microsoft.com/office/drawing/2014/main" id="{A3C5D6AF-EF5B-4AFA-8131-9BE9D871C7AE}"/>
+                <a16:creationId xmlns:a16="http://schemas.microsoft.com/office/drawing/2014/main" id="{178BF13B-0DCA-4E74-9764-0C9C65A116BB}"/>
               </a:ext>
             </a:extLst>
           </p:cNvPr>
@@ -7066,7 +7056,7 @@
                   <a:srgbClr val="1F9D88"/>
                 </a:solidFill>
               </a:rPr>
-              <a:t>Phase 6 code + tests</a:t>
+              <a:t>XAI suite + tests</a:t>
             </a:r>
           </a:p>
         </p:txBody>
@@ -7076,7 +7066,7 @@
           <p:cNvPr id="20" name="">
             <a:extLst xmlns:a="http://schemas.openxmlformats.org/drawingml/2006/main">
               <a:ext uri="{FF2B5EF4-FFF2-40B4-BE49-F238E27FC236}">
-                <a16:creationId xmlns:a16="http://schemas.microsoft.com/office/drawing/2014/main" id="{BF35ED8E-7091-4B88-ABAA-95D765DD1D2F}"/>
+                <a16:creationId xmlns:a16="http://schemas.microsoft.com/office/drawing/2014/main" id="{0BFC4DFF-1BDF-4F23-B00E-2DA6DB0E95D7}"/>
               </a:ext>
             </a:extLst>
           </p:cNvPr>
@@ -7109,7 +7099,7 @@
           <p:cNvPr id="21" name="">
             <a:extLst xmlns:a="http://schemas.openxmlformats.org/drawingml/2006/main">
               <a:ext uri="{FF2B5EF4-FFF2-40B4-BE49-F238E27FC236}">
-                <a16:creationId xmlns:a16="http://schemas.microsoft.com/office/drawing/2014/main" id="{798000F0-15A7-4BF0-A3C1-270F6F3EFA69}"/>
+                <a16:creationId xmlns:a16="http://schemas.microsoft.com/office/drawing/2014/main" id="{23808DF4-9646-4960-8EB7-E53663228D93}"/>
               </a:ext>
             </a:extLst>
           </p:cNvPr>
@@ -7159,7 +7149,7 @@
           <p:cNvPr id="22" name="">
             <a:extLst xmlns:a="http://schemas.openxmlformats.org/drawingml/2006/main">
               <a:ext uri="{FF2B5EF4-FFF2-40B4-BE49-F238E27FC236}">
-                <a16:creationId xmlns:a16="http://schemas.microsoft.com/office/drawing/2014/main" id="{0640AD11-6DF3-44AE-AD82-030F9AF9C084}"/>
+                <a16:creationId xmlns:a16="http://schemas.microsoft.com/office/drawing/2014/main" id="{138A7F17-4CF2-4565-A845-8F1C4921AC22}"/>
               </a:ext>
             </a:extLst>
           </p:cNvPr>
@@ -7199,7 +7189,7 @@
                   <a:srgbClr val="0A1D30"/>
                 </a:solidFill>
               </a:rPr>
-              <a:t>In-depth conclusions</a:t>
+              <a:t>Actionable conclusions</a:t>
             </a:r>
           </a:p>
         </p:txBody>
@@ -7209,7 +7199,7 @@
           <p:cNvPr id="23" name="">
             <a:extLst xmlns:a="http://schemas.openxmlformats.org/drawingml/2006/main">
               <a:ext uri="{FF2B5EF4-FFF2-40B4-BE49-F238E27FC236}">
-                <a16:creationId xmlns:a16="http://schemas.microsoft.com/office/drawing/2014/main" id="{169874AF-FFE4-4E4A-B003-99179B7A31B9}"/>
+                <a16:creationId xmlns:a16="http://schemas.microsoft.com/office/drawing/2014/main" id="{B84FF84B-D3E9-4675-83E0-2A67E778B152}"/>
               </a:ext>
             </a:extLst>
           </p:cNvPr>
@@ -7259,7 +7249,7 @@
           <p:cNvPr id="24" name="">
             <a:extLst xmlns:a="http://schemas.openxmlformats.org/drawingml/2006/main">
               <a:ext uri="{FF2B5EF4-FFF2-40B4-BE49-F238E27FC236}">
-                <a16:creationId xmlns:a16="http://schemas.microsoft.com/office/drawing/2014/main" id="{4D39778A-72E6-4E9F-8BE1-9FBBA9718260}"/>
+                <a16:creationId xmlns:a16="http://schemas.microsoft.com/office/drawing/2014/main" id="{972BC80F-99C4-4423-8020-8B9327AF8401}"/>
               </a:ext>
             </a:extLst>
           </p:cNvPr>
@@ -7299,7 +7289,7 @@
                   <a:srgbClr val="E5A33D"/>
                 </a:solidFill>
               </a:rPr>
-              <a:t>Action rules implemented</a:t>
+              <a:t>Decision rules</a:t>
             </a:r>
           </a:p>
         </p:txBody>
@@ -7309,7 +7299,7 @@
           <p:cNvPr id="25" name="">
             <a:extLst xmlns:a="http://schemas.openxmlformats.org/drawingml/2006/main">
               <a:ext uri="{FF2B5EF4-FFF2-40B4-BE49-F238E27FC236}">
-                <a16:creationId xmlns:a16="http://schemas.microsoft.com/office/drawing/2014/main" id="{FDA46829-C114-4047-AD0F-3A758C331C73}"/>
+                <a16:creationId xmlns:a16="http://schemas.microsoft.com/office/drawing/2014/main" id="{7AB96719-BDE0-462B-B657-F649F0A02F6C}"/>
               </a:ext>
             </a:extLst>
           </p:cNvPr>
@@ -7342,7 +7332,7 @@
           <p:cNvPr id="26" name="">
             <a:extLst xmlns:a="http://schemas.openxmlformats.org/drawingml/2006/main">
               <a:ext uri="{FF2B5EF4-FFF2-40B4-BE49-F238E27FC236}">
-                <a16:creationId xmlns:a16="http://schemas.microsoft.com/office/drawing/2014/main" id="{26EC7C44-8A4D-45A9-A324-DB32B52AA537}"/>
+                <a16:creationId xmlns:a16="http://schemas.microsoft.com/office/drawing/2014/main" id="{0B8E575B-ED29-460A-B513-07C6DEECE576}"/>
               </a:ext>
             </a:extLst>
           </p:cNvPr>
@@ -7392,7 +7382,7 @@
           <p:cNvPr id="27" name="">
             <a:extLst xmlns:a="http://schemas.openxmlformats.org/drawingml/2006/main">
               <a:ext uri="{FF2B5EF4-FFF2-40B4-BE49-F238E27FC236}">
-                <a16:creationId xmlns:a16="http://schemas.microsoft.com/office/drawing/2014/main" id="{86E3F633-8283-4BA6-A4A4-767F116F2D17}"/>
+                <a16:creationId xmlns:a16="http://schemas.microsoft.com/office/drawing/2014/main" id="{34E1BFB2-0490-4A22-8E42-8A564EDA1AF8}"/>
               </a:ext>
             </a:extLst>
           </p:cNvPr>
@@ -7442,7 +7432,7 @@
           <p:cNvPr id="28" name="">
             <a:extLst xmlns:a="http://schemas.openxmlformats.org/drawingml/2006/main">
               <a:ext uri="{FF2B5EF4-FFF2-40B4-BE49-F238E27FC236}">
-                <a16:creationId xmlns:a16="http://schemas.microsoft.com/office/drawing/2014/main" id="{3248461D-6309-48ED-BDFE-860AA8487A89}"/>
+                <a16:creationId xmlns:a16="http://schemas.microsoft.com/office/drawing/2014/main" id="{5AA563C5-B65E-4262-8768-095CF860E0A3}"/>
               </a:ext>
             </a:extLst>
           </p:cNvPr>
@@ -7492,7 +7482,7 @@
           <p:cNvPr id="29" name="">
             <a:extLst xmlns:a="http://schemas.openxmlformats.org/drawingml/2006/main">
               <a:ext uri="{FF2B5EF4-FFF2-40B4-BE49-F238E27FC236}">
-                <a16:creationId xmlns:a16="http://schemas.microsoft.com/office/drawing/2014/main" id="{2DD4F0F1-1FE6-4752-A438-9D30732424B5}"/>
+                <a16:creationId xmlns:a16="http://schemas.microsoft.com/office/drawing/2014/main" id="{BE27D6F1-0589-4179-AB4F-281806BBB179}"/>
               </a:ext>
             </a:extLst>
           </p:cNvPr>
@@ -7532,7 +7522,7 @@
                   <a:srgbClr val="D86565"/>
                 </a:solidFill>
               </a:rPr>
-              <a:t>Phase 7 pre/post harness</a:t>
+              <a:t>Robustness harness</a:t>
             </a:r>
           </a:p>
         </p:txBody>
@@ -7542,7 +7532,7 @@
           <p:cNvPr id="30" name="">
             <a:extLst xmlns:a="http://schemas.openxmlformats.org/drawingml/2006/main">
               <a:ext uri="{FF2B5EF4-FFF2-40B4-BE49-F238E27FC236}">
-                <a16:creationId xmlns:a16="http://schemas.microsoft.com/office/drawing/2014/main" id="{F8CF67BA-7C43-4BB8-A1B6-96B0AF62AE4E}"/>
+                <a16:creationId xmlns:a16="http://schemas.microsoft.com/office/drawing/2014/main" id="{36EB7718-547C-42A1-9DCA-C1A91CB0732C}"/>
               </a:ext>
             </a:extLst>
           </p:cNvPr>
@@ -7575,7 +7565,7 @@
           <p:cNvPr id="31" name="">
             <a:extLst xmlns:a="http://schemas.openxmlformats.org/drawingml/2006/main">
               <a:ext uri="{FF2B5EF4-FFF2-40B4-BE49-F238E27FC236}">
-                <a16:creationId xmlns:a16="http://schemas.microsoft.com/office/drawing/2014/main" id="{4760F143-19AE-4225-85C6-26EFB81E8F7E}"/>
+                <a16:creationId xmlns:a16="http://schemas.microsoft.com/office/drawing/2014/main" id="{A16106F4-B236-44E1-8A10-CE1008D43FE2}"/>
               </a:ext>
             </a:extLst>
           </p:cNvPr>
@@ -7610,7 +7600,7 @@
           <p:cNvPr id="32" name="">
             <a:extLst xmlns:a="http://schemas.openxmlformats.org/drawingml/2006/main">
               <a:ext uri="{FF2B5EF4-FFF2-40B4-BE49-F238E27FC236}">
-                <a16:creationId xmlns:a16="http://schemas.microsoft.com/office/drawing/2014/main" id="{BDC8A94A-768B-4DCF-87E7-39DDC8D9728D}"/>
+                <a16:creationId xmlns:a16="http://schemas.microsoft.com/office/drawing/2014/main" id="{77AFB0EB-B400-47DC-A9EA-2120E8572CD6}"/>
               </a:ext>
             </a:extLst>
           </p:cNvPr>
@@ -7650,7 +7640,7 @@
                   <a:srgbClr val="FFFFFF"/>
                 </a:solidFill>
               </a:rPr>
-              <a:t>Complete traceability: every professor request maps to an implemented stage and reviewed evidence.</a:t>
+              <a:t>Performance, explanations, and defenses form one reproducible evidence chain.</a:t>
             </a:r>
           </a:p>
         </p:txBody>
@@ -7660,7 +7650,7 @@
           <p:cNvPr id="33" name="">
             <a:extLst xmlns:a="http://schemas.openxmlformats.org/drawingml/2006/main">
               <a:ext uri="{FF2B5EF4-FFF2-40B4-BE49-F238E27FC236}">
-                <a16:creationId xmlns:a16="http://schemas.microsoft.com/office/drawing/2014/main" id="{41764A58-E876-4686-8F2B-88D92D435608}"/>
+                <a16:creationId xmlns:a16="http://schemas.microsoft.com/office/drawing/2014/main" id="{3D395988-08C8-4948-9636-097AB1820A90}"/>
               </a:ext>
             </a:extLst>
           </p:cNvPr>
@@ -7693,7 +7683,7 @@
           <p:cNvPr id="34" name="">
             <a:extLst xmlns:a="http://schemas.openxmlformats.org/drawingml/2006/main">
               <a:ext uri="{FF2B5EF4-FFF2-40B4-BE49-F238E27FC236}">
-                <a16:creationId xmlns:a16="http://schemas.microsoft.com/office/drawing/2014/main" id="{B843FB9C-8546-4FB9-B382-CD02E70C6B44}"/>
+                <a16:creationId xmlns:a16="http://schemas.microsoft.com/office/drawing/2014/main" id="{AEDFAFFF-CF35-45CB-99F0-442038AD28CC}"/>
               </a:ext>
             </a:extLst>
           </p:cNvPr>
@@ -7705,7 +7695,7 @@
         <p:spPr>
           <a:xfrm xmlns:a="http://schemas.openxmlformats.org/drawingml/2006/main">
             <a:off x="647700" y="6496050"/>
-            <a:ext cx="9715500" cy="190500"/>
+            <a:ext cx="8953500" cy="190500"/>
           </a:xfrm>
           <a:prstGeom xmlns:a="http://schemas.openxmlformats.org/drawingml/2006/main" prst="rect">
             <a:avLst/>
@@ -7733,7 +7723,7 @@
                   <a:srgbClr val="657888"/>
                 </a:solidFill>
               </a:rPr>
-              <a:t>Author-verified results, deep explanations, and defense analysis are documented together.</a:t>
+              <a:t>The workflow closes with monitored decisions, safe abstention, and layered defense.</a:t>
             </a:r>
           </a:p>
         </p:txBody>
@@ -7743,19 +7733,19 @@
           <p:cNvPr id="35" name="">
             <a:extLst xmlns:a="http://schemas.openxmlformats.org/drawingml/2006/main">
               <a:ext uri="{FF2B5EF4-FFF2-40B4-BE49-F238E27FC236}">
-                <a16:creationId xmlns:a16="http://schemas.microsoft.com/office/drawing/2014/main" id="{6FF131E7-2625-4553-82BB-897E2AF8917F}"/>
-              </a:ext>
-            </a:extLst>
-          </p:cNvPr>
-          <p:cNvSpPr>
-            <a:spLocks xmlns:a="http://schemas.openxmlformats.org/drawingml/2006/main" noGrp="1"/>
-          </p:cNvSpPr>
-          <p:nvPr/>
-        </p:nvSpPr>
-        <p:spPr>
-          <a:xfrm xmlns:a="http://schemas.openxmlformats.org/drawingml/2006/main">
-            <a:off x="9620250" y="6467475"/>
-            <a:ext cx="1905000" cy="247650"/>
+                <a16:creationId xmlns:a16="http://schemas.microsoft.com/office/drawing/2014/main" id="{EECCDE2F-D734-4320-B8FF-1DA4AD12503C}"/>
+              </a:ext>
+            </a:extLst>
+          </p:cNvPr>
+          <p:cNvSpPr>
+            <a:spLocks xmlns:a="http://schemas.openxmlformats.org/drawingml/2006/main" noGrp="1"/>
+          </p:cNvSpPr>
+          <p:nvPr/>
+        </p:nvSpPr>
+        <p:spPr>
+          <a:xfrm xmlns:a="http://schemas.openxmlformats.org/drawingml/2006/main">
+            <a:off x="10287000" y="6467475"/>
+            <a:ext cx="952500" cy="247650"/>
           </a:xfrm>
           <a:prstGeom xmlns:a="http://schemas.openxmlformats.org/drawingml/2006/main" prst="rect">
             <a:avLst/>
@@ -7791,7 +7781,7 @@
     </p:spTree>
     <p:extLst>
       <p:ext uri="{BB962C8B-B14F-4D97-AF65-F5344CB8AC3E}">
-        <p14:creationId xmlns:p14="http://schemas.microsoft.com/office/powerpoint/2010/main" val="2106137065"/>
+        <p14:creationId xmlns:p14="http://schemas.microsoft.com/office/powerpoint/2010/main" val="2102274031"/>
       </p:ext>
     </p:extLst>
   </p:cSld>
@@ -7822,7 +7812,7 @@
           <p:cNvPr id="29" name="">
             <a:extLst xmlns:a="http://schemas.openxmlformats.org/drawingml/2006/main">
               <a:ext uri="{FF2B5EF4-FFF2-40B4-BE49-F238E27FC236}">
-                <a16:creationId xmlns:a16="http://schemas.microsoft.com/office/drawing/2014/main" id="{C6207522-AEF1-41E3-B13C-074095E347B8}"/>
+                <a16:creationId xmlns:a16="http://schemas.microsoft.com/office/drawing/2014/main" id="{3D282568-0C69-4BC1-B86C-FC853E837A3D}"/>
               </a:ext>
             </a:extLst>
           </p:cNvPr>
@@ -7872,7 +7862,7 @@
           <p:cNvPr id="2" name="">
             <a:extLst xmlns:a="http://schemas.openxmlformats.org/drawingml/2006/main">
               <a:ext uri="{FF2B5EF4-FFF2-40B4-BE49-F238E27FC236}">
-                <a16:creationId xmlns:a16="http://schemas.microsoft.com/office/drawing/2014/main" id="{7339D5D5-D06E-4378-A9E3-A2FBCA100AE1}"/>
+                <a16:creationId xmlns:a16="http://schemas.microsoft.com/office/drawing/2014/main" id="{C09EE9F6-0386-4BAE-ABF9-F53DADFF31FF}"/>
               </a:ext>
             </a:extLst>
           </p:cNvPr>
@@ -7922,7 +7912,7 @@
           <p:cNvPr id="3" name="">
             <a:extLst xmlns:a="http://schemas.openxmlformats.org/drawingml/2006/main">
               <a:ext uri="{FF2B5EF4-FFF2-40B4-BE49-F238E27FC236}">
-                <a16:creationId xmlns:a16="http://schemas.microsoft.com/office/drawing/2014/main" id="{8CFE70B0-C572-414C-90BC-9FC6BCAA372F}"/>
+                <a16:creationId xmlns:a16="http://schemas.microsoft.com/office/drawing/2014/main" id="{CA3D2F6F-757F-4866-A5BC-89B5F51D7D8B}"/>
               </a:ext>
             </a:extLst>
           </p:cNvPr>
@@ -7972,7 +7962,7 @@
           <p:cNvPr id="4" name="">
             <a:extLst xmlns:a="http://schemas.openxmlformats.org/drawingml/2006/main">
               <a:ext uri="{FF2B5EF4-FFF2-40B4-BE49-F238E27FC236}">
-                <a16:creationId xmlns:a16="http://schemas.microsoft.com/office/drawing/2014/main" id="{2232C82A-A72B-490B-AFE7-50FFB39874B3}"/>
+                <a16:creationId xmlns:a16="http://schemas.microsoft.com/office/drawing/2014/main" id="{9CAA4BF2-2FA0-4171-A907-71A8139B4560}"/>
               </a:ext>
             </a:extLst>
           </p:cNvPr>
@@ -8005,7 +7995,7 @@
           <p:cNvPr id="5" name="">
             <a:extLst xmlns:a="http://schemas.openxmlformats.org/drawingml/2006/main">
               <a:ext uri="{FF2B5EF4-FFF2-40B4-BE49-F238E27FC236}">
-                <a16:creationId xmlns:a16="http://schemas.microsoft.com/office/drawing/2014/main" id="{7B25198C-ED55-4CC3-94DA-29F6721494E1}"/>
+                <a16:creationId xmlns:a16="http://schemas.microsoft.com/office/drawing/2014/main" id="{095C1B85-BD9F-49DA-8310-83F74E397158}"/>
               </a:ext>
             </a:extLst>
           </p:cNvPr>
@@ -8055,7 +8045,7 @@
           <p:cNvPr id="6" name="">
             <a:extLst xmlns:a="http://schemas.openxmlformats.org/drawingml/2006/main">
               <a:ext uri="{FF2B5EF4-FFF2-40B4-BE49-F238E27FC236}">
-                <a16:creationId xmlns:a16="http://schemas.microsoft.com/office/drawing/2014/main" id="{572E3A14-3591-4AFD-9E68-CDB2903289DD}"/>
+                <a16:creationId xmlns:a16="http://schemas.microsoft.com/office/drawing/2014/main" id="{BD0D9572-02BD-4274-BA19-AE2DB538AC5A}"/>
               </a:ext>
             </a:extLst>
           </p:cNvPr>
@@ -8105,7 +8095,7 @@
           <p:cNvPr id="7" name="">
             <a:extLst xmlns:a="http://schemas.openxmlformats.org/drawingml/2006/main">
               <a:ext uri="{FF2B5EF4-FFF2-40B4-BE49-F238E27FC236}">
-                <a16:creationId xmlns:a16="http://schemas.microsoft.com/office/drawing/2014/main" id="{72A29C55-8B46-4603-9D6D-3754521B28C2}"/>
+                <a16:creationId xmlns:a16="http://schemas.microsoft.com/office/drawing/2014/main" id="{1454FDA5-651E-4974-81CF-87E429D8B56B}"/>
               </a:ext>
             </a:extLst>
           </p:cNvPr>
@@ -8155,7 +8145,7 @@
           <p:cNvPr id="8" name="">
             <a:extLst xmlns:a="http://schemas.openxmlformats.org/drawingml/2006/main">
               <a:ext uri="{FF2B5EF4-FFF2-40B4-BE49-F238E27FC236}">
-                <a16:creationId xmlns:a16="http://schemas.microsoft.com/office/drawing/2014/main" id="{9BDCDF69-4677-4759-9AE6-B70B9D0931D2}"/>
+                <a16:creationId xmlns:a16="http://schemas.microsoft.com/office/drawing/2014/main" id="{924C7CC5-60E2-4321-84EB-37B8887BA2D7}"/>
               </a:ext>
             </a:extLst>
           </p:cNvPr>
@@ -8205,7 +8195,7 @@
           <p:cNvPr id="9" name="">
             <a:extLst xmlns:a="http://schemas.openxmlformats.org/drawingml/2006/main">
               <a:ext uri="{FF2B5EF4-FFF2-40B4-BE49-F238E27FC236}">
-                <a16:creationId xmlns:a16="http://schemas.microsoft.com/office/drawing/2014/main" id="{EC382ED7-4AB1-4FCB-B7F4-5E3EBC3EE7ED}"/>
+                <a16:creationId xmlns:a16="http://schemas.microsoft.com/office/drawing/2014/main" id="{DA56AA92-4C5F-4105-9406-5DBC36CFB03B}"/>
               </a:ext>
             </a:extLst>
           </p:cNvPr>
@@ -8255,7 +8245,7 @@
           <p:cNvPr id="10" name="">
             <a:extLst xmlns:a="http://schemas.openxmlformats.org/drawingml/2006/main">
               <a:ext uri="{FF2B5EF4-FFF2-40B4-BE49-F238E27FC236}">
-                <a16:creationId xmlns:a16="http://schemas.microsoft.com/office/drawing/2014/main" id="{057F5117-3B79-4518-9483-7F67ADFE7D0B}"/>
+                <a16:creationId xmlns:a16="http://schemas.microsoft.com/office/drawing/2014/main" id="{C995421F-AB9A-4478-BA86-E7454B1465EA}"/>
               </a:ext>
             </a:extLst>
           </p:cNvPr>
@@ -8305,7 +8295,7 @@
           <p:cNvPr id="11" name="">
             <a:extLst xmlns:a="http://schemas.openxmlformats.org/drawingml/2006/main">
               <a:ext uri="{FF2B5EF4-FFF2-40B4-BE49-F238E27FC236}">
-                <a16:creationId xmlns:a16="http://schemas.microsoft.com/office/drawing/2014/main" id="{2370FF74-E458-4BF1-AD12-ECF503840CFA}"/>
+                <a16:creationId xmlns:a16="http://schemas.microsoft.com/office/drawing/2014/main" id="{67FB0AA7-DA73-4116-877C-92CCF6ABACB4}"/>
               </a:ext>
             </a:extLst>
           </p:cNvPr>
@@ -8355,7 +8345,7 @@
           <p:cNvPr id="12" name="">
             <a:extLst xmlns:a="http://schemas.openxmlformats.org/drawingml/2006/main">
               <a:ext uri="{FF2B5EF4-FFF2-40B4-BE49-F238E27FC236}">
-                <a16:creationId xmlns:a16="http://schemas.microsoft.com/office/drawing/2014/main" id="{E23847CE-2CAF-4D0C-B193-4D12D23EA7C1}"/>
+                <a16:creationId xmlns:a16="http://schemas.microsoft.com/office/drawing/2014/main" id="{8FE3317A-B268-46E2-B44A-B453D34EA284}"/>
               </a:ext>
             </a:extLst>
           </p:cNvPr>
@@ -8388,7 +8378,7 @@
           <p:cNvPr id="13" name="">
             <a:extLst xmlns:a="http://schemas.openxmlformats.org/drawingml/2006/main">
               <a:ext uri="{FF2B5EF4-FFF2-40B4-BE49-F238E27FC236}">
-                <a16:creationId xmlns:a16="http://schemas.microsoft.com/office/drawing/2014/main" id="{570D96F0-9F71-4DAD-94EA-D007A5254A3F}"/>
+                <a16:creationId xmlns:a16="http://schemas.microsoft.com/office/drawing/2014/main" id="{E22AFFF2-F3D6-41A1-B398-FB3EA44E4913}"/>
               </a:ext>
             </a:extLst>
           </p:cNvPr>
@@ -8421,7 +8411,7 @@
           <p:cNvPr id="14" name="">
             <a:extLst xmlns:a="http://schemas.openxmlformats.org/drawingml/2006/main">
               <a:ext uri="{FF2B5EF4-FFF2-40B4-BE49-F238E27FC236}">
-                <a16:creationId xmlns:a16="http://schemas.microsoft.com/office/drawing/2014/main" id="{31F953B0-371E-4528-A93B-E00496B2C0FF}"/>
+                <a16:creationId xmlns:a16="http://schemas.microsoft.com/office/drawing/2014/main" id="{68853299-403E-467F-877B-33644C06A866}"/>
               </a:ext>
             </a:extLst>
           </p:cNvPr>
@@ -8454,7 +8444,7 @@
           <p:cNvPr id="15" name="">
             <a:extLst xmlns:a="http://schemas.openxmlformats.org/drawingml/2006/main">
               <a:ext uri="{FF2B5EF4-FFF2-40B4-BE49-F238E27FC236}">
-                <a16:creationId xmlns:a16="http://schemas.microsoft.com/office/drawing/2014/main" id="{EC235D62-C501-403A-A0EE-EA633FA233C8}"/>
+                <a16:creationId xmlns:a16="http://schemas.microsoft.com/office/drawing/2014/main" id="{1004D866-21B2-4593-94CA-23224955D4F4}"/>
               </a:ext>
             </a:extLst>
           </p:cNvPr>
@@ -8487,7 +8477,7 @@
           <p:cNvPr id="16" name="">
             <a:extLst xmlns:a="http://schemas.openxmlformats.org/drawingml/2006/main">
               <a:ext uri="{FF2B5EF4-FFF2-40B4-BE49-F238E27FC236}">
-                <a16:creationId xmlns:a16="http://schemas.microsoft.com/office/drawing/2014/main" id="{9327B77A-124B-449C-9E58-3855BB4E7F09}"/>
+                <a16:creationId xmlns:a16="http://schemas.microsoft.com/office/drawing/2014/main" id="{6CCCEBB0-9CE2-44CA-B658-ED724423D418}"/>
               </a:ext>
             </a:extLst>
           </p:cNvPr>
@@ -8520,7 +8510,7 @@
           <p:cNvPr id="17" name="">
             <a:extLst xmlns:a="http://schemas.openxmlformats.org/drawingml/2006/main">
               <a:ext uri="{FF2B5EF4-FFF2-40B4-BE49-F238E27FC236}">
-                <a16:creationId xmlns:a16="http://schemas.microsoft.com/office/drawing/2014/main" id="{98DD3D1B-8EA5-481E-82E4-0554EA2A27A3}"/>
+                <a16:creationId xmlns:a16="http://schemas.microsoft.com/office/drawing/2014/main" id="{A71C28D1-84F8-42FF-B0CA-DC21CB4E58B6}"/>
               </a:ext>
             </a:extLst>
           </p:cNvPr>
@@ -8553,7 +8543,7 @@
           <p:cNvPr id="18" name="">
             <a:extLst xmlns:a="http://schemas.openxmlformats.org/drawingml/2006/main">
               <a:ext uri="{FF2B5EF4-FFF2-40B4-BE49-F238E27FC236}">
-                <a16:creationId xmlns:a16="http://schemas.microsoft.com/office/drawing/2014/main" id="{0F34D71F-5E3E-45E9-B4C7-6F6BF46D7C51}"/>
+                <a16:creationId xmlns:a16="http://schemas.microsoft.com/office/drawing/2014/main" id="{60F9B095-8AA6-4FF7-AE1E-40FCE5D32B42}"/>
               </a:ext>
             </a:extLst>
           </p:cNvPr>
@@ -8603,7 +8593,7 @@
           <p:cNvPr id="19" name="">
             <a:extLst xmlns:a="http://schemas.openxmlformats.org/drawingml/2006/main">
               <a:ext uri="{FF2B5EF4-FFF2-40B4-BE49-F238E27FC236}">
-                <a16:creationId xmlns:a16="http://schemas.microsoft.com/office/drawing/2014/main" id="{281CCB92-AC36-407F-8FF9-098740065967}"/>
+                <a16:creationId xmlns:a16="http://schemas.microsoft.com/office/drawing/2014/main" id="{38F38AF5-979B-47E6-B802-CEDED00CCC26}"/>
               </a:ext>
             </a:extLst>
           </p:cNvPr>
@@ -8670,7 +8660,7 @@
           <p:cNvPr id="20" name="">
             <a:extLst xmlns:a="http://schemas.openxmlformats.org/drawingml/2006/main">
               <a:ext uri="{FF2B5EF4-FFF2-40B4-BE49-F238E27FC236}">
-                <a16:creationId xmlns:a16="http://schemas.microsoft.com/office/drawing/2014/main" id="{DE1541D6-37C6-47DE-ADDF-110921CAABBE}"/>
+                <a16:creationId xmlns:a16="http://schemas.microsoft.com/office/drawing/2014/main" id="{C2F0EC3A-6710-4519-85B1-8A4FDAF04673}"/>
               </a:ext>
             </a:extLst>
           </p:cNvPr>
@@ -8720,7 +8710,7 @@
           <p:cNvPr id="21" name="">
             <a:extLst xmlns:a="http://schemas.openxmlformats.org/drawingml/2006/main">
               <a:ext uri="{FF2B5EF4-FFF2-40B4-BE49-F238E27FC236}">
-                <a16:creationId xmlns:a16="http://schemas.microsoft.com/office/drawing/2014/main" id="{C5C13B52-F1DE-4F9A-92DC-BD59B0149FE5}"/>
+                <a16:creationId xmlns:a16="http://schemas.microsoft.com/office/drawing/2014/main" id="{3AA25BF0-D52B-4F4C-AA71-2AC2B2521E56}"/>
               </a:ext>
             </a:extLst>
           </p:cNvPr>
@@ -8787,7 +8777,7 @@
           <p:cNvPr id="22" name="">
             <a:extLst xmlns:a="http://schemas.openxmlformats.org/drawingml/2006/main">
               <a:ext uri="{FF2B5EF4-FFF2-40B4-BE49-F238E27FC236}">
-                <a16:creationId xmlns:a16="http://schemas.microsoft.com/office/drawing/2014/main" id="{D426E5D6-FD81-4DDB-B9F3-8B6941C1E18D}"/>
+                <a16:creationId xmlns:a16="http://schemas.microsoft.com/office/drawing/2014/main" id="{93EB9D34-B715-4F98-81DE-C05693078A9F}"/>
               </a:ext>
             </a:extLst>
           </p:cNvPr>
@@ -8837,7 +8827,7 @@
           <p:cNvPr id="23" name="">
             <a:extLst xmlns:a="http://schemas.openxmlformats.org/drawingml/2006/main">
               <a:ext uri="{FF2B5EF4-FFF2-40B4-BE49-F238E27FC236}">
-                <a16:creationId xmlns:a16="http://schemas.microsoft.com/office/drawing/2014/main" id="{AD88DA3B-4D18-47CF-868F-775D42604AA7}"/>
+                <a16:creationId xmlns:a16="http://schemas.microsoft.com/office/drawing/2014/main" id="{92B520A1-0F24-4153-A514-43A7916170C6}"/>
               </a:ext>
             </a:extLst>
           </p:cNvPr>
@@ -8904,7 +8894,7 @@
           <p:cNvPr id="24" name="">
             <a:extLst xmlns:a="http://schemas.openxmlformats.org/drawingml/2006/main">
               <a:ext uri="{FF2B5EF4-FFF2-40B4-BE49-F238E27FC236}">
-                <a16:creationId xmlns:a16="http://schemas.microsoft.com/office/drawing/2014/main" id="{E22CF925-0E55-4672-B510-7641ECF13430}"/>
+                <a16:creationId xmlns:a16="http://schemas.microsoft.com/office/drawing/2014/main" id="{83ED0412-3373-4F7D-A16A-62A749B56A38}"/>
               </a:ext>
             </a:extLst>
           </p:cNvPr>
@@ -8954,7 +8944,7 @@
           <p:cNvPr id="25" name="">
             <a:extLst xmlns:a="http://schemas.openxmlformats.org/drawingml/2006/main">
               <a:ext uri="{FF2B5EF4-FFF2-40B4-BE49-F238E27FC236}">
-                <a16:creationId xmlns:a16="http://schemas.microsoft.com/office/drawing/2014/main" id="{CB7CB2C6-1D24-4E48-B2AE-3F897568CF85}"/>
+                <a16:creationId xmlns:a16="http://schemas.microsoft.com/office/drawing/2014/main" id="{1258EFA6-6504-4ADB-81AE-1E582ABC484B}"/>
               </a:ext>
             </a:extLst>
           </p:cNvPr>
@@ -9004,7 +8994,7 @@
           <p:cNvPr id="26" name="">
             <a:extLst xmlns:a="http://schemas.openxmlformats.org/drawingml/2006/main">
               <a:ext uri="{FF2B5EF4-FFF2-40B4-BE49-F238E27FC236}">
-                <a16:creationId xmlns:a16="http://schemas.microsoft.com/office/drawing/2014/main" id="{26811A22-DACD-4D02-8062-8E3B3B12403C}"/>
+                <a16:creationId xmlns:a16="http://schemas.microsoft.com/office/drawing/2014/main" id="{E7921341-E21E-48C8-B0C1-BFB8ED0F293A}"/>
               </a:ext>
             </a:extLst>
           </p:cNvPr>
@@ -9037,7 +9027,7 @@
           <p:cNvPr id="27" name="">
             <a:extLst xmlns:a="http://schemas.openxmlformats.org/drawingml/2006/main">
               <a:ext uri="{FF2B5EF4-FFF2-40B4-BE49-F238E27FC236}">
-                <a16:creationId xmlns:a16="http://schemas.microsoft.com/office/drawing/2014/main" id="{BA274C87-8620-489C-98F1-BFCA38198E68}"/>
+                <a16:creationId xmlns:a16="http://schemas.microsoft.com/office/drawing/2014/main" id="{704A93E9-5771-496D-B17B-35E05995D9D4}"/>
               </a:ext>
             </a:extLst>
           </p:cNvPr>
@@ -9049,7 +9039,7 @@
         <p:spPr>
           <a:xfrm xmlns:a="http://schemas.openxmlformats.org/drawingml/2006/main">
             <a:off x="647700" y="6496050"/>
-            <a:ext cx="9715500" cy="190500"/>
+            <a:ext cx="8953500" cy="190500"/>
           </a:xfrm>
           <a:prstGeom xmlns:a="http://schemas.openxmlformats.org/drawingml/2006/main" prst="rect">
             <a:avLst/>
@@ -9087,19 +9077,19 @@
           <p:cNvPr id="28" name="">
             <a:extLst xmlns:a="http://schemas.openxmlformats.org/drawingml/2006/main">
               <a:ext uri="{FF2B5EF4-FFF2-40B4-BE49-F238E27FC236}">
-                <a16:creationId xmlns:a16="http://schemas.microsoft.com/office/drawing/2014/main" id="{6E110503-7D3D-400B-AC44-34D0E7E2DD06}"/>
-              </a:ext>
-            </a:extLst>
-          </p:cNvPr>
-          <p:cNvSpPr>
-            <a:spLocks xmlns:a="http://schemas.openxmlformats.org/drawingml/2006/main" noGrp="1"/>
-          </p:cNvSpPr>
-          <p:nvPr/>
-        </p:nvSpPr>
-        <p:spPr>
-          <a:xfrm xmlns:a="http://schemas.openxmlformats.org/drawingml/2006/main">
-            <a:off x="9620250" y="6467475"/>
-            <a:ext cx="1905000" cy="247650"/>
+                <a16:creationId xmlns:a16="http://schemas.microsoft.com/office/drawing/2014/main" id="{57ED21A9-B06B-4ED5-9135-F346A4B3C34C}"/>
+              </a:ext>
+            </a:extLst>
+          </p:cNvPr>
+          <p:cNvSpPr>
+            <a:spLocks xmlns:a="http://schemas.openxmlformats.org/drawingml/2006/main" noGrp="1"/>
+          </p:cNvSpPr>
+          <p:nvPr/>
+        </p:nvSpPr>
+        <p:spPr>
+          <a:xfrm xmlns:a="http://schemas.openxmlformats.org/drawingml/2006/main">
+            <a:off x="10287000" y="6467475"/>
+            <a:ext cx="952500" cy="247650"/>
           </a:xfrm>
           <a:prstGeom xmlns:a="http://schemas.openxmlformats.org/drawingml/2006/main" prst="rect">
             <a:avLst/>
@@ -9135,7 +9125,7 @@
     </p:spTree>
     <p:extLst>
       <p:ext uri="{BB962C8B-B14F-4D97-AF65-F5344CB8AC3E}">
-        <p14:creationId xmlns:p14="http://schemas.microsoft.com/office/powerpoint/2010/main" val="1147769967"/>
+        <p14:creationId xmlns:p14="http://schemas.microsoft.com/office/powerpoint/2010/main" val="1466898423"/>
       </p:ext>
     </p:extLst>
   </p:cSld>
@@ -9166,7 +9156,7 @@
           <p:cNvPr id="39" name="">
             <a:extLst xmlns:a="http://schemas.openxmlformats.org/drawingml/2006/main">
               <a:ext uri="{FF2B5EF4-FFF2-40B4-BE49-F238E27FC236}">
-                <a16:creationId xmlns:a16="http://schemas.microsoft.com/office/drawing/2014/main" id="{A5617412-F515-4C28-BA94-9169752EF7C8}"/>
+                <a16:creationId xmlns:a16="http://schemas.microsoft.com/office/drawing/2014/main" id="{AE0893B7-6449-4C8F-A86F-0BD05F39377B}"/>
               </a:ext>
             </a:extLst>
           </p:cNvPr>
@@ -9216,7 +9206,7 @@
           <p:cNvPr id="2" name="">
             <a:extLst xmlns:a="http://schemas.openxmlformats.org/drawingml/2006/main">
               <a:ext uri="{FF2B5EF4-FFF2-40B4-BE49-F238E27FC236}">
-                <a16:creationId xmlns:a16="http://schemas.microsoft.com/office/drawing/2014/main" id="{3B870FD0-1E1C-4C43-80AB-09A4A5DCF856}"/>
+                <a16:creationId xmlns:a16="http://schemas.microsoft.com/office/drawing/2014/main" id="{E05FD22E-2DF0-4B89-80C6-0854B271FBDA}"/>
               </a:ext>
             </a:extLst>
           </p:cNvPr>
@@ -9266,7 +9256,7 @@
           <p:cNvPr id="3" name="">
             <a:extLst xmlns:a="http://schemas.openxmlformats.org/drawingml/2006/main">
               <a:ext uri="{FF2B5EF4-FFF2-40B4-BE49-F238E27FC236}">
-                <a16:creationId xmlns:a16="http://schemas.microsoft.com/office/drawing/2014/main" id="{7726789A-B4E1-41CD-9A3C-9884F84C0084}"/>
+                <a16:creationId xmlns:a16="http://schemas.microsoft.com/office/drawing/2014/main" id="{6EA5D685-8DC8-40A3-96B0-89009AA6AA24}"/>
               </a:ext>
             </a:extLst>
           </p:cNvPr>
@@ -9316,7 +9306,7 @@
           <p:cNvPr id="4" name="">
             <a:extLst xmlns:a="http://schemas.openxmlformats.org/drawingml/2006/main">
               <a:ext uri="{FF2B5EF4-FFF2-40B4-BE49-F238E27FC236}">
-                <a16:creationId xmlns:a16="http://schemas.microsoft.com/office/drawing/2014/main" id="{4C87B988-42BB-49C2-9244-4AA1ACEB3CE2}"/>
+                <a16:creationId xmlns:a16="http://schemas.microsoft.com/office/drawing/2014/main" id="{6A1F7767-FE8E-42D6-9028-FB40C8714931}"/>
               </a:ext>
             </a:extLst>
           </p:cNvPr>
@@ -9349,7 +9339,7 @@
           <p:cNvPr id="5" name="">
             <a:extLst xmlns:a="http://schemas.openxmlformats.org/drawingml/2006/main">
               <a:ext uri="{FF2B5EF4-FFF2-40B4-BE49-F238E27FC236}">
-                <a16:creationId xmlns:a16="http://schemas.microsoft.com/office/drawing/2014/main" id="{745B5E45-5C70-4149-A25E-F1DC4475F07D}"/>
+                <a16:creationId xmlns:a16="http://schemas.microsoft.com/office/drawing/2014/main" id="{F0C0E4B3-27D0-4F07-A0E6-7B41E6934E4D}"/>
               </a:ext>
             </a:extLst>
           </p:cNvPr>
@@ -9399,7 +9389,7 @@
           <p:cNvPr id="6" name="">
             <a:extLst xmlns:a="http://schemas.openxmlformats.org/drawingml/2006/main">
               <a:ext uri="{FF2B5EF4-FFF2-40B4-BE49-F238E27FC236}">
-                <a16:creationId xmlns:a16="http://schemas.microsoft.com/office/drawing/2014/main" id="{1F84C327-1E2A-422E-B137-156B66193956}"/>
+                <a16:creationId xmlns:a16="http://schemas.microsoft.com/office/drawing/2014/main" id="{B4E73468-3F23-44F6-B9C6-78192A6C6C93}"/>
               </a:ext>
             </a:extLst>
           </p:cNvPr>
@@ -9449,7 +9439,7 @@
           <p:cNvPr id="7" name="">
             <a:extLst xmlns:a="http://schemas.openxmlformats.org/drawingml/2006/main">
               <a:ext uri="{FF2B5EF4-FFF2-40B4-BE49-F238E27FC236}">
-                <a16:creationId xmlns:a16="http://schemas.microsoft.com/office/drawing/2014/main" id="{E6D68032-D1CA-4889-8172-08B4594A0B77}"/>
+                <a16:creationId xmlns:a16="http://schemas.microsoft.com/office/drawing/2014/main" id="{24A0C19D-7D88-4B48-A49D-2169ACE1C463}"/>
               </a:ext>
             </a:extLst>
           </p:cNvPr>
@@ -9499,7 +9489,7 @@
           <p:cNvPr id="8" name="">
             <a:extLst xmlns:a="http://schemas.openxmlformats.org/drawingml/2006/main">
               <a:ext uri="{FF2B5EF4-FFF2-40B4-BE49-F238E27FC236}">
-                <a16:creationId xmlns:a16="http://schemas.microsoft.com/office/drawing/2014/main" id="{74CCA37A-1DAB-483C-A635-A045FA5B2B7E}"/>
+                <a16:creationId xmlns:a16="http://schemas.microsoft.com/office/drawing/2014/main" id="{201A21D8-F036-40D6-9EAF-93FAB870B4EC}"/>
               </a:ext>
             </a:extLst>
           </p:cNvPr>
@@ -9532,7 +9522,7 @@
           <p:cNvPr id="9" name="">
             <a:extLst xmlns:a="http://schemas.openxmlformats.org/drawingml/2006/main">
               <a:ext uri="{FF2B5EF4-FFF2-40B4-BE49-F238E27FC236}">
-                <a16:creationId xmlns:a16="http://schemas.microsoft.com/office/drawing/2014/main" id="{9AB13994-BDEE-4A25-889B-0FD9ED5A1318}"/>
+                <a16:creationId xmlns:a16="http://schemas.microsoft.com/office/drawing/2014/main" id="{CA4DA4E7-D045-425C-9C01-C98BB630841A}"/>
               </a:ext>
             </a:extLst>
           </p:cNvPr>
@@ -9565,7 +9555,7 @@
           <p:cNvPr id="10" name="">
             <a:extLst xmlns:a="http://schemas.openxmlformats.org/drawingml/2006/main">
               <a:ext uri="{FF2B5EF4-FFF2-40B4-BE49-F238E27FC236}">
-                <a16:creationId xmlns:a16="http://schemas.microsoft.com/office/drawing/2014/main" id="{A7505073-9932-450F-B270-CCE4279842EB}"/>
+                <a16:creationId xmlns:a16="http://schemas.microsoft.com/office/drawing/2014/main" id="{62461D95-1342-4AD8-B397-62039663614F}"/>
               </a:ext>
             </a:extLst>
           </p:cNvPr>
@@ -9598,7 +9588,7 @@
           <p:cNvPr id="11" name="">
             <a:extLst xmlns:a="http://schemas.openxmlformats.org/drawingml/2006/main">
               <a:ext uri="{FF2B5EF4-FFF2-40B4-BE49-F238E27FC236}">
-                <a16:creationId xmlns:a16="http://schemas.microsoft.com/office/drawing/2014/main" id="{6C25A79A-5C40-421F-BD51-5D34A47B3E4E}"/>
+                <a16:creationId xmlns:a16="http://schemas.microsoft.com/office/drawing/2014/main" id="{BC34EA8F-3DB3-451C-A602-03202139BC9D}"/>
               </a:ext>
             </a:extLst>
           </p:cNvPr>
@@ -9631,7 +9621,7 @@
           <p:cNvPr id="12" name="">
             <a:extLst xmlns:a="http://schemas.openxmlformats.org/drawingml/2006/main">
               <a:ext uri="{FF2B5EF4-FFF2-40B4-BE49-F238E27FC236}">
-                <a16:creationId xmlns:a16="http://schemas.microsoft.com/office/drawing/2014/main" id="{78ADC5E1-D0C8-407E-8F31-E2A627F8FE38}"/>
+                <a16:creationId xmlns:a16="http://schemas.microsoft.com/office/drawing/2014/main" id="{3AD41502-E3F0-4F7C-B26E-0A8F381E6778}"/>
               </a:ext>
             </a:extLst>
           </p:cNvPr>
@@ -9666,7 +9656,7 @@
           <p:cNvPr id="13" name="">
             <a:extLst xmlns:a="http://schemas.openxmlformats.org/drawingml/2006/main">
               <a:ext uri="{FF2B5EF4-FFF2-40B4-BE49-F238E27FC236}">
-                <a16:creationId xmlns:a16="http://schemas.microsoft.com/office/drawing/2014/main" id="{300253AD-EE4D-4FE1-8CFD-1270C3EE67D2}"/>
+                <a16:creationId xmlns:a16="http://schemas.microsoft.com/office/drawing/2014/main" id="{6D47535C-D8E4-4197-92F9-EE4702456CE6}"/>
               </a:ext>
             </a:extLst>
           </p:cNvPr>
@@ -9716,7 +9706,7 @@
           <p:cNvPr id="14" name="">
             <a:extLst xmlns:a="http://schemas.openxmlformats.org/drawingml/2006/main">
               <a:ext uri="{FF2B5EF4-FFF2-40B4-BE49-F238E27FC236}">
-                <a16:creationId xmlns:a16="http://schemas.microsoft.com/office/drawing/2014/main" id="{26C2DB99-AE84-4955-A5D3-5BA05B02ACF1}"/>
+                <a16:creationId xmlns:a16="http://schemas.microsoft.com/office/drawing/2014/main" id="{BBB91AC6-963A-41F3-9711-B87A54A4CA33}"/>
               </a:ext>
             </a:extLst>
           </p:cNvPr>
@@ -9766,7 +9756,7 @@
           <p:cNvPr id="15" name="">
             <a:extLst xmlns:a="http://schemas.openxmlformats.org/drawingml/2006/main">
               <a:ext uri="{FF2B5EF4-FFF2-40B4-BE49-F238E27FC236}">
-                <a16:creationId xmlns:a16="http://schemas.microsoft.com/office/drawing/2014/main" id="{6FB11C5F-F6CE-4839-B613-D3D42E322EC5}"/>
+                <a16:creationId xmlns:a16="http://schemas.microsoft.com/office/drawing/2014/main" id="{4E28DDEA-6193-4F48-8E83-B23279F457E7}"/>
               </a:ext>
             </a:extLst>
           </p:cNvPr>
@@ -9816,7 +9806,7 @@
           <p:cNvPr id="16" name="">
             <a:extLst xmlns:a="http://schemas.openxmlformats.org/drawingml/2006/main">
               <a:ext uri="{FF2B5EF4-FFF2-40B4-BE49-F238E27FC236}">
-                <a16:creationId xmlns:a16="http://schemas.microsoft.com/office/drawing/2014/main" id="{C483A999-B182-49FF-84B4-AE61406E5BF5}"/>
+                <a16:creationId xmlns:a16="http://schemas.microsoft.com/office/drawing/2014/main" id="{9EDFDD82-065D-47DE-B886-3BB234645CD3}"/>
               </a:ext>
             </a:extLst>
           </p:cNvPr>
@@ -9851,7 +9841,7 @@
           <p:cNvPr id="17" name="">
             <a:extLst xmlns:a="http://schemas.openxmlformats.org/drawingml/2006/main">
               <a:ext uri="{FF2B5EF4-FFF2-40B4-BE49-F238E27FC236}">
-                <a16:creationId xmlns:a16="http://schemas.microsoft.com/office/drawing/2014/main" id="{81100062-C6BB-4760-AE45-E1619C5D87D5}"/>
+                <a16:creationId xmlns:a16="http://schemas.microsoft.com/office/drawing/2014/main" id="{C447EFC3-1AAE-40E9-B308-D872DD8D6EF7}"/>
               </a:ext>
             </a:extLst>
           </p:cNvPr>
@@ -9901,7 +9891,7 @@
           <p:cNvPr id="18" name="">
             <a:extLst xmlns:a="http://schemas.openxmlformats.org/drawingml/2006/main">
               <a:ext uri="{FF2B5EF4-FFF2-40B4-BE49-F238E27FC236}">
-                <a16:creationId xmlns:a16="http://schemas.microsoft.com/office/drawing/2014/main" id="{BB459467-AA34-4A91-900C-402B6480661B}"/>
+                <a16:creationId xmlns:a16="http://schemas.microsoft.com/office/drawing/2014/main" id="{5B8EC7DA-A5AE-42D6-A44F-E86A6EFB4375}"/>
               </a:ext>
             </a:extLst>
           </p:cNvPr>
@@ -9951,7 +9941,7 @@
           <p:cNvPr id="19" name="">
             <a:extLst xmlns:a="http://schemas.openxmlformats.org/drawingml/2006/main">
               <a:ext uri="{FF2B5EF4-FFF2-40B4-BE49-F238E27FC236}">
-                <a16:creationId xmlns:a16="http://schemas.microsoft.com/office/drawing/2014/main" id="{276E521A-D400-4D43-91BA-34857736BA23}"/>
+                <a16:creationId xmlns:a16="http://schemas.microsoft.com/office/drawing/2014/main" id="{B1CE342B-67AA-47FE-B430-024382852607}"/>
               </a:ext>
             </a:extLst>
           </p:cNvPr>
@@ -10001,7 +9991,7 @@
           <p:cNvPr id="20" name="">
             <a:extLst xmlns:a="http://schemas.openxmlformats.org/drawingml/2006/main">
               <a:ext uri="{FF2B5EF4-FFF2-40B4-BE49-F238E27FC236}">
-                <a16:creationId xmlns:a16="http://schemas.microsoft.com/office/drawing/2014/main" id="{3A76A25B-7A6B-4ECB-8F57-D48ED8E0E4E7}"/>
+                <a16:creationId xmlns:a16="http://schemas.microsoft.com/office/drawing/2014/main" id="{C9ACCC48-F067-4108-A542-63FFC2AE3E6E}"/>
               </a:ext>
             </a:extLst>
           </p:cNvPr>
@@ -10036,7 +10026,7 @@
           <p:cNvPr id="21" name="">
             <a:extLst xmlns:a="http://schemas.openxmlformats.org/drawingml/2006/main">
               <a:ext uri="{FF2B5EF4-FFF2-40B4-BE49-F238E27FC236}">
-                <a16:creationId xmlns:a16="http://schemas.microsoft.com/office/drawing/2014/main" id="{997ECEE4-89B2-4435-A091-3366A4993347}"/>
+                <a16:creationId xmlns:a16="http://schemas.microsoft.com/office/drawing/2014/main" id="{95F71DEE-BF59-469E-8209-5C00772FD4AD}"/>
               </a:ext>
             </a:extLst>
           </p:cNvPr>
@@ -10086,7 +10076,7 @@
           <p:cNvPr id="22" name="">
             <a:extLst xmlns:a="http://schemas.openxmlformats.org/drawingml/2006/main">
               <a:ext uri="{FF2B5EF4-FFF2-40B4-BE49-F238E27FC236}">
-                <a16:creationId xmlns:a16="http://schemas.microsoft.com/office/drawing/2014/main" id="{B4EB82E7-E787-4DB6-A58D-F6437E6A3A5B}"/>
+                <a16:creationId xmlns:a16="http://schemas.microsoft.com/office/drawing/2014/main" id="{0863F869-04E4-4EF6-9D0F-9F5C640AB965}"/>
               </a:ext>
             </a:extLst>
           </p:cNvPr>
@@ -10136,7 +10126,7 @@
           <p:cNvPr id="23" name="">
             <a:extLst xmlns:a="http://schemas.openxmlformats.org/drawingml/2006/main">
               <a:ext uri="{FF2B5EF4-FFF2-40B4-BE49-F238E27FC236}">
-                <a16:creationId xmlns:a16="http://schemas.microsoft.com/office/drawing/2014/main" id="{77CBDBEE-A76C-4A27-ADB7-B3E7BE6E6518}"/>
+                <a16:creationId xmlns:a16="http://schemas.microsoft.com/office/drawing/2014/main" id="{767CBB42-F7A7-48A7-9D2C-38C648CACAFE}"/>
               </a:ext>
             </a:extLst>
           </p:cNvPr>
@@ -10186,7 +10176,7 @@
           <p:cNvPr id="24" name="">
             <a:extLst xmlns:a="http://schemas.openxmlformats.org/drawingml/2006/main">
               <a:ext uri="{FF2B5EF4-FFF2-40B4-BE49-F238E27FC236}">
-                <a16:creationId xmlns:a16="http://schemas.microsoft.com/office/drawing/2014/main" id="{FD1B6F04-C816-4A61-81A9-E63297EAD407}"/>
+                <a16:creationId xmlns:a16="http://schemas.microsoft.com/office/drawing/2014/main" id="{92F00EAE-8242-4D19-A0AB-FA18E1E53D28}"/>
               </a:ext>
             </a:extLst>
           </p:cNvPr>
@@ -10221,7 +10211,7 @@
           <p:cNvPr id="25" name="">
             <a:extLst xmlns:a="http://schemas.openxmlformats.org/drawingml/2006/main">
               <a:ext uri="{FF2B5EF4-FFF2-40B4-BE49-F238E27FC236}">
-                <a16:creationId xmlns:a16="http://schemas.microsoft.com/office/drawing/2014/main" id="{C9CCD67C-09A9-4AEA-8876-9818D2D9956B}"/>
+                <a16:creationId xmlns:a16="http://schemas.microsoft.com/office/drawing/2014/main" id="{C272136E-41B0-4D61-BA02-424513E7BA3B}"/>
               </a:ext>
             </a:extLst>
           </p:cNvPr>
@@ -10271,7 +10261,7 @@
           <p:cNvPr id="26" name="">
             <a:extLst xmlns:a="http://schemas.openxmlformats.org/drawingml/2006/main">
               <a:ext uri="{FF2B5EF4-FFF2-40B4-BE49-F238E27FC236}">
-                <a16:creationId xmlns:a16="http://schemas.microsoft.com/office/drawing/2014/main" id="{450F9DAE-E370-4794-B4BC-BB0131C8A42A}"/>
+                <a16:creationId xmlns:a16="http://schemas.microsoft.com/office/drawing/2014/main" id="{F606ED76-E157-4F0B-8143-DAC3BC70613B}"/>
               </a:ext>
             </a:extLst>
           </p:cNvPr>
@@ -10321,7 +10311,7 @@
           <p:cNvPr id="27" name="">
             <a:extLst xmlns:a="http://schemas.openxmlformats.org/drawingml/2006/main">
               <a:ext uri="{FF2B5EF4-FFF2-40B4-BE49-F238E27FC236}">
-                <a16:creationId xmlns:a16="http://schemas.microsoft.com/office/drawing/2014/main" id="{03A9D2EB-1C98-4AF5-8F2F-72D516CDA5A7}"/>
+                <a16:creationId xmlns:a16="http://schemas.microsoft.com/office/drawing/2014/main" id="{9A651278-DC68-4CBB-9440-6D7DA86E58E3}"/>
               </a:ext>
             </a:extLst>
           </p:cNvPr>
@@ -10371,7 +10361,7 @@
           <p:cNvPr id="28" name="">
             <a:extLst xmlns:a="http://schemas.openxmlformats.org/drawingml/2006/main">
               <a:ext uri="{FF2B5EF4-FFF2-40B4-BE49-F238E27FC236}">
-                <a16:creationId xmlns:a16="http://schemas.microsoft.com/office/drawing/2014/main" id="{F5E83637-252F-454A-922C-7B4511F711B4}"/>
+                <a16:creationId xmlns:a16="http://schemas.microsoft.com/office/drawing/2014/main" id="{EBBAD76C-0803-471A-BB2F-C9A0083D0936}"/>
               </a:ext>
             </a:extLst>
           </p:cNvPr>
@@ -10406,7 +10396,7 @@
           <p:cNvPr id="29" name="">
             <a:extLst xmlns:a="http://schemas.openxmlformats.org/drawingml/2006/main">
               <a:ext uri="{FF2B5EF4-FFF2-40B4-BE49-F238E27FC236}">
-                <a16:creationId xmlns:a16="http://schemas.microsoft.com/office/drawing/2014/main" id="{42D191DD-EEB8-404E-BD86-B63E18093E34}"/>
+                <a16:creationId xmlns:a16="http://schemas.microsoft.com/office/drawing/2014/main" id="{477F56DB-E2D8-4AE8-B2D3-982735A4BAC9}"/>
               </a:ext>
             </a:extLst>
           </p:cNvPr>
@@ -10456,7 +10446,7 @@
           <p:cNvPr id="30" name="">
             <a:extLst xmlns:a="http://schemas.openxmlformats.org/drawingml/2006/main">
               <a:ext uri="{FF2B5EF4-FFF2-40B4-BE49-F238E27FC236}">
-                <a16:creationId xmlns:a16="http://schemas.microsoft.com/office/drawing/2014/main" id="{9EF72953-6ACC-4485-9428-5F59E7FF14CA}"/>
+                <a16:creationId xmlns:a16="http://schemas.microsoft.com/office/drawing/2014/main" id="{1001B92C-961C-4738-8347-DE451D9011F3}"/>
               </a:ext>
             </a:extLst>
           </p:cNvPr>
@@ -10506,7 +10496,7 @@
           <p:cNvPr id="31" name="">
             <a:extLst xmlns:a="http://schemas.openxmlformats.org/drawingml/2006/main">
               <a:ext uri="{FF2B5EF4-FFF2-40B4-BE49-F238E27FC236}">
-                <a16:creationId xmlns:a16="http://schemas.microsoft.com/office/drawing/2014/main" id="{3908B116-B001-4DA1-A13C-287BF2BEEB9E}"/>
+                <a16:creationId xmlns:a16="http://schemas.microsoft.com/office/drawing/2014/main" id="{38BE8D72-1C5D-4AAD-A441-F134C69AC7AA}"/>
               </a:ext>
             </a:extLst>
           </p:cNvPr>
@@ -10556,7 +10546,7 @@
           <p:cNvPr id="32" name="">
             <a:extLst xmlns:a="http://schemas.openxmlformats.org/drawingml/2006/main">
               <a:ext uri="{FF2B5EF4-FFF2-40B4-BE49-F238E27FC236}">
-                <a16:creationId xmlns:a16="http://schemas.microsoft.com/office/drawing/2014/main" id="{68434760-0434-48EE-A124-DD2F9A83DA16}"/>
+                <a16:creationId xmlns:a16="http://schemas.microsoft.com/office/drawing/2014/main" id="{1548CFC6-3315-482A-9406-7A0AF5A32375}"/>
               </a:ext>
             </a:extLst>
           </p:cNvPr>
@@ -10606,7 +10596,7 @@
           <p:cNvPr id="33" name="">
             <a:extLst xmlns:a="http://schemas.openxmlformats.org/drawingml/2006/main">
               <a:ext uri="{FF2B5EF4-FFF2-40B4-BE49-F238E27FC236}">
-                <a16:creationId xmlns:a16="http://schemas.microsoft.com/office/drawing/2014/main" id="{C6E48389-5965-4835-AB7F-B0D0E4371F8D}"/>
+                <a16:creationId xmlns:a16="http://schemas.microsoft.com/office/drawing/2014/main" id="{82B38DF5-5F0D-4D6E-B287-EF30B4FD5F7E}"/>
               </a:ext>
             </a:extLst>
           </p:cNvPr>
@@ -10656,7 +10646,7 @@
           <p:cNvPr id="34" name="">
             <a:extLst xmlns:a="http://schemas.openxmlformats.org/drawingml/2006/main">
               <a:ext uri="{FF2B5EF4-FFF2-40B4-BE49-F238E27FC236}">
-                <a16:creationId xmlns:a16="http://schemas.microsoft.com/office/drawing/2014/main" id="{AA96CB0E-868F-42AF-90E1-FD7DC5097703}"/>
+                <a16:creationId xmlns:a16="http://schemas.microsoft.com/office/drawing/2014/main" id="{C70B5B2A-7C5A-4D6E-BE8B-4AF802F7BB3E}"/>
               </a:ext>
             </a:extLst>
           </p:cNvPr>
@@ -10706,7 +10696,7 @@
           <p:cNvPr id="35" name="">
             <a:extLst xmlns:a="http://schemas.openxmlformats.org/drawingml/2006/main">
               <a:ext uri="{FF2B5EF4-FFF2-40B4-BE49-F238E27FC236}">
-                <a16:creationId xmlns:a16="http://schemas.microsoft.com/office/drawing/2014/main" id="{B2F27B53-78D0-4D39-9048-6DFCB6683B18}"/>
+                <a16:creationId xmlns:a16="http://schemas.microsoft.com/office/drawing/2014/main" id="{8305C7FB-B891-4AA1-A799-3EE885DEB10B}"/>
               </a:ext>
             </a:extLst>
           </p:cNvPr>
@@ -10756,7 +10746,7 @@
           <p:cNvPr id="36" name="">
             <a:extLst xmlns:a="http://schemas.openxmlformats.org/drawingml/2006/main">
               <a:ext uri="{FF2B5EF4-FFF2-40B4-BE49-F238E27FC236}">
-                <a16:creationId xmlns:a16="http://schemas.microsoft.com/office/drawing/2014/main" id="{D6C75049-0FF0-4E5C-8578-0AA162D8E2DB}"/>
+                <a16:creationId xmlns:a16="http://schemas.microsoft.com/office/drawing/2014/main" id="{5A0BAF58-7A19-4807-A2E6-7FFE09C7783C}"/>
               </a:ext>
             </a:extLst>
           </p:cNvPr>
@@ -10789,7 +10779,7 @@
           <p:cNvPr id="37" name="">
             <a:extLst xmlns:a="http://schemas.openxmlformats.org/drawingml/2006/main">
               <a:ext uri="{FF2B5EF4-FFF2-40B4-BE49-F238E27FC236}">
-                <a16:creationId xmlns:a16="http://schemas.microsoft.com/office/drawing/2014/main" id="{479B64B8-DD3C-43EE-AC0B-09BF91D14FE4}"/>
+                <a16:creationId xmlns:a16="http://schemas.microsoft.com/office/drawing/2014/main" id="{BD958B25-E1EB-499B-B312-4306E56C45DC}"/>
               </a:ext>
             </a:extLst>
           </p:cNvPr>
@@ -10801,7 +10791,7 @@
         <p:spPr>
           <a:xfrm xmlns:a="http://schemas.openxmlformats.org/drawingml/2006/main">
             <a:off x="647700" y="6496050"/>
-            <a:ext cx="9715500" cy="190500"/>
+            <a:ext cx="8953500" cy="190500"/>
           </a:xfrm>
           <a:prstGeom xmlns:a="http://schemas.openxmlformats.org/drawingml/2006/main" prst="rect">
             <a:avLst/>
@@ -10839,19 +10829,19 @@
           <p:cNvPr id="38" name="">
             <a:extLst xmlns:a="http://schemas.openxmlformats.org/drawingml/2006/main">
               <a:ext uri="{FF2B5EF4-FFF2-40B4-BE49-F238E27FC236}">
-                <a16:creationId xmlns:a16="http://schemas.microsoft.com/office/drawing/2014/main" id="{A408D000-A512-454C-B4D7-B4017F7DC2FE}"/>
-              </a:ext>
-            </a:extLst>
-          </p:cNvPr>
-          <p:cNvSpPr>
-            <a:spLocks xmlns:a="http://schemas.openxmlformats.org/drawingml/2006/main" noGrp="1"/>
-          </p:cNvSpPr>
-          <p:nvPr/>
-        </p:nvSpPr>
-        <p:spPr>
-          <a:xfrm xmlns:a="http://schemas.openxmlformats.org/drawingml/2006/main">
-            <a:off x="9620250" y="6467475"/>
-            <a:ext cx="1905000" cy="247650"/>
+                <a16:creationId xmlns:a16="http://schemas.microsoft.com/office/drawing/2014/main" id="{E0F67A41-39B1-47CF-8A09-417E15DF26A9}"/>
+              </a:ext>
+            </a:extLst>
+          </p:cNvPr>
+          <p:cNvSpPr>
+            <a:spLocks xmlns:a="http://schemas.openxmlformats.org/drawingml/2006/main" noGrp="1"/>
+          </p:cNvSpPr>
+          <p:nvPr/>
+        </p:nvSpPr>
+        <p:spPr>
+          <a:xfrm xmlns:a="http://schemas.openxmlformats.org/drawingml/2006/main">
+            <a:off x="10287000" y="6467475"/>
+            <a:ext cx="952500" cy="247650"/>
           </a:xfrm>
           <a:prstGeom xmlns:a="http://schemas.openxmlformats.org/drawingml/2006/main" prst="rect">
             <a:avLst/>
@@ -10887,7 +10877,7 @@
     </p:spTree>
     <p:extLst>
       <p:ext uri="{BB962C8B-B14F-4D97-AF65-F5344CB8AC3E}">
-        <p14:creationId xmlns:p14="http://schemas.microsoft.com/office/powerpoint/2010/main" val="731666688"/>
+        <p14:creationId xmlns:p14="http://schemas.microsoft.com/office/powerpoint/2010/main" val="1997847629"/>
       </p:ext>
     </p:extLst>
   </p:cSld>
@@ -10918,7 +10908,7 @@
           <p:cNvPr id="53" name="">
             <a:extLst xmlns:a="http://schemas.openxmlformats.org/drawingml/2006/main">
               <a:ext uri="{FF2B5EF4-FFF2-40B4-BE49-F238E27FC236}">
-                <a16:creationId xmlns:a16="http://schemas.microsoft.com/office/drawing/2014/main" id="{C51D9F58-B380-43C3-B867-15D243BB359F}"/>
+                <a16:creationId xmlns:a16="http://schemas.microsoft.com/office/drawing/2014/main" id="{B30EB104-321D-4A96-B492-A85D99757CE9}"/>
               </a:ext>
             </a:extLst>
           </p:cNvPr>
@@ -10968,7 +10958,7 @@
           <p:cNvPr id="2" name="">
             <a:extLst xmlns:a="http://schemas.openxmlformats.org/drawingml/2006/main">
               <a:ext uri="{FF2B5EF4-FFF2-40B4-BE49-F238E27FC236}">
-                <a16:creationId xmlns:a16="http://schemas.microsoft.com/office/drawing/2014/main" id="{A7E5E919-0D24-40D5-8E45-27ACDD6A4942}"/>
+                <a16:creationId xmlns:a16="http://schemas.microsoft.com/office/drawing/2014/main" id="{0183EB01-6F7C-4ABE-8311-89F49D930A53}"/>
               </a:ext>
             </a:extLst>
           </p:cNvPr>
@@ -11018,7 +11008,7 @@
           <p:cNvPr id="3" name="">
             <a:extLst xmlns:a="http://schemas.openxmlformats.org/drawingml/2006/main">
               <a:ext uri="{FF2B5EF4-FFF2-40B4-BE49-F238E27FC236}">
-                <a16:creationId xmlns:a16="http://schemas.microsoft.com/office/drawing/2014/main" id="{171C937D-D7B6-4C34-AF71-5A132881C38C}"/>
+                <a16:creationId xmlns:a16="http://schemas.microsoft.com/office/drawing/2014/main" id="{EB9D7B24-91E2-4ABD-9C18-3E2A69DD687B}"/>
               </a:ext>
             </a:extLst>
           </p:cNvPr>
@@ -11068,7 +11058,7 @@
           <p:cNvPr id="4" name="">
             <a:extLst xmlns:a="http://schemas.openxmlformats.org/drawingml/2006/main">
               <a:ext uri="{FF2B5EF4-FFF2-40B4-BE49-F238E27FC236}">
-                <a16:creationId xmlns:a16="http://schemas.microsoft.com/office/drawing/2014/main" id="{3BF3B042-F629-4E5A-B8C2-A66644ED5397}"/>
+                <a16:creationId xmlns:a16="http://schemas.microsoft.com/office/drawing/2014/main" id="{51970D34-25AB-4447-A253-FA9011FB947E}"/>
               </a:ext>
             </a:extLst>
           </p:cNvPr>
@@ -11101,7 +11091,7 @@
           <p:cNvPr id="5" name="">
             <a:extLst xmlns:a="http://schemas.openxmlformats.org/drawingml/2006/main">
               <a:ext uri="{FF2B5EF4-FFF2-40B4-BE49-F238E27FC236}">
-                <a16:creationId xmlns:a16="http://schemas.microsoft.com/office/drawing/2014/main" id="{F7302BBF-F481-4688-9DB2-63BCF4F85EC2}"/>
+                <a16:creationId xmlns:a16="http://schemas.microsoft.com/office/drawing/2014/main" id="{556D57D1-F97B-4C42-979E-49813256E275}"/>
               </a:ext>
             </a:extLst>
           </p:cNvPr>
@@ -11151,7 +11141,7 @@
           <p:cNvPr id="6" name="">
             <a:extLst xmlns:a="http://schemas.openxmlformats.org/drawingml/2006/main">
               <a:ext uri="{FF2B5EF4-FFF2-40B4-BE49-F238E27FC236}">
-                <a16:creationId xmlns:a16="http://schemas.microsoft.com/office/drawing/2014/main" id="{E14A70AE-4EDB-411C-8AE0-9BD7548F96D8}"/>
+                <a16:creationId xmlns:a16="http://schemas.microsoft.com/office/drawing/2014/main" id="{5A3D2E7A-5D7B-4F29-B2B3-579538EC29A0}"/>
               </a:ext>
             </a:extLst>
           </p:cNvPr>
@@ -11201,7 +11191,7 @@
           <p:cNvPr id="7" name="">
             <a:extLst xmlns:a="http://schemas.openxmlformats.org/drawingml/2006/main">
               <a:ext uri="{FF2B5EF4-FFF2-40B4-BE49-F238E27FC236}">
-                <a16:creationId xmlns:a16="http://schemas.microsoft.com/office/drawing/2014/main" id="{7FF86FD4-E6A5-46B8-912B-B2102142F4C4}"/>
+                <a16:creationId xmlns:a16="http://schemas.microsoft.com/office/drawing/2014/main" id="{DD382541-E218-4A6A-B5AA-D0CC34BA695C}"/>
               </a:ext>
             </a:extLst>
           </p:cNvPr>
@@ -11234,7 +11224,7 @@
           <p:cNvPr id="8" name="">
             <a:extLst xmlns:a="http://schemas.openxmlformats.org/drawingml/2006/main">
               <a:ext uri="{FF2B5EF4-FFF2-40B4-BE49-F238E27FC236}">
-                <a16:creationId xmlns:a16="http://schemas.microsoft.com/office/drawing/2014/main" id="{407B9508-1C82-46BE-AE0C-A5D14AD118E1}"/>
+                <a16:creationId xmlns:a16="http://schemas.microsoft.com/office/drawing/2014/main" id="{0F1AEA11-B37B-4CA8-B27A-9AF72FCD3B01}"/>
               </a:ext>
             </a:extLst>
           </p:cNvPr>
@@ -11267,7 +11257,7 @@
           <p:cNvPr id="9" name="">
             <a:extLst xmlns:a="http://schemas.openxmlformats.org/drawingml/2006/main">
               <a:ext uri="{FF2B5EF4-FFF2-40B4-BE49-F238E27FC236}">
-                <a16:creationId xmlns:a16="http://schemas.microsoft.com/office/drawing/2014/main" id="{674B40D0-7187-495B-AFCD-864C861C376B}"/>
+                <a16:creationId xmlns:a16="http://schemas.microsoft.com/office/drawing/2014/main" id="{79DB2C66-1DA4-4127-92D0-B1C3A29686B8}"/>
               </a:ext>
             </a:extLst>
           </p:cNvPr>
@@ -11317,7 +11307,7 @@
           <p:cNvPr id="10" name="">
             <a:extLst xmlns:a="http://schemas.openxmlformats.org/drawingml/2006/main">
               <a:ext uri="{FF2B5EF4-FFF2-40B4-BE49-F238E27FC236}">
-                <a16:creationId xmlns:a16="http://schemas.microsoft.com/office/drawing/2014/main" id="{D34B8DCC-0623-4707-AE74-D91BF6AEFA0C}"/>
+                <a16:creationId xmlns:a16="http://schemas.microsoft.com/office/drawing/2014/main" id="{BD737E02-D4DB-4FD0-82D1-2988D06D22F9}"/>
               </a:ext>
             </a:extLst>
           </p:cNvPr>
@@ -11367,7 +11357,7 @@
           <p:cNvPr id="11" name="">
             <a:extLst xmlns:a="http://schemas.openxmlformats.org/drawingml/2006/main">
               <a:ext uri="{FF2B5EF4-FFF2-40B4-BE49-F238E27FC236}">
-                <a16:creationId xmlns:a16="http://schemas.microsoft.com/office/drawing/2014/main" id="{C31DCDE7-E417-4572-A61A-E9176C9AE13A}"/>
+                <a16:creationId xmlns:a16="http://schemas.microsoft.com/office/drawing/2014/main" id="{69C6560A-1A20-40F9-A59F-0B3A7D4F5C74}"/>
               </a:ext>
             </a:extLst>
           </p:cNvPr>
@@ -11417,7 +11407,7 @@
           <p:cNvPr id="12" name="">
             <a:extLst xmlns:a="http://schemas.openxmlformats.org/drawingml/2006/main">
               <a:ext uri="{FF2B5EF4-FFF2-40B4-BE49-F238E27FC236}">
-                <a16:creationId xmlns:a16="http://schemas.microsoft.com/office/drawing/2014/main" id="{4575A15D-02CE-4879-B405-1976759B4919}"/>
+                <a16:creationId xmlns:a16="http://schemas.microsoft.com/office/drawing/2014/main" id="{F8048A92-DCF8-4357-8523-2E07DEE57674}"/>
               </a:ext>
             </a:extLst>
           </p:cNvPr>
@@ -11450,7 +11440,7 @@
           <p:cNvPr id="13" name="">
             <a:extLst xmlns:a="http://schemas.openxmlformats.org/drawingml/2006/main">
               <a:ext uri="{FF2B5EF4-FFF2-40B4-BE49-F238E27FC236}">
-                <a16:creationId xmlns:a16="http://schemas.microsoft.com/office/drawing/2014/main" id="{3A6A34E3-C88D-4A28-ABD4-7E4D1984CD41}"/>
+                <a16:creationId xmlns:a16="http://schemas.microsoft.com/office/drawing/2014/main" id="{4A1E787B-F2D0-43F9-951F-858754B7124C}"/>
               </a:ext>
             </a:extLst>
           </p:cNvPr>
@@ -11500,7 +11490,7 @@
           <p:cNvPr id="14" name="">
             <a:extLst xmlns:a="http://schemas.openxmlformats.org/drawingml/2006/main">
               <a:ext uri="{FF2B5EF4-FFF2-40B4-BE49-F238E27FC236}">
-                <a16:creationId xmlns:a16="http://schemas.microsoft.com/office/drawing/2014/main" id="{24A7C504-7F72-4308-B929-59DA6DBC9516}"/>
+                <a16:creationId xmlns:a16="http://schemas.microsoft.com/office/drawing/2014/main" id="{3C26B1E2-4E92-43B2-883D-A4EB38ADD92F}"/>
               </a:ext>
             </a:extLst>
           </p:cNvPr>
@@ -11550,7 +11540,7 @@
           <p:cNvPr id="15" name="">
             <a:extLst xmlns:a="http://schemas.openxmlformats.org/drawingml/2006/main">
               <a:ext uri="{FF2B5EF4-FFF2-40B4-BE49-F238E27FC236}">
-                <a16:creationId xmlns:a16="http://schemas.microsoft.com/office/drawing/2014/main" id="{EF83359E-C381-4E87-BD25-108F8940740F}"/>
+                <a16:creationId xmlns:a16="http://schemas.microsoft.com/office/drawing/2014/main" id="{8E94E010-3BC9-4E48-AF24-EAC3CEB0336C}"/>
               </a:ext>
             </a:extLst>
           </p:cNvPr>
@@ -11600,7 +11590,7 @@
           <p:cNvPr id="16" name="">
             <a:extLst xmlns:a="http://schemas.openxmlformats.org/drawingml/2006/main">
               <a:ext uri="{FF2B5EF4-FFF2-40B4-BE49-F238E27FC236}">
-                <a16:creationId xmlns:a16="http://schemas.microsoft.com/office/drawing/2014/main" id="{6045114D-370B-4169-9E54-F7DF66498E62}"/>
+                <a16:creationId xmlns:a16="http://schemas.microsoft.com/office/drawing/2014/main" id="{724B97B1-908D-47C2-95AB-0E57893BF7A8}"/>
               </a:ext>
             </a:extLst>
           </p:cNvPr>
@@ -11633,7 +11623,7 @@
           <p:cNvPr id="17" name="">
             <a:extLst xmlns:a="http://schemas.openxmlformats.org/drawingml/2006/main">
               <a:ext uri="{FF2B5EF4-FFF2-40B4-BE49-F238E27FC236}">
-                <a16:creationId xmlns:a16="http://schemas.microsoft.com/office/drawing/2014/main" id="{83879DDA-E680-4790-8EC2-B5C1BE6C37B1}"/>
+                <a16:creationId xmlns:a16="http://schemas.microsoft.com/office/drawing/2014/main" id="{EAA9E4CB-C99B-4EFB-8EF2-67008852F825}"/>
               </a:ext>
             </a:extLst>
           </p:cNvPr>
@@ -11683,7 +11673,7 @@
           <p:cNvPr id="18" name="">
             <a:extLst xmlns:a="http://schemas.openxmlformats.org/drawingml/2006/main">
               <a:ext uri="{FF2B5EF4-FFF2-40B4-BE49-F238E27FC236}">
-                <a16:creationId xmlns:a16="http://schemas.microsoft.com/office/drawing/2014/main" id="{5626C6E6-9377-4D18-B3AD-BE74B02C38E9}"/>
+                <a16:creationId xmlns:a16="http://schemas.microsoft.com/office/drawing/2014/main" id="{A8C8D8B4-58B0-4B24-8B47-B2BF8A1FAF7E}"/>
               </a:ext>
             </a:extLst>
           </p:cNvPr>
@@ -11733,7 +11723,7 @@
           <p:cNvPr id="19" name="">
             <a:extLst xmlns:a="http://schemas.openxmlformats.org/drawingml/2006/main">
               <a:ext uri="{FF2B5EF4-FFF2-40B4-BE49-F238E27FC236}">
-                <a16:creationId xmlns:a16="http://schemas.microsoft.com/office/drawing/2014/main" id="{87285914-C339-4D53-BC45-F11C3B5B7848}"/>
+                <a16:creationId xmlns:a16="http://schemas.microsoft.com/office/drawing/2014/main" id="{440117D4-DB2F-4B89-A1D9-6D8ECFBE39B5}"/>
               </a:ext>
             </a:extLst>
           </p:cNvPr>
@@ -11783,7 +11773,7 @@
           <p:cNvPr id="20" name="">
             <a:extLst xmlns:a="http://schemas.openxmlformats.org/drawingml/2006/main">
               <a:ext uri="{FF2B5EF4-FFF2-40B4-BE49-F238E27FC236}">
-                <a16:creationId xmlns:a16="http://schemas.microsoft.com/office/drawing/2014/main" id="{C0089FD5-8EA0-4020-949C-D481F0F6E5D9}"/>
+                <a16:creationId xmlns:a16="http://schemas.microsoft.com/office/drawing/2014/main" id="{C006B4AC-2427-4F2F-B798-B46804B99CB5}"/>
               </a:ext>
             </a:extLst>
           </p:cNvPr>
@@ -11816,7 +11806,7 @@
           <p:cNvPr id="21" name="">
             <a:extLst xmlns:a="http://schemas.openxmlformats.org/drawingml/2006/main">
               <a:ext uri="{FF2B5EF4-FFF2-40B4-BE49-F238E27FC236}">
-                <a16:creationId xmlns:a16="http://schemas.microsoft.com/office/drawing/2014/main" id="{E7E0436A-C186-4149-AA45-11D0CE57BE2D}"/>
+                <a16:creationId xmlns:a16="http://schemas.microsoft.com/office/drawing/2014/main" id="{D1FB0631-C27B-4BAF-AB59-ECEC5FCED849}"/>
               </a:ext>
             </a:extLst>
           </p:cNvPr>
@@ -11866,7 +11856,7 @@
           <p:cNvPr id="22" name="">
             <a:extLst xmlns:a="http://schemas.openxmlformats.org/drawingml/2006/main">
               <a:ext uri="{FF2B5EF4-FFF2-40B4-BE49-F238E27FC236}">
-                <a16:creationId xmlns:a16="http://schemas.microsoft.com/office/drawing/2014/main" id="{E11CE190-D51B-4A5D-BF30-3AA7EEB9CF51}"/>
+                <a16:creationId xmlns:a16="http://schemas.microsoft.com/office/drawing/2014/main" id="{D0298ED0-1EE8-4E32-8924-760530AF95CE}"/>
               </a:ext>
             </a:extLst>
           </p:cNvPr>
@@ -11916,7 +11906,7 @@
           <p:cNvPr id="23" name="">
             <a:extLst xmlns:a="http://schemas.openxmlformats.org/drawingml/2006/main">
               <a:ext uri="{FF2B5EF4-FFF2-40B4-BE49-F238E27FC236}">
-                <a16:creationId xmlns:a16="http://schemas.microsoft.com/office/drawing/2014/main" id="{71A34A5A-1358-430D-8F4B-4A847F3F184E}"/>
+                <a16:creationId xmlns:a16="http://schemas.microsoft.com/office/drawing/2014/main" id="{52CC1DA3-498A-4D5C-A52C-DCD9EF3C17ED}"/>
               </a:ext>
             </a:extLst>
           </p:cNvPr>
@@ -11966,7 +11956,7 @@
           <p:cNvPr id="24" name="">
             <a:extLst xmlns:a="http://schemas.openxmlformats.org/drawingml/2006/main">
               <a:ext uri="{FF2B5EF4-FFF2-40B4-BE49-F238E27FC236}">
-                <a16:creationId xmlns:a16="http://schemas.microsoft.com/office/drawing/2014/main" id="{044BE2E5-9CA5-49DE-9318-A9F5CA695F22}"/>
+                <a16:creationId xmlns:a16="http://schemas.microsoft.com/office/drawing/2014/main" id="{E048DE55-3631-4051-A4EC-AEC6418C0337}"/>
               </a:ext>
             </a:extLst>
           </p:cNvPr>
@@ -11999,7 +11989,7 @@
           <p:cNvPr id="25" name="">
             <a:extLst xmlns:a="http://schemas.openxmlformats.org/drawingml/2006/main">
               <a:ext uri="{FF2B5EF4-FFF2-40B4-BE49-F238E27FC236}">
-                <a16:creationId xmlns:a16="http://schemas.microsoft.com/office/drawing/2014/main" id="{62DD88DA-2BE7-4DA0-AFA5-55DD8A809C63}"/>
+                <a16:creationId xmlns:a16="http://schemas.microsoft.com/office/drawing/2014/main" id="{BC6E9DDF-864F-4209-A773-2674B281C654}"/>
               </a:ext>
             </a:extLst>
           </p:cNvPr>
@@ -12049,7 +12039,7 @@
           <p:cNvPr id="26" name="">
             <a:extLst xmlns:a="http://schemas.openxmlformats.org/drawingml/2006/main">
               <a:ext uri="{FF2B5EF4-FFF2-40B4-BE49-F238E27FC236}">
-                <a16:creationId xmlns:a16="http://schemas.microsoft.com/office/drawing/2014/main" id="{4D479571-7A8C-4B0C-8FE6-64BEDFD738D9}"/>
+                <a16:creationId xmlns:a16="http://schemas.microsoft.com/office/drawing/2014/main" id="{69AF5EF8-EDD7-4954-B869-CB9CF8907C6C}"/>
               </a:ext>
             </a:extLst>
           </p:cNvPr>
@@ -12099,7 +12089,7 @@
           <p:cNvPr id="27" name="">
             <a:extLst xmlns:a="http://schemas.openxmlformats.org/drawingml/2006/main">
               <a:ext uri="{FF2B5EF4-FFF2-40B4-BE49-F238E27FC236}">
-                <a16:creationId xmlns:a16="http://schemas.microsoft.com/office/drawing/2014/main" id="{86AEB3A7-918A-4BF0-A943-FC3A5FF26395}"/>
+                <a16:creationId xmlns:a16="http://schemas.microsoft.com/office/drawing/2014/main" id="{1EFDF157-7CB3-48BB-B80A-B4363E10CFFE}"/>
               </a:ext>
             </a:extLst>
           </p:cNvPr>
@@ -12149,7 +12139,7 @@
           <p:cNvPr id="28" name="">
             <a:extLst xmlns:a="http://schemas.openxmlformats.org/drawingml/2006/main">
               <a:ext uri="{FF2B5EF4-FFF2-40B4-BE49-F238E27FC236}">
-                <a16:creationId xmlns:a16="http://schemas.microsoft.com/office/drawing/2014/main" id="{FD589CF7-2B6C-44AD-BFEC-314E00A00402}"/>
+                <a16:creationId xmlns:a16="http://schemas.microsoft.com/office/drawing/2014/main" id="{C85B058B-022C-4ACC-B551-E02C38956ADE}"/>
               </a:ext>
             </a:extLst>
           </p:cNvPr>
@@ -12182,7 +12172,7 @@
           <p:cNvPr id="29" name="">
             <a:extLst xmlns:a="http://schemas.openxmlformats.org/drawingml/2006/main">
               <a:ext uri="{FF2B5EF4-FFF2-40B4-BE49-F238E27FC236}">
-                <a16:creationId xmlns:a16="http://schemas.microsoft.com/office/drawing/2014/main" id="{0E6F7116-ECD0-427A-936D-2775C1BBF26F}"/>
+                <a16:creationId xmlns:a16="http://schemas.microsoft.com/office/drawing/2014/main" id="{A705EA0A-7407-4B19-9960-8A15A4EECAFC}"/>
               </a:ext>
             </a:extLst>
           </p:cNvPr>
@@ -12232,7 +12222,7 @@
           <p:cNvPr id="30" name="">
             <a:extLst xmlns:a="http://schemas.openxmlformats.org/drawingml/2006/main">
               <a:ext uri="{FF2B5EF4-FFF2-40B4-BE49-F238E27FC236}">
-                <a16:creationId xmlns:a16="http://schemas.microsoft.com/office/drawing/2014/main" id="{2F954ED6-5E7F-4B71-9243-531FBACF69F8}"/>
+                <a16:creationId xmlns:a16="http://schemas.microsoft.com/office/drawing/2014/main" id="{63FECBF3-106D-40EC-BA58-808813D1AD42}"/>
               </a:ext>
             </a:extLst>
           </p:cNvPr>
@@ -12282,7 +12272,7 @@
           <p:cNvPr id="31" name="">
             <a:extLst xmlns:a="http://schemas.openxmlformats.org/drawingml/2006/main">
               <a:ext uri="{FF2B5EF4-FFF2-40B4-BE49-F238E27FC236}">
-                <a16:creationId xmlns:a16="http://schemas.microsoft.com/office/drawing/2014/main" id="{E3966559-B086-4F16-AA3F-2B494CEA7B51}"/>
+                <a16:creationId xmlns:a16="http://schemas.microsoft.com/office/drawing/2014/main" id="{3EF2063F-6BE8-4CBE-8C1B-97BD562897D0}"/>
               </a:ext>
             </a:extLst>
           </p:cNvPr>
@@ -12332,7 +12322,7 @@
           <p:cNvPr id="32" name="">
             <a:extLst xmlns:a="http://schemas.openxmlformats.org/drawingml/2006/main">
               <a:ext uri="{FF2B5EF4-FFF2-40B4-BE49-F238E27FC236}">
-                <a16:creationId xmlns:a16="http://schemas.microsoft.com/office/drawing/2014/main" id="{C3AE4038-407C-49FD-A764-4E520C661B89}"/>
+                <a16:creationId xmlns:a16="http://schemas.microsoft.com/office/drawing/2014/main" id="{346E9E23-FA0C-4A94-B024-3DB1CBE50DB5}"/>
               </a:ext>
             </a:extLst>
           </p:cNvPr>
@@ -12365,7 +12355,7 @@
           <p:cNvPr id="33" name="">
             <a:extLst xmlns:a="http://schemas.openxmlformats.org/drawingml/2006/main">
               <a:ext uri="{FF2B5EF4-FFF2-40B4-BE49-F238E27FC236}">
-                <a16:creationId xmlns:a16="http://schemas.microsoft.com/office/drawing/2014/main" id="{BCB59CE6-ACD4-459B-8D00-842FD168ADFE}"/>
+                <a16:creationId xmlns:a16="http://schemas.microsoft.com/office/drawing/2014/main" id="{B1545F71-18BB-46A4-A672-7C57577BEF54}"/>
               </a:ext>
             </a:extLst>
           </p:cNvPr>
@@ -12415,7 +12405,7 @@
           <p:cNvPr id="34" name="">
             <a:extLst xmlns:a="http://schemas.openxmlformats.org/drawingml/2006/main">
               <a:ext uri="{FF2B5EF4-FFF2-40B4-BE49-F238E27FC236}">
-                <a16:creationId xmlns:a16="http://schemas.microsoft.com/office/drawing/2014/main" id="{1033D22B-6B63-4488-A53A-C4CCA0683842}"/>
+                <a16:creationId xmlns:a16="http://schemas.microsoft.com/office/drawing/2014/main" id="{8FB56339-BD44-45A7-A827-60C72AC343DD}"/>
               </a:ext>
             </a:extLst>
           </p:cNvPr>
@@ -12465,7 +12455,7 @@
           <p:cNvPr id="35" name="">
             <a:extLst xmlns:a="http://schemas.openxmlformats.org/drawingml/2006/main">
               <a:ext uri="{FF2B5EF4-FFF2-40B4-BE49-F238E27FC236}">
-                <a16:creationId xmlns:a16="http://schemas.microsoft.com/office/drawing/2014/main" id="{9ADEDF0D-6281-4ADA-B9E8-248E4849DE01}"/>
+                <a16:creationId xmlns:a16="http://schemas.microsoft.com/office/drawing/2014/main" id="{05D6E266-BED6-462E-8AAE-064F75A059BD}"/>
               </a:ext>
             </a:extLst>
           </p:cNvPr>
@@ -12515,7 +12505,7 @@
           <p:cNvPr id="36" name="">
             <a:extLst xmlns:a="http://schemas.openxmlformats.org/drawingml/2006/main">
               <a:ext uri="{FF2B5EF4-FFF2-40B4-BE49-F238E27FC236}">
-                <a16:creationId xmlns:a16="http://schemas.microsoft.com/office/drawing/2014/main" id="{6F18B97E-1EEA-44A2-86BE-341A7364FD79}"/>
+                <a16:creationId xmlns:a16="http://schemas.microsoft.com/office/drawing/2014/main" id="{DA099797-4CC9-4C9B-A1A6-DF8D3F8A4125}"/>
               </a:ext>
             </a:extLst>
           </p:cNvPr>
@@ -12548,7 +12538,7 @@
           <p:cNvPr id="37" name="">
             <a:extLst xmlns:a="http://schemas.openxmlformats.org/drawingml/2006/main">
               <a:ext uri="{FF2B5EF4-FFF2-40B4-BE49-F238E27FC236}">
-                <a16:creationId xmlns:a16="http://schemas.microsoft.com/office/drawing/2014/main" id="{73287276-5DD9-4C1F-A03F-82B5996DC3BB}"/>
+                <a16:creationId xmlns:a16="http://schemas.microsoft.com/office/drawing/2014/main" id="{277073B9-CBBF-4A1A-8FBA-CBDC86246021}"/>
               </a:ext>
             </a:extLst>
           </p:cNvPr>
@@ -12598,7 +12588,7 @@
           <p:cNvPr id="38" name="">
             <a:extLst xmlns:a="http://schemas.openxmlformats.org/drawingml/2006/main">
               <a:ext uri="{FF2B5EF4-FFF2-40B4-BE49-F238E27FC236}">
-                <a16:creationId xmlns:a16="http://schemas.microsoft.com/office/drawing/2014/main" id="{60E2846E-0FB1-462B-AC11-EBAAA58EB52E}"/>
+                <a16:creationId xmlns:a16="http://schemas.microsoft.com/office/drawing/2014/main" id="{440DD505-C589-44A8-A9E5-ECAAB7C8559F}"/>
               </a:ext>
             </a:extLst>
           </p:cNvPr>
@@ -12648,7 +12638,7 @@
           <p:cNvPr id="39" name="">
             <a:extLst xmlns:a="http://schemas.openxmlformats.org/drawingml/2006/main">
               <a:ext uri="{FF2B5EF4-FFF2-40B4-BE49-F238E27FC236}">
-                <a16:creationId xmlns:a16="http://schemas.microsoft.com/office/drawing/2014/main" id="{8ED1180E-5F0C-4553-AB1B-341ED22F5614}"/>
+                <a16:creationId xmlns:a16="http://schemas.microsoft.com/office/drawing/2014/main" id="{A2FD6B8B-7F53-4B0F-B2A8-D79DB968724F}"/>
               </a:ext>
             </a:extLst>
           </p:cNvPr>
@@ -12698,7 +12688,7 @@
           <p:cNvPr id="40" name="">
             <a:extLst xmlns:a="http://schemas.openxmlformats.org/drawingml/2006/main">
               <a:ext uri="{FF2B5EF4-FFF2-40B4-BE49-F238E27FC236}">
-                <a16:creationId xmlns:a16="http://schemas.microsoft.com/office/drawing/2014/main" id="{858593B8-8F94-4D7C-BC6A-41216349F437}"/>
+                <a16:creationId xmlns:a16="http://schemas.microsoft.com/office/drawing/2014/main" id="{CDAF5765-08BF-4DF1-A1AE-B78657ACEFB6}"/>
               </a:ext>
             </a:extLst>
           </p:cNvPr>
@@ -12731,7 +12721,7 @@
           <p:cNvPr id="41" name="">
             <a:extLst xmlns:a="http://schemas.openxmlformats.org/drawingml/2006/main">
               <a:ext uri="{FF2B5EF4-FFF2-40B4-BE49-F238E27FC236}">
-                <a16:creationId xmlns:a16="http://schemas.microsoft.com/office/drawing/2014/main" id="{C4B94BAC-A347-4351-92EA-5D799FB436E5}"/>
+                <a16:creationId xmlns:a16="http://schemas.microsoft.com/office/drawing/2014/main" id="{1DEA39AC-D3C8-4C1F-BADE-D9BC7BE4F7B5}"/>
               </a:ext>
             </a:extLst>
           </p:cNvPr>
@@ -12781,7 +12771,7 @@
           <p:cNvPr id="42" name="">
             <a:extLst xmlns:a="http://schemas.openxmlformats.org/drawingml/2006/main">
               <a:ext uri="{FF2B5EF4-FFF2-40B4-BE49-F238E27FC236}">
-                <a16:creationId xmlns:a16="http://schemas.microsoft.com/office/drawing/2014/main" id="{2D32D04C-7815-44EC-A654-A19D69A75102}"/>
+                <a16:creationId xmlns:a16="http://schemas.microsoft.com/office/drawing/2014/main" id="{9B13BBE8-83CE-48A2-84C4-6E541646E40E}"/>
               </a:ext>
             </a:extLst>
           </p:cNvPr>
@@ -12831,7 +12821,7 @@
           <p:cNvPr id="43" name="">
             <a:extLst xmlns:a="http://schemas.openxmlformats.org/drawingml/2006/main">
               <a:ext uri="{FF2B5EF4-FFF2-40B4-BE49-F238E27FC236}">
-                <a16:creationId xmlns:a16="http://schemas.microsoft.com/office/drawing/2014/main" id="{B49BE097-C6F7-443D-BC5D-C495B9C2023E}"/>
+                <a16:creationId xmlns:a16="http://schemas.microsoft.com/office/drawing/2014/main" id="{A0DDFD9E-39C7-4379-A5B6-3109986CFFB3}"/>
               </a:ext>
             </a:extLst>
           </p:cNvPr>
@@ -12881,7 +12871,7 @@
           <p:cNvPr id="44" name="">
             <a:extLst xmlns:a="http://schemas.openxmlformats.org/drawingml/2006/main">
               <a:ext uri="{FF2B5EF4-FFF2-40B4-BE49-F238E27FC236}">
-                <a16:creationId xmlns:a16="http://schemas.microsoft.com/office/drawing/2014/main" id="{FD459749-AFDD-4736-A7FA-866CFE2C6FEB}"/>
+                <a16:creationId xmlns:a16="http://schemas.microsoft.com/office/drawing/2014/main" id="{63093914-998C-45FE-A162-425CD2C952B4}"/>
               </a:ext>
             </a:extLst>
           </p:cNvPr>
@@ -12916,7 +12906,7 @@
           <p:cNvPr id="45" name="">
             <a:extLst xmlns:a="http://schemas.openxmlformats.org/drawingml/2006/main">
               <a:ext uri="{FF2B5EF4-FFF2-40B4-BE49-F238E27FC236}">
-                <a16:creationId xmlns:a16="http://schemas.microsoft.com/office/drawing/2014/main" id="{BCAC8AC1-52CB-4F58-9596-8B1389E7AF03}"/>
+                <a16:creationId xmlns:a16="http://schemas.microsoft.com/office/drawing/2014/main" id="{A5CCE587-F8C1-4CE5-9968-5255431CBED9}"/>
               </a:ext>
             </a:extLst>
           </p:cNvPr>
@@ -12966,7 +12956,7 @@
           <p:cNvPr id="46" name="">
             <a:extLst xmlns:a="http://schemas.openxmlformats.org/drawingml/2006/main">
               <a:ext uri="{FF2B5EF4-FFF2-40B4-BE49-F238E27FC236}">
-                <a16:creationId xmlns:a16="http://schemas.microsoft.com/office/drawing/2014/main" id="{7809F8BE-E072-4DC1-A983-EB87D4A0D7D3}"/>
+                <a16:creationId xmlns:a16="http://schemas.microsoft.com/office/drawing/2014/main" id="{375FB75A-9A17-4A9A-AEE5-A1B287873DF1}"/>
               </a:ext>
             </a:extLst>
           </p:cNvPr>
@@ -13016,7 +13006,7 @@
           <p:cNvPr id="47" name="">
             <a:extLst xmlns:a="http://schemas.openxmlformats.org/drawingml/2006/main">
               <a:ext uri="{FF2B5EF4-FFF2-40B4-BE49-F238E27FC236}">
-                <a16:creationId xmlns:a16="http://schemas.microsoft.com/office/drawing/2014/main" id="{0842C2B9-3021-4369-89C5-2E27B8E16812}"/>
+                <a16:creationId xmlns:a16="http://schemas.microsoft.com/office/drawing/2014/main" id="{125AE4C4-64A1-4A01-96F3-9B1AE44BF7E5}"/>
               </a:ext>
             </a:extLst>
           </p:cNvPr>
@@ -13066,7 +13056,7 @@
           <p:cNvPr id="48" name="">
             <a:extLst xmlns:a="http://schemas.openxmlformats.org/drawingml/2006/main">
               <a:ext uri="{FF2B5EF4-FFF2-40B4-BE49-F238E27FC236}">
-                <a16:creationId xmlns:a16="http://schemas.microsoft.com/office/drawing/2014/main" id="{D55A3A58-65A2-4504-A1DA-0DF014202E04}"/>
+                <a16:creationId xmlns:a16="http://schemas.microsoft.com/office/drawing/2014/main" id="{F1077E89-C91F-4F57-A281-A9D173C110EE}"/>
               </a:ext>
             </a:extLst>
           </p:cNvPr>
@@ -13116,7 +13106,7 @@
           <p:cNvPr id="49" name="">
             <a:extLst xmlns:a="http://schemas.openxmlformats.org/drawingml/2006/main">
               <a:ext uri="{FF2B5EF4-FFF2-40B4-BE49-F238E27FC236}">
-                <a16:creationId xmlns:a16="http://schemas.microsoft.com/office/drawing/2014/main" id="{B8CA0057-0CDC-41F9-9225-BB50172FE4B9}"/>
+                <a16:creationId xmlns:a16="http://schemas.microsoft.com/office/drawing/2014/main" id="{FC62116D-9B40-4E1D-A7E1-EE28A79E9CF9}"/>
               </a:ext>
             </a:extLst>
           </p:cNvPr>
@@ -13166,7 +13156,7 @@
           <p:cNvPr id="50" name="">
             <a:extLst xmlns:a="http://schemas.openxmlformats.org/drawingml/2006/main">
               <a:ext uri="{FF2B5EF4-FFF2-40B4-BE49-F238E27FC236}">
-                <a16:creationId xmlns:a16="http://schemas.microsoft.com/office/drawing/2014/main" id="{E93FA151-FDAB-43AB-91C9-5E6C0A2A9AC8}"/>
+                <a16:creationId xmlns:a16="http://schemas.microsoft.com/office/drawing/2014/main" id="{E89A6AEA-184C-4C6B-8C5D-147EF7041448}"/>
               </a:ext>
             </a:extLst>
           </p:cNvPr>
@@ -13199,7 +13189,7 @@
           <p:cNvPr id="51" name="">
             <a:extLst xmlns:a="http://schemas.openxmlformats.org/drawingml/2006/main">
               <a:ext uri="{FF2B5EF4-FFF2-40B4-BE49-F238E27FC236}">
-                <a16:creationId xmlns:a16="http://schemas.microsoft.com/office/drawing/2014/main" id="{EE75C711-5548-4347-8FC0-DCA558CA3E57}"/>
+                <a16:creationId xmlns:a16="http://schemas.microsoft.com/office/drawing/2014/main" id="{EC71DCE0-56F5-4830-A1A9-1890F57E421C}"/>
               </a:ext>
             </a:extLst>
           </p:cNvPr>
@@ -13211,7 +13201,7 @@
         <p:spPr>
           <a:xfrm xmlns:a="http://schemas.openxmlformats.org/drawingml/2006/main">
             <a:off x="647700" y="6496050"/>
-            <a:ext cx="9715500" cy="190500"/>
+            <a:ext cx="8953500" cy="190500"/>
           </a:xfrm>
           <a:prstGeom xmlns:a="http://schemas.openxmlformats.org/drawingml/2006/main" prst="rect">
             <a:avLst/>
@@ -13249,19 +13239,19 @@
           <p:cNvPr id="52" name="">
             <a:extLst xmlns:a="http://schemas.openxmlformats.org/drawingml/2006/main">
               <a:ext uri="{FF2B5EF4-FFF2-40B4-BE49-F238E27FC236}">
-                <a16:creationId xmlns:a16="http://schemas.microsoft.com/office/drawing/2014/main" id="{6B8C0DBC-FF14-49EB-BC17-8A6D30570211}"/>
-              </a:ext>
-            </a:extLst>
-          </p:cNvPr>
-          <p:cNvSpPr>
-            <a:spLocks xmlns:a="http://schemas.openxmlformats.org/drawingml/2006/main" noGrp="1"/>
-          </p:cNvSpPr>
-          <p:nvPr/>
-        </p:nvSpPr>
-        <p:spPr>
-          <a:xfrm xmlns:a="http://schemas.openxmlformats.org/drawingml/2006/main">
-            <a:off x="9620250" y="6467475"/>
-            <a:ext cx="1905000" cy="247650"/>
+                <a16:creationId xmlns:a16="http://schemas.microsoft.com/office/drawing/2014/main" id="{E5D7B46B-CE64-4DCE-A0A5-4FCD1987734B}"/>
+              </a:ext>
+            </a:extLst>
+          </p:cNvPr>
+          <p:cNvSpPr>
+            <a:spLocks xmlns:a="http://schemas.openxmlformats.org/drawingml/2006/main" noGrp="1"/>
+          </p:cNvSpPr>
+          <p:nvPr/>
+        </p:nvSpPr>
+        <p:spPr>
+          <a:xfrm xmlns:a="http://schemas.openxmlformats.org/drawingml/2006/main">
+            <a:off x="10287000" y="6467475"/>
+            <a:ext cx="952500" cy="247650"/>
           </a:xfrm>
           <a:prstGeom xmlns:a="http://schemas.openxmlformats.org/drawingml/2006/main" prst="rect">
             <a:avLst/>
@@ -13297,7 +13287,7 @@
     </p:spTree>
     <p:extLst>
       <p:ext uri="{BB962C8B-B14F-4D97-AF65-F5344CB8AC3E}">
-        <p14:creationId xmlns:p14="http://schemas.microsoft.com/office/powerpoint/2010/main" val="1975235635"/>
+        <p14:creationId xmlns:p14="http://schemas.microsoft.com/office/powerpoint/2010/main" val="1063724861"/>
       </p:ext>
     </p:extLst>
   </p:cSld>
@@ -13328,7 +13318,7 @@
           <p:cNvPr id="30" name="">
             <a:extLst xmlns:a="http://schemas.openxmlformats.org/drawingml/2006/main">
               <a:ext uri="{FF2B5EF4-FFF2-40B4-BE49-F238E27FC236}">
-                <a16:creationId xmlns:a16="http://schemas.microsoft.com/office/drawing/2014/main" id="{D0C0893B-27AA-459E-AE48-4B222FA6179F}"/>
+                <a16:creationId xmlns:a16="http://schemas.microsoft.com/office/drawing/2014/main" id="{2B5D4C6B-2C7E-485B-B590-90351641E1EB}"/>
               </a:ext>
             </a:extLst>
           </p:cNvPr>
@@ -13378,7 +13368,7 @@
           <p:cNvPr id="2" name="">
             <a:extLst xmlns:a="http://schemas.openxmlformats.org/drawingml/2006/main">
               <a:ext uri="{FF2B5EF4-FFF2-40B4-BE49-F238E27FC236}">
-                <a16:creationId xmlns:a16="http://schemas.microsoft.com/office/drawing/2014/main" id="{6FD4B7D1-F638-48AE-98DA-2F1799EA241C}"/>
+                <a16:creationId xmlns:a16="http://schemas.microsoft.com/office/drawing/2014/main" id="{F8DF16BE-312C-4174-A406-17E492709BE9}"/>
               </a:ext>
             </a:extLst>
           </p:cNvPr>
@@ -13428,7 +13418,7 @@
           <p:cNvPr id="3" name="">
             <a:extLst xmlns:a="http://schemas.openxmlformats.org/drawingml/2006/main">
               <a:ext uri="{FF2B5EF4-FFF2-40B4-BE49-F238E27FC236}">
-                <a16:creationId xmlns:a16="http://schemas.microsoft.com/office/drawing/2014/main" id="{C2BA400C-3023-417F-98B6-69FF8C50F419}"/>
+                <a16:creationId xmlns:a16="http://schemas.microsoft.com/office/drawing/2014/main" id="{47EA96BF-9C53-4A33-B8EC-E0187B68B7DB}"/>
               </a:ext>
             </a:extLst>
           </p:cNvPr>
@@ -13478,7 +13468,7 @@
           <p:cNvPr id="4" name="">
             <a:extLst xmlns:a="http://schemas.openxmlformats.org/drawingml/2006/main">
               <a:ext uri="{FF2B5EF4-FFF2-40B4-BE49-F238E27FC236}">
-                <a16:creationId xmlns:a16="http://schemas.microsoft.com/office/drawing/2014/main" id="{70761418-5E91-43A7-B178-902B20E85287}"/>
+                <a16:creationId xmlns:a16="http://schemas.microsoft.com/office/drawing/2014/main" id="{43F89585-2837-4A12-A5B7-677E417C4466}"/>
               </a:ext>
             </a:extLst>
           </p:cNvPr>
@@ -13511,7 +13501,7 @@
           <p:cNvPr id="5" name="">
             <a:extLst xmlns:a="http://schemas.openxmlformats.org/drawingml/2006/main">
               <a:ext uri="{FF2B5EF4-FFF2-40B4-BE49-F238E27FC236}">
-                <a16:creationId xmlns:a16="http://schemas.microsoft.com/office/drawing/2014/main" id="{5BD7306A-E0FE-4BCE-AF67-2E6BBB8B7876}"/>
+                <a16:creationId xmlns:a16="http://schemas.microsoft.com/office/drawing/2014/main" id="{4C5BC28C-BC38-4055-8FFD-CA8FAA26CF0C}"/>
               </a:ext>
             </a:extLst>
           </p:cNvPr>
@@ -13561,7 +13551,7 @@
           <p:cNvPr id="6" name="">
             <a:extLst xmlns:a="http://schemas.openxmlformats.org/drawingml/2006/main">
               <a:ext uri="{FF2B5EF4-FFF2-40B4-BE49-F238E27FC236}">
-                <a16:creationId xmlns:a16="http://schemas.microsoft.com/office/drawing/2014/main" id="{371E8CC5-0C3B-4C93-8A66-8DD4EF464C8E}"/>
+                <a16:creationId xmlns:a16="http://schemas.microsoft.com/office/drawing/2014/main" id="{377FB0C8-E273-4F4A-94E8-FD5D5179B6F0}"/>
               </a:ext>
             </a:extLst>
           </p:cNvPr>
@@ -13611,7 +13601,7 @@
           <p:cNvPr id="7" name="">
             <a:extLst xmlns:a="http://schemas.openxmlformats.org/drawingml/2006/main">
               <a:ext uri="{FF2B5EF4-FFF2-40B4-BE49-F238E27FC236}">
-                <a16:creationId xmlns:a16="http://schemas.microsoft.com/office/drawing/2014/main" id="{E43E8B72-F4CF-4ED8-BCCA-6B3688D5510D}"/>
+                <a16:creationId xmlns:a16="http://schemas.microsoft.com/office/drawing/2014/main" id="{27575D78-1411-40C7-839B-42FD3564F059}"/>
               </a:ext>
             </a:extLst>
           </p:cNvPr>
@@ -13661,7 +13651,7 @@
           <p:cNvPr id="8" name="">
             <a:extLst xmlns:a="http://schemas.openxmlformats.org/drawingml/2006/main">
               <a:ext uri="{FF2B5EF4-FFF2-40B4-BE49-F238E27FC236}">
-                <a16:creationId xmlns:a16="http://schemas.microsoft.com/office/drawing/2014/main" id="{C3057458-D638-4B1F-8552-551A24EEF276}"/>
+                <a16:creationId xmlns:a16="http://schemas.microsoft.com/office/drawing/2014/main" id="{626BFCAE-0830-4804-8EF5-045BFC59C91A}"/>
               </a:ext>
             </a:extLst>
           </p:cNvPr>
@@ -13711,7 +13701,7 @@
           <p:cNvPr id="9" name="">
             <a:extLst xmlns:a="http://schemas.openxmlformats.org/drawingml/2006/main">
               <a:ext uri="{FF2B5EF4-FFF2-40B4-BE49-F238E27FC236}">
-                <a16:creationId xmlns:a16="http://schemas.microsoft.com/office/drawing/2014/main" id="{C3FFDE79-42C3-4FDA-BF99-81541360CE01}"/>
+                <a16:creationId xmlns:a16="http://schemas.microsoft.com/office/drawing/2014/main" id="{0C358167-A67A-4D4F-82BD-407B562C2CA1}"/>
               </a:ext>
             </a:extLst>
           </p:cNvPr>
@@ -13761,7 +13751,7 @@
           <p:cNvPr id="10" name="">
             <a:extLst xmlns:a="http://schemas.openxmlformats.org/drawingml/2006/main">
               <a:ext uri="{FF2B5EF4-FFF2-40B4-BE49-F238E27FC236}">
-                <a16:creationId xmlns:a16="http://schemas.microsoft.com/office/drawing/2014/main" id="{1E2FD92A-18E5-423B-B827-E3FB224D3C85}"/>
+                <a16:creationId xmlns:a16="http://schemas.microsoft.com/office/drawing/2014/main" id="{37C6BE50-6175-4361-B66F-AE65A9F3B1DB}"/>
               </a:ext>
             </a:extLst>
           </p:cNvPr>
@@ -13794,7 +13784,7 @@
           <p:cNvPr id="11" name="">
             <a:extLst xmlns:a="http://schemas.openxmlformats.org/drawingml/2006/main">
               <a:ext uri="{FF2B5EF4-FFF2-40B4-BE49-F238E27FC236}">
-                <a16:creationId xmlns:a16="http://schemas.microsoft.com/office/drawing/2014/main" id="{6626C7D0-A227-41CF-A272-5A231CD8980D}"/>
+                <a16:creationId xmlns:a16="http://schemas.microsoft.com/office/drawing/2014/main" id="{943664D5-23D0-4BF2-A3C1-92ABE76EB0E2}"/>
               </a:ext>
             </a:extLst>
           </p:cNvPr>
@@ -13844,7 +13834,7 @@
           <p:cNvPr id="12" name="">
             <a:extLst xmlns:a="http://schemas.openxmlformats.org/drawingml/2006/main">
               <a:ext uri="{FF2B5EF4-FFF2-40B4-BE49-F238E27FC236}">
-                <a16:creationId xmlns:a16="http://schemas.microsoft.com/office/drawing/2014/main" id="{2FE86E99-CE0F-418E-9283-96FAE4D66587}"/>
+                <a16:creationId xmlns:a16="http://schemas.microsoft.com/office/drawing/2014/main" id="{B7271303-63F5-4200-8063-D43F1B3E42F8}"/>
               </a:ext>
             </a:extLst>
           </p:cNvPr>
@@ -13894,7 +13884,7 @@
           <p:cNvPr id="13" name="">
             <a:extLst xmlns:a="http://schemas.openxmlformats.org/drawingml/2006/main">
               <a:ext uri="{FF2B5EF4-FFF2-40B4-BE49-F238E27FC236}">
-                <a16:creationId xmlns:a16="http://schemas.microsoft.com/office/drawing/2014/main" id="{520B7B9E-8286-468E-AD9A-D4CC276CEE2C}"/>
+                <a16:creationId xmlns:a16="http://schemas.microsoft.com/office/drawing/2014/main" id="{946C0F88-720F-4048-86E6-12825ADAA3EA}"/>
               </a:ext>
             </a:extLst>
           </p:cNvPr>
@@ -13944,7 +13934,7 @@
           <p:cNvPr id="14" name="">
             <a:extLst xmlns:a="http://schemas.openxmlformats.org/drawingml/2006/main">
               <a:ext uri="{FF2B5EF4-FFF2-40B4-BE49-F238E27FC236}">
-                <a16:creationId xmlns:a16="http://schemas.microsoft.com/office/drawing/2014/main" id="{6BADEFD3-F916-4ECD-BAA2-5F9F9E2C5545}"/>
+                <a16:creationId xmlns:a16="http://schemas.microsoft.com/office/drawing/2014/main" id="{159350BB-69F6-4032-AD7D-6F624B9DCB0C}"/>
               </a:ext>
             </a:extLst>
           </p:cNvPr>
@@ -13977,7 +13967,7 @@
           <p:cNvPr id="15" name="">
             <a:extLst xmlns:a="http://schemas.openxmlformats.org/drawingml/2006/main">
               <a:ext uri="{FF2B5EF4-FFF2-40B4-BE49-F238E27FC236}">
-                <a16:creationId xmlns:a16="http://schemas.microsoft.com/office/drawing/2014/main" id="{4BD25798-C671-4045-BF2C-410A0BA82B83}"/>
+                <a16:creationId xmlns:a16="http://schemas.microsoft.com/office/drawing/2014/main" id="{FE4A1233-740E-4A2C-AD49-3416B96A6BEC}"/>
               </a:ext>
             </a:extLst>
           </p:cNvPr>
@@ -14027,7 +14017,7 @@
           <p:cNvPr id="16" name="">
             <a:extLst xmlns:a="http://schemas.openxmlformats.org/drawingml/2006/main">
               <a:ext uri="{FF2B5EF4-FFF2-40B4-BE49-F238E27FC236}">
-                <a16:creationId xmlns:a16="http://schemas.microsoft.com/office/drawing/2014/main" id="{A50C450F-22DD-4CCC-937D-12D86FA2416B}"/>
+                <a16:creationId xmlns:a16="http://schemas.microsoft.com/office/drawing/2014/main" id="{6CD693C7-38D2-421D-A011-F237773500F9}"/>
               </a:ext>
             </a:extLst>
           </p:cNvPr>
@@ -14077,7 +14067,7 @@
           <p:cNvPr id="17" name="">
             <a:extLst xmlns:a="http://schemas.openxmlformats.org/drawingml/2006/main">
               <a:ext uri="{FF2B5EF4-FFF2-40B4-BE49-F238E27FC236}">
-                <a16:creationId xmlns:a16="http://schemas.microsoft.com/office/drawing/2014/main" id="{6CA7865A-3E87-4A7D-8490-FDF89F0650B4}"/>
+                <a16:creationId xmlns:a16="http://schemas.microsoft.com/office/drawing/2014/main" id="{297629F5-3873-49CE-9018-5768F90546E2}"/>
               </a:ext>
             </a:extLst>
           </p:cNvPr>
@@ -14127,7 +14117,7 @@
           <p:cNvPr id="18" name="">
             <a:extLst xmlns:a="http://schemas.openxmlformats.org/drawingml/2006/main">
               <a:ext uri="{FF2B5EF4-FFF2-40B4-BE49-F238E27FC236}">
-                <a16:creationId xmlns:a16="http://schemas.microsoft.com/office/drawing/2014/main" id="{78B61E5C-DE5F-475E-991F-DD45300CAA83}"/>
+                <a16:creationId xmlns:a16="http://schemas.microsoft.com/office/drawing/2014/main" id="{5E63FA13-C95A-4BC8-8371-67B3B1BEAC55}"/>
               </a:ext>
             </a:extLst>
           </p:cNvPr>
@@ -14160,7 +14150,7 @@
           <p:cNvPr id="19" name="">
             <a:extLst xmlns:a="http://schemas.openxmlformats.org/drawingml/2006/main">
               <a:ext uri="{FF2B5EF4-FFF2-40B4-BE49-F238E27FC236}">
-                <a16:creationId xmlns:a16="http://schemas.microsoft.com/office/drawing/2014/main" id="{5CDE78F9-94EB-4A7E-B7F3-20B2351F330E}"/>
+                <a16:creationId xmlns:a16="http://schemas.microsoft.com/office/drawing/2014/main" id="{6C664B62-B520-4A06-8C08-83B8D46B18FA}"/>
               </a:ext>
             </a:extLst>
           </p:cNvPr>
@@ -14210,7 +14200,7 @@
           <p:cNvPr id="20" name="">
             <a:extLst xmlns:a="http://schemas.openxmlformats.org/drawingml/2006/main">
               <a:ext uri="{FF2B5EF4-FFF2-40B4-BE49-F238E27FC236}">
-                <a16:creationId xmlns:a16="http://schemas.microsoft.com/office/drawing/2014/main" id="{42F8CDF7-56D7-44DE-AEBA-68E9248CF7B9}"/>
+                <a16:creationId xmlns:a16="http://schemas.microsoft.com/office/drawing/2014/main" id="{AE40D93C-77C8-4D35-B57C-D7B05933BDBA}"/>
               </a:ext>
             </a:extLst>
           </p:cNvPr>
@@ -14260,7 +14250,7 @@
           <p:cNvPr id="21" name="">
             <a:extLst xmlns:a="http://schemas.openxmlformats.org/drawingml/2006/main">
               <a:ext uri="{FF2B5EF4-FFF2-40B4-BE49-F238E27FC236}">
-                <a16:creationId xmlns:a16="http://schemas.microsoft.com/office/drawing/2014/main" id="{9E585CF4-25D1-4998-AEA4-938B5935E66A}"/>
+                <a16:creationId xmlns:a16="http://schemas.microsoft.com/office/drawing/2014/main" id="{A9B5B72F-3C6F-4A19-8874-88DCDCBD6846}"/>
               </a:ext>
             </a:extLst>
           </p:cNvPr>
@@ -14310,7 +14300,7 @@
           <p:cNvPr id="22" name="">
             <a:extLst xmlns:a="http://schemas.openxmlformats.org/drawingml/2006/main">
               <a:ext uri="{FF2B5EF4-FFF2-40B4-BE49-F238E27FC236}">
-                <a16:creationId xmlns:a16="http://schemas.microsoft.com/office/drawing/2014/main" id="{A5BD156D-A9FB-4B4C-BD26-D39395529F27}"/>
+                <a16:creationId xmlns:a16="http://schemas.microsoft.com/office/drawing/2014/main" id="{FB6F505E-26E0-4565-BA94-64DEC77D1401}"/>
               </a:ext>
             </a:extLst>
           </p:cNvPr>
@@ -14343,7 +14333,7 @@
           <p:cNvPr id="23" name="">
             <a:extLst xmlns:a="http://schemas.openxmlformats.org/drawingml/2006/main">
               <a:ext uri="{FF2B5EF4-FFF2-40B4-BE49-F238E27FC236}">
-                <a16:creationId xmlns:a16="http://schemas.microsoft.com/office/drawing/2014/main" id="{B453718F-EE27-4E43-99C9-D7D9D71B7792}"/>
+                <a16:creationId xmlns:a16="http://schemas.microsoft.com/office/drawing/2014/main" id="{E08EA842-F540-48C6-8CFD-068C758768C4}"/>
               </a:ext>
             </a:extLst>
           </p:cNvPr>
@@ -14378,7 +14368,7 @@
           <p:cNvPr id="24" name="">
             <a:extLst xmlns:a="http://schemas.openxmlformats.org/drawingml/2006/main">
               <a:ext uri="{FF2B5EF4-FFF2-40B4-BE49-F238E27FC236}">
-                <a16:creationId xmlns:a16="http://schemas.microsoft.com/office/drawing/2014/main" id="{B55888F1-AF25-41F5-9E2E-B0627B2A4000}"/>
+                <a16:creationId xmlns:a16="http://schemas.microsoft.com/office/drawing/2014/main" id="{486B945F-9E1A-4AB2-BDAF-406737F14009}"/>
               </a:ext>
             </a:extLst>
           </p:cNvPr>
@@ -14428,7 +14418,7 @@
           <p:cNvPr id="25" name="">
             <a:extLst xmlns:a="http://schemas.openxmlformats.org/drawingml/2006/main">
               <a:ext uri="{FF2B5EF4-FFF2-40B4-BE49-F238E27FC236}">
-                <a16:creationId xmlns:a16="http://schemas.microsoft.com/office/drawing/2014/main" id="{EA735AAE-2FB4-46A4-BB76-6FD8DFB318BA}"/>
+                <a16:creationId xmlns:a16="http://schemas.microsoft.com/office/drawing/2014/main" id="{3133594F-B2C3-4CF6-B25F-8772A2BD07DD}"/>
               </a:ext>
             </a:extLst>
           </p:cNvPr>
@@ -14478,7 +14468,7 @@
           <p:cNvPr id="26" name="">
             <a:extLst xmlns:a="http://schemas.openxmlformats.org/drawingml/2006/main">
               <a:ext uri="{FF2B5EF4-FFF2-40B4-BE49-F238E27FC236}">
-                <a16:creationId xmlns:a16="http://schemas.microsoft.com/office/drawing/2014/main" id="{CDEB1278-6021-43C0-9C7E-F5E8682A9596}"/>
+                <a16:creationId xmlns:a16="http://schemas.microsoft.com/office/drawing/2014/main" id="{1C63AD73-CC05-4FFE-B364-60F033126AB0}"/>
               </a:ext>
             </a:extLst>
           </p:cNvPr>
@@ -14596,7 +14586,7 @@
           <p:cNvPr id="27" name="">
             <a:extLst xmlns:a="http://schemas.openxmlformats.org/drawingml/2006/main">
               <a:ext uri="{FF2B5EF4-FFF2-40B4-BE49-F238E27FC236}">
-                <a16:creationId xmlns:a16="http://schemas.microsoft.com/office/drawing/2014/main" id="{3B6CDE1B-46AD-4288-B6F3-CC97D1E0F459}"/>
+                <a16:creationId xmlns:a16="http://schemas.microsoft.com/office/drawing/2014/main" id="{006F0915-8A45-4180-9965-781AB61ACA63}"/>
               </a:ext>
             </a:extLst>
           </p:cNvPr>
@@ -14629,7 +14619,7 @@
           <p:cNvPr id="28" name="">
             <a:extLst xmlns:a="http://schemas.openxmlformats.org/drawingml/2006/main">
               <a:ext uri="{FF2B5EF4-FFF2-40B4-BE49-F238E27FC236}">
-                <a16:creationId xmlns:a16="http://schemas.microsoft.com/office/drawing/2014/main" id="{4606F44D-D67E-4103-A502-D14D3F0885B7}"/>
+                <a16:creationId xmlns:a16="http://schemas.microsoft.com/office/drawing/2014/main" id="{FB33AB34-16F5-4AA5-B12E-D6D53074A498}"/>
               </a:ext>
             </a:extLst>
           </p:cNvPr>
@@ -14641,7 +14631,7 @@
         <p:spPr>
           <a:xfrm xmlns:a="http://schemas.openxmlformats.org/drawingml/2006/main">
             <a:off x="647700" y="6496050"/>
-            <a:ext cx="9715500" cy="190500"/>
+            <a:ext cx="8953500" cy="190500"/>
           </a:xfrm>
           <a:prstGeom xmlns:a="http://schemas.openxmlformats.org/drawingml/2006/main" prst="rect">
             <a:avLst/>
@@ -14679,19 +14669,19 @@
           <p:cNvPr id="29" name="">
             <a:extLst xmlns:a="http://schemas.openxmlformats.org/drawingml/2006/main">
               <a:ext uri="{FF2B5EF4-FFF2-40B4-BE49-F238E27FC236}">
-                <a16:creationId xmlns:a16="http://schemas.microsoft.com/office/drawing/2014/main" id="{D051FEBF-4330-4902-88B1-7CC0BCA38254}"/>
-              </a:ext>
-            </a:extLst>
-          </p:cNvPr>
-          <p:cNvSpPr>
-            <a:spLocks xmlns:a="http://schemas.openxmlformats.org/drawingml/2006/main" noGrp="1"/>
-          </p:cNvSpPr>
-          <p:nvPr/>
-        </p:nvSpPr>
-        <p:spPr>
-          <a:xfrm xmlns:a="http://schemas.openxmlformats.org/drawingml/2006/main">
-            <a:off x="9620250" y="6467475"/>
-            <a:ext cx="1905000" cy="247650"/>
+                <a16:creationId xmlns:a16="http://schemas.microsoft.com/office/drawing/2014/main" id="{75CE418C-CC50-4DCF-B82D-42FB4AC5FF4E}"/>
+              </a:ext>
+            </a:extLst>
+          </p:cNvPr>
+          <p:cNvSpPr>
+            <a:spLocks xmlns:a="http://schemas.openxmlformats.org/drawingml/2006/main" noGrp="1"/>
+          </p:cNvSpPr>
+          <p:nvPr/>
+        </p:nvSpPr>
+        <p:spPr>
+          <a:xfrm xmlns:a="http://schemas.openxmlformats.org/drawingml/2006/main">
+            <a:off x="10287000" y="6467475"/>
+            <a:ext cx="952500" cy="247650"/>
           </a:xfrm>
           <a:prstGeom xmlns:a="http://schemas.openxmlformats.org/drawingml/2006/main" prst="rect">
             <a:avLst/>
@@ -14727,7 +14717,7 @@
     </p:spTree>
     <p:extLst>
       <p:ext uri="{BB962C8B-B14F-4D97-AF65-F5344CB8AC3E}">
-        <p14:creationId xmlns:p14="http://schemas.microsoft.com/office/powerpoint/2010/main" val="960457165"/>
+        <p14:creationId xmlns:p14="http://schemas.microsoft.com/office/powerpoint/2010/main" val="1261138438"/>
       </p:ext>
     </p:extLst>
   </p:cSld>
@@ -14758,7 +14748,7 @@
           <p:cNvPr id="36" name="">
             <a:extLst xmlns:a="http://schemas.openxmlformats.org/drawingml/2006/main">
               <a:ext uri="{FF2B5EF4-FFF2-40B4-BE49-F238E27FC236}">
-                <a16:creationId xmlns:a16="http://schemas.microsoft.com/office/drawing/2014/main" id="{C5135512-E421-4B9E-A3C9-1CF63D99619C}"/>
+                <a16:creationId xmlns:a16="http://schemas.microsoft.com/office/drawing/2014/main" id="{8D7E032B-B2CC-4C81-84DF-CD836499BC1A}"/>
               </a:ext>
             </a:extLst>
           </p:cNvPr>
@@ -14808,7 +14798,7 @@
           <p:cNvPr id="2" name="">
             <a:extLst xmlns:a="http://schemas.openxmlformats.org/drawingml/2006/main">
               <a:ext uri="{FF2B5EF4-FFF2-40B4-BE49-F238E27FC236}">
-                <a16:creationId xmlns:a16="http://schemas.microsoft.com/office/drawing/2014/main" id="{2D7186B3-6EB5-4CEE-ADF4-E44757C52BC9}"/>
+                <a16:creationId xmlns:a16="http://schemas.microsoft.com/office/drawing/2014/main" id="{4939535D-0E7F-4874-9053-E0995338CC70}"/>
               </a:ext>
             </a:extLst>
           </p:cNvPr>
@@ -14858,7 +14848,7 @@
           <p:cNvPr id="3" name="">
             <a:extLst xmlns:a="http://schemas.openxmlformats.org/drawingml/2006/main">
               <a:ext uri="{FF2B5EF4-FFF2-40B4-BE49-F238E27FC236}">
-                <a16:creationId xmlns:a16="http://schemas.microsoft.com/office/drawing/2014/main" id="{84DFE9E1-3B13-43E5-9939-F9C5CCA56518}"/>
+                <a16:creationId xmlns:a16="http://schemas.microsoft.com/office/drawing/2014/main" id="{8E09BB3A-F4C0-42F8-AD72-BEA10FF071AC}"/>
               </a:ext>
             </a:extLst>
           </p:cNvPr>
@@ -14908,7 +14898,7 @@
           <p:cNvPr id="4" name="">
             <a:extLst xmlns:a="http://schemas.openxmlformats.org/drawingml/2006/main">
               <a:ext uri="{FF2B5EF4-FFF2-40B4-BE49-F238E27FC236}">
-                <a16:creationId xmlns:a16="http://schemas.microsoft.com/office/drawing/2014/main" id="{7A73F7D8-6580-4306-A23B-8FBD08628AF6}"/>
+                <a16:creationId xmlns:a16="http://schemas.microsoft.com/office/drawing/2014/main" id="{94F20576-FE2F-4090-88A3-ACA80C539D48}"/>
               </a:ext>
             </a:extLst>
           </p:cNvPr>
@@ -14941,7 +14931,7 @@
           <p:cNvPr id="5" name="">
             <a:extLst xmlns:a="http://schemas.openxmlformats.org/drawingml/2006/main">
               <a:ext uri="{FF2B5EF4-FFF2-40B4-BE49-F238E27FC236}">
-                <a16:creationId xmlns:a16="http://schemas.microsoft.com/office/drawing/2014/main" id="{701984BB-518B-4F9F-8FE2-261AA7636528}"/>
+                <a16:creationId xmlns:a16="http://schemas.microsoft.com/office/drawing/2014/main" id="{FAF0A239-8479-4D8D-9F48-CDB75FE52C89}"/>
               </a:ext>
             </a:extLst>
           </p:cNvPr>
@@ -14991,7 +14981,7 @@
           <p:cNvPr id="6" name="">
             <a:extLst xmlns:a="http://schemas.openxmlformats.org/drawingml/2006/main">
               <a:ext uri="{FF2B5EF4-FFF2-40B4-BE49-F238E27FC236}">
-                <a16:creationId xmlns:a16="http://schemas.microsoft.com/office/drawing/2014/main" id="{A0B84A68-3F68-4E7C-936F-A72A689546E4}"/>
+                <a16:creationId xmlns:a16="http://schemas.microsoft.com/office/drawing/2014/main" id="{FCF0BC56-01EE-4D58-AD30-5141E37A0F76}"/>
               </a:ext>
             </a:extLst>
           </p:cNvPr>
@@ -15041,7 +15031,7 @@
           <p:cNvPr id="7" name="">
             <a:extLst xmlns:a="http://schemas.openxmlformats.org/drawingml/2006/main">
               <a:ext uri="{FF2B5EF4-FFF2-40B4-BE49-F238E27FC236}">
-                <a16:creationId xmlns:a16="http://schemas.microsoft.com/office/drawing/2014/main" id="{8171121A-301E-425D-95DB-B2B1E87A2E42}"/>
+                <a16:creationId xmlns:a16="http://schemas.microsoft.com/office/drawing/2014/main" id="{3CE6D075-358E-431B-917D-0A5BFB2F380F}"/>
               </a:ext>
             </a:extLst>
           </p:cNvPr>
@@ -15076,7 +15066,7 @@
           <p:cNvPr id="8" name="">
             <a:extLst xmlns:a="http://schemas.openxmlformats.org/drawingml/2006/main">
               <a:ext uri="{FF2B5EF4-FFF2-40B4-BE49-F238E27FC236}">
-                <a16:creationId xmlns:a16="http://schemas.microsoft.com/office/drawing/2014/main" id="{D2FA81DC-8679-495B-86BD-C15BDDA87DB9}"/>
+                <a16:creationId xmlns:a16="http://schemas.microsoft.com/office/drawing/2014/main" id="{F8C9B7CF-9832-4B00-B718-D9DBB8DAF5A0}"/>
               </a:ext>
             </a:extLst>
           </p:cNvPr>
@@ -15143,7 +15133,7 @@
           <p:cNvPr id="9" name="">
             <a:extLst xmlns:a="http://schemas.openxmlformats.org/drawingml/2006/main">
               <a:ext uri="{FF2B5EF4-FFF2-40B4-BE49-F238E27FC236}">
-                <a16:creationId xmlns:a16="http://schemas.microsoft.com/office/drawing/2014/main" id="{29F3678F-9E15-4F04-9738-86EA5E21D9F9}"/>
+                <a16:creationId xmlns:a16="http://schemas.microsoft.com/office/drawing/2014/main" id="{C23DEEB2-8A59-4CD4-8DFC-0AEA6CCAD73A}"/>
               </a:ext>
             </a:extLst>
           </p:cNvPr>
@@ -15278,7 +15268,7 @@
           <p:cNvPr id="10" name="">
             <a:extLst xmlns:a="http://schemas.openxmlformats.org/drawingml/2006/main">
               <a:ext uri="{FF2B5EF4-FFF2-40B4-BE49-F238E27FC236}">
-                <a16:creationId xmlns:a16="http://schemas.microsoft.com/office/drawing/2014/main" id="{11140067-79AD-4A09-9F77-32D0827EE847}"/>
+                <a16:creationId xmlns:a16="http://schemas.microsoft.com/office/drawing/2014/main" id="{013F9252-4352-46C0-B3DA-7BA2333DC359}"/>
               </a:ext>
             </a:extLst>
           </p:cNvPr>
@@ -15311,7 +15301,7 @@
           <p:cNvPr id="11" name="">
             <a:extLst xmlns:a="http://schemas.openxmlformats.org/drawingml/2006/main">
               <a:ext uri="{FF2B5EF4-FFF2-40B4-BE49-F238E27FC236}">
-                <a16:creationId xmlns:a16="http://schemas.microsoft.com/office/drawing/2014/main" id="{E67A3093-8921-4ACA-996B-0A673568EDD2}"/>
+                <a16:creationId xmlns:a16="http://schemas.microsoft.com/office/drawing/2014/main" id="{2169C0F2-D069-47E7-A313-51F646E8ABF0}"/>
               </a:ext>
             </a:extLst>
           </p:cNvPr>
@@ -15344,7 +15334,7 @@
           <p:cNvPr id="12" name="">
             <a:extLst xmlns:a="http://schemas.openxmlformats.org/drawingml/2006/main">
               <a:ext uri="{FF2B5EF4-FFF2-40B4-BE49-F238E27FC236}">
-                <a16:creationId xmlns:a16="http://schemas.microsoft.com/office/drawing/2014/main" id="{6291D79E-B705-4EC4-8935-341828B7F7FB}"/>
+                <a16:creationId xmlns:a16="http://schemas.microsoft.com/office/drawing/2014/main" id="{EEFF343A-94EF-44B0-BDA5-1AF06E7E5AC4}"/>
               </a:ext>
             </a:extLst>
           </p:cNvPr>
@@ -15377,7 +15367,7 @@
           <p:cNvPr id="13" name="">
             <a:extLst xmlns:a="http://schemas.openxmlformats.org/drawingml/2006/main">
               <a:ext uri="{FF2B5EF4-FFF2-40B4-BE49-F238E27FC236}">
-                <a16:creationId xmlns:a16="http://schemas.microsoft.com/office/drawing/2014/main" id="{A2F67619-CEA7-41B0-B1DD-AACC3D564495}"/>
+                <a16:creationId xmlns:a16="http://schemas.microsoft.com/office/drawing/2014/main" id="{7E46EF22-EA77-4E51-BEF4-DA16EBE62126}"/>
               </a:ext>
             </a:extLst>
           </p:cNvPr>
@@ -15427,7 +15417,7 @@
           <p:cNvPr id="14" name="">
             <a:extLst xmlns:a="http://schemas.openxmlformats.org/drawingml/2006/main">
               <a:ext uri="{FF2B5EF4-FFF2-40B4-BE49-F238E27FC236}">
-                <a16:creationId xmlns:a16="http://schemas.microsoft.com/office/drawing/2014/main" id="{B0347FEC-539E-437A-A0B8-123C1F0F4B42}"/>
+                <a16:creationId xmlns:a16="http://schemas.microsoft.com/office/drawing/2014/main" id="{7775D243-DD83-44F7-94E8-035C13CCC2A4}"/>
               </a:ext>
             </a:extLst>
           </p:cNvPr>
@@ -15477,7 +15467,7 @@
           <p:cNvPr id="15" name="">
             <a:extLst xmlns:a="http://schemas.openxmlformats.org/drawingml/2006/main">
               <a:ext uri="{FF2B5EF4-FFF2-40B4-BE49-F238E27FC236}">
-                <a16:creationId xmlns:a16="http://schemas.microsoft.com/office/drawing/2014/main" id="{323B1210-A3DC-4388-ACC0-5EED138B088B}"/>
+                <a16:creationId xmlns:a16="http://schemas.microsoft.com/office/drawing/2014/main" id="{AD68BF82-273E-486A-9742-BEB1FFD6D05E}"/>
               </a:ext>
             </a:extLst>
           </p:cNvPr>
@@ -15510,7 +15500,7 @@
           <p:cNvPr id="16" name="">
             <a:extLst xmlns:a="http://schemas.openxmlformats.org/drawingml/2006/main">
               <a:ext uri="{FF2B5EF4-FFF2-40B4-BE49-F238E27FC236}">
-                <a16:creationId xmlns:a16="http://schemas.microsoft.com/office/drawing/2014/main" id="{67D802F2-2F8C-4BDB-B517-406B86FE8D10}"/>
+                <a16:creationId xmlns:a16="http://schemas.microsoft.com/office/drawing/2014/main" id="{C64ED296-5225-449E-ADB2-DB2B8F59D443}"/>
               </a:ext>
             </a:extLst>
           </p:cNvPr>
@@ -15560,7 +15550,7 @@
           <p:cNvPr id="17" name="">
             <a:extLst xmlns:a="http://schemas.openxmlformats.org/drawingml/2006/main">
               <a:ext uri="{FF2B5EF4-FFF2-40B4-BE49-F238E27FC236}">
-                <a16:creationId xmlns:a16="http://schemas.microsoft.com/office/drawing/2014/main" id="{D9B05F03-BAFA-485E-AB47-0AE8EF3BCB99}"/>
+                <a16:creationId xmlns:a16="http://schemas.microsoft.com/office/drawing/2014/main" id="{EBB6C243-ED83-436A-BEBE-757AA03CA7D6}"/>
               </a:ext>
             </a:extLst>
           </p:cNvPr>
@@ -15610,7 +15600,7 @@
           <p:cNvPr id="18" name="">
             <a:extLst xmlns:a="http://schemas.openxmlformats.org/drawingml/2006/main">
               <a:ext uri="{FF2B5EF4-FFF2-40B4-BE49-F238E27FC236}">
-                <a16:creationId xmlns:a16="http://schemas.microsoft.com/office/drawing/2014/main" id="{13543F4B-FCEE-4BB8-A244-DDF52425C750}"/>
+                <a16:creationId xmlns:a16="http://schemas.microsoft.com/office/drawing/2014/main" id="{C1015437-DDB0-43A7-9477-00B4E0113B65}"/>
               </a:ext>
             </a:extLst>
           </p:cNvPr>
@@ -15643,7 +15633,7 @@
           <p:cNvPr id="19" name="">
             <a:extLst xmlns:a="http://schemas.openxmlformats.org/drawingml/2006/main">
               <a:ext uri="{FF2B5EF4-FFF2-40B4-BE49-F238E27FC236}">
-                <a16:creationId xmlns:a16="http://schemas.microsoft.com/office/drawing/2014/main" id="{9CD5B34E-E754-4E46-886C-F3E9FF7CDE96}"/>
+                <a16:creationId xmlns:a16="http://schemas.microsoft.com/office/drawing/2014/main" id="{6B07431E-3A16-4CA2-A77B-2BB924259122}"/>
               </a:ext>
             </a:extLst>
           </p:cNvPr>
@@ -15693,7 +15683,7 @@
           <p:cNvPr id="20" name="">
             <a:extLst xmlns:a="http://schemas.openxmlformats.org/drawingml/2006/main">
               <a:ext uri="{FF2B5EF4-FFF2-40B4-BE49-F238E27FC236}">
-                <a16:creationId xmlns:a16="http://schemas.microsoft.com/office/drawing/2014/main" id="{986B4971-A95D-47C8-B742-2E5564782891}"/>
+                <a16:creationId xmlns:a16="http://schemas.microsoft.com/office/drawing/2014/main" id="{430C6A18-E306-4EE3-9080-E31AA0C4EEA3}"/>
               </a:ext>
             </a:extLst>
           </p:cNvPr>
@@ -15743,7 +15733,7 @@
           <p:cNvPr id="21" name="">
             <a:extLst xmlns:a="http://schemas.openxmlformats.org/drawingml/2006/main">
               <a:ext uri="{FF2B5EF4-FFF2-40B4-BE49-F238E27FC236}">
-                <a16:creationId xmlns:a16="http://schemas.microsoft.com/office/drawing/2014/main" id="{B2DD526D-BB10-49E5-9AA5-555B34737164}"/>
+                <a16:creationId xmlns:a16="http://schemas.microsoft.com/office/drawing/2014/main" id="{CE72870A-17DF-45BE-9B05-D91D373535D9}"/>
               </a:ext>
             </a:extLst>
           </p:cNvPr>
@@ -15776,7 +15766,7 @@
           <p:cNvPr id="22" name="">
             <a:extLst xmlns:a="http://schemas.openxmlformats.org/drawingml/2006/main">
               <a:ext uri="{FF2B5EF4-FFF2-40B4-BE49-F238E27FC236}">
-                <a16:creationId xmlns:a16="http://schemas.microsoft.com/office/drawing/2014/main" id="{8D3A3C23-3002-4A43-B4F4-D598AC873F25}"/>
+                <a16:creationId xmlns:a16="http://schemas.microsoft.com/office/drawing/2014/main" id="{C2828CE1-79B3-4FBD-904C-F8394B2C34A0}"/>
               </a:ext>
             </a:extLst>
           </p:cNvPr>
@@ -15826,7 +15816,7 @@
           <p:cNvPr id="23" name="">
             <a:extLst xmlns:a="http://schemas.openxmlformats.org/drawingml/2006/main">
               <a:ext uri="{FF2B5EF4-FFF2-40B4-BE49-F238E27FC236}">
-                <a16:creationId xmlns:a16="http://schemas.microsoft.com/office/drawing/2014/main" id="{BF9B3042-5088-46DE-9A00-5705E0043DB7}"/>
+                <a16:creationId xmlns:a16="http://schemas.microsoft.com/office/drawing/2014/main" id="{EFEF6AF6-9893-4394-A754-148A31EE26E3}"/>
               </a:ext>
             </a:extLst>
           </p:cNvPr>
@@ -15876,7 +15866,7 @@
           <p:cNvPr id="24" name="">
             <a:extLst xmlns:a="http://schemas.openxmlformats.org/drawingml/2006/main">
               <a:ext uri="{FF2B5EF4-FFF2-40B4-BE49-F238E27FC236}">
-                <a16:creationId xmlns:a16="http://schemas.microsoft.com/office/drawing/2014/main" id="{3A5C91A2-59ED-4330-A23E-DCA619A26B1B}"/>
+                <a16:creationId xmlns:a16="http://schemas.microsoft.com/office/drawing/2014/main" id="{227D2DF5-739A-4F9D-B02E-D3AC90C7C66C}"/>
               </a:ext>
             </a:extLst>
           </p:cNvPr>
@@ -15909,7 +15899,7 @@
           <p:cNvPr id="25" name="">
             <a:extLst xmlns:a="http://schemas.openxmlformats.org/drawingml/2006/main">
               <a:ext uri="{FF2B5EF4-FFF2-40B4-BE49-F238E27FC236}">
-                <a16:creationId xmlns:a16="http://schemas.microsoft.com/office/drawing/2014/main" id="{2AB3CBAE-DC30-46B6-8589-02CC72C076FF}"/>
+                <a16:creationId xmlns:a16="http://schemas.microsoft.com/office/drawing/2014/main" id="{67179CF9-619F-4038-AE85-38FF5B397F30}"/>
               </a:ext>
             </a:extLst>
           </p:cNvPr>
@@ -15959,7 +15949,7 @@
           <p:cNvPr id="26" name="">
             <a:extLst xmlns:a="http://schemas.openxmlformats.org/drawingml/2006/main">
               <a:ext uri="{FF2B5EF4-FFF2-40B4-BE49-F238E27FC236}">
-                <a16:creationId xmlns:a16="http://schemas.microsoft.com/office/drawing/2014/main" id="{B1375D46-E356-4F04-817D-14D85A5D7F55}"/>
+                <a16:creationId xmlns:a16="http://schemas.microsoft.com/office/drawing/2014/main" id="{62F8D30F-D52F-4E9F-845F-8B1BF130CCF2}"/>
               </a:ext>
             </a:extLst>
           </p:cNvPr>
@@ -16009,7 +15999,7 @@
           <p:cNvPr id="27" name="">
             <a:extLst xmlns:a="http://schemas.openxmlformats.org/drawingml/2006/main">
               <a:ext uri="{FF2B5EF4-FFF2-40B4-BE49-F238E27FC236}">
-                <a16:creationId xmlns:a16="http://schemas.microsoft.com/office/drawing/2014/main" id="{1D7366AF-1849-4BA9-8A2F-D5653BFF1711}"/>
+                <a16:creationId xmlns:a16="http://schemas.microsoft.com/office/drawing/2014/main" id="{406A7F2A-D551-4850-BA82-58EB16C0400C}"/>
               </a:ext>
             </a:extLst>
           </p:cNvPr>
@@ -16042,7 +16032,7 @@
           <p:cNvPr id="28" name="">
             <a:extLst xmlns:a="http://schemas.openxmlformats.org/drawingml/2006/main">
               <a:ext uri="{FF2B5EF4-FFF2-40B4-BE49-F238E27FC236}">
-                <a16:creationId xmlns:a16="http://schemas.microsoft.com/office/drawing/2014/main" id="{46AED1E8-BE92-4B68-9035-F944AFC6DA0D}"/>
+                <a16:creationId xmlns:a16="http://schemas.microsoft.com/office/drawing/2014/main" id="{D7D4B7B3-5702-4B2A-B78C-766B4D17E5EC}"/>
               </a:ext>
             </a:extLst>
           </p:cNvPr>
@@ -16092,7 +16082,7 @@
           <p:cNvPr id="29" name="">
             <a:extLst xmlns:a="http://schemas.openxmlformats.org/drawingml/2006/main">
               <a:ext uri="{FF2B5EF4-FFF2-40B4-BE49-F238E27FC236}">
-                <a16:creationId xmlns:a16="http://schemas.microsoft.com/office/drawing/2014/main" id="{3C98106C-585A-4945-B114-87E61F4DF8E4}"/>
+                <a16:creationId xmlns:a16="http://schemas.microsoft.com/office/drawing/2014/main" id="{5619B0DD-0F21-488F-A36B-3B67166CBECB}"/>
               </a:ext>
             </a:extLst>
           </p:cNvPr>
@@ -16142,7 +16132,7 @@
           <p:cNvPr id="30" name="">
             <a:extLst xmlns:a="http://schemas.openxmlformats.org/drawingml/2006/main">
               <a:ext uri="{FF2B5EF4-FFF2-40B4-BE49-F238E27FC236}">
-                <a16:creationId xmlns:a16="http://schemas.microsoft.com/office/drawing/2014/main" id="{7C927AF0-FB84-4FF8-8D87-4D4D872C1709}"/>
+                <a16:creationId xmlns:a16="http://schemas.microsoft.com/office/drawing/2014/main" id="{669477E9-5AB3-454B-9606-EB0C03DB72A6}"/>
               </a:ext>
             </a:extLst>
           </p:cNvPr>
@@ -16177,7 +16167,7 @@
           <p:cNvPr id="31" name="">
             <a:extLst xmlns:a="http://schemas.openxmlformats.org/drawingml/2006/main">
               <a:ext uri="{FF2B5EF4-FFF2-40B4-BE49-F238E27FC236}">
-                <a16:creationId xmlns:a16="http://schemas.microsoft.com/office/drawing/2014/main" id="{413F380C-F022-462F-A52A-DDE01656BEF5}"/>
+                <a16:creationId xmlns:a16="http://schemas.microsoft.com/office/drawing/2014/main" id="{9DA6A814-61D1-4E99-9B97-1845720E1BC3}"/>
               </a:ext>
             </a:extLst>
           </p:cNvPr>
@@ -16244,7 +16234,7 @@
           <p:cNvPr id="32" name="">
             <a:extLst xmlns:a="http://schemas.openxmlformats.org/drawingml/2006/main">
               <a:ext uri="{FF2B5EF4-FFF2-40B4-BE49-F238E27FC236}">
-                <a16:creationId xmlns:a16="http://schemas.microsoft.com/office/drawing/2014/main" id="{70EA2D1B-6AC2-4413-BAEC-C85A6B50D032}"/>
+                <a16:creationId xmlns:a16="http://schemas.microsoft.com/office/drawing/2014/main" id="{EBFAA341-510D-4F15-9E85-F8D5345A2C3C}"/>
               </a:ext>
             </a:extLst>
           </p:cNvPr>
@@ -16345,7 +16335,7 @@
           <p:cNvPr id="33" name="">
             <a:extLst xmlns:a="http://schemas.openxmlformats.org/drawingml/2006/main">
               <a:ext uri="{FF2B5EF4-FFF2-40B4-BE49-F238E27FC236}">
-                <a16:creationId xmlns:a16="http://schemas.microsoft.com/office/drawing/2014/main" id="{E084C142-590F-4381-9993-9BF3CB1478E4}"/>
+                <a16:creationId xmlns:a16="http://schemas.microsoft.com/office/drawing/2014/main" id="{CB24D055-D360-4658-A7D1-831297E182A5}"/>
               </a:ext>
             </a:extLst>
           </p:cNvPr>
@@ -16378,7 +16368,7 @@
           <p:cNvPr id="34" name="">
             <a:extLst xmlns:a="http://schemas.openxmlformats.org/drawingml/2006/main">
               <a:ext uri="{FF2B5EF4-FFF2-40B4-BE49-F238E27FC236}">
-                <a16:creationId xmlns:a16="http://schemas.microsoft.com/office/drawing/2014/main" id="{298D3E7B-E7C7-4EB3-8D1C-DC1884C90A5A}"/>
+                <a16:creationId xmlns:a16="http://schemas.microsoft.com/office/drawing/2014/main" id="{7CD93E3D-6B28-4F58-BAE3-08F385FCC903}"/>
               </a:ext>
             </a:extLst>
           </p:cNvPr>
@@ -16390,7 +16380,7 @@
         <p:spPr>
           <a:xfrm xmlns:a="http://schemas.openxmlformats.org/drawingml/2006/main">
             <a:off x="647700" y="6496050"/>
-            <a:ext cx="9715500" cy="190500"/>
+            <a:ext cx="8953500" cy="190500"/>
           </a:xfrm>
           <a:prstGeom xmlns:a="http://schemas.openxmlformats.org/drawingml/2006/main" prst="rect">
             <a:avLst/>
@@ -16428,19 +16418,19 @@
           <p:cNvPr id="35" name="">
             <a:extLst xmlns:a="http://schemas.openxmlformats.org/drawingml/2006/main">
               <a:ext uri="{FF2B5EF4-FFF2-40B4-BE49-F238E27FC236}">
-                <a16:creationId xmlns:a16="http://schemas.microsoft.com/office/drawing/2014/main" id="{C6C32143-A707-47E3-8448-E3F43E8FD456}"/>
-              </a:ext>
-            </a:extLst>
-          </p:cNvPr>
-          <p:cNvSpPr>
-            <a:spLocks xmlns:a="http://schemas.openxmlformats.org/drawingml/2006/main" noGrp="1"/>
-          </p:cNvSpPr>
-          <p:nvPr/>
-        </p:nvSpPr>
-        <p:spPr>
-          <a:xfrm xmlns:a="http://schemas.openxmlformats.org/drawingml/2006/main">
-            <a:off x="9620250" y="6467475"/>
-            <a:ext cx="1905000" cy="247650"/>
+                <a16:creationId xmlns:a16="http://schemas.microsoft.com/office/drawing/2014/main" id="{67CA1659-4CE4-4BFF-9A1C-318B8D9DD40B}"/>
+              </a:ext>
+            </a:extLst>
+          </p:cNvPr>
+          <p:cNvSpPr>
+            <a:spLocks xmlns:a="http://schemas.openxmlformats.org/drawingml/2006/main" noGrp="1"/>
+          </p:cNvSpPr>
+          <p:nvPr/>
+        </p:nvSpPr>
+        <p:spPr>
+          <a:xfrm xmlns:a="http://schemas.openxmlformats.org/drawingml/2006/main">
+            <a:off x="10287000" y="6467475"/>
+            <a:ext cx="952500" cy="247650"/>
           </a:xfrm>
           <a:prstGeom xmlns:a="http://schemas.openxmlformats.org/drawingml/2006/main" prst="rect">
             <a:avLst/>
@@ -16476,7 +16466,7 @@
     </p:spTree>
     <p:extLst>
       <p:ext uri="{BB962C8B-B14F-4D97-AF65-F5344CB8AC3E}">
-        <p14:creationId xmlns:p14="http://schemas.microsoft.com/office/powerpoint/2010/main" val="2003762806"/>
+        <p14:creationId xmlns:p14="http://schemas.microsoft.com/office/powerpoint/2010/main" val="791622582"/>
       </p:ext>
     </p:extLst>
   </p:cSld>
@@ -16507,7 +16497,7 @@
           <p:cNvPr id="34" name="">
             <a:extLst xmlns:a="http://schemas.openxmlformats.org/drawingml/2006/main">
               <a:ext uri="{FF2B5EF4-FFF2-40B4-BE49-F238E27FC236}">
-                <a16:creationId xmlns:a16="http://schemas.microsoft.com/office/drawing/2014/main" id="{77AC7F25-3145-4A6B-9B2A-59D3F2709E77}"/>
+                <a16:creationId xmlns:a16="http://schemas.microsoft.com/office/drawing/2014/main" id="{25FF9D17-8E8B-4B25-AE81-F889B4736DC8}"/>
               </a:ext>
             </a:extLst>
           </p:cNvPr>
@@ -16557,7 +16547,7 @@
           <p:cNvPr id="2" name="">
             <a:extLst xmlns:a="http://schemas.openxmlformats.org/drawingml/2006/main">
               <a:ext uri="{FF2B5EF4-FFF2-40B4-BE49-F238E27FC236}">
-                <a16:creationId xmlns:a16="http://schemas.microsoft.com/office/drawing/2014/main" id="{177325F4-3843-4135-B0E0-BCE804282BE5}"/>
+                <a16:creationId xmlns:a16="http://schemas.microsoft.com/office/drawing/2014/main" id="{C0E55808-95F4-47FC-B224-CA19B94A79EC}"/>
               </a:ext>
             </a:extLst>
           </p:cNvPr>
@@ -16607,7 +16597,7 @@
           <p:cNvPr id="3" name="">
             <a:extLst xmlns:a="http://schemas.openxmlformats.org/drawingml/2006/main">
               <a:ext uri="{FF2B5EF4-FFF2-40B4-BE49-F238E27FC236}">
-                <a16:creationId xmlns:a16="http://schemas.microsoft.com/office/drawing/2014/main" id="{8DA3428D-0F37-4615-87AA-149970A3E926}"/>
+                <a16:creationId xmlns:a16="http://schemas.microsoft.com/office/drawing/2014/main" id="{AE0384C6-6EB3-4EF0-89D4-0ABB6DE3AB7D}"/>
               </a:ext>
             </a:extLst>
           </p:cNvPr>
@@ -16657,7 +16647,7 @@
           <p:cNvPr id="4" name="">
             <a:extLst xmlns:a="http://schemas.openxmlformats.org/drawingml/2006/main">
               <a:ext uri="{FF2B5EF4-FFF2-40B4-BE49-F238E27FC236}">
-                <a16:creationId xmlns:a16="http://schemas.microsoft.com/office/drawing/2014/main" id="{5F7ED4EC-DEFD-4D46-BE84-E673D3A3EA7D}"/>
+                <a16:creationId xmlns:a16="http://schemas.microsoft.com/office/drawing/2014/main" id="{52BE3D82-4400-47D4-AF49-4BB287419587}"/>
               </a:ext>
             </a:extLst>
           </p:cNvPr>
@@ -16690,7 +16680,7 @@
           <p:cNvPr id="5" name="">
             <a:extLst xmlns:a="http://schemas.openxmlformats.org/drawingml/2006/main">
               <a:ext uri="{FF2B5EF4-FFF2-40B4-BE49-F238E27FC236}">
-                <a16:creationId xmlns:a16="http://schemas.microsoft.com/office/drawing/2014/main" id="{967AC970-05D4-4033-8338-61CBFBE7F260}"/>
+                <a16:creationId xmlns:a16="http://schemas.microsoft.com/office/drawing/2014/main" id="{2E8C6612-4858-4895-B8BC-081E0DCB13CF}"/>
               </a:ext>
             </a:extLst>
           </p:cNvPr>
@@ -16740,7 +16730,7 @@
           <p:cNvPr id="6" name="">
             <a:extLst xmlns:a="http://schemas.openxmlformats.org/drawingml/2006/main">
               <a:ext uri="{FF2B5EF4-FFF2-40B4-BE49-F238E27FC236}">
-                <a16:creationId xmlns:a16="http://schemas.microsoft.com/office/drawing/2014/main" id="{8382EC3C-FFFB-4E94-A843-71DF59DE19F9}"/>
+                <a16:creationId xmlns:a16="http://schemas.microsoft.com/office/drawing/2014/main" id="{4AB15C9C-78C3-401B-B1DD-CF2DDE46FD43}"/>
               </a:ext>
             </a:extLst>
           </p:cNvPr>
@@ -16790,7 +16780,7 @@
           <p:cNvPr id="7" name="">
             <a:extLst xmlns:a="http://schemas.openxmlformats.org/drawingml/2006/main">
               <a:ext uri="{FF2B5EF4-FFF2-40B4-BE49-F238E27FC236}">
-                <a16:creationId xmlns:a16="http://schemas.microsoft.com/office/drawing/2014/main" id="{F69C1756-D68C-436D-9309-F3B8BF0E833E}"/>
+                <a16:creationId xmlns:a16="http://schemas.microsoft.com/office/drawing/2014/main" id="{F151F6F7-2B0F-40F9-B38F-61681D60B7EE}"/>
               </a:ext>
             </a:extLst>
           </p:cNvPr>
@@ -16823,7 +16813,7 @@
           <p:cNvPr id="8" name="">
             <a:extLst xmlns:a="http://schemas.openxmlformats.org/drawingml/2006/main">
               <a:ext uri="{FF2B5EF4-FFF2-40B4-BE49-F238E27FC236}">
-                <a16:creationId xmlns:a16="http://schemas.microsoft.com/office/drawing/2014/main" id="{EA6B5A12-6A72-438B-BE6A-3A6D4B0DABF7}"/>
+                <a16:creationId xmlns:a16="http://schemas.microsoft.com/office/drawing/2014/main" id="{774547DF-F56D-4102-BA4A-2E289F734DEA}"/>
               </a:ext>
             </a:extLst>
           </p:cNvPr>
@@ -16873,7 +16863,7 @@
           <p:cNvPr id="9" name="">
             <a:extLst xmlns:a="http://schemas.openxmlformats.org/drawingml/2006/main">
               <a:ext uri="{FF2B5EF4-FFF2-40B4-BE49-F238E27FC236}">
-                <a16:creationId xmlns:a16="http://schemas.microsoft.com/office/drawing/2014/main" id="{18804923-A355-4FC1-B722-EE588441F39E}"/>
+                <a16:creationId xmlns:a16="http://schemas.microsoft.com/office/drawing/2014/main" id="{D8F789AF-B87C-41C6-B420-7D3EB0F17E57}"/>
               </a:ext>
             </a:extLst>
           </p:cNvPr>
@@ -16923,7 +16913,7 @@
           <p:cNvPr id="10" name="">
             <a:extLst xmlns:a="http://schemas.openxmlformats.org/drawingml/2006/main">
               <a:ext uri="{FF2B5EF4-FFF2-40B4-BE49-F238E27FC236}">
-                <a16:creationId xmlns:a16="http://schemas.microsoft.com/office/drawing/2014/main" id="{974A0E1A-F8D7-4A10-8176-0C05F716A3C5}"/>
+                <a16:creationId xmlns:a16="http://schemas.microsoft.com/office/drawing/2014/main" id="{D69F91CF-8192-421A-8F9A-3B200546DBE3}"/>
               </a:ext>
             </a:extLst>
           </p:cNvPr>
@@ -16973,7 +16963,7 @@
           <p:cNvPr id="11" name="">
             <a:extLst xmlns:a="http://schemas.openxmlformats.org/drawingml/2006/main">
               <a:ext uri="{FF2B5EF4-FFF2-40B4-BE49-F238E27FC236}">
-                <a16:creationId xmlns:a16="http://schemas.microsoft.com/office/drawing/2014/main" id="{64F2C14A-AD4F-4CAE-BBB8-14FD0F016317}"/>
+                <a16:creationId xmlns:a16="http://schemas.microsoft.com/office/drawing/2014/main" id="{BA361707-F7D0-4CAA-B515-3BA304E4AF5E}"/>
               </a:ext>
             </a:extLst>
           </p:cNvPr>
@@ -17006,7 +16996,7 @@
           <p:cNvPr id="12" name="">
             <a:extLst xmlns:a="http://schemas.openxmlformats.org/drawingml/2006/main">
               <a:ext uri="{FF2B5EF4-FFF2-40B4-BE49-F238E27FC236}">
-                <a16:creationId xmlns:a16="http://schemas.microsoft.com/office/drawing/2014/main" id="{2CB79C45-0EE9-4F45-AF38-CDA9A4237B3D}"/>
+                <a16:creationId xmlns:a16="http://schemas.microsoft.com/office/drawing/2014/main" id="{EA353700-5505-4501-94E5-AB8C573FCB17}"/>
               </a:ext>
             </a:extLst>
           </p:cNvPr>
@@ -17056,7 +17046,7 @@
           <p:cNvPr id="13" name="">
             <a:extLst xmlns:a="http://schemas.openxmlformats.org/drawingml/2006/main">
               <a:ext uri="{FF2B5EF4-FFF2-40B4-BE49-F238E27FC236}">
-                <a16:creationId xmlns:a16="http://schemas.microsoft.com/office/drawing/2014/main" id="{E9CD2018-38ED-48FA-AB16-A3B43100503B}"/>
+                <a16:creationId xmlns:a16="http://schemas.microsoft.com/office/drawing/2014/main" id="{C016E74F-BAFB-4C6F-BD31-47C7844EF789}"/>
               </a:ext>
             </a:extLst>
           </p:cNvPr>
@@ -17106,7 +17096,7 @@
           <p:cNvPr id="14" name="">
             <a:extLst xmlns:a="http://schemas.openxmlformats.org/drawingml/2006/main">
               <a:ext uri="{FF2B5EF4-FFF2-40B4-BE49-F238E27FC236}">
-                <a16:creationId xmlns:a16="http://schemas.microsoft.com/office/drawing/2014/main" id="{31C53726-2C57-4975-8E35-80BE8F29E6DF}"/>
+                <a16:creationId xmlns:a16="http://schemas.microsoft.com/office/drawing/2014/main" id="{49D8BC53-2591-488B-822F-DA5A4CA2E8AD}"/>
               </a:ext>
             </a:extLst>
           </p:cNvPr>
@@ -17156,7 +17146,7 @@
           <p:cNvPr id="15" name="">
             <a:extLst xmlns:a="http://schemas.openxmlformats.org/drawingml/2006/main">
               <a:ext uri="{FF2B5EF4-FFF2-40B4-BE49-F238E27FC236}">
-                <a16:creationId xmlns:a16="http://schemas.microsoft.com/office/drawing/2014/main" id="{CFB487ED-5006-44D5-8A33-131692A6AE64}"/>
+                <a16:creationId xmlns:a16="http://schemas.microsoft.com/office/drawing/2014/main" id="{323F50A3-2F7B-4427-AD80-51E73E422203}"/>
               </a:ext>
             </a:extLst>
           </p:cNvPr>
@@ -17189,7 +17179,7 @@
           <p:cNvPr id="16" name="">
             <a:extLst xmlns:a="http://schemas.openxmlformats.org/drawingml/2006/main">
               <a:ext uri="{FF2B5EF4-FFF2-40B4-BE49-F238E27FC236}">
-                <a16:creationId xmlns:a16="http://schemas.microsoft.com/office/drawing/2014/main" id="{2EE53ADE-0D23-4C49-8497-E7E9A615B7F7}"/>
+                <a16:creationId xmlns:a16="http://schemas.microsoft.com/office/drawing/2014/main" id="{BFA53CAC-6563-4329-8CC7-6AC3CE2DC391}"/>
               </a:ext>
             </a:extLst>
           </p:cNvPr>
@@ -17239,7 +17229,7 @@
           <p:cNvPr id="17" name="">
             <a:extLst xmlns:a="http://schemas.openxmlformats.org/drawingml/2006/main">
               <a:ext uri="{FF2B5EF4-FFF2-40B4-BE49-F238E27FC236}">
-                <a16:creationId xmlns:a16="http://schemas.microsoft.com/office/drawing/2014/main" id="{0A97B53E-5A01-4B93-87BD-0ADC79CF7775}"/>
+                <a16:creationId xmlns:a16="http://schemas.microsoft.com/office/drawing/2014/main" id="{653EF57F-CF76-4409-BCCC-27B0A3487428}"/>
               </a:ext>
             </a:extLst>
           </p:cNvPr>
@@ -17289,7 +17279,7 @@
           <p:cNvPr id="18" name="">
             <a:extLst xmlns:a="http://schemas.openxmlformats.org/drawingml/2006/main">
               <a:ext uri="{FF2B5EF4-FFF2-40B4-BE49-F238E27FC236}">
-                <a16:creationId xmlns:a16="http://schemas.microsoft.com/office/drawing/2014/main" id="{956246E8-8445-40F5-86D0-9DF57A9F1FC0}"/>
+                <a16:creationId xmlns:a16="http://schemas.microsoft.com/office/drawing/2014/main" id="{B51F7E67-7655-4B63-B421-9FDE701EC1D8}"/>
               </a:ext>
             </a:extLst>
           </p:cNvPr>
@@ -17339,7 +17329,7 @@
           <p:cNvPr id="19" name="">
             <a:extLst xmlns:a="http://schemas.openxmlformats.org/drawingml/2006/main">
               <a:ext uri="{FF2B5EF4-FFF2-40B4-BE49-F238E27FC236}">
-                <a16:creationId xmlns:a16="http://schemas.microsoft.com/office/drawing/2014/main" id="{62D37304-4D64-42CF-8DFA-F4FEE2E14BA9}"/>
+                <a16:creationId xmlns:a16="http://schemas.microsoft.com/office/drawing/2014/main" id="{ED985C49-7C25-4ADE-91E7-208B0B4C34F4}"/>
               </a:ext>
             </a:extLst>
           </p:cNvPr>
@@ -17372,7 +17362,7 @@
           <p:cNvPr id="20" name="">
             <a:extLst xmlns:a="http://schemas.openxmlformats.org/drawingml/2006/main">
               <a:ext uri="{FF2B5EF4-FFF2-40B4-BE49-F238E27FC236}">
-                <a16:creationId xmlns:a16="http://schemas.microsoft.com/office/drawing/2014/main" id="{58CB9D00-18DD-4D64-A887-E1568869E9CB}"/>
+                <a16:creationId xmlns:a16="http://schemas.microsoft.com/office/drawing/2014/main" id="{449A79DB-C63C-46B6-B36C-AB0ACE1BBB78}"/>
               </a:ext>
             </a:extLst>
           </p:cNvPr>
@@ -17422,7 +17412,7 @@
           <p:cNvPr id="21" name="">
             <a:extLst xmlns:a="http://schemas.openxmlformats.org/drawingml/2006/main">
               <a:ext uri="{FF2B5EF4-FFF2-40B4-BE49-F238E27FC236}">
-                <a16:creationId xmlns:a16="http://schemas.microsoft.com/office/drawing/2014/main" id="{05674D4C-FCC3-41A0-B486-2DA87E635E5F}"/>
+                <a16:creationId xmlns:a16="http://schemas.microsoft.com/office/drawing/2014/main" id="{C1D64627-2D06-4AE9-9392-E36DC842C113}"/>
               </a:ext>
             </a:extLst>
           </p:cNvPr>
@@ -17472,7 +17462,7 @@
           <p:cNvPr id="22" name="">
             <a:extLst xmlns:a="http://schemas.openxmlformats.org/drawingml/2006/main">
               <a:ext uri="{FF2B5EF4-FFF2-40B4-BE49-F238E27FC236}">
-                <a16:creationId xmlns:a16="http://schemas.microsoft.com/office/drawing/2014/main" id="{DE60FCC2-DA66-4A1C-9F50-C4F634101B21}"/>
+                <a16:creationId xmlns:a16="http://schemas.microsoft.com/office/drawing/2014/main" id="{5E501F60-D90B-41C7-B7E3-02F1BBBACE95}"/>
               </a:ext>
             </a:extLst>
           </p:cNvPr>
@@ -17522,7 +17512,7 @@
           <p:cNvPr id="23" name="">
             <a:extLst xmlns:a="http://schemas.openxmlformats.org/drawingml/2006/main">
               <a:ext uri="{FF2B5EF4-FFF2-40B4-BE49-F238E27FC236}">
-                <a16:creationId xmlns:a16="http://schemas.microsoft.com/office/drawing/2014/main" id="{E8A460F2-2DD4-4A95-8C01-51A3F46ED040}"/>
+                <a16:creationId xmlns:a16="http://schemas.microsoft.com/office/drawing/2014/main" id="{42F696CB-4DE2-4654-A28B-B85D5D19F24F}"/>
               </a:ext>
             </a:extLst>
           </p:cNvPr>
@@ -17572,7 +17562,7 @@
           <p:cNvPr id="24" name="">
             <a:extLst xmlns:a="http://schemas.openxmlformats.org/drawingml/2006/main">
               <a:ext uri="{FF2B5EF4-FFF2-40B4-BE49-F238E27FC236}">
-                <a16:creationId xmlns:a16="http://schemas.microsoft.com/office/drawing/2014/main" id="{04395488-06AD-45C4-B429-4FE43643DB31}"/>
+                <a16:creationId xmlns:a16="http://schemas.microsoft.com/office/drawing/2014/main" id="{46636053-2382-4E67-82AF-6DCF81B52233}"/>
               </a:ext>
             </a:extLst>
           </p:cNvPr>
@@ -17622,7 +17612,7 @@
           <p:cNvPr id="25" name="">
             <a:extLst xmlns:a="http://schemas.openxmlformats.org/drawingml/2006/main">
               <a:ext uri="{FF2B5EF4-FFF2-40B4-BE49-F238E27FC236}">
-                <a16:creationId xmlns:a16="http://schemas.microsoft.com/office/drawing/2014/main" id="{AACD7A58-F5B3-4A38-A3F9-FC416F9F4700}"/>
+                <a16:creationId xmlns:a16="http://schemas.microsoft.com/office/drawing/2014/main" id="{5A380E02-8B86-4BCE-BD38-0D5625457193}"/>
               </a:ext>
             </a:extLst>
           </p:cNvPr>
@@ -17672,7 +17662,7 @@
           <p:cNvPr id="26" name="">
             <a:extLst xmlns:a="http://schemas.openxmlformats.org/drawingml/2006/main">
               <a:ext uri="{FF2B5EF4-FFF2-40B4-BE49-F238E27FC236}">
-                <a16:creationId xmlns:a16="http://schemas.microsoft.com/office/drawing/2014/main" id="{85B15E70-5836-4DA7-86B2-67879A01058A}"/>
+                <a16:creationId xmlns:a16="http://schemas.microsoft.com/office/drawing/2014/main" id="{9584A31C-8555-4DFA-BEA7-3BFEB75B02B7}"/>
               </a:ext>
             </a:extLst>
           </p:cNvPr>
@@ -17722,7 +17712,7 @@
           <p:cNvPr id="27" name="">
             <a:extLst xmlns:a="http://schemas.openxmlformats.org/drawingml/2006/main">
               <a:ext uri="{FF2B5EF4-FFF2-40B4-BE49-F238E27FC236}">
-                <a16:creationId xmlns:a16="http://schemas.microsoft.com/office/drawing/2014/main" id="{F720113B-48E0-4C6C-8FFF-84C494430F89}"/>
+                <a16:creationId xmlns:a16="http://schemas.microsoft.com/office/drawing/2014/main" id="{E3C7A2D0-C634-40DD-BE1B-4E1CC4B84E03}"/>
               </a:ext>
             </a:extLst>
           </p:cNvPr>
@@ -17772,7 +17762,7 @@
           <p:cNvPr id="28" name="">
             <a:extLst xmlns:a="http://schemas.openxmlformats.org/drawingml/2006/main">
               <a:ext uri="{FF2B5EF4-FFF2-40B4-BE49-F238E27FC236}">
-                <a16:creationId xmlns:a16="http://schemas.microsoft.com/office/drawing/2014/main" id="{CF359153-492D-4F8E-BDDD-19AD1D18A552}"/>
+                <a16:creationId xmlns:a16="http://schemas.microsoft.com/office/drawing/2014/main" id="{E19109EF-E68B-431F-8EB0-FECC296158B3}"/>
               </a:ext>
             </a:extLst>
           </p:cNvPr>
@@ -17822,7 +17812,7 @@
           <p:cNvPr id="29" name="">
             <a:extLst xmlns:a="http://schemas.openxmlformats.org/drawingml/2006/main">
               <a:ext uri="{FF2B5EF4-FFF2-40B4-BE49-F238E27FC236}">
-                <a16:creationId xmlns:a16="http://schemas.microsoft.com/office/drawing/2014/main" id="{D08F173E-D232-4FEE-8DBE-7C635BEB6B11}"/>
+                <a16:creationId xmlns:a16="http://schemas.microsoft.com/office/drawing/2014/main" id="{A21DFC3F-CB49-44DF-8289-9525BF7C7DBE}"/>
               </a:ext>
             </a:extLst>
           </p:cNvPr>
@@ -17872,7 +17862,7 @@
           <p:cNvPr id="30" name="">
             <a:extLst xmlns:a="http://schemas.openxmlformats.org/drawingml/2006/main">
               <a:ext uri="{FF2B5EF4-FFF2-40B4-BE49-F238E27FC236}">
-                <a16:creationId xmlns:a16="http://schemas.microsoft.com/office/drawing/2014/main" id="{40022662-278E-45D1-86DC-902485D6DB0A}"/>
+                <a16:creationId xmlns:a16="http://schemas.microsoft.com/office/drawing/2014/main" id="{5937E5F1-B229-4BE7-BFB4-09B1F6F34F5E}"/>
               </a:ext>
             </a:extLst>
           </p:cNvPr>
@@ -17922,7 +17912,7 @@
           <p:cNvPr id="31" name="">
             <a:extLst xmlns:a="http://schemas.openxmlformats.org/drawingml/2006/main">
               <a:ext uri="{FF2B5EF4-FFF2-40B4-BE49-F238E27FC236}">
-                <a16:creationId xmlns:a16="http://schemas.microsoft.com/office/drawing/2014/main" id="{A99821AD-2BA4-4102-8A0F-1B210C908713}"/>
+                <a16:creationId xmlns:a16="http://schemas.microsoft.com/office/drawing/2014/main" id="{B67CB78D-6BBC-409E-ADEF-139E6D31E9C9}"/>
               </a:ext>
             </a:extLst>
           </p:cNvPr>
@@ -17955,7 +17945,7 @@
           <p:cNvPr id="32" name="">
             <a:extLst xmlns:a="http://schemas.openxmlformats.org/drawingml/2006/main">
               <a:ext uri="{FF2B5EF4-FFF2-40B4-BE49-F238E27FC236}">
-                <a16:creationId xmlns:a16="http://schemas.microsoft.com/office/drawing/2014/main" id="{96A4407F-0214-484C-946D-3405F393F508}"/>
+                <a16:creationId xmlns:a16="http://schemas.microsoft.com/office/drawing/2014/main" id="{BD92D1DC-CB28-4376-9048-E3C28EF10408}"/>
               </a:ext>
             </a:extLst>
           </p:cNvPr>
@@ -17967,7 +17957,7 @@
         <p:spPr>
           <a:xfrm xmlns:a="http://schemas.openxmlformats.org/drawingml/2006/main">
             <a:off x="647700" y="6496050"/>
-            <a:ext cx="9715500" cy="190500"/>
+            <a:ext cx="8953500" cy="190500"/>
           </a:xfrm>
           <a:prstGeom xmlns:a="http://schemas.openxmlformats.org/drawingml/2006/main" prst="rect">
             <a:avLst/>
@@ -18005,19 +17995,19 @@
           <p:cNvPr id="33" name="">
             <a:extLst xmlns:a="http://schemas.openxmlformats.org/drawingml/2006/main">
               <a:ext uri="{FF2B5EF4-FFF2-40B4-BE49-F238E27FC236}">
-                <a16:creationId xmlns:a16="http://schemas.microsoft.com/office/drawing/2014/main" id="{1265E16F-D036-4FE0-B635-725A9899F32D}"/>
-              </a:ext>
-            </a:extLst>
-          </p:cNvPr>
-          <p:cNvSpPr>
-            <a:spLocks xmlns:a="http://schemas.openxmlformats.org/drawingml/2006/main" noGrp="1"/>
-          </p:cNvSpPr>
-          <p:nvPr/>
-        </p:nvSpPr>
-        <p:spPr>
-          <a:xfrm xmlns:a="http://schemas.openxmlformats.org/drawingml/2006/main">
-            <a:off x="9620250" y="6467475"/>
-            <a:ext cx="1905000" cy="247650"/>
+                <a16:creationId xmlns:a16="http://schemas.microsoft.com/office/drawing/2014/main" id="{96B3D83A-3D16-4990-A8F7-125A2F6BEDF6}"/>
+              </a:ext>
+            </a:extLst>
+          </p:cNvPr>
+          <p:cNvSpPr>
+            <a:spLocks xmlns:a="http://schemas.openxmlformats.org/drawingml/2006/main" noGrp="1"/>
+          </p:cNvSpPr>
+          <p:nvPr/>
+        </p:nvSpPr>
+        <p:spPr>
+          <a:xfrm xmlns:a="http://schemas.openxmlformats.org/drawingml/2006/main">
+            <a:off x="10287000" y="6467475"/>
+            <a:ext cx="952500" cy="247650"/>
           </a:xfrm>
           <a:prstGeom xmlns:a="http://schemas.openxmlformats.org/drawingml/2006/main" prst="rect">
             <a:avLst/>
@@ -18053,7 +18043,7 @@
     </p:spTree>
     <p:extLst>
       <p:ext uri="{BB962C8B-B14F-4D97-AF65-F5344CB8AC3E}">
-        <p14:creationId xmlns:p14="http://schemas.microsoft.com/office/powerpoint/2010/main" val="1767858765"/>
+        <p14:creationId xmlns:p14="http://schemas.microsoft.com/office/powerpoint/2010/main" val="1340697175"/>
       </p:ext>
     </p:extLst>
   </p:cSld>
@@ -18084,7 +18074,7 @@
           <p:cNvPr id="31" name="">
             <a:extLst xmlns:a="http://schemas.openxmlformats.org/drawingml/2006/main">
               <a:ext uri="{FF2B5EF4-FFF2-40B4-BE49-F238E27FC236}">
-                <a16:creationId xmlns:a16="http://schemas.microsoft.com/office/drawing/2014/main" id="{7EF45399-3DE0-4E69-A3AB-9AB50D39A7A9}"/>
+                <a16:creationId xmlns:a16="http://schemas.microsoft.com/office/drawing/2014/main" id="{C6152B4F-7B4A-47C7-AEF4-2B874D41B601}"/>
               </a:ext>
             </a:extLst>
           </p:cNvPr>
@@ -18134,7 +18124,7 @@
           <p:cNvPr id="2" name="">
             <a:extLst xmlns:a="http://schemas.openxmlformats.org/drawingml/2006/main">
               <a:ext uri="{FF2B5EF4-FFF2-40B4-BE49-F238E27FC236}">
-                <a16:creationId xmlns:a16="http://schemas.microsoft.com/office/drawing/2014/main" id="{5F211539-A8E9-4ED0-8987-00C781B8D9F2}"/>
+                <a16:creationId xmlns:a16="http://schemas.microsoft.com/office/drawing/2014/main" id="{36522388-50D6-46A9-A73D-C9C4778E3E83}"/>
               </a:ext>
             </a:extLst>
           </p:cNvPr>
@@ -18184,7 +18174,7 @@
           <p:cNvPr id="3" name="">
             <a:extLst xmlns:a="http://schemas.openxmlformats.org/drawingml/2006/main">
               <a:ext uri="{FF2B5EF4-FFF2-40B4-BE49-F238E27FC236}">
-                <a16:creationId xmlns:a16="http://schemas.microsoft.com/office/drawing/2014/main" id="{A3C46A6C-5ABE-4713-A5C1-589BECF21638}"/>
+                <a16:creationId xmlns:a16="http://schemas.microsoft.com/office/drawing/2014/main" id="{FE3C8D3A-9663-49EF-B939-28940F3C7881}"/>
               </a:ext>
             </a:extLst>
           </p:cNvPr>
@@ -18234,7 +18224,7 @@
           <p:cNvPr id="4" name="">
             <a:extLst xmlns:a="http://schemas.openxmlformats.org/drawingml/2006/main">
               <a:ext uri="{FF2B5EF4-FFF2-40B4-BE49-F238E27FC236}">
-                <a16:creationId xmlns:a16="http://schemas.microsoft.com/office/drawing/2014/main" id="{348AE0E2-A1CC-4944-8244-33A3B84DAE17}"/>
+                <a16:creationId xmlns:a16="http://schemas.microsoft.com/office/drawing/2014/main" id="{1D7492BC-85D9-46C8-9A2B-D8F031F5EAC6}"/>
               </a:ext>
             </a:extLst>
           </p:cNvPr>
@@ -18267,7 +18257,7 @@
           <p:cNvPr id="5" name="">
             <a:extLst xmlns:a="http://schemas.openxmlformats.org/drawingml/2006/main">
               <a:ext uri="{FF2B5EF4-FFF2-40B4-BE49-F238E27FC236}">
-                <a16:creationId xmlns:a16="http://schemas.microsoft.com/office/drawing/2014/main" id="{91AE9D44-798C-426A-8B60-C481C2FB729B}"/>
+                <a16:creationId xmlns:a16="http://schemas.microsoft.com/office/drawing/2014/main" id="{CA3A787B-0A5F-43A0-B6EB-23DBDDE8B56D}"/>
               </a:ext>
             </a:extLst>
           </p:cNvPr>
@@ -18317,7 +18307,7 @@
           <p:cNvPr id="6" name="">
             <a:extLst xmlns:a="http://schemas.openxmlformats.org/drawingml/2006/main">
               <a:ext uri="{FF2B5EF4-FFF2-40B4-BE49-F238E27FC236}">
-                <a16:creationId xmlns:a16="http://schemas.microsoft.com/office/drawing/2014/main" id="{214C0E3A-AC1E-4802-8F6B-EC12036E9D96}"/>
+                <a16:creationId xmlns:a16="http://schemas.microsoft.com/office/drawing/2014/main" id="{9DBE0537-F68F-46E6-AE69-CF94F2C397A2}"/>
               </a:ext>
             </a:extLst>
           </p:cNvPr>
@@ -18352,7 +18342,7 @@
           <p:cNvPr id="7" name="">
             <a:extLst xmlns:a="http://schemas.openxmlformats.org/drawingml/2006/main">
               <a:ext uri="{FF2B5EF4-FFF2-40B4-BE49-F238E27FC236}">
-                <a16:creationId xmlns:a16="http://schemas.microsoft.com/office/drawing/2014/main" id="{45A323E2-C005-4086-9868-C443D5B4AB74}"/>
+                <a16:creationId xmlns:a16="http://schemas.microsoft.com/office/drawing/2014/main" id="{8521F1CD-D3D8-47F2-9377-8AF79AC1A8D9}"/>
               </a:ext>
             </a:extLst>
           </p:cNvPr>
@@ -18402,7 +18392,7 @@
           <p:cNvPr id="8" name="">
             <a:extLst xmlns:a="http://schemas.openxmlformats.org/drawingml/2006/main">
               <a:ext uri="{FF2B5EF4-FFF2-40B4-BE49-F238E27FC236}">
-                <a16:creationId xmlns:a16="http://schemas.microsoft.com/office/drawing/2014/main" id="{5326944E-EC23-404B-9E4A-361D189E787C}"/>
+                <a16:creationId xmlns:a16="http://schemas.microsoft.com/office/drawing/2014/main" id="{AFE587FD-4926-4F05-AB32-9B4C7D188F23}"/>
               </a:ext>
             </a:extLst>
           </p:cNvPr>
@@ -18469,7 +18459,7 @@
           <p:cNvPr id="9" name="">
             <a:extLst xmlns:a="http://schemas.openxmlformats.org/drawingml/2006/main">
               <a:ext uri="{FF2B5EF4-FFF2-40B4-BE49-F238E27FC236}">
-                <a16:creationId xmlns:a16="http://schemas.microsoft.com/office/drawing/2014/main" id="{E90DBA28-BEF7-4DFF-B472-A43F25B18B6F}"/>
+                <a16:creationId xmlns:a16="http://schemas.microsoft.com/office/drawing/2014/main" id="{82332564-6C3E-41C1-8E2D-BBA868DE4FAE}"/>
               </a:ext>
             </a:extLst>
           </p:cNvPr>
@@ -18536,7 +18526,7 @@
           <p:cNvPr id="10" name="">
             <a:extLst xmlns:a="http://schemas.openxmlformats.org/drawingml/2006/main">
               <a:ext uri="{FF2B5EF4-FFF2-40B4-BE49-F238E27FC236}">
-                <a16:creationId xmlns:a16="http://schemas.microsoft.com/office/drawing/2014/main" id="{42B01392-8393-44E2-9331-52C6A37378C4}"/>
+                <a16:creationId xmlns:a16="http://schemas.microsoft.com/office/drawing/2014/main" id="{6B959D40-438C-4CBA-A184-065CE6716DFA}"/>
               </a:ext>
             </a:extLst>
           </p:cNvPr>
@@ -18586,7 +18576,7 @@
           <p:cNvPr id="11" name="">
             <a:extLst xmlns:a="http://schemas.openxmlformats.org/drawingml/2006/main">
               <a:ext uri="{FF2B5EF4-FFF2-40B4-BE49-F238E27FC236}">
-                <a16:creationId xmlns:a16="http://schemas.microsoft.com/office/drawing/2014/main" id="{4C86361A-CAC0-4E1B-A00B-5DB9B270E962}"/>
+                <a16:creationId xmlns:a16="http://schemas.microsoft.com/office/drawing/2014/main" id="{ED84376E-FAFF-4F2D-A299-647AA3D67972}"/>
               </a:ext>
             </a:extLst>
           </p:cNvPr>
@@ -18636,7 +18626,7 @@
           <p:cNvPr id="12" name="">
             <a:extLst xmlns:a="http://schemas.openxmlformats.org/drawingml/2006/main">
               <a:ext uri="{FF2B5EF4-FFF2-40B4-BE49-F238E27FC236}">
-                <a16:creationId xmlns:a16="http://schemas.microsoft.com/office/drawing/2014/main" id="{EA6425AD-EC73-4FB2-A149-C32EFE3E55D5}"/>
+                <a16:creationId xmlns:a16="http://schemas.microsoft.com/office/drawing/2014/main" id="{34D7F01F-A69E-4098-8676-076A47238E6E}"/>
               </a:ext>
             </a:extLst>
           </p:cNvPr>
@@ -18686,7 +18676,7 @@
           <p:cNvPr id="13" name="">
             <a:extLst xmlns:a="http://schemas.openxmlformats.org/drawingml/2006/main">
               <a:ext uri="{FF2B5EF4-FFF2-40B4-BE49-F238E27FC236}">
-                <a16:creationId xmlns:a16="http://schemas.microsoft.com/office/drawing/2014/main" id="{01EF781D-308C-4DB1-8529-4540BE6B4558}"/>
+                <a16:creationId xmlns:a16="http://schemas.microsoft.com/office/drawing/2014/main" id="{B7FD03DA-F984-4685-92D4-E0B76F376BAF}"/>
               </a:ext>
             </a:extLst>
           </p:cNvPr>
@@ -18719,7 +18709,7 @@
           <p:cNvPr id="14" name="">
             <a:extLst xmlns:a="http://schemas.openxmlformats.org/drawingml/2006/main">
               <a:ext uri="{FF2B5EF4-FFF2-40B4-BE49-F238E27FC236}">
-                <a16:creationId xmlns:a16="http://schemas.microsoft.com/office/drawing/2014/main" id="{5E5AC82E-08FF-496B-8A36-8126D557867C}"/>
+                <a16:creationId xmlns:a16="http://schemas.microsoft.com/office/drawing/2014/main" id="{1EF9A031-70E7-4A9F-B4B8-6A0A09BEA295}"/>
               </a:ext>
             </a:extLst>
           </p:cNvPr>
@@ -18769,7 +18759,7 @@
           <p:cNvPr id="15" name="">
             <a:extLst xmlns:a="http://schemas.openxmlformats.org/drawingml/2006/main">
               <a:ext uri="{FF2B5EF4-FFF2-40B4-BE49-F238E27FC236}">
-                <a16:creationId xmlns:a16="http://schemas.microsoft.com/office/drawing/2014/main" id="{DE6C5789-6C23-4298-A724-54A0191E4C86}"/>
+                <a16:creationId xmlns:a16="http://schemas.microsoft.com/office/drawing/2014/main" id="{76371720-5E7C-4011-B8EA-8450942B6AC6}"/>
               </a:ext>
             </a:extLst>
           </p:cNvPr>
@@ -18819,7 +18809,7 @@
           <p:cNvPr id="16" name="">
             <a:extLst xmlns:a="http://schemas.openxmlformats.org/drawingml/2006/main">
               <a:ext uri="{FF2B5EF4-FFF2-40B4-BE49-F238E27FC236}">
-                <a16:creationId xmlns:a16="http://schemas.microsoft.com/office/drawing/2014/main" id="{6617016C-80B5-46A5-B2E8-D32BE625B1D8}"/>
+                <a16:creationId xmlns:a16="http://schemas.microsoft.com/office/drawing/2014/main" id="{114138A5-DCF2-4DF6-83C2-D4CDBF9649F8}"/>
               </a:ext>
             </a:extLst>
           </p:cNvPr>
@@ -18869,7 +18859,7 @@
           <p:cNvPr id="17" name="">
             <a:extLst xmlns:a="http://schemas.openxmlformats.org/drawingml/2006/main">
               <a:ext uri="{FF2B5EF4-FFF2-40B4-BE49-F238E27FC236}">
-                <a16:creationId xmlns:a16="http://schemas.microsoft.com/office/drawing/2014/main" id="{C94798E8-E848-409F-953A-0F413CFC91EB}"/>
+                <a16:creationId xmlns:a16="http://schemas.microsoft.com/office/drawing/2014/main" id="{F0902694-8511-4EF0-A30B-A0798FEF73A4}"/>
               </a:ext>
             </a:extLst>
           </p:cNvPr>
@@ -18902,7 +18892,7 @@
           <p:cNvPr id="18" name="">
             <a:extLst xmlns:a="http://schemas.openxmlformats.org/drawingml/2006/main">
               <a:ext uri="{FF2B5EF4-FFF2-40B4-BE49-F238E27FC236}">
-                <a16:creationId xmlns:a16="http://schemas.microsoft.com/office/drawing/2014/main" id="{336B0A76-0EE3-4908-BCDB-DD541A82DC93}"/>
+                <a16:creationId xmlns:a16="http://schemas.microsoft.com/office/drawing/2014/main" id="{AFA695D8-3365-4B00-B6E7-8A168D3CE99F}"/>
               </a:ext>
             </a:extLst>
           </p:cNvPr>
@@ -18952,7 +18942,7 @@
           <p:cNvPr id="19" name="">
             <a:extLst xmlns:a="http://schemas.openxmlformats.org/drawingml/2006/main">
               <a:ext uri="{FF2B5EF4-FFF2-40B4-BE49-F238E27FC236}">
-                <a16:creationId xmlns:a16="http://schemas.microsoft.com/office/drawing/2014/main" id="{CA2C7F3B-EB28-4EF4-95AB-03726F922861}"/>
+                <a16:creationId xmlns:a16="http://schemas.microsoft.com/office/drawing/2014/main" id="{E8C36C14-D55F-40C9-8C41-4B249A205AA5}"/>
               </a:ext>
             </a:extLst>
           </p:cNvPr>
@@ -19002,7 +18992,7 @@
           <p:cNvPr id="20" name="">
             <a:extLst xmlns:a="http://schemas.openxmlformats.org/drawingml/2006/main">
               <a:ext uri="{FF2B5EF4-FFF2-40B4-BE49-F238E27FC236}">
-                <a16:creationId xmlns:a16="http://schemas.microsoft.com/office/drawing/2014/main" id="{43703801-0562-4BD7-A310-AE2B3B88AFAD}"/>
+                <a16:creationId xmlns:a16="http://schemas.microsoft.com/office/drawing/2014/main" id="{F3BC3FCA-6313-4194-8FDD-A9C45C3572E3}"/>
               </a:ext>
             </a:extLst>
           </p:cNvPr>
@@ -19052,7 +19042,7 @@
           <p:cNvPr id="21" name="">
             <a:extLst xmlns:a="http://schemas.openxmlformats.org/drawingml/2006/main">
               <a:ext uri="{FF2B5EF4-FFF2-40B4-BE49-F238E27FC236}">
-                <a16:creationId xmlns:a16="http://schemas.microsoft.com/office/drawing/2014/main" id="{B2A5672F-AE46-445C-926A-CBDD04B90E16}"/>
+                <a16:creationId xmlns:a16="http://schemas.microsoft.com/office/drawing/2014/main" id="{8CFB0F23-2F59-4059-8FE2-D7C1A6414B3A}"/>
               </a:ext>
             </a:extLst>
           </p:cNvPr>
@@ -19085,7 +19075,7 @@
           <p:cNvPr id="22" name="">
             <a:extLst xmlns:a="http://schemas.openxmlformats.org/drawingml/2006/main">
               <a:ext uri="{FF2B5EF4-FFF2-40B4-BE49-F238E27FC236}">
-                <a16:creationId xmlns:a16="http://schemas.microsoft.com/office/drawing/2014/main" id="{A8B0D730-C743-42E5-BAB6-B094445B03F4}"/>
+                <a16:creationId xmlns:a16="http://schemas.microsoft.com/office/drawing/2014/main" id="{FA4BC357-207D-4217-A89D-9CA7FD2EAA56}"/>
               </a:ext>
             </a:extLst>
           </p:cNvPr>
@@ -19135,7 +19125,7 @@
           <p:cNvPr id="23" name="">
             <a:extLst xmlns:a="http://schemas.openxmlformats.org/drawingml/2006/main">
               <a:ext uri="{FF2B5EF4-FFF2-40B4-BE49-F238E27FC236}">
-                <a16:creationId xmlns:a16="http://schemas.microsoft.com/office/drawing/2014/main" id="{2A5EBD3E-B82C-4AFA-BE8B-6E9834170A63}"/>
+                <a16:creationId xmlns:a16="http://schemas.microsoft.com/office/drawing/2014/main" id="{329AF8BE-B22C-479F-A71F-8A741C1FF9D0}"/>
               </a:ext>
             </a:extLst>
           </p:cNvPr>
@@ -19185,7 +19175,7 @@
           <p:cNvPr id="24" name="">
             <a:extLst xmlns:a="http://schemas.openxmlformats.org/drawingml/2006/main">
               <a:ext uri="{FF2B5EF4-FFF2-40B4-BE49-F238E27FC236}">
-                <a16:creationId xmlns:a16="http://schemas.microsoft.com/office/drawing/2014/main" id="{CFA90AC4-308F-4137-9182-CB06F9B54014}"/>
+                <a16:creationId xmlns:a16="http://schemas.microsoft.com/office/drawing/2014/main" id="{7D2D4549-E7A1-40C5-8532-94BAC3FD045D}"/>
               </a:ext>
             </a:extLst>
           </p:cNvPr>
@@ -19235,7 +19225,7 @@
           <p:cNvPr id="25" name="">
             <a:extLst xmlns:a="http://schemas.openxmlformats.org/drawingml/2006/main">
               <a:ext uri="{FF2B5EF4-FFF2-40B4-BE49-F238E27FC236}">
-                <a16:creationId xmlns:a16="http://schemas.microsoft.com/office/drawing/2014/main" id="{C37B76E6-1865-4B4D-9A3A-D74C3C4A6A7D}"/>
+                <a16:creationId xmlns:a16="http://schemas.microsoft.com/office/drawing/2014/main" id="{B195F4A7-133B-419B-BD1E-79374B1F9877}"/>
               </a:ext>
             </a:extLst>
           </p:cNvPr>
@@ -19268,7 +19258,7 @@
           <p:cNvPr id="26" name="">
             <a:extLst xmlns:a="http://schemas.openxmlformats.org/drawingml/2006/main">
               <a:ext uri="{FF2B5EF4-FFF2-40B4-BE49-F238E27FC236}">
-                <a16:creationId xmlns:a16="http://schemas.microsoft.com/office/drawing/2014/main" id="{B4E49A2B-8D2A-43C8-9416-547CD1A230B3}"/>
+                <a16:creationId xmlns:a16="http://schemas.microsoft.com/office/drawing/2014/main" id="{60340066-AC3F-449A-A78D-9752CF580D2A}"/>
               </a:ext>
             </a:extLst>
           </p:cNvPr>
@@ -19303,7 +19293,7 @@
           <p:cNvPr id="27" name="">
             <a:extLst xmlns:a="http://schemas.openxmlformats.org/drawingml/2006/main">
               <a:ext uri="{FF2B5EF4-FFF2-40B4-BE49-F238E27FC236}">
-                <a16:creationId xmlns:a16="http://schemas.microsoft.com/office/drawing/2014/main" id="{96201596-FC83-42F3-ADD2-5BBB7902CA48}"/>
+                <a16:creationId xmlns:a16="http://schemas.microsoft.com/office/drawing/2014/main" id="{9F4EB644-2A2F-4A58-BC52-025FF3A9213F}"/>
               </a:ext>
             </a:extLst>
           </p:cNvPr>
@@ -19353,7 +19343,7 @@
           <p:cNvPr id="28" name="">
             <a:extLst xmlns:a="http://schemas.openxmlformats.org/drawingml/2006/main">
               <a:ext uri="{FF2B5EF4-FFF2-40B4-BE49-F238E27FC236}">
-                <a16:creationId xmlns:a16="http://schemas.microsoft.com/office/drawing/2014/main" id="{087F6866-6AD6-49C2-81EF-5B93BB5B92CE}"/>
+                <a16:creationId xmlns:a16="http://schemas.microsoft.com/office/drawing/2014/main" id="{4251CA8D-CD4D-41DC-B183-D664000655F2}"/>
               </a:ext>
             </a:extLst>
           </p:cNvPr>
@@ -19386,7 +19376,7 @@
           <p:cNvPr id="29" name="">
             <a:extLst xmlns:a="http://schemas.openxmlformats.org/drawingml/2006/main">
               <a:ext uri="{FF2B5EF4-FFF2-40B4-BE49-F238E27FC236}">
-                <a16:creationId xmlns:a16="http://schemas.microsoft.com/office/drawing/2014/main" id="{DBF3E819-7CDC-4EFC-8522-A8DD2AC0C28C}"/>
+                <a16:creationId xmlns:a16="http://schemas.microsoft.com/office/drawing/2014/main" id="{5DDCF0E6-6EBB-40CE-B3B9-B870EFA364F3}"/>
               </a:ext>
             </a:extLst>
           </p:cNvPr>
@@ -19398,7 +19388,7 @@
         <p:spPr>
           <a:xfrm xmlns:a="http://schemas.openxmlformats.org/drawingml/2006/main">
             <a:off x="647700" y="6496050"/>
-            <a:ext cx="9715500" cy="190500"/>
+            <a:ext cx="8953500" cy="190500"/>
           </a:xfrm>
           <a:prstGeom xmlns:a="http://schemas.openxmlformats.org/drawingml/2006/main" prst="rect">
             <a:avLst/>
@@ -19436,19 +19426,19 @@
           <p:cNvPr id="30" name="">
             <a:extLst xmlns:a="http://schemas.openxmlformats.org/drawingml/2006/main">
               <a:ext uri="{FF2B5EF4-FFF2-40B4-BE49-F238E27FC236}">
-                <a16:creationId xmlns:a16="http://schemas.microsoft.com/office/drawing/2014/main" id="{E2B842BE-A07C-4882-B4AD-B6F1BFE67035}"/>
-              </a:ext>
-            </a:extLst>
-          </p:cNvPr>
-          <p:cNvSpPr>
-            <a:spLocks xmlns:a="http://schemas.openxmlformats.org/drawingml/2006/main" noGrp="1"/>
-          </p:cNvSpPr>
-          <p:nvPr/>
-        </p:nvSpPr>
-        <p:spPr>
-          <a:xfrm xmlns:a="http://schemas.openxmlformats.org/drawingml/2006/main">
-            <a:off x="9620250" y="6467475"/>
-            <a:ext cx="1905000" cy="247650"/>
+                <a16:creationId xmlns:a16="http://schemas.microsoft.com/office/drawing/2014/main" id="{D4EF6CA6-09E5-4596-9278-DB702B77F9C6}"/>
+              </a:ext>
+            </a:extLst>
+          </p:cNvPr>
+          <p:cNvSpPr>
+            <a:spLocks xmlns:a="http://schemas.openxmlformats.org/drawingml/2006/main" noGrp="1"/>
+          </p:cNvSpPr>
+          <p:nvPr/>
+        </p:nvSpPr>
+        <p:spPr>
+          <a:xfrm xmlns:a="http://schemas.openxmlformats.org/drawingml/2006/main">
+            <a:off x="10287000" y="6467475"/>
+            <a:ext cx="952500" cy="247650"/>
           </a:xfrm>
           <a:prstGeom xmlns:a="http://schemas.openxmlformats.org/drawingml/2006/main" prst="rect">
             <a:avLst/>
@@ -19484,7 +19474,7 @@
     </p:spTree>
     <p:extLst>
       <p:ext uri="{BB962C8B-B14F-4D97-AF65-F5344CB8AC3E}">
-        <p14:creationId xmlns:p14="http://schemas.microsoft.com/office/powerpoint/2010/main" val="1281271460"/>
+        <p14:creationId xmlns:p14="http://schemas.microsoft.com/office/powerpoint/2010/main" val="493348347"/>
       </p:ext>
     </p:extLst>
   </p:cSld>
@@ -19515,7 +19505,7 @@
           <p:cNvPr id="43" name="">
             <a:extLst xmlns:a="http://schemas.openxmlformats.org/drawingml/2006/main">
               <a:ext uri="{FF2B5EF4-FFF2-40B4-BE49-F238E27FC236}">
-                <a16:creationId xmlns:a16="http://schemas.microsoft.com/office/drawing/2014/main" id="{43038AF1-9FF9-4645-86B4-DD76AE9CC291}"/>
+                <a16:creationId xmlns:a16="http://schemas.microsoft.com/office/drawing/2014/main" id="{681927B9-65EB-4915-8172-5128D057B40B}"/>
               </a:ext>
             </a:extLst>
           </p:cNvPr>
@@ -19565,7 +19555,7 @@
           <p:cNvPr id="2" name="">
             <a:extLst xmlns:a="http://schemas.openxmlformats.org/drawingml/2006/main">
               <a:ext uri="{FF2B5EF4-FFF2-40B4-BE49-F238E27FC236}">
-                <a16:creationId xmlns:a16="http://schemas.microsoft.com/office/drawing/2014/main" id="{545AC658-3699-41EC-85BC-91859715DBB9}"/>
+                <a16:creationId xmlns:a16="http://schemas.microsoft.com/office/drawing/2014/main" id="{674982E2-8C14-45EF-92AC-7CD22587EF13}"/>
               </a:ext>
             </a:extLst>
           </p:cNvPr>
@@ -19615,7 +19605,7 @@
           <p:cNvPr id="3" name="">
             <a:extLst xmlns:a="http://schemas.openxmlformats.org/drawingml/2006/main">
               <a:ext uri="{FF2B5EF4-FFF2-40B4-BE49-F238E27FC236}">
-                <a16:creationId xmlns:a16="http://schemas.microsoft.com/office/drawing/2014/main" id="{2566E502-B8F1-4B9F-8DBA-E1C33CC05A3C}"/>
+                <a16:creationId xmlns:a16="http://schemas.microsoft.com/office/drawing/2014/main" id="{C5D7D1B5-DC42-47E6-84C3-02E1BFC8ECE1}"/>
               </a:ext>
             </a:extLst>
           </p:cNvPr>
@@ -19665,7 +19655,7 @@
           <p:cNvPr id="4" name="">
             <a:extLst xmlns:a="http://schemas.openxmlformats.org/drawingml/2006/main">
               <a:ext uri="{FF2B5EF4-FFF2-40B4-BE49-F238E27FC236}">
-                <a16:creationId xmlns:a16="http://schemas.microsoft.com/office/drawing/2014/main" id="{C2B8F6A1-C892-44B8-B813-A043D5E31D18}"/>
+                <a16:creationId xmlns:a16="http://schemas.microsoft.com/office/drawing/2014/main" id="{163C67B4-F602-4753-92B7-B3000B7FA80C}"/>
               </a:ext>
             </a:extLst>
           </p:cNvPr>
@@ -19698,7 +19688,7 @@
           <p:cNvPr id="5" name="">
             <a:extLst xmlns:a="http://schemas.openxmlformats.org/drawingml/2006/main">
               <a:ext uri="{FF2B5EF4-FFF2-40B4-BE49-F238E27FC236}">
-                <a16:creationId xmlns:a16="http://schemas.microsoft.com/office/drawing/2014/main" id="{944CCCEE-DD9D-4C74-9EFD-69741D35F3DE}"/>
+                <a16:creationId xmlns:a16="http://schemas.microsoft.com/office/drawing/2014/main" id="{FDE5C154-DC4E-4D25-9957-4C6D89B61DAE}"/>
               </a:ext>
             </a:extLst>
           </p:cNvPr>
@@ -19748,7 +19738,7 @@
           <p:cNvPr id="6" name="">
             <a:extLst xmlns:a="http://schemas.openxmlformats.org/drawingml/2006/main">
               <a:ext uri="{FF2B5EF4-FFF2-40B4-BE49-F238E27FC236}">
-                <a16:creationId xmlns:a16="http://schemas.microsoft.com/office/drawing/2014/main" id="{EEDE9CE6-843F-49E0-ADA4-190AC1F3865E}"/>
+                <a16:creationId xmlns:a16="http://schemas.microsoft.com/office/drawing/2014/main" id="{81A6816D-013C-4EBA-98FA-37445F4E8592}"/>
               </a:ext>
             </a:extLst>
           </p:cNvPr>
@@ -19798,7 +19788,7 @@
           <p:cNvPr id="7" name="">
             <a:extLst xmlns:a="http://schemas.openxmlformats.org/drawingml/2006/main">
               <a:ext uri="{FF2B5EF4-FFF2-40B4-BE49-F238E27FC236}">
-                <a16:creationId xmlns:a16="http://schemas.microsoft.com/office/drawing/2014/main" id="{0199C981-71A8-4214-97D0-43129F291801}"/>
+                <a16:creationId xmlns:a16="http://schemas.microsoft.com/office/drawing/2014/main" id="{3B23FABF-FD6D-4A5D-8B8F-8D284355F182}"/>
               </a:ext>
             </a:extLst>
           </p:cNvPr>
@@ -19831,7 +19821,7 @@
           <p:cNvPr id="8" name="">
             <a:extLst xmlns:a="http://schemas.openxmlformats.org/drawingml/2006/main">
               <a:ext uri="{FF2B5EF4-FFF2-40B4-BE49-F238E27FC236}">
-                <a16:creationId xmlns:a16="http://schemas.microsoft.com/office/drawing/2014/main" id="{E004A8D1-E27E-481B-9071-10748DED2A28}"/>
+                <a16:creationId xmlns:a16="http://schemas.microsoft.com/office/drawing/2014/main" id="{531A656D-E92B-44ED-B324-6854CC46D969}"/>
               </a:ext>
             </a:extLst>
           </p:cNvPr>
@@ -19864,7 +19854,7 @@
           <p:cNvPr id="9" name="">
             <a:extLst xmlns:a="http://schemas.openxmlformats.org/drawingml/2006/main">
               <a:ext uri="{FF2B5EF4-FFF2-40B4-BE49-F238E27FC236}">
-                <a16:creationId xmlns:a16="http://schemas.microsoft.com/office/drawing/2014/main" id="{D54D5629-8D62-4911-A33C-7C63D06476BE}"/>
+                <a16:creationId xmlns:a16="http://schemas.microsoft.com/office/drawing/2014/main" id="{06F5B1AE-0C2B-447E-9322-C3E2D982E532}"/>
               </a:ext>
             </a:extLst>
           </p:cNvPr>
@@ -19899,7 +19889,7 @@
           <p:cNvPr id="10" name="">
             <a:extLst xmlns:a="http://schemas.openxmlformats.org/drawingml/2006/main">
               <a:ext uri="{FF2B5EF4-FFF2-40B4-BE49-F238E27FC236}">
-                <a16:creationId xmlns:a16="http://schemas.microsoft.com/office/drawing/2014/main" id="{1F626458-DF47-4A9C-8FE5-0F535FB60D21}"/>
+                <a16:creationId xmlns:a16="http://schemas.microsoft.com/office/drawing/2014/main" id="{58B469F1-E740-414D-A25B-25D417B985A6}"/>
               </a:ext>
             </a:extLst>
           </p:cNvPr>
@@ -19930,7 +19920,7 @@
           <p:cNvPr id="11" name="">
             <a:extLst xmlns:a="http://schemas.openxmlformats.org/drawingml/2006/main">
               <a:ext uri="{FF2B5EF4-FFF2-40B4-BE49-F238E27FC236}">
-                <a16:creationId xmlns:a16="http://schemas.microsoft.com/office/drawing/2014/main" id="{53C27AF1-8C00-45AB-BD2F-105E913F9702}"/>
+                <a16:creationId xmlns:a16="http://schemas.microsoft.com/office/drawing/2014/main" id="{CA73A766-276D-491C-88BB-5C232B1D3CB3}"/>
               </a:ext>
             </a:extLst>
           </p:cNvPr>
@@ -19980,7 +19970,7 @@
           <p:cNvPr id="12" name="">
             <a:extLst xmlns:a="http://schemas.openxmlformats.org/drawingml/2006/main">
               <a:ext uri="{FF2B5EF4-FFF2-40B4-BE49-F238E27FC236}">
-                <a16:creationId xmlns:a16="http://schemas.microsoft.com/office/drawing/2014/main" id="{BB217AAB-C38A-42CA-B528-639D0471B71C}"/>
+                <a16:creationId xmlns:a16="http://schemas.microsoft.com/office/drawing/2014/main" id="{8938487F-C194-4CA6-B336-C2EFE606325C}"/>
               </a:ext>
             </a:extLst>
           </p:cNvPr>
@@ -20030,7 +20020,7 @@
           <p:cNvPr id="13" name="">
             <a:extLst xmlns:a="http://schemas.openxmlformats.org/drawingml/2006/main">
               <a:ext uri="{FF2B5EF4-FFF2-40B4-BE49-F238E27FC236}">
-                <a16:creationId xmlns:a16="http://schemas.microsoft.com/office/drawing/2014/main" id="{AC9C66DF-90DB-44C0-87ED-F5F82CDA05E6}"/>
+                <a16:creationId xmlns:a16="http://schemas.microsoft.com/office/drawing/2014/main" id="{7E78BACC-7F93-4913-8128-5EB9343277E6}"/>
               </a:ext>
             </a:extLst>
           </p:cNvPr>
@@ -20061,7 +20051,7 @@
           <p:cNvPr id="14" name="">
             <a:extLst xmlns:a="http://schemas.openxmlformats.org/drawingml/2006/main">
               <a:ext uri="{FF2B5EF4-FFF2-40B4-BE49-F238E27FC236}">
-                <a16:creationId xmlns:a16="http://schemas.microsoft.com/office/drawing/2014/main" id="{DA6396EA-7F4F-47E1-A3E9-196788540BDB}"/>
+                <a16:creationId xmlns:a16="http://schemas.microsoft.com/office/drawing/2014/main" id="{338D496E-6B3E-477B-A491-5F3779211F96}"/>
               </a:ext>
             </a:extLst>
           </p:cNvPr>
@@ -20111,7 +20101,7 @@
           <p:cNvPr id="15" name="">
             <a:extLst xmlns:a="http://schemas.openxmlformats.org/drawingml/2006/main">
               <a:ext uri="{FF2B5EF4-FFF2-40B4-BE49-F238E27FC236}">
-                <a16:creationId xmlns:a16="http://schemas.microsoft.com/office/drawing/2014/main" id="{7315B79A-649F-4CBB-8A7C-FD0E7762BBB3}"/>
+                <a16:creationId xmlns:a16="http://schemas.microsoft.com/office/drawing/2014/main" id="{5805F985-40B3-43DA-B1C9-723609EC2478}"/>
               </a:ext>
             </a:extLst>
           </p:cNvPr>
@@ -20142,7 +20132,7 @@
           <p:cNvPr id="16" name="">
             <a:extLst xmlns:a="http://schemas.openxmlformats.org/drawingml/2006/main">
               <a:ext uri="{FF2B5EF4-FFF2-40B4-BE49-F238E27FC236}">
-                <a16:creationId xmlns:a16="http://schemas.microsoft.com/office/drawing/2014/main" id="{15CC4649-E8CA-43DA-88BD-B8826076E715}"/>
+                <a16:creationId xmlns:a16="http://schemas.microsoft.com/office/drawing/2014/main" id="{B9BCD9FE-B748-4A97-A11C-0A0209A0142B}"/>
               </a:ext>
             </a:extLst>
           </p:cNvPr>
@@ -20192,7 +20182,7 @@
           <p:cNvPr id="17" name="">
             <a:extLst xmlns:a="http://schemas.openxmlformats.org/drawingml/2006/main">
               <a:ext uri="{FF2B5EF4-FFF2-40B4-BE49-F238E27FC236}">
-                <a16:creationId xmlns:a16="http://schemas.microsoft.com/office/drawing/2014/main" id="{DE7B74EA-3B99-4E4E-9B24-64CBCA9BD9AE}"/>
+                <a16:creationId xmlns:a16="http://schemas.microsoft.com/office/drawing/2014/main" id="{F3037FE2-09E0-48B2-A7C9-7936FAC4C47D}"/>
               </a:ext>
             </a:extLst>
           </p:cNvPr>
@@ -20223,7 +20213,7 @@
           <p:cNvPr id="18" name="">
             <a:extLst xmlns:a="http://schemas.openxmlformats.org/drawingml/2006/main">
               <a:ext uri="{FF2B5EF4-FFF2-40B4-BE49-F238E27FC236}">
-                <a16:creationId xmlns:a16="http://schemas.microsoft.com/office/drawing/2014/main" id="{9BC173EC-0B8A-4F62-9D14-F41A3D0EEE9B}"/>
+                <a16:creationId xmlns:a16="http://schemas.microsoft.com/office/drawing/2014/main" id="{9D18ACAC-37CF-42E8-9FEF-44852190B716}"/>
               </a:ext>
             </a:extLst>
           </p:cNvPr>
@@ -20273,7 +20263,7 @@
           <p:cNvPr id="19" name="">
             <a:extLst xmlns:a="http://schemas.openxmlformats.org/drawingml/2006/main">
               <a:ext uri="{FF2B5EF4-FFF2-40B4-BE49-F238E27FC236}">
-                <a16:creationId xmlns:a16="http://schemas.microsoft.com/office/drawing/2014/main" id="{6007CA53-900B-4B45-AAB6-52E2151C6C6D}"/>
+                <a16:creationId xmlns:a16="http://schemas.microsoft.com/office/drawing/2014/main" id="{E3DA065C-1AD6-4D80-B45E-A32D5FFC97F4}"/>
               </a:ext>
             </a:extLst>
           </p:cNvPr>
@@ -20308,7 +20298,7 @@
           <p:cNvPr id="20" name="">
             <a:extLst xmlns:a="http://schemas.openxmlformats.org/drawingml/2006/main">
               <a:ext uri="{FF2B5EF4-FFF2-40B4-BE49-F238E27FC236}">
-                <a16:creationId xmlns:a16="http://schemas.microsoft.com/office/drawing/2014/main" id="{9EA36BE5-0705-4F09-8891-90E9FC5610EE}"/>
+                <a16:creationId xmlns:a16="http://schemas.microsoft.com/office/drawing/2014/main" id="{D00DC9E2-5E15-4023-BCDF-0322743B7F9B}"/>
               </a:ext>
             </a:extLst>
           </p:cNvPr>
@@ -20339,7 +20329,7 @@
           <p:cNvPr id="21" name="">
             <a:extLst xmlns:a="http://schemas.openxmlformats.org/drawingml/2006/main">
               <a:ext uri="{FF2B5EF4-FFF2-40B4-BE49-F238E27FC236}">
-                <a16:creationId xmlns:a16="http://schemas.microsoft.com/office/drawing/2014/main" id="{3C1E0320-4EF4-4502-9B00-C69CDD3A1E59}"/>
+                <a16:creationId xmlns:a16="http://schemas.microsoft.com/office/drawing/2014/main" id="{9DAC6F30-28C1-4906-A955-2CAF75BEC04A}"/>
               </a:ext>
             </a:extLst>
           </p:cNvPr>
@@ -20389,7 +20379,7 @@
           <p:cNvPr id="22" name="">
             <a:extLst xmlns:a="http://schemas.openxmlformats.org/drawingml/2006/main">
               <a:ext uri="{FF2B5EF4-FFF2-40B4-BE49-F238E27FC236}">
-                <a16:creationId xmlns:a16="http://schemas.microsoft.com/office/drawing/2014/main" id="{E6D3B916-573C-4391-A921-849C4C99A101}"/>
+                <a16:creationId xmlns:a16="http://schemas.microsoft.com/office/drawing/2014/main" id="{537457FD-F524-4208-A725-9A8E43050F9C}"/>
               </a:ext>
             </a:extLst>
           </p:cNvPr>
@@ -20439,7 +20429,7 @@
           <p:cNvPr id="23" name="">
             <a:extLst xmlns:a="http://schemas.openxmlformats.org/drawingml/2006/main">
               <a:ext uri="{FF2B5EF4-FFF2-40B4-BE49-F238E27FC236}">
-                <a16:creationId xmlns:a16="http://schemas.microsoft.com/office/drawing/2014/main" id="{4FF167D1-CEA6-43E3-A972-D624ABA5BD17}"/>
+                <a16:creationId xmlns:a16="http://schemas.microsoft.com/office/drawing/2014/main" id="{ECCC0C87-17C5-44CF-90AE-89C4BCE36AE5}"/>
               </a:ext>
             </a:extLst>
           </p:cNvPr>
@@ -20470,7 +20460,7 @@
           <p:cNvPr id="24" name="">
             <a:extLst xmlns:a="http://schemas.openxmlformats.org/drawingml/2006/main">
               <a:ext uri="{FF2B5EF4-FFF2-40B4-BE49-F238E27FC236}">
-                <a16:creationId xmlns:a16="http://schemas.microsoft.com/office/drawing/2014/main" id="{C8ED20EE-6419-43B7-B86E-EE5371CE4978}"/>
+                <a16:creationId xmlns:a16="http://schemas.microsoft.com/office/drawing/2014/main" id="{85D6CA63-A224-43A0-85CE-1FB0C12F74DE}"/>
               </a:ext>
             </a:extLst>
           </p:cNvPr>
@@ -20520,7 +20510,7 @@
           <p:cNvPr id="25" name="">
             <a:extLst xmlns:a="http://schemas.openxmlformats.org/drawingml/2006/main">
               <a:ext uri="{FF2B5EF4-FFF2-40B4-BE49-F238E27FC236}">
-                <a16:creationId xmlns:a16="http://schemas.microsoft.com/office/drawing/2014/main" id="{499716BC-84EE-46B3-ADA8-D9F0F915E3D6}"/>
+                <a16:creationId xmlns:a16="http://schemas.microsoft.com/office/drawing/2014/main" id="{92112646-2FDD-417B-82A8-E6ADC3D27B81}"/>
               </a:ext>
             </a:extLst>
           </p:cNvPr>
@@ -20551,7 +20541,7 @@
           <p:cNvPr id="26" name="">
             <a:extLst xmlns:a="http://schemas.openxmlformats.org/drawingml/2006/main">
               <a:ext uri="{FF2B5EF4-FFF2-40B4-BE49-F238E27FC236}">
-                <a16:creationId xmlns:a16="http://schemas.microsoft.com/office/drawing/2014/main" id="{EA3F668E-3BD0-48DE-B9F1-073E9A58AC98}"/>
+                <a16:creationId xmlns:a16="http://schemas.microsoft.com/office/drawing/2014/main" id="{A6271293-2463-4B23-A7D2-E19EE57C38E1}"/>
               </a:ext>
             </a:extLst>
           </p:cNvPr>
@@ -20601,7 +20591,7 @@
           <p:cNvPr id="27" name="">
             <a:extLst xmlns:a="http://schemas.openxmlformats.org/drawingml/2006/main">
               <a:ext uri="{FF2B5EF4-FFF2-40B4-BE49-F238E27FC236}">
-                <a16:creationId xmlns:a16="http://schemas.microsoft.com/office/drawing/2014/main" id="{ADE28BCC-C2F1-4932-A495-735C1DFDDD7F}"/>
+                <a16:creationId xmlns:a16="http://schemas.microsoft.com/office/drawing/2014/main" id="{214849F1-6CAA-4020-A3CD-CFB4802D2C30}"/>
               </a:ext>
             </a:extLst>
           </p:cNvPr>
@@ -20632,7 +20622,7 @@
           <p:cNvPr id="28" name="">
             <a:extLst xmlns:a="http://schemas.openxmlformats.org/drawingml/2006/main">
               <a:ext uri="{FF2B5EF4-FFF2-40B4-BE49-F238E27FC236}">
-                <a16:creationId xmlns:a16="http://schemas.microsoft.com/office/drawing/2014/main" id="{3B494033-0F54-448C-B524-622E62375B38}"/>
+                <a16:creationId xmlns:a16="http://schemas.microsoft.com/office/drawing/2014/main" id="{A4836DDD-E89C-4BBD-A7DC-A6EA0ED799BD}"/>
               </a:ext>
             </a:extLst>
           </p:cNvPr>
@@ -20682,7 +20672,7 @@
           <p:cNvPr id="29" name="">
             <a:extLst xmlns:a="http://schemas.openxmlformats.org/drawingml/2006/main">
               <a:ext uri="{FF2B5EF4-FFF2-40B4-BE49-F238E27FC236}">
-                <a16:creationId xmlns:a16="http://schemas.microsoft.com/office/drawing/2014/main" id="{849DE85B-717C-4933-AFEA-5E1B7395D3EC}"/>
+                <a16:creationId xmlns:a16="http://schemas.microsoft.com/office/drawing/2014/main" id="{B091CA82-8E0D-4B9E-905D-E6ECBC25426B}"/>
               </a:ext>
             </a:extLst>
           </p:cNvPr>
@@ -20717,7 +20707,7 @@
           <p:cNvPr id="30" name="">
             <a:extLst xmlns:a="http://schemas.openxmlformats.org/drawingml/2006/main">
               <a:ext uri="{FF2B5EF4-FFF2-40B4-BE49-F238E27FC236}">
-                <a16:creationId xmlns:a16="http://schemas.microsoft.com/office/drawing/2014/main" id="{3E750380-2579-4A83-A0DB-CCE0BE376B34}"/>
+                <a16:creationId xmlns:a16="http://schemas.microsoft.com/office/drawing/2014/main" id="{9428BA04-123D-4F10-B386-974966D841DC}"/>
               </a:ext>
             </a:extLst>
           </p:cNvPr>
@@ -20748,7 +20738,7 @@
           <p:cNvPr id="31" name="">
             <a:extLst xmlns:a="http://schemas.openxmlformats.org/drawingml/2006/main">
               <a:ext uri="{FF2B5EF4-FFF2-40B4-BE49-F238E27FC236}">
-                <a16:creationId xmlns:a16="http://schemas.microsoft.com/office/drawing/2014/main" id="{A062A391-725F-4B6A-8BC6-341F1B11C511}"/>
+                <a16:creationId xmlns:a16="http://schemas.microsoft.com/office/drawing/2014/main" id="{3EA8E29F-8F3E-4CE7-81EE-FDBD8A9241A7}"/>
               </a:ext>
             </a:extLst>
           </p:cNvPr>
@@ -20798,7 +20788,7 @@
           <p:cNvPr id="32" name="">
             <a:extLst xmlns:a="http://schemas.openxmlformats.org/drawingml/2006/main">
               <a:ext uri="{FF2B5EF4-FFF2-40B4-BE49-F238E27FC236}">
-                <a16:creationId xmlns:a16="http://schemas.microsoft.com/office/drawing/2014/main" id="{5820BB83-599F-446C-B61A-3FD65775647E}"/>
+                <a16:creationId xmlns:a16="http://schemas.microsoft.com/office/drawing/2014/main" id="{55E5239D-BBAB-4277-9E7F-E1CA4CCBB777}"/>
               </a:ext>
             </a:extLst>
           </p:cNvPr>
@@ -20848,7 +20838,7 @@
           <p:cNvPr id="33" name="">
             <a:extLst xmlns:a="http://schemas.openxmlformats.org/drawingml/2006/main">
               <a:ext uri="{FF2B5EF4-FFF2-40B4-BE49-F238E27FC236}">
-                <a16:creationId xmlns:a16="http://schemas.microsoft.com/office/drawing/2014/main" id="{A4786C47-38DD-41BD-9607-C6BC22E4BB80}"/>
+                <a16:creationId xmlns:a16="http://schemas.microsoft.com/office/drawing/2014/main" id="{D2B632A2-CC4A-4954-9C83-39A13BF7F91A}"/>
               </a:ext>
             </a:extLst>
           </p:cNvPr>
@@ -20879,7 +20869,7 @@
           <p:cNvPr id="34" name="">
             <a:extLst xmlns:a="http://schemas.openxmlformats.org/drawingml/2006/main">
               <a:ext uri="{FF2B5EF4-FFF2-40B4-BE49-F238E27FC236}">
-                <a16:creationId xmlns:a16="http://schemas.microsoft.com/office/drawing/2014/main" id="{518D2523-AAC0-4298-BF0D-CA282F63E00B}"/>
+                <a16:creationId xmlns:a16="http://schemas.microsoft.com/office/drawing/2014/main" id="{15229FE1-5983-4571-BEC7-453A7D4189C5}"/>
               </a:ext>
             </a:extLst>
           </p:cNvPr>
@@ -20929,7 +20919,7 @@
           <p:cNvPr id="35" name="">
             <a:extLst xmlns:a="http://schemas.openxmlformats.org/drawingml/2006/main">
               <a:ext uri="{FF2B5EF4-FFF2-40B4-BE49-F238E27FC236}">
-                <a16:creationId xmlns:a16="http://schemas.microsoft.com/office/drawing/2014/main" id="{3E711FA5-3582-4F86-BC11-9972E6F485FD}"/>
+                <a16:creationId xmlns:a16="http://schemas.microsoft.com/office/drawing/2014/main" id="{4CA84916-57B5-4FB4-A05B-980E964E86B8}"/>
               </a:ext>
             </a:extLst>
           </p:cNvPr>
@@ -20960,7 +20950,7 @@
           <p:cNvPr id="36" name="">
             <a:extLst xmlns:a="http://schemas.openxmlformats.org/drawingml/2006/main">
               <a:ext uri="{FF2B5EF4-FFF2-40B4-BE49-F238E27FC236}">
-                <a16:creationId xmlns:a16="http://schemas.microsoft.com/office/drawing/2014/main" id="{C08D6017-012A-4F93-9524-A15A0A4AD0DF}"/>
+                <a16:creationId xmlns:a16="http://schemas.microsoft.com/office/drawing/2014/main" id="{F5CCC588-3F55-4167-8675-8B73B9A49DCE}"/>
               </a:ext>
             </a:extLst>
           </p:cNvPr>
@@ -21010,7 +21000,7 @@
           <p:cNvPr id="37" name="">
             <a:extLst xmlns:a="http://schemas.openxmlformats.org/drawingml/2006/main">
               <a:ext uri="{FF2B5EF4-FFF2-40B4-BE49-F238E27FC236}">
-                <a16:creationId xmlns:a16="http://schemas.microsoft.com/office/drawing/2014/main" id="{834D6214-23C9-4FF7-8844-300B5A362E82}"/>
+                <a16:creationId xmlns:a16="http://schemas.microsoft.com/office/drawing/2014/main" id="{34691BBC-286B-4D14-8AB1-06D03568E40D}"/>
               </a:ext>
             </a:extLst>
           </p:cNvPr>
@@ -21041,7 +21031,7 @@
           <p:cNvPr id="38" name="">
             <a:extLst xmlns:a="http://schemas.openxmlformats.org/drawingml/2006/main">
               <a:ext uri="{FF2B5EF4-FFF2-40B4-BE49-F238E27FC236}">
-                <a16:creationId xmlns:a16="http://schemas.microsoft.com/office/drawing/2014/main" id="{18A376AF-38ED-4DF5-B932-B5F6B7DB6F4A}"/>
+                <a16:creationId xmlns:a16="http://schemas.microsoft.com/office/drawing/2014/main" id="{8A304E34-5E95-46D5-A14B-4DAF5D145B17}"/>
               </a:ext>
             </a:extLst>
           </p:cNvPr>
@@ -21091,7 +21081,7 @@
           <p:cNvPr id="39" name="">
             <a:extLst xmlns:a="http://schemas.openxmlformats.org/drawingml/2006/main">
               <a:ext uri="{FF2B5EF4-FFF2-40B4-BE49-F238E27FC236}">
-                <a16:creationId xmlns:a16="http://schemas.microsoft.com/office/drawing/2014/main" id="{303AED8A-C7FA-4702-9468-8A52CE81D765}"/>
+                <a16:creationId xmlns:a16="http://schemas.microsoft.com/office/drawing/2014/main" id="{2E4AB0AB-B536-4910-BDFC-F743D60560E8}"/>
               </a:ext>
             </a:extLst>
           </p:cNvPr>
@@ -21141,7 +21131,7 @@
           <p:cNvPr id="40" name="">
             <a:extLst xmlns:a="http://schemas.openxmlformats.org/drawingml/2006/main">
               <a:ext uri="{FF2B5EF4-FFF2-40B4-BE49-F238E27FC236}">
-                <a16:creationId xmlns:a16="http://schemas.microsoft.com/office/drawing/2014/main" id="{D0F1E3C2-597E-488A-B988-A43F36C03EEB}"/>
+                <a16:creationId xmlns:a16="http://schemas.microsoft.com/office/drawing/2014/main" id="{CB864E8B-7970-4B51-BDF6-1CF344D8C3B3}"/>
               </a:ext>
             </a:extLst>
           </p:cNvPr>
@@ -21174,7 +21164,7 @@
           <p:cNvPr id="41" name="">
             <a:extLst xmlns:a="http://schemas.openxmlformats.org/drawingml/2006/main">
               <a:ext uri="{FF2B5EF4-FFF2-40B4-BE49-F238E27FC236}">
-                <a16:creationId xmlns:a16="http://schemas.microsoft.com/office/drawing/2014/main" id="{D9EED247-01B7-4945-914D-7712748FD327}"/>
+                <a16:creationId xmlns:a16="http://schemas.microsoft.com/office/drawing/2014/main" id="{AEE58374-F57E-427F-A03D-371C4D6FC32A}"/>
               </a:ext>
             </a:extLst>
           </p:cNvPr>
@@ -21186,7 +21176,7 @@
         <p:spPr>
           <a:xfrm xmlns:a="http://schemas.openxmlformats.org/drawingml/2006/main">
             <a:off x="647700" y="6496050"/>
-            <a:ext cx="9715500" cy="190500"/>
+            <a:ext cx="8953500" cy="190500"/>
           </a:xfrm>
           <a:prstGeom xmlns:a="http://schemas.openxmlformats.org/drawingml/2006/main" prst="rect">
             <a:avLst/>
@@ -21224,19 +21214,19 @@
           <p:cNvPr id="42" name="">
             <a:extLst xmlns:a="http://schemas.openxmlformats.org/drawingml/2006/main">
               <a:ext uri="{FF2B5EF4-FFF2-40B4-BE49-F238E27FC236}">
-                <a16:creationId xmlns:a16="http://schemas.microsoft.com/office/drawing/2014/main" id="{5426DBC2-C6CA-4010-8E66-EEF528B2BAA1}"/>
-              </a:ext>
-            </a:extLst>
-          </p:cNvPr>
-          <p:cNvSpPr>
-            <a:spLocks xmlns:a="http://schemas.openxmlformats.org/drawingml/2006/main" noGrp="1"/>
-          </p:cNvSpPr>
-          <p:nvPr/>
-        </p:nvSpPr>
-        <p:spPr>
-          <a:xfrm xmlns:a="http://schemas.openxmlformats.org/drawingml/2006/main">
-            <a:off x="9620250" y="6467475"/>
-            <a:ext cx="1905000" cy="247650"/>
+                <a16:creationId xmlns:a16="http://schemas.microsoft.com/office/drawing/2014/main" id="{21CE192E-84CD-42D8-9755-88255CDE9E3A}"/>
+              </a:ext>
+            </a:extLst>
+          </p:cNvPr>
+          <p:cNvSpPr>
+            <a:spLocks xmlns:a="http://schemas.openxmlformats.org/drawingml/2006/main" noGrp="1"/>
+          </p:cNvSpPr>
+          <p:nvPr/>
+        </p:nvSpPr>
+        <p:spPr>
+          <a:xfrm xmlns:a="http://schemas.openxmlformats.org/drawingml/2006/main">
+            <a:off x="10287000" y="6467475"/>
+            <a:ext cx="952500" cy="247650"/>
           </a:xfrm>
           <a:prstGeom xmlns:a="http://schemas.openxmlformats.org/drawingml/2006/main" prst="rect">
             <a:avLst/>
@@ -21272,7 +21262,7 @@
     </p:spTree>
     <p:extLst>
       <p:ext uri="{BB962C8B-B14F-4D97-AF65-F5344CB8AC3E}">
-        <p14:creationId xmlns:p14="http://schemas.microsoft.com/office/powerpoint/2010/main" val="2055322558"/>
+        <p14:creationId xmlns:p14="http://schemas.microsoft.com/office/powerpoint/2010/main" val="727766259"/>
       </p:ext>
     </p:extLst>
   </p:cSld>

</xml_diff>